<commit_message>
10.16: redesign exec summary around the four choices
Co-Authored-By: Claude Opus 5.5 <noreply@anthropic.com>
Claude-Session: https://claude.ai/code/session_0198bm9pfzRwgZQBqNvd56W8
</commit_message>
<xml_diff>
--- a/deck/Optum-LS-Conversational-AI-10.16.pptx
+++ b/deck/Optum-LS-Conversational-AI-10.16.pptx
@@ -8834,7 +8834,7 @@
                   <a:schemeClr val="accent1"/>
                 </a:solidFill>
               </a:rPr>
-              <a:t>Competitors’ conversational AI points to four choices that will shape any Optum LS offering</a:t>
+              <a:t>Competitors’ conversational AI points to four choices for any Optum LS offering</a:t>
             </a:r>
             <a:endParaRPr lang="en-US" sz="2200" dirty="0"/>
           </a:p>
@@ -8842,14 +8842,679 @@
       </p:sp>
       <p:sp>
         <p:nvSpPr>
-          <p:cNvPr id="4" name="lens card"/>
+          <p:cNvPr id="25" name="Slide Number Placeholder 0"/>
+          <p:cNvSpPr>
+            <a:spLocks noGrp="1"/>
+          </p:cNvSpPr>
+          <p:nvPr>
+            <p:ph type="sldNum" sz="quarter" idx="4294967295"/>
+          </p:nvPr>
+        </p:nvSpPr>
+        <p:spPr>
+          <a:xfrm>
+            <a:off x="10725912" y="6309360"/>
+            <a:ext cx="914400" cy="201168"/>
+          </a:xfrm>
+          <a:prstGeom prst="rect">
+            <a:avLst/>
+          </a:prstGeom>
+          <a:extLst>
+            <a:ext uri="{C572A759-6A51-4108-AA02-DFA0A04FC94B}">
+              <ma14:wrappingTextBoxFlag xmlns:ma14="http://schemas.microsoft.com/office/mac/drawingml/2011/main" val="0"/>
+            </a:ext>
+          </a:extLst>
+        </p:spPr>
+        <p:txBody>
+          <a:bodyPr lIns="0" tIns="0" rIns="0" bIns="0"/>
+          <a:lstStyle>
+            <a:lvl1pPr>
+              <a:defRPr sz="900">
+                <a:solidFill>
+                  <a:schemeClr val="accent4"/>
+                </a:solidFill>
+              </a:defRPr>
+            </a:lvl1pPr>
+          </a:lstStyle>
+          <a:p>
+            <a:pPr algn="r"/>
+            <a:fld id="{F7021451-1387-4CA6-816F-3879F97B5CBC}" type="slidenum">
+              <a:rPr b="0" lang="en-US"/>
+              <a:t>2</a:t>
+            </a:fld>
+            <a:endParaRPr lang="en-US"/>
+          </a:p>
+        </p:txBody>
+      </p:sp>
+      <p:sp>
+        <p:nvSpPr>
+          <p:cNvPr id="26" name="label"/>
+          <p:cNvSpPr txBox="1"/>
+          <p:nvPr/>
+        </p:nvSpPr>
+        <p:spPr>
+          <a:xfrm>
+            <a:off x="548640" y="1161288"/>
+            <a:ext cx="5486400" cy="201168"/>
+          </a:xfrm>
+          <a:prstGeom prst="rect">
+            <a:avLst/>
+          </a:prstGeom>
+          <a:noFill/>
+          <a:ln/>
+        </p:spPr>
+        <p:txBody>
+          <a:bodyPr wrap="square" lIns="0" tIns="0" rIns="0" bIns="0" rtlCol="0" anchor="t"/>
+          <a:lstStyle/>
+          <a:p>
+            <a:pPr indent="0" marL="0">
+              <a:buNone/>
+            </a:pPr>
+            <a:r>
+              <a:rPr lang="en-US" sz="1000" b="1" spc="100" kern="0" dirty="0">
+                <a:solidFill>
+                  <a:schemeClr val="accent2"/>
+                </a:solidFill>
+              </a:rPr>
+              <a:t>FOUR CHOICES</a:t>
+            </a:r>
+            <a:endParaRPr lang="en-US" sz="1000" dirty="0"/>
+          </a:p>
+        </p:txBody>
+      </p:sp>
+      <p:sp>
+        <p:nvSpPr>
+          <p:cNvPr id="27" name="choice tile 1"/>
           <p:cNvSpPr/>
           <p:nvPr/>
         </p:nvSpPr>
         <p:spPr>
           <a:xfrm>
-            <a:off x="548640" y="1536192"/>
-            <a:ext cx="11091672" cy="1536192"/>
+            <a:off x="548640" y="1417320"/>
+            <a:ext cx="2670048" cy="1005840"/>
+          </a:xfrm>
+          <a:prstGeom prst="rect">
+            <a:avLst/>
+          </a:prstGeom>
+          <a:solidFill>
+            <a:schemeClr val="accent5"/>
+          </a:solidFill>
+          <a:ln/>
+        </p:spPr>
+        <p:txBody>
+          <a:bodyPr/>
+          <a:p/>
+        </p:txBody>
+      </p:sp>
+      <p:sp>
+        <p:nvSpPr>
+          <p:cNvPr id="28" name="card label"/>
+          <p:cNvSpPr txBox="1"/>
+          <p:nvPr/>
+        </p:nvSpPr>
+        <p:spPr>
+          <a:xfrm>
+            <a:off x="694944" y="1527048"/>
+            <a:ext cx="2395728" cy="201168"/>
+          </a:xfrm>
+          <a:prstGeom prst="rect">
+            <a:avLst/>
+          </a:prstGeom>
+          <a:noFill/>
+          <a:ln/>
+        </p:spPr>
+        <p:txBody>
+          <a:bodyPr wrap="square" lIns="0" tIns="0" rIns="0" bIns="0" rtlCol="0" anchor="ctr"/>
+          <a:lstStyle/>
+          <a:p>
+            <a:pPr indent="0" marL="0">
+              <a:buNone/>
+            </a:pPr>
+            <a:r>
+              <a:rPr lang="en-US" sz="1050" b="1" spc="80" kern="0" dirty="0">
+                <a:solidFill>
+                  <a:srgbClr val="002677"/>
+                </a:solidFill>
+              </a:rPr>
+              <a:t>WHERE IT SITS</a:t>
+            </a:r>
+            <a:endParaRPr lang="en-US" sz="1300" dirty="0"/>
+          </a:p>
+        </p:txBody>
+      </p:sp>
+      <p:sp>
+        <p:nvSpPr>
+          <p:cNvPr id="29" name="Text 29"/>
+          <p:cNvSpPr txBox="1"/>
+          <p:nvPr/>
+        </p:nvSpPr>
+        <p:spPr>
+          <a:xfrm>
+            <a:off x="694944" y="1764792"/>
+            <a:ext cx="2395728" cy="365760"/>
+          </a:xfrm>
+          <a:prstGeom prst="rect">
+            <a:avLst/>
+          </a:prstGeom>
+          <a:noFill/>
+          <a:ln/>
+        </p:spPr>
+        <p:txBody>
+          <a:bodyPr wrap="square" lIns="0" tIns="0" rIns="0" bIns="0" rtlCol="0" anchor="t"/>
+          <a:lstStyle/>
+          <a:p>
+            <a:pPr indent="0" marL="0">
+              <a:spcAft>
+                <a:spcPts val="900"/>
+              </a:spcAft>
+              <a:buNone/>
+            </a:pPr>
+            <a:r>
+              <a:rPr lang="en-US" sz="1000" dirty="0">
+                <a:solidFill>
+                  <a:srgbClr val="4B4D4F"/>
+                </a:solidFill>
+              </a:rPr>
+              <a:t>Before purchase, in place of analyst requests, or inside the rep’s CRM</a:t>
+            </a:r>
+            <a:endParaRPr lang="en-US" sz="1100" dirty="0"/>
+          </a:p>
+        </p:txBody>
+      </p:sp>
+      <p:sp>
+        <p:nvSpPr>
+          <p:cNvPr id="30" name="Text 29"/>
+          <p:cNvSpPr txBox="1"/>
+          <p:nvPr/>
+        </p:nvSpPr>
+        <p:spPr>
+          <a:xfrm>
+            <a:off x="694944" y="2176272"/>
+            <a:ext cx="2395728" cy="164592"/>
+          </a:xfrm>
+          <a:prstGeom prst="rect">
+            <a:avLst/>
+          </a:prstGeom>
+          <a:noFill/>
+          <a:ln/>
+        </p:spPr>
+        <p:txBody>
+          <a:bodyPr wrap="square" lIns="0" tIns="0" rIns="0" bIns="0" rtlCol="0" anchor="t"/>
+          <a:lstStyle/>
+          <a:p>
+            <a:pPr indent="0" marL="0">
+              <a:spcAft>
+                <a:spcPts val="900"/>
+              </a:spcAft>
+              <a:buNone/>
+            </a:pPr>
+            <a:r>
+              <a:rPr lang="en-US" sz="900" dirty="0" b="1">
+                <a:solidFill>
+                  <a:srgbClr val="7A7C7E"/>
+                </a:solidFill>
+              </a:rPr>
+              <a:t>Seen in: </a:t>
+            </a:r>
+            <a:r>
+              <a:rPr lang="en-US" sz="900" dirty="0">
+                <a:solidFill>
+                  <a:srgbClr val="7A7C7E"/>
+                </a:solidFill>
+              </a:rPr>
+              <a:t>Truven, Flatiron, Verana, IQVIA</a:t>
+            </a:r>
+            <a:endParaRPr lang="en-US" sz="1100" dirty="0"/>
+          </a:p>
+        </p:txBody>
+      </p:sp>
+      <p:sp>
+        <p:nvSpPr>
+          <p:cNvPr id="31" name="choice tile 2"/>
+          <p:cNvSpPr/>
+          <p:nvPr/>
+        </p:nvSpPr>
+        <p:spPr>
+          <a:xfrm>
+            <a:off x="3355848" y="1417320"/>
+            <a:ext cx="2670048" cy="1005840"/>
+          </a:xfrm>
+          <a:prstGeom prst="rect">
+            <a:avLst/>
+          </a:prstGeom>
+          <a:solidFill>
+            <a:schemeClr val="accent5"/>
+          </a:solidFill>
+          <a:ln/>
+        </p:spPr>
+        <p:txBody>
+          <a:bodyPr/>
+          <a:p/>
+        </p:txBody>
+      </p:sp>
+      <p:sp>
+        <p:nvSpPr>
+          <p:cNvPr id="32" name="card label"/>
+          <p:cNvSpPr txBox="1"/>
+          <p:nvPr/>
+        </p:nvSpPr>
+        <p:spPr>
+          <a:xfrm>
+            <a:off x="3502152" y="1527048"/>
+            <a:ext cx="2395728" cy="201168"/>
+          </a:xfrm>
+          <a:prstGeom prst="rect">
+            <a:avLst/>
+          </a:prstGeom>
+          <a:noFill/>
+          <a:ln/>
+        </p:spPr>
+        <p:txBody>
+          <a:bodyPr wrap="square" lIns="0" tIns="0" rIns="0" bIns="0" rtlCol="0" anchor="ctr"/>
+          <a:lstStyle/>
+          <a:p>
+            <a:pPr indent="0" marL="0">
+              <a:buNone/>
+            </a:pPr>
+            <a:r>
+              <a:rPr lang="en-US" sz="1050" b="1" spc="80" kern="0" dirty="0">
+                <a:solidFill>
+                  <a:srgbClr val="002677"/>
+                </a:solidFill>
+              </a:rPr>
+              <a:t>HOW IT SHOWS ITS WORK</a:t>
+            </a:r>
+            <a:endParaRPr lang="en-US" sz="1300" dirty="0"/>
+          </a:p>
+        </p:txBody>
+      </p:sp>
+      <p:sp>
+        <p:nvSpPr>
+          <p:cNvPr id="33" name="Text 29"/>
+          <p:cNvSpPr txBox="1"/>
+          <p:nvPr/>
+        </p:nvSpPr>
+        <p:spPr>
+          <a:xfrm>
+            <a:off x="3502152" y="1764792"/>
+            <a:ext cx="2395728" cy="365760"/>
+          </a:xfrm>
+          <a:prstGeom prst="rect">
+            <a:avLst/>
+          </a:prstGeom>
+          <a:noFill/>
+          <a:ln/>
+        </p:spPr>
+        <p:txBody>
+          <a:bodyPr wrap="square" lIns="0" tIns="0" rIns="0" bIns="0" rtlCol="0" anchor="t"/>
+          <a:lstStyle/>
+          <a:p>
+            <a:pPr indent="0" marL="0">
+              <a:spcAft>
+                <a:spcPts val="900"/>
+              </a:spcAft>
+              <a:buNone/>
+            </a:pPr>
+            <a:r>
+              <a:rPr lang="en-US" sz="1000" dirty="0">
+                <a:solidFill>
+                  <a:srgbClr val="4B4D4F"/>
+                </a:solidFill>
+              </a:rPr>
+              <a:t>Sources and assumptions kept visible; limits published</a:t>
+            </a:r>
+            <a:endParaRPr lang="en-US" sz="1100" dirty="0"/>
+          </a:p>
+        </p:txBody>
+      </p:sp>
+      <p:sp>
+        <p:nvSpPr>
+          <p:cNvPr id="34" name="Text 29"/>
+          <p:cNvSpPr txBox="1"/>
+          <p:nvPr/>
+        </p:nvSpPr>
+        <p:spPr>
+          <a:xfrm>
+            <a:off x="3502152" y="2176272"/>
+            <a:ext cx="2395728" cy="164592"/>
+          </a:xfrm>
+          <a:prstGeom prst="rect">
+            <a:avLst/>
+          </a:prstGeom>
+          <a:noFill/>
+          <a:ln/>
+        </p:spPr>
+        <p:txBody>
+          <a:bodyPr wrap="square" lIns="0" tIns="0" rIns="0" bIns="0" rtlCol="0" anchor="t"/>
+          <a:lstStyle/>
+          <a:p>
+            <a:pPr indent="0" marL="0">
+              <a:spcAft>
+                <a:spcPts val="900"/>
+              </a:spcAft>
+              <a:buNone/>
+            </a:pPr>
+            <a:r>
+              <a:rPr lang="en-US" sz="900" dirty="0" b="1">
+                <a:solidFill>
+                  <a:srgbClr val="7A7C7E"/>
+                </a:solidFill>
+              </a:rPr>
+              <a:t>Seen in: </a:t>
+            </a:r>
+            <a:r>
+              <a:rPr lang="en-US" sz="900" dirty="0">
+                <a:solidFill>
+                  <a:srgbClr val="7A7C7E"/>
+                </a:solidFill>
+              </a:rPr>
+              <a:t>EVERSANA, IQVIA</a:t>
+            </a:r>
+            <a:endParaRPr lang="en-US" sz="1100" dirty="0"/>
+          </a:p>
+        </p:txBody>
+      </p:sp>
+      <p:sp>
+        <p:nvSpPr>
+          <p:cNvPr id="35" name="choice tile 3"/>
+          <p:cNvSpPr/>
+          <p:nvPr/>
+        </p:nvSpPr>
+        <p:spPr>
+          <a:xfrm>
+            <a:off x="6163056" y="1417320"/>
+            <a:ext cx="2670048" cy="1005840"/>
+          </a:xfrm>
+          <a:prstGeom prst="rect">
+            <a:avLst/>
+          </a:prstGeom>
+          <a:solidFill>
+            <a:schemeClr val="accent5"/>
+          </a:solidFill>
+          <a:ln/>
+        </p:spPr>
+        <p:txBody>
+          <a:bodyPr/>
+          <a:p/>
+        </p:txBody>
+      </p:sp>
+      <p:sp>
+        <p:nvSpPr>
+          <p:cNvPr id="36" name="card label"/>
+          <p:cNvSpPr txBox="1"/>
+          <p:nvPr/>
+        </p:nvSpPr>
+        <p:spPr>
+          <a:xfrm>
+            <a:off x="6309360" y="1527048"/>
+            <a:ext cx="2395728" cy="201168"/>
+          </a:xfrm>
+          <a:prstGeom prst="rect">
+            <a:avLst/>
+          </a:prstGeom>
+          <a:noFill/>
+          <a:ln/>
+        </p:spPr>
+        <p:txBody>
+          <a:bodyPr wrap="square" lIns="0" tIns="0" rIns="0" bIns="0" rtlCol="0" anchor="ctr"/>
+          <a:lstStyle/>
+          <a:p>
+            <a:pPr indent="0" marL="0">
+              <a:buNone/>
+            </a:pPr>
+            <a:r>
+              <a:rPr lang="en-US" sz="1050" b="1" spc="80" kern="0" dirty="0">
+                <a:solidFill>
+                  <a:srgbClr val="002677"/>
+                </a:solidFill>
+              </a:rPr>
+              <a:t>HOW MUCH AUTONOMY</a:t>
+            </a:r>
+            <a:endParaRPr lang="en-US" sz="1300" dirty="0"/>
+          </a:p>
+        </p:txBody>
+      </p:sp>
+      <p:sp>
+        <p:nvSpPr>
+          <p:cNvPr id="37" name="Text 29"/>
+          <p:cNvSpPr txBox="1"/>
+          <p:nvPr/>
+        </p:nvSpPr>
+        <p:spPr>
+          <a:xfrm>
+            <a:off x="6309360" y="1764792"/>
+            <a:ext cx="2395728" cy="365760"/>
+          </a:xfrm>
+          <a:prstGeom prst="rect">
+            <a:avLst/>
+          </a:prstGeom>
+          <a:noFill/>
+          <a:ln/>
+        </p:spPr>
+        <p:txBody>
+          <a:bodyPr wrap="square" lIns="0" tIns="0" rIns="0" bIns="0" rtlCol="0" anchor="t"/>
+          <a:lstStyle/>
+          <a:p>
+            <a:pPr indent="0" marL="0">
+              <a:spcAft>
+                <a:spcPts val="900"/>
+              </a:spcAft>
+              <a:buNone/>
+            </a:pPr>
+            <a:r>
+              <a:rPr lang="en-US" sz="1000" dirty="0">
+                <a:solidFill>
+                  <a:srgbClr val="4B4D4F"/>
+                </a:solidFill>
+              </a:rPr>
+              <a:t>Highest in RWE analysis; narrower in medical and regulatory work</a:t>
+            </a:r>
+            <a:endParaRPr lang="en-US" sz="1100" dirty="0"/>
+          </a:p>
+        </p:txBody>
+      </p:sp>
+      <p:sp>
+        <p:nvSpPr>
+          <p:cNvPr id="38" name="Text 29"/>
+          <p:cNvSpPr txBox="1"/>
+          <p:nvPr/>
+        </p:nvSpPr>
+        <p:spPr>
+          <a:xfrm>
+            <a:off x="6309360" y="2176272"/>
+            <a:ext cx="2395728" cy="164592"/>
+          </a:xfrm>
+          <a:prstGeom prst="rect">
+            <a:avLst/>
+          </a:prstGeom>
+          <a:noFill/>
+          <a:ln/>
+        </p:spPr>
+        <p:txBody>
+          <a:bodyPr wrap="square" lIns="0" tIns="0" rIns="0" bIns="0" rtlCol="0" anchor="t"/>
+          <a:lstStyle/>
+          <a:p>
+            <a:pPr indent="0" marL="0">
+              <a:spcAft>
+                <a:spcPts val="900"/>
+              </a:spcAft>
+              <a:buNone/>
+            </a:pPr>
+            <a:r>
+              <a:rPr lang="en-US" sz="900" dirty="0" b="1">
+                <a:solidFill>
+                  <a:srgbClr val="7A7C7E"/>
+                </a:solidFill>
+              </a:rPr>
+              <a:t>Seen in: </a:t>
+            </a:r>
+            <a:r>
+              <a:rPr lang="en-US" sz="900" dirty="0">
+                <a:solidFill>
+                  <a:srgbClr val="7A7C7E"/>
+                </a:solidFill>
+              </a:rPr>
+              <a:t>Flatiron, Verana, ZS, Veeva</a:t>
+            </a:r>
+            <a:endParaRPr lang="en-US" sz="1100" dirty="0"/>
+          </a:p>
+        </p:txBody>
+      </p:sp>
+      <p:sp>
+        <p:nvSpPr>
+          <p:cNvPr id="39" name="choice tile 4"/>
+          <p:cNvSpPr/>
+          <p:nvPr/>
+        </p:nvSpPr>
+        <p:spPr>
+          <a:xfrm>
+            <a:off x="8970264" y="1417320"/>
+            <a:ext cx="2670048" cy="1005840"/>
+          </a:xfrm>
+          <a:prstGeom prst="rect">
+            <a:avLst/>
+          </a:prstGeom>
+          <a:solidFill>
+            <a:schemeClr val="accent5"/>
+          </a:solidFill>
+          <a:ln/>
+        </p:spPr>
+        <p:txBody>
+          <a:bodyPr/>
+          <a:p/>
+        </p:txBody>
+      </p:sp>
+      <p:sp>
+        <p:nvSpPr>
+          <p:cNvPr id="40" name="card label"/>
+          <p:cNvSpPr txBox="1"/>
+          <p:nvPr/>
+        </p:nvSpPr>
+        <p:spPr>
+          <a:xfrm>
+            <a:off x="9116568" y="1527048"/>
+            <a:ext cx="2395728" cy="201168"/>
+          </a:xfrm>
+          <a:prstGeom prst="rect">
+            <a:avLst/>
+          </a:prstGeom>
+          <a:noFill/>
+          <a:ln/>
+        </p:spPr>
+        <p:txBody>
+          <a:bodyPr wrap="square" lIns="0" tIns="0" rIns="0" bIns="0" rtlCol="0" anchor="ctr"/>
+          <a:lstStyle/>
+          <a:p>
+            <a:pPr indent="0" marL="0">
+              <a:buNone/>
+            </a:pPr>
+            <a:r>
+              <a:rPr lang="en-US" sz="1050" b="1" spc="80" kern="0" dirty="0">
+                <a:solidFill>
+                  <a:srgbClr val="002677"/>
+                </a:solidFill>
+              </a:rPr>
+              <a:t>BUILT OR PARTNERED</a:t>
+            </a:r>
+            <a:endParaRPr lang="en-US" sz="1300" dirty="0"/>
+          </a:p>
+        </p:txBody>
+      </p:sp>
+      <p:sp>
+        <p:nvSpPr>
+          <p:cNvPr id="41" name="Text 29"/>
+          <p:cNvSpPr txBox="1"/>
+          <p:nvPr/>
+        </p:nvSpPr>
+        <p:spPr>
+          <a:xfrm>
+            <a:off x="9116568" y="1764792"/>
+            <a:ext cx="2395728" cy="365760"/>
+          </a:xfrm>
+          <a:prstGeom prst="rect">
+            <a:avLst/>
+          </a:prstGeom>
+          <a:noFill/>
+          <a:ln/>
+        </p:spPr>
+        <p:txBody>
+          <a:bodyPr wrap="square" lIns="0" tIns="0" rIns="0" bIns="0" rtlCol="0" anchor="t"/>
+          <a:lstStyle/>
+          <a:p>
+            <a:pPr indent="0" marL="0">
+              <a:spcAft>
+                <a:spcPts val="900"/>
+              </a:spcAft>
+              <a:buNone/>
+            </a:pPr>
+            <a:r>
+              <a:rPr lang="en-US" sz="1000" dirty="0">
+                <a:solidFill>
+                  <a:srgbClr val="4B4D4F"/>
+                </a:solidFill>
+              </a:rPr>
+              <a:t>LLM providers supply competitors and sell their own products</a:t>
+            </a:r>
+            <a:endParaRPr lang="en-US" sz="1100" dirty="0"/>
+          </a:p>
+        </p:txBody>
+      </p:sp>
+      <p:sp>
+        <p:nvSpPr>
+          <p:cNvPr id="42" name="Text 29"/>
+          <p:cNvSpPr txBox="1"/>
+          <p:nvPr/>
+        </p:nvSpPr>
+        <p:spPr>
+          <a:xfrm>
+            <a:off x="9116568" y="2176272"/>
+            <a:ext cx="2395728" cy="164592"/>
+          </a:xfrm>
+          <a:prstGeom prst="rect">
+            <a:avLst/>
+          </a:prstGeom>
+          <a:noFill/>
+          <a:ln/>
+        </p:spPr>
+        <p:txBody>
+          <a:bodyPr wrap="square" lIns="0" tIns="0" rIns="0" bIns="0" rtlCol="0" anchor="t"/>
+          <a:lstStyle/>
+          <a:p>
+            <a:pPr indent="0" marL="0">
+              <a:spcAft>
+                <a:spcPts val="900"/>
+              </a:spcAft>
+              <a:buNone/>
+            </a:pPr>
+            <a:r>
+              <a:rPr lang="en-US" sz="900" dirty="0" b="1">
+                <a:solidFill>
+                  <a:srgbClr val="7A7C7E"/>
+                </a:solidFill>
+              </a:rPr>
+              <a:t>Seen in: </a:t>
+            </a:r>
+            <a:r>
+              <a:rPr lang="en-US" sz="900" dirty="0">
+                <a:solidFill>
+                  <a:srgbClr val="7A7C7E"/>
+                </a:solidFill>
+              </a:rPr>
+              <a:t>Anthropic, OpenAI, Cohere</a:t>
+            </a:r>
+            <a:endParaRPr lang="en-US" sz="1100" dirty="0"/>
+          </a:p>
+        </p:txBody>
+      </p:sp>
+      <p:sp>
+        <p:nvSpPr>
+          <p:cNvPr id="43" name="key findings card"/>
+          <p:cNvSpPr/>
+          <p:nvPr/>
+        </p:nvSpPr>
+        <p:spPr>
+          <a:xfrm>
+            <a:off x="548640" y="2578608"/>
+            <a:ext cx="3026664" cy="1810512"/>
           </a:xfrm>
           <a:prstGeom prst="rect">
             <a:avLst/>
@@ -8873,62 +9538,14 @@
       </p:sp>
       <p:sp>
         <p:nvSpPr>
-          <p:cNvPr id="5" name="icon circle"/>
-          <p:cNvSpPr/>
-          <p:nvPr/>
-        </p:nvSpPr>
-        <p:spPr>
-          <a:xfrm>
-            <a:off x="777240" y="1737360"/>
-            <a:ext cx="475488" cy="475488"/>
-          </a:xfrm>
-          <a:prstGeom prst="ellipse">
-            <a:avLst/>
-          </a:prstGeom>
-          <a:solidFill>
-            <a:schemeClr val="accent5"/>
-          </a:solidFill>
-          <a:ln/>
-        </p:spPr>
-        <p:txBody>
-          <a:bodyPr/>
-          <a:p/>
-        </p:txBody>
-      </p:sp>
-      <p:pic>
-        <p:nvPicPr>
-          <p:cNvPr id="6" name="icon MdTravelExplore" descr="preencoded.png">    </p:cNvPr>
-          <p:cNvPicPr>
-            <a:picLocks noChangeAspect="1"/>
-          </p:cNvPicPr>
-          <p:nvPr/>
-        </p:nvPicPr>
-        <p:blipFill>
-          <a:blip r:embed="rId1"/>
-          <a:stretch>
-            <a:fillRect/>
-          </a:stretch>
-        </p:blipFill>
-        <p:spPr>
-          <a:xfrm>
-            <a:off x="881847" y="1841967"/>
-            <a:ext cx="266273" cy="266273"/>
-          </a:xfrm>
-          <a:prstGeom prst="rect">
-            <a:avLst/>
-          </a:prstGeom>
-        </p:spPr>
-      </p:pic>
-      <p:sp>
-        <p:nvSpPr>
-          <p:cNvPr id="7" name="card label"/>
+          <p:cNvPr id="44" name="card label"/>
           <p:cNvSpPr txBox="1"/>
           <p:nvPr/>
         </p:nvSpPr>
         <p:spPr>
           <a:xfrm>
-            <a:off x="1417320" y="1719072"/>
-            <a:ext cx="5486400" cy="237744"/>
+            <a:off x="731520" y="2706624"/>
+            <a:ext cx="2697480" cy="219456"/>
           </a:xfrm>
           <a:prstGeom prst="rect">
             <a:avLst/>
@@ -8944,12 +9561,12 @@
               <a:buNone/>
             </a:pPr>
             <a:r>
-              <a:rPr lang="en-US" sz="1300" b="1" spc="150" kern="0" dirty="0">
-                <a:solidFill>
-                  <a:schemeClr val="accent2"/>
-                </a:solidFill>
-              </a:rPr>
-              <a:t>OUTSIDE-IN RESEARCH LENS</a:t>
+              <a:rPr lang="en-US" sz="1200" b="1" spc="150" kern="0" dirty="0">
+                <a:solidFill>
+                  <a:srgbClr val="FF612B"/>
+                </a:solidFill>
+              </a:rPr>
+              <a:t>KEY FINDINGS</a:t>
             </a:r>
             <a:endParaRPr lang="en-US" sz="1300" dirty="0"/>
           </a:p>
@@ -8957,14 +9574,14 @@
       </p:sp>
       <p:sp>
         <p:nvSpPr>
-          <p:cNvPr id="8" name="Text 5"/>
+          <p:cNvPr id="45" name="hero 19"/>
           <p:cNvSpPr txBox="1"/>
           <p:nvPr/>
         </p:nvSpPr>
         <p:spPr>
           <a:xfrm>
-            <a:off x="1417320" y="2048256"/>
-            <a:ext cx="9966960" cy="201168"/>
+            <a:off x="621792" y="3054096"/>
+            <a:ext cx="566928" cy="420624"/>
           </a:xfrm>
           <a:prstGeom prst="rect">
             <a:avLst/>
@@ -8974,18 +9591,279 @@
         </p:spPr>
         <p:txBody>
           <a:bodyPr wrap="square" lIns="0" tIns="0" rIns="0" bIns="0" rtlCol="0" anchor="t"/>
+          <a:lstStyle/>
+          <a:p>
+            <a:pPr indent="0" marL="0" algn="ctr">
+              <a:buNone/>
+            </a:pPr>
+            <a:r>
+              <a:rPr lang="en-US" sz="2400" b="1" dirty="0">
+                <a:solidFill>
+                  <a:srgbClr val="FF612B"/>
+                </a:solidFill>
+              </a:rPr>
+              <a:t>19</a:t>
+            </a:r>
+            <a:endParaRPr lang="en-US" sz="3400" dirty="0"/>
+          </a:p>
+        </p:txBody>
+      </p:sp>
+      <p:sp>
+        <p:nvSpPr>
+          <p:cNvPr id="46" name="Text 29"/>
+          <p:cNvSpPr txBox="1"/>
+          <p:nvPr/>
+        </p:nvSpPr>
+        <p:spPr>
+          <a:xfrm>
+            <a:off x="1207007" y="3090672"/>
+            <a:ext cx="2240280" cy="475488"/>
+          </a:xfrm>
+          <a:prstGeom prst="rect">
+            <a:avLst/>
+          </a:prstGeom>
+          <a:noFill/>
+          <a:ln/>
+        </p:spPr>
+        <p:txBody>
+          <a:bodyPr wrap="square" lIns="0" tIns="0" rIns="0" bIns="0" rtlCol="0" anchor="t"/>
+          <a:lstStyle/>
+          <a:p>
+            <a:pPr indent="0" marL="0">
+              <a:spcAft>
+                <a:spcPts val="900"/>
+              </a:spcAft>
+              <a:buNone/>
+            </a:pPr>
+            <a:r>
+              <a:rPr lang="en-US" sz="950" dirty="0" b="1">
+                <a:solidFill>
+                  <a:srgbClr val="4B4D4F"/>
+                </a:solidFill>
+              </a:rPr>
+              <a:t>conversational AI offerings</a:t>
+            </a:r>
+            <a:r>
+              <a:rPr lang="en-US" sz="950" dirty="0">
+                <a:solidFill>
+                  <a:srgbClr val="4B4D4F"/>
+                </a:solidFill>
+              </a:rPr>
+              <a:t>, marketed by </a:t>
+            </a:r>
+            <a:r>
+              <a:rPr lang="en-US" sz="950" dirty="0" b="1">
+                <a:solidFill>
+                  <a:srgbClr val="4B4D4F"/>
+                </a:solidFill>
+              </a:rPr>
+              <a:t>15 of 43 U.S. competitors</a:t>
+            </a:r>
+            <a:endParaRPr lang="en-US" sz="1100" dirty="0"/>
+          </a:p>
+        </p:txBody>
+      </p:sp>
+      <p:sp>
+        <p:nvSpPr>
+          <p:cNvPr id="47" name="hero 19"/>
+          <p:cNvSpPr txBox="1"/>
+          <p:nvPr/>
+        </p:nvSpPr>
+        <p:spPr>
+          <a:xfrm>
+            <a:off x="621792" y="3694176"/>
+            <a:ext cx="566928" cy="420624"/>
+          </a:xfrm>
+          <a:prstGeom prst="rect">
+            <a:avLst/>
+          </a:prstGeom>
+          <a:noFill/>
+          <a:ln/>
+        </p:spPr>
+        <p:txBody>
+          <a:bodyPr wrap="square" lIns="0" tIns="0" rIns="0" bIns="0" rtlCol="0" anchor="t"/>
+          <a:lstStyle/>
+          <a:p>
+            <a:pPr indent="0" marL="0" algn="ctr">
+              <a:buNone/>
+            </a:pPr>
+            <a:r>
+              <a:rPr lang="en-US" sz="2400" b="1" dirty="0">
+                <a:solidFill>
+                  <a:srgbClr val="FF612B"/>
+                </a:solidFill>
+              </a:rPr>
+              <a:t>9</a:t>
+            </a:r>
+            <a:endParaRPr lang="en-US" sz="3400" dirty="0"/>
+          </a:p>
+        </p:txBody>
+      </p:sp>
+      <p:sp>
+        <p:nvSpPr>
+          <p:cNvPr id="48" name="Text 29"/>
+          <p:cNvSpPr txBox="1"/>
+          <p:nvPr/>
+        </p:nvSpPr>
+        <p:spPr>
+          <a:xfrm>
+            <a:off x="1207007" y="3730752"/>
+            <a:ext cx="2240280" cy="475488"/>
+          </a:xfrm>
+          <a:prstGeom prst="rect">
+            <a:avLst/>
+          </a:prstGeom>
+          <a:noFill/>
+          <a:ln/>
+        </p:spPr>
+        <p:txBody>
+          <a:bodyPr wrap="square" lIns="0" tIns="0" rIns="0" bIns="0" rtlCol="0" anchor="t"/>
+          <a:lstStyle/>
+          <a:p>
+            <a:pPr indent="0" marL="0">
+              <a:spcAft>
+                <a:spcPts val="900"/>
+              </a:spcAft>
+              <a:buNone/>
+            </a:pPr>
+            <a:r>
+              <a:rPr lang="en-US" sz="950" dirty="0" b="1">
+                <a:solidFill>
+                  <a:srgbClr val="4B4D4F"/>
+                </a:solidFill>
+              </a:rPr>
+              <a:t>of 34 RWE competitors</a:t>
+            </a:r>
+            <a:r>
+              <a:rPr lang="en-US" sz="950" dirty="0">
+                <a:solidFill>
+                  <a:srgbClr val="4B4D4F"/>
+                </a:solidFill>
+              </a:rPr>
+              <a:t> market one, the highest share of any domain</a:t>
+            </a:r>
+            <a:endParaRPr lang="en-US" sz="1100" dirty="0"/>
+          </a:p>
+        </p:txBody>
+      </p:sp>
+      <p:sp>
+        <p:nvSpPr>
+          <p:cNvPr id="49" name="research scope card"/>
+          <p:cNvSpPr/>
+          <p:nvPr/>
+        </p:nvSpPr>
+        <p:spPr>
+          <a:xfrm>
+            <a:off x="3758184" y="2578608"/>
+            <a:ext cx="7882127" cy="1810512"/>
+          </a:xfrm>
+          <a:prstGeom prst="rect">
+            <a:avLst/>
+          </a:prstGeom>
+          <a:solidFill>
+            <a:schemeClr val="bg1"/>
+          </a:solidFill>
+          <a:ln/>
+          <a:effectLst>
+            <a:outerShdw sx="100000" sy="100000" kx="0" ky="0" algn="bl" rotWithShape="0" blurRad="101600" dist="25400" dir="5400000">
+              <a:srgbClr val="000000">
+                <a:alpha val="10000"/>
+              </a:srgbClr>
+            </a:outerShdw>
+          </a:effectLst>
+        </p:spPr>
+        <p:txBody>
+          <a:bodyPr/>
+          <a:p/>
+        </p:txBody>
+      </p:sp>
+      <p:sp>
+        <p:nvSpPr>
+          <p:cNvPr id="50" name="card label"/>
+          <p:cNvSpPr txBox="1"/>
+          <p:nvPr/>
+        </p:nvSpPr>
+        <p:spPr>
+          <a:xfrm>
+            <a:off x="3959352" y="2706624"/>
+            <a:ext cx="7479792" cy="219456"/>
+          </a:xfrm>
+          <a:prstGeom prst="rect">
+            <a:avLst/>
+          </a:prstGeom>
+          <a:noFill/>
+          <a:ln/>
+        </p:spPr>
+        <p:txBody>
+          <a:bodyPr wrap="square" lIns="0" tIns="0" rIns="0" bIns="0" rtlCol="0" anchor="ctr"/>
           <a:lstStyle/>
           <a:p>
             <a:pPr indent="0" marL="0">
               <a:buNone/>
             </a:pPr>
             <a:r>
-              <a:rPr lang="en-US" sz="1100" b="1" dirty="0">
-                <a:solidFill>
-                  <a:schemeClr val="tx1"/>
-                </a:solidFill>
-              </a:rPr>
-              <a:t>An assessment of publicly marketed conversational AI across five domains where Optum LS publicly markets offerings:</a:t>
+              <a:rPr lang="en-US" sz="1200" b="1" spc="150" kern="0" dirty="0">
+                <a:solidFill>
+                  <a:srgbClr val="FF612B"/>
+                </a:solidFill>
+              </a:rPr>
+              <a:t>RESEARCH SCOPE</a:t>
+            </a:r>
+            <a:endParaRPr lang="en-US" sz="1300" dirty="0"/>
+          </a:p>
+        </p:txBody>
+      </p:sp>
+      <p:sp>
+        <p:nvSpPr>
+          <p:cNvPr id="51" name="Text 29"/>
+          <p:cNvSpPr txBox="1"/>
+          <p:nvPr/>
+        </p:nvSpPr>
+        <p:spPr>
+          <a:xfrm>
+            <a:off x="3959352" y="3113532"/>
+            <a:ext cx="7479792" cy="420624"/>
+          </a:xfrm>
+          <a:prstGeom prst="rect">
+            <a:avLst/>
+          </a:prstGeom>
+          <a:noFill/>
+          <a:ln/>
+        </p:spPr>
+        <p:txBody>
+          <a:bodyPr wrap="square" lIns="0" tIns="0" rIns="0" bIns="0" rtlCol="0" anchor="t"/>
+          <a:lstStyle/>
+          <a:p>
+            <a:pPr indent="0" marL="0">
+              <a:spcAft>
+                <a:spcPts val="900"/>
+              </a:spcAft>
+              <a:buNone/>
+            </a:pPr>
+            <a:r>
+              <a:rPr lang="en-US" sz="1050" dirty="0">
+                <a:solidFill>
+                  <a:srgbClr val="4B4D4F"/>
+                </a:solidFill>
+              </a:rPr>
+              <a:t>Competitor products were sorted by customer task rather than by vendor, to match each with a specific Optum LS offering.</a:t>
+            </a:r>
+            <a:endParaRPr lang="en-US" sz="1100" dirty="0"/>
+          </a:p>
+          <a:p>
+            <a:pPr indent="0" marL="0">
+              <a:spcAft>
+                <a:spcPts val="900"/>
+              </a:spcAft>
+              <a:buNone/>
+            </a:pPr>
+            <a:r>
+              <a:rPr lang="en-US" sz="1050" dirty="0">
+                <a:solidFill>
+                  <a:srgbClr val="4B4D4F"/>
+                </a:solidFill>
+              </a:rPr>
+              <a:t>Those tasks were then grouped into five domains where both Optum LS and its competitors publicly market products:</a:t>
             </a:r>
             <a:endParaRPr lang="en-US" sz="1100" dirty="0"/>
           </a:p>
@@ -8999,7 +9877,7 @@
         </p:nvSpPr>
         <p:spPr>
           <a:xfrm>
-            <a:off x="1417320" y="2322576"/>
+            <a:off x="3959352" y="3721608"/>
             <a:ext cx="422727" cy="246888"/>
           </a:xfrm>
           <a:prstGeom prst="roundRect">
@@ -9030,7 +9908,7 @@
         </p:nvSpPr>
         <p:spPr>
           <a:xfrm>
-            <a:off x="1417320" y="2322576"/>
+            <a:off x="3959352" y="3721608"/>
             <a:ext cx="422727" cy="246888"/>
           </a:xfrm>
           <a:prstGeom prst="rect">
@@ -9066,7 +9944,7 @@
         </p:nvSpPr>
         <p:spPr>
           <a:xfrm>
-            <a:off x="1931487" y="2322576"/>
+            <a:off x="4473519" y="3721608"/>
             <a:ext cx="1777868" cy="246888"/>
           </a:xfrm>
           <a:prstGeom prst="roundRect">
@@ -9097,7 +9975,7 @@
         </p:nvSpPr>
         <p:spPr>
           <a:xfrm>
-            <a:off x="1931487" y="2322576"/>
+            <a:off x="4473519" y="3721608"/>
             <a:ext cx="1777868" cy="246888"/>
           </a:xfrm>
           <a:prstGeom prst="rect">
@@ -9133,7 +10011,7 @@
         </p:nvSpPr>
         <p:spPr>
           <a:xfrm>
-            <a:off x="3800795" y="2322576"/>
+            <a:off x="6342827" y="3721608"/>
             <a:ext cx="2184410" cy="246888"/>
           </a:xfrm>
           <a:prstGeom prst="roundRect">
@@ -9164,7 +10042,7 @@
         </p:nvSpPr>
         <p:spPr>
           <a:xfrm>
-            <a:off x="3800795" y="2322576"/>
+            <a:off x="6342827" y="3721608"/>
             <a:ext cx="2184410" cy="246888"/>
           </a:xfrm>
           <a:prstGeom prst="rect">
@@ -9200,7 +10078,7 @@
         </p:nvSpPr>
         <p:spPr>
           <a:xfrm>
-            <a:off x="6076645" y="2322576"/>
+            <a:off x="8618677" y="3721608"/>
             <a:ext cx="1235812" cy="246888"/>
           </a:xfrm>
           <a:prstGeom prst="roundRect">
@@ -9231,7 +10109,7 @@
         </p:nvSpPr>
         <p:spPr>
           <a:xfrm>
-            <a:off x="6076645" y="2322576"/>
+            <a:off x="8618677" y="3721608"/>
             <a:ext cx="1235812" cy="246888"/>
           </a:xfrm>
           <a:prstGeom prst="rect">
@@ -9267,7 +10145,7 @@
         </p:nvSpPr>
         <p:spPr>
           <a:xfrm>
-            <a:off x="7403897" y="2322576"/>
+            <a:off x="9945929" y="3721608"/>
             <a:ext cx="310896" cy="246888"/>
           </a:xfrm>
           <a:prstGeom prst="rect">
@@ -9303,7 +10181,7 @@
         </p:nvSpPr>
         <p:spPr>
           <a:xfrm>
-            <a:off x="7769657" y="2322576"/>
+            <a:off x="10311689" y="3721608"/>
             <a:ext cx="1100298" cy="246888"/>
           </a:xfrm>
           <a:prstGeom prst="roundRect">
@@ -9334,7 +10212,7 @@
         </p:nvSpPr>
         <p:spPr>
           <a:xfrm>
-            <a:off x="7769657" y="2322576"/>
+            <a:off x="10311689" y="3721608"/>
             <a:ext cx="1100298" cy="246888"/>
           </a:xfrm>
           <a:prstGeom prst="rect">
@@ -9364,35 +10242,118 @@
       </p:sp>
       <p:sp>
         <p:nvSpPr>
-          <p:cNvPr id="20" name="Text 17"/>
+          <p:cNvPr id="52" name="aside rule"/>
+          <p:cNvSpPr/>
+          <p:nvPr/>
+        </p:nvSpPr>
+        <p:spPr>
+          <a:xfrm>
+            <a:off x="548640" y="4672584"/>
+            <a:ext cx="32004" cy="1115568"/>
+          </a:xfrm>
+          <a:prstGeom prst="rect">
+            <a:avLst/>
+          </a:prstGeom>
+          <a:solidFill>
+            <a:srgbClr val="D9D4C7"/>
+          </a:solidFill>
+          <a:ln>
+            <a:noFill/>
+          </a:ln>
+          <a:effectLst/>
+        </p:spPr>
+        <p:style>
+          <a:lnRef idx="1">
+            <a:schemeClr val="accent1"/>
+          </a:lnRef>
+          <a:fillRef idx="3">
+            <a:schemeClr val="accent1"/>
+          </a:fillRef>
+          <a:effectRef idx="2">
+            <a:schemeClr val="accent1"/>
+          </a:effectRef>
+          <a:fontRef idx="minor">
+            <a:schemeClr val="lt1"/>
+          </a:fontRef>
+        </p:style>
+        <p:txBody>
+          <a:bodyPr rtlCol="0" anchor="ctr"/>
+          <a:lstStyle/>
+          <a:p>
+            <a:pPr algn="ctr"/>
+          </a:p>
+        </p:txBody>
+      </p:sp>
+      <p:sp>
+        <p:nvSpPr>
+          <p:cNvPr id="53" name="card label"/>
           <p:cNvSpPr txBox="1"/>
           <p:nvPr/>
         </p:nvSpPr>
         <p:spPr>
           <a:xfrm>
-            <a:off x="1417320" y="2651760"/>
-            <a:ext cx="9966960" cy="201168"/>
-          </a:xfrm>
-          <a:prstGeom prst="rect">
-            <a:avLst/>
-          </a:prstGeom>
-          <a:noFill/>
-          <a:ln/>
-        </p:spPr>
-        <p:txBody>
-          <a:bodyPr wrap="square" lIns="0" tIns="0" rIns="0" bIns="0" rtlCol="0" anchor="t"/>
+            <a:off x="694944" y="4672584"/>
+            <a:ext cx="2843784" cy="329184"/>
+          </a:xfrm>
+          <a:prstGeom prst="rect">
+            <a:avLst/>
+          </a:prstGeom>
+          <a:noFill/>
+          <a:ln/>
+        </p:spPr>
+        <p:txBody>
+          <a:bodyPr wrap="square" lIns="0" tIns="0" rIns="0" bIns="0" rtlCol="0" anchor="ctr"/>
           <a:lstStyle/>
           <a:p>
             <a:pPr indent="0" marL="0">
               <a:buNone/>
             </a:pPr>
             <a:r>
-              <a:rPr lang="en-US" sz="1100" b="1" dirty="0">
-                <a:solidFill>
-                  <a:schemeClr val="tx1"/>
-                </a:solidFill>
-              </a:rPr>
-              <a:t>The U.S. is the primary focus; selected international offerings add context.</a:t>
+              <a:rPr lang="en-US" sz="900" b="1" spc="100" kern="0" dirty="0">
+                <a:solidFill>
+                  <a:srgbClr val="7A7C7E"/>
+                </a:solidFill>
+              </a:rPr>
+              <a:t>WHAT COUNTS AS CONVERSATIONAL AI?</a:t>
+            </a:r>
+            <a:endParaRPr lang="en-US" sz="1300" dirty="0"/>
+          </a:p>
+        </p:txBody>
+      </p:sp>
+      <p:sp>
+        <p:nvSpPr>
+          <p:cNvPr id="54" name="Text 29"/>
+          <p:cNvSpPr txBox="1"/>
+          <p:nvPr/>
+        </p:nvSpPr>
+        <p:spPr>
+          <a:xfrm>
+            <a:off x="694944" y="5001768"/>
+            <a:ext cx="2843784" cy="786384"/>
+          </a:xfrm>
+          <a:prstGeom prst="rect">
+            <a:avLst/>
+          </a:prstGeom>
+          <a:noFill/>
+          <a:ln/>
+        </p:spPr>
+        <p:txBody>
+          <a:bodyPr wrap="square" lIns="0" tIns="0" rIns="0" bIns="0" rtlCol="0" anchor="t"/>
+          <a:lstStyle/>
+          <a:p>
+            <a:pPr indent="0" marL="0">
+              <a:spcAft>
+                <a:spcPts val="900"/>
+              </a:spcAft>
+              <a:buNone/>
+            </a:pPr>
+            <a:r>
+              <a:rPr lang="en-US" sz="900" dirty="0">
+                <a:solidFill>
+                  <a:srgbClr val="7A7C7E"/>
+                </a:solidFill>
+              </a:rPr>
+              <a:t>A publicly marketed interface that lets life-sciences customers use natural language to interact with data, research or business workflows. Exclude patient-facing chatbots, clinician scribes and AI without a natural-language interface.</a:t>
             </a:r>
             <a:endParaRPr lang="en-US" sz="1100" dirty="0"/>
           </a:p>
@@ -9400,14 +10361,14 @@
       </p:sp>
       <p:sp>
         <p:nvSpPr>
-          <p:cNvPr id="21" name="key findings card"/>
+          <p:cNvPr id="55" name="optum ls positioning card"/>
           <p:cNvSpPr/>
           <p:nvPr/>
         </p:nvSpPr>
         <p:spPr>
           <a:xfrm>
-            <a:off x="548640" y="3218688"/>
-            <a:ext cx="3575304" cy="2834640"/>
+            <a:off x="3758184" y="4544568"/>
+            <a:ext cx="7882127" cy="1508759"/>
           </a:xfrm>
           <a:prstGeom prst="rect">
             <a:avLst/>
@@ -9431,62 +10392,14 @@
       </p:sp>
       <p:sp>
         <p:nvSpPr>
-          <p:cNvPr id="22" name="icon circle"/>
-          <p:cNvSpPr/>
-          <p:nvPr/>
-        </p:nvSpPr>
-        <p:spPr>
-          <a:xfrm>
-            <a:off x="777240" y="3419856"/>
-            <a:ext cx="457200" cy="457200"/>
-          </a:xfrm>
-          <a:prstGeom prst="ellipse">
-            <a:avLst/>
-          </a:prstGeom>
-          <a:solidFill>
-            <a:schemeClr val="accent5"/>
-          </a:solidFill>
-          <a:ln/>
-        </p:spPr>
-        <p:txBody>
-          <a:bodyPr/>
-          <a:p/>
-        </p:txBody>
-      </p:sp>
-      <p:pic>
-        <p:nvPicPr>
-          <p:cNvPr id="23" name="icon MdInsights" descr="preencoded.png">    </p:cNvPr>
-          <p:cNvPicPr>
-            <a:picLocks noChangeAspect="1"/>
-          </p:cNvPicPr>
-          <p:nvPr/>
-        </p:nvPicPr>
-        <p:blipFill>
-          <a:blip r:embed="rId2"/>
-          <a:stretch>
-            <a:fillRect/>
-          </a:stretch>
-        </p:blipFill>
-        <p:spPr>
-          <a:xfrm>
-            <a:off x="877824" y="3520440"/>
-            <a:ext cx="256032" cy="256032"/>
-          </a:xfrm>
-          <a:prstGeom prst="rect">
-            <a:avLst/>
-          </a:prstGeom>
-        </p:spPr>
-      </p:pic>
-      <p:sp>
-        <p:nvSpPr>
-          <p:cNvPr id="24" name="card label"/>
+          <p:cNvPr id="56" name="card label"/>
           <p:cNvSpPr txBox="1"/>
           <p:nvPr/>
         </p:nvSpPr>
         <p:spPr>
           <a:xfrm>
-            <a:off x="1353312" y="3511296"/>
-            <a:ext cx="2660904" cy="237744"/>
+            <a:off x="3959352" y="4672584"/>
+            <a:ext cx="3657600" cy="219456"/>
           </a:xfrm>
           <a:prstGeom prst="rect">
             <a:avLst/>
@@ -9502,12 +10415,12 @@
               <a:buNone/>
             </a:pPr>
             <a:r>
-              <a:rPr lang="en-US" sz="1300" b="1" spc="150" kern="0" dirty="0">
-                <a:solidFill>
-                  <a:schemeClr val="accent2"/>
-                </a:solidFill>
-              </a:rPr>
-              <a:t>KEY FINDINGS</a:t>
+              <a:rPr lang="en-US" sz="1200" b="1" spc="150" kern="0" dirty="0">
+                <a:solidFill>
+                  <a:srgbClr val="FF612B"/>
+                </a:solidFill>
+              </a:rPr>
+              <a:t>OPTUM LS POSITIONING</a:t>
             </a:r>
             <a:endParaRPr lang="en-US" sz="1300" dirty="0"/>
           </a:p>
@@ -9515,332 +10428,14 @@
       </p:sp>
       <p:sp>
         <p:nvSpPr>
-          <p:cNvPr id="25" name="hero 19"/>
+          <p:cNvPr id="57" name="Text 29"/>
           <p:cNvSpPr txBox="1"/>
           <p:nvPr/>
         </p:nvSpPr>
         <p:spPr>
           <a:xfrm>
-            <a:off x="777240" y="4069080"/>
-            <a:ext cx="621792" cy="502920"/>
-          </a:xfrm>
-          <a:prstGeom prst="rect">
-            <a:avLst/>
-          </a:prstGeom>
-          <a:noFill/>
-          <a:ln/>
-        </p:spPr>
-        <p:txBody>
-          <a:bodyPr wrap="square" lIns="0" tIns="0" rIns="0" bIns="0" rtlCol="0" anchor="t"/>
-          <a:lstStyle/>
-          <a:p>
-            <a:pPr indent="0" marL="0" algn="ctr">
-              <a:buNone/>
-            </a:pPr>
-            <a:r>
-              <a:rPr lang="en-US" sz="3400" b="1" dirty="0">
-                <a:solidFill>
-                  <a:schemeClr val="accent2"/>
-                </a:solidFill>
-              </a:rPr>
-              <a:t>19</a:t>
-            </a:r>
-            <a:endParaRPr lang="en-US" sz="3400" dirty="0"/>
-          </a:p>
-        </p:txBody>
-      </p:sp>
-      <p:sp>
-        <p:nvSpPr>
-          <p:cNvPr id="26" name="Text 22"/>
-          <p:cNvSpPr txBox="1"/>
-          <p:nvPr/>
-        </p:nvSpPr>
-        <p:spPr>
-          <a:xfrm>
-            <a:off x="1444752" y="4133088"/>
-            <a:ext cx="2478024" cy="749808"/>
-          </a:xfrm>
-          <a:prstGeom prst="rect">
-            <a:avLst/>
-          </a:prstGeom>
-          <a:noFill/>
-          <a:ln/>
-        </p:spPr>
-        <p:txBody>
-          <a:bodyPr wrap="square" lIns="0" tIns="0" rIns="0" bIns="0" rtlCol="0" anchor="t"/>
-          <a:lstStyle/>
-          <a:p>
-            <a:pPr indent="0" marL="0">
-              <a:buNone/>
-            </a:pPr>
-            <a:r>
-              <a:rPr lang="en-US" sz="1050" dirty="0" b="1">
-                <a:solidFill>
-                  <a:schemeClr val="tx1"/>
-                </a:solidFill>
-              </a:rPr>
-              <a:t>conversational AI offerings</a:t>
-            </a:r>
-            <a:r>
-              <a:rPr lang="en-US" sz="1050" dirty="0">
-                <a:solidFill>
-                  <a:schemeClr val="tx1"/>
-                </a:solidFill>
-              </a:rPr>
-              <a:t> marketed by </a:t>
-            </a:r>
-            <a:r>
-              <a:rPr lang="en-US" sz="1050" dirty="0" b="1">
-                <a:solidFill>
-                  <a:schemeClr val="tx1"/>
-                </a:solidFill>
-              </a:rPr>
-              <a:t>15 of 43 U.S. competitors</a:t>
-            </a:r>
-            <a:r>
-              <a:rPr lang="en-US" sz="1050" dirty="0">
-                <a:solidFill>
-                  <a:schemeClr val="tx1"/>
-                </a:solidFill>
-              </a:rPr>
-              <a:t>.</a:t>
-            </a:r>
-            <a:endParaRPr lang="en-US" sz="1050" dirty="0"/>
-          </a:p>
-        </p:txBody>
-      </p:sp>
-      <p:sp>
-        <p:nvSpPr>
-          <p:cNvPr id="27" name="Shape 23"/>
-          <p:cNvSpPr/>
-          <p:nvPr/>
-        </p:nvSpPr>
-        <p:spPr>
-          <a:xfrm>
-            <a:off x="777240" y="5010912"/>
-            <a:ext cx="3118104" cy="0"/>
-          </a:xfrm>
-          <a:prstGeom prst="line">
-            <a:avLst/>
-          </a:prstGeom>
-          <a:noFill/>
-          <a:ln w="9525">
-            <a:solidFill>
-              <a:schemeClr val="accent3"/>
-            </a:solidFill>
-            <a:prstDash val="solid"/>
-          </a:ln>
-        </p:spPr>
-        <p:txBody>
-          <a:bodyPr/>
-          <a:p/>
-        </p:txBody>
-      </p:sp>
-      <p:sp>
-        <p:nvSpPr>
-          <p:cNvPr id="28" name="hero 10"/>
-          <p:cNvSpPr txBox="1"/>
-          <p:nvPr/>
-        </p:nvSpPr>
-        <p:spPr>
-          <a:xfrm>
-            <a:off x="777240" y="5056632"/>
-            <a:ext cx="621792" cy="502920"/>
-          </a:xfrm>
-          <a:prstGeom prst="rect">
-            <a:avLst/>
-          </a:prstGeom>
-          <a:noFill/>
-          <a:ln/>
-        </p:spPr>
-        <p:txBody>
-          <a:bodyPr wrap="square" lIns="0" tIns="0" rIns="0" bIns="0" rtlCol="0" anchor="t"/>
-          <a:lstStyle/>
-          <a:p>
-            <a:pPr indent="0" marL="0" algn="ctr">
-              <a:buNone/>
-            </a:pPr>
-            <a:r>
-              <a:rPr lang="en-US" sz="3400" b="1" dirty="0">
-                <a:solidFill>
-                  <a:schemeClr val="accent2"/>
-                </a:solidFill>
-              </a:rPr>
-              <a:t>9</a:t>
-            </a:r>
-            <a:endParaRPr lang="en-US" sz="3400" dirty="0"/>
-          </a:p>
-        </p:txBody>
-      </p:sp>
-      <p:sp>
-        <p:nvSpPr>
-          <p:cNvPr id="29" name="Text 25"/>
-          <p:cNvSpPr txBox="1"/>
-          <p:nvPr/>
-        </p:nvSpPr>
-        <p:spPr>
-          <a:xfrm>
-            <a:off x="1444752" y="5120640"/>
-            <a:ext cx="2478024" cy="749808"/>
-          </a:xfrm>
-          <a:prstGeom prst="rect">
-            <a:avLst/>
-          </a:prstGeom>
-          <a:noFill/>
-          <a:ln/>
-        </p:spPr>
-        <p:txBody>
-          <a:bodyPr wrap="square" lIns="0" tIns="0" rIns="0" bIns="0" rtlCol="0" anchor="t"/>
-          <a:lstStyle/>
-          <a:p>
-            <a:pPr indent="0" marL="0">
-              <a:buNone/>
-            </a:pPr>
-            <a:r>
-              <a:rPr lang="en-US" sz="1050" b="1" dirty="0">
-                <a:solidFill>
-                  <a:schemeClr val="tx1"/>
-                </a:solidFill>
-              </a:rPr>
-              <a:t>of 34 RWE competitors</a:t>
-            </a:r>
-            <a:r>
-              <a:rPr lang="en-US" sz="1050" dirty="0">
-                <a:solidFill>
-                  <a:schemeClr val="tx1"/>
-                </a:solidFill>
-              </a:rPr>
-              <a:t> market one, the highest share of any domain; trials and market access have one each.</a:t>
-            </a:r>
-            <a:endParaRPr lang="en-US" sz="1050" dirty="0"/>
-          </a:p>
-        </p:txBody>
-      </p:sp>
-      <p:sp>
-        <p:nvSpPr>
-          <p:cNvPr id="30" name="optum ls positioning card"/>
-          <p:cNvSpPr/>
-          <p:nvPr/>
-        </p:nvSpPr>
-        <p:spPr>
-          <a:xfrm>
-            <a:off x="4306824" y="3218688"/>
-            <a:ext cx="3575304" cy="2834640"/>
-          </a:xfrm>
-          <a:prstGeom prst="rect">
-            <a:avLst/>
-          </a:prstGeom>
-          <a:solidFill>
-            <a:schemeClr val="bg1"/>
-          </a:solidFill>
-          <a:ln/>
-          <a:effectLst>
-            <a:outerShdw sx="100000" sy="100000" kx="0" ky="0" algn="bl" rotWithShape="0" blurRad="101600" dist="25400" dir="5400000">
-              <a:srgbClr val="000000">
-                <a:alpha val="10000"/>
-              </a:srgbClr>
-            </a:outerShdw>
-          </a:effectLst>
-        </p:spPr>
-        <p:txBody>
-          <a:bodyPr/>
-          <a:p/>
-        </p:txBody>
-      </p:sp>
-      <p:sp>
-        <p:nvSpPr>
-          <p:cNvPr id="31" name="icon circle"/>
-          <p:cNvSpPr/>
-          <p:nvPr/>
-        </p:nvSpPr>
-        <p:spPr>
-          <a:xfrm>
-            <a:off x="4535424" y="3419856"/>
-            <a:ext cx="457200" cy="457200"/>
-          </a:xfrm>
-          <a:prstGeom prst="ellipse">
-            <a:avLst/>
-          </a:prstGeom>
-          <a:solidFill>
-            <a:schemeClr val="accent5"/>
-          </a:solidFill>
-          <a:ln/>
-        </p:spPr>
-        <p:txBody>
-          <a:bodyPr/>
-          <a:p/>
-        </p:txBody>
-      </p:sp>
-      <p:pic>
-        <p:nvPicPr>
-          <p:cNvPr id="32" name="icon MdOutlineLayers" descr="preencoded.png">    </p:cNvPr>
-          <p:cNvPicPr>
-            <a:picLocks noChangeAspect="1"/>
-          </p:cNvPicPr>
-          <p:nvPr/>
-        </p:nvPicPr>
-        <p:blipFill>
-          <a:blip r:embed="rId3"/>
-          <a:stretch>
-            <a:fillRect/>
-          </a:stretch>
-        </p:blipFill>
-        <p:spPr>
-          <a:xfrm>
-            <a:off x="4636008" y="3520440"/>
-            <a:ext cx="256032" cy="256032"/>
-          </a:xfrm>
-          <a:prstGeom prst="rect">
-            <a:avLst/>
-          </a:prstGeom>
-        </p:spPr>
-      </p:pic>
-      <p:sp>
-        <p:nvSpPr>
-          <p:cNvPr id="33" name="card label"/>
-          <p:cNvSpPr txBox="1"/>
-          <p:nvPr/>
-        </p:nvSpPr>
-        <p:spPr>
-          <a:xfrm>
-            <a:off x="5111496" y="3511296"/>
-            <a:ext cx="2660904" cy="237744"/>
-          </a:xfrm>
-          <a:prstGeom prst="rect">
-            <a:avLst/>
-          </a:prstGeom>
-          <a:noFill/>
-          <a:ln/>
-        </p:spPr>
-        <p:txBody>
-          <a:bodyPr wrap="square" lIns="0" tIns="0" rIns="0" bIns="0" rtlCol="0" anchor="ctr"/>
-          <a:lstStyle/>
-          <a:p>
-            <a:pPr indent="0" marL="0">
-              <a:buNone/>
-            </a:pPr>
-            <a:r>
-              <a:rPr lang="en-US" sz="1300" b="1" spc="150" kern="0" dirty="0">
-                <a:solidFill>
-                  <a:schemeClr val="accent2"/>
-                </a:solidFill>
-              </a:rPr>
-              <a:t>OPTUM LS POSITIONING</a:t>
-            </a:r>
-            <a:endParaRPr lang="en-US" sz="1300" dirty="0"/>
-          </a:p>
-        </p:txBody>
-      </p:sp>
-      <p:sp>
-        <p:nvSpPr>
-          <p:cNvPr id="34" name="Text 29"/>
-          <p:cNvSpPr txBox="1"/>
-          <p:nvPr/>
-        </p:nvSpPr>
-        <p:spPr>
-          <a:xfrm>
-            <a:off x="4535424" y="4087368"/>
-            <a:ext cx="3118104" cy="1645920"/>
+            <a:off x="3959352" y="5001768"/>
+            <a:ext cx="7479792" cy="960119"/>
           </a:xfrm>
           <a:prstGeom prst="rect">
             <a:avLst/>
@@ -9859,9 +10454,9 @@
               <a:buNone/>
             </a:pPr>
             <a:r>
-              <a:rPr lang="en-US" sz="1100" dirty="0">
-                <a:solidFill>
-                  <a:schemeClr val="tx1"/>
+              <a:rPr lang="en-US" sz="1050" dirty="0">
+                <a:solidFill>
+                  <a:srgbClr val="4B4D4F"/>
                 </a:solidFill>
               </a:rPr>
               <a:t>Optum LS publicly emphasizes linked healthcare data, AI-enabled research tools and scientific expertise.</a:t>
@@ -9876,12 +10471,12 @@
               <a:buNone/>
             </a:pPr>
             <a:r>
-              <a:rPr lang="en-US" sz="1100" dirty="0">
-                <a:solidFill>
-                  <a:schemeClr val="tx1"/>
-                </a:solidFill>
-              </a:rPr>
-              <a:t>Several competitors lead with a conversational interface for comparable tasks.</a:t>
+              <a:rPr lang="en-US" sz="1050" dirty="0">
+                <a:solidFill>
+                  <a:srgbClr val="4B4D4F"/>
+                </a:solidFill>
+              </a:rPr>
+              <a:t>Several competitors lead with conversational AI for comparable tasks.</a:t>
             </a:r>
             <a:endParaRPr lang="en-US" sz="1100" dirty="0"/>
           </a:p>
@@ -9893,274 +10488,14 @@
               <a:buNone/>
             </a:pPr>
             <a:r>
-              <a:rPr lang="en-US" sz="1100" b="1" dirty="0">
-                <a:solidFill>
-                  <a:schemeClr val="accent1"/>
+              <a:rPr lang="en-US" sz="1050" b="1" dirty="0">
+                <a:solidFill>
+                  <a:srgbClr val="002677"/>
                 </a:solidFill>
               </a:rPr>
               <a:t>This analysis assumes Optum LS is developing or evaluating its own.</a:t>
             </a:r>
             <a:endParaRPr lang="en-US" sz="1100" dirty="0"/>
-          </a:p>
-        </p:txBody>
-      </p:sp>
-      <p:sp>
-        <p:nvSpPr>
-          <p:cNvPr id="35" name="strategic implication card"/>
-          <p:cNvSpPr/>
-          <p:nvPr/>
-        </p:nvSpPr>
-        <p:spPr>
-          <a:xfrm>
-            <a:off x="8065008" y="3218688"/>
-            <a:ext cx="3575304" cy="2834640"/>
-          </a:xfrm>
-          <a:prstGeom prst="rect">
-            <a:avLst/>
-          </a:prstGeom>
-          <a:solidFill>
-            <a:schemeClr val="bg1"/>
-          </a:solidFill>
-          <a:ln/>
-          <a:effectLst>
-            <a:outerShdw sx="100000" sy="100000" kx="0" ky="0" algn="bl" rotWithShape="0" blurRad="101600" dist="25400" dir="5400000">
-              <a:srgbClr val="000000">
-                <a:alpha val="10000"/>
-              </a:srgbClr>
-            </a:outerShdw>
-          </a:effectLst>
-        </p:spPr>
-        <p:txBody>
-          <a:bodyPr/>
-          <a:p/>
-        </p:txBody>
-      </p:sp>
-      <p:sp>
-        <p:nvSpPr>
-          <p:cNvPr id="36" name="icon circle"/>
-          <p:cNvSpPr/>
-          <p:nvPr/>
-        </p:nvSpPr>
-        <p:spPr>
-          <a:xfrm>
-            <a:off x="8293608" y="3419856"/>
-            <a:ext cx="457200" cy="457200"/>
-          </a:xfrm>
-          <a:prstGeom prst="ellipse">
-            <a:avLst/>
-          </a:prstGeom>
-          <a:solidFill>
-            <a:schemeClr val="accent5"/>
-          </a:solidFill>
-          <a:ln/>
-        </p:spPr>
-        <p:txBody>
-          <a:bodyPr/>
-          <a:p/>
-        </p:txBody>
-      </p:sp>
-      <p:pic>
-        <p:nvPicPr>
-          <p:cNvPr id="37" name="icon MdOutlineLightbulb" descr="preencoded.png">    </p:cNvPr>
-          <p:cNvPicPr>
-            <a:picLocks noChangeAspect="1"/>
-          </p:cNvPicPr>
-          <p:nvPr/>
-        </p:nvPicPr>
-        <p:blipFill>
-          <a:blip r:embed="rId4"/>
-          <a:stretch>
-            <a:fillRect/>
-          </a:stretch>
-        </p:blipFill>
-        <p:spPr>
-          <a:xfrm>
-            <a:off x="8394192" y="3520440"/>
-            <a:ext cx="256032" cy="256032"/>
-          </a:xfrm>
-          <a:prstGeom prst="rect">
-            <a:avLst/>
-          </a:prstGeom>
-        </p:spPr>
-      </p:pic>
-      <p:sp>
-        <p:nvSpPr>
-          <p:cNvPr id="38" name="card label"/>
-          <p:cNvSpPr txBox="1"/>
-          <p:nvPr/>
-        </p:nvSpPr>
-        <p:spPr>
-          <a:xfrm>
-            <a:off x="8869680" y="3511296"/>
-            <a:ext cx="2660904" cy="237744"/>
-          </a:xfrm>
-          <a:prstGeom prst="rect">
-            <a:avLst/>
-          </a:prstGeom>
-          <a:noFill/>
-          <a:ln/>
-        </p:spPr>
-        <p:txBody>
-          <a:bodyPr wrap="square" lIns="0" tIns="0" rIns="0" bIns="0" rtlCol="0" anchor="ctr"/>
-          <a:lstStyle/>
-          <a:p>
-            <a:pPr indent="0" marL="0">
-              <a:buNone/>
-            </a:pPr>
-            <a:r>
-              <a:rPr lang="en-US" sz="1300" b="1" spc="150" kern="0" dirty="0">
-                <a:solidFill>
-                  <a:schemeClr val="accent2"/>
-                </a:solidFill>
-              </a:rPr>
-              <a:t>WORKING HYPOTHESIS</a:t>
-            </a:r>
-            <a:endParaRPr lang="en-US" sz="1300" dirty="0"/>
-          </a:p>
-        </p:txBody>
-      </p:sp>
-      <p:sp>
-        <p:nvSpPr>
-          <p:cNvPr id="39" name="Text 33"/>
-          <p:cNvSpPr txBox="1"/>
-          <p:nvPr/>
-        </p:nvSpPr>
-        <p:spPr>
-          <a:xfrm>
-            <a:off x="8293608" y="4087368"/>
-            <a:ext cx="3118104" cy="1828800"/>
-          </a:xfrm>
-          <a:prstGeom prst="rect">
-            <a:avLst/>
-          </a:prstGeom>
-          <a:noFill/>
-          <a:ln/>
-        </p:spPr>
-        <p:txBody>
-          <a:bodyPr wrap="square" lIns="0" tIns="0" rIns="0" bIns="0" rtlCol="0" anchor="t"/>
-          <a:lstStyle/>
-          <a:p>
-            <a:pPr indent="0" marL="0">
-              <a:buNone/>
-            </a:pPr>
-            <a:r>
-              <a:rPr lang="en-US" sz="1100" dirty="0">
-                <a:solidFill>
-                  <a:schemeClr val="tx1"/>
-                </a:solidFill>
-              </a:rPr>
-              <a:t>If Optum LS is building its own conversational access, competitors point to four choices that will shape it: </a:t>
-            </a:r>
-            <a:r>
-              <a:rPr lang="en-US" sz="1100" dirty="0" b="1">
-                <a:solidFill>
-                  <a:schemeClr val="tx1"/>
-                </a:solidFill>
-              </a:rPr>
-              <a:t>where it sits</a:t>
-            </a:r>
-            <a:r>
-              <a:rPr lang="en-US" sz="1100" dirty="0">
-                <a:solidFill>
-                  <a:schemeClr val="tx1"/>
-                </a:solidFill>
-              </a:rPr>
-              <a:t> (pre-sale previews, self-service analysis, inside CRM), </a:t>
-            </a:r>
-            <a:r>
-              <a:rPr lang="en-US" sz="1100" dirty="0" b="1">
-                <a:solidFill>
-                  <a:schemeClr val="tx1"/>
-                </a:solidFill>
-              </a:rPr>
-              <a:t>how visibly it shows its work</a:t>
-            </a:r>
-            <a:r>
-              <a:rPr lang="en-US" sz="1100" dirty="0">
-                <a:solidFill>
-                  <a:schemeClr val="tx1"/>
-                </a:solidFill>
-              </a:rPr>
-              <a:t>, </a:t>
-            </a:r>
-            <a:r>
-              <a:rPr lang="en-US" sz="1100" dirty="0" b="1">
-                <a:solidFill>
-                  <a:schemeClr val="tx1"/>
-                </a:solidFill>
-              </a:rPr>
-              <a:t>how much autonomy it gets</a:t>
-            </a:r>
-            <a:r>
-              <a:rPr lang="en-US" sz="1100" dirty="0">
-                <a:solidFill>
-                  <a:schemeClr val="tx1"/>
-                </a:solidFill>
-              </a:rPr>
-              <a:t> as regulatory stakes rise, and </a:t>
-            </a:r>
-            <a:r>
-              <a:rPr lang="en-US" sz="1100" dirty="0" b="1">
-                <a:solidFill>
-                  <a:schemeClr val="tx1"/>
-                </a:solidFill>
-              </a:rPr>
-              <a:t>whether it’s built or partnered</a:t>
-            </a:r>
-            <a:r>
-              <a:rPr lang="en-US" sz="1100" dirty="0">
-                <a:solidFill>
-                  <a:schemeClr val="tx1"/>
-                </a:solidFill>
-              </a:rPr>
-              <a:t>.</a:t>
-            </a:r>
-            <a:endParaRPr lang="en-US" sz="1100" dirty="0"/>
-          </a:p>
-        </p:txBody>
-      </p:sp>
-      <p:sp>
-        <p:nvSpPr>
-          <p:cNvPr id="25" name="Slide Number Placeholder 0"/>
-          <p:cNvSpPr>
-            <a:spLocks noGrp="1"/>
-          </p:cNvSpPr>
-          <p:nvPr>
-            <p:ph type="sldNum" sz="quarter" idx="4294967295"/>
-          </p:nvPr>
-        </p:nvSpPr>
-        <p:spPr>
-          <a:xfrm>
-            <a:off x="10725912" y="6309360"/>
-            <a:ext cx="914400" cy="201168"/>
-          </a:xfrm>
-          <a:prstGeom prst="rect">
-            <a:avLst/>
-          </a:prstGeom>
-          <a:extLst>
-            <a:ext uri="{C572A759-6A51-4108-AA02-DFA0A04FC94B}">
-              <ma14:wrappingTextBoxFlag xmlns:ma14="http://schemas.microsoft.com/office/mac/drawingml/2011/main" val="0"/>
-            </a:ext>
-          </a:extLst>
-        </p:spPr>
-        <p:txBody>
-          <a:bodyPr lIns="0" tIns="0" rIns="0" bIns="0"/>
-          <a:lstStyle>
-            <a:lvl1pPr>
-              <a:defRPr sz="900">
-                <a:solidFill>
-                  <a:schemeClr val="accent4"/>
-                </a:solidFill>
-              </a:defRPr>
-            </a:lvl1pPr>
-          </a:lstStyle>
-          <a:p>
-            <a:pPr algn="r"/>
-            <a:fld id="{F7021451-1387-4CA6-816F-3879F97B5CBC}" type="slidenum">
-              <a:rPr b="0" lang="en-US"/>
-              <a:t>2</a:t>
-            </a:fld>
-            <a:endParaRPr lang="en-US"/>
           </a:p>
         </p:txBody>
       </p:sp>

</xml_diff>

<commit_message>
10.16: simplify cover (drop domain chips, new scope line, centred block)
Co-Authored-By: Claude Opus 5.5 <noreply@anthropic.com>
Claude-Session: https://claude.ai/code/session_0198bm9pfzRwgZQBqNvd56W8
</commit_message>
<xml_diff>
--- a/deck/Optum-LS-Conversational-AI-10.16.pptx
+++ b/deck/Optum-LS-Conversational-AI-10.16.pptx
@@ -2912,7 +2912,7 @@
         </p:nvSpPr>
         <p:spPr>
           <a:xfrm>
-            <a:off x="822960" y="1051560"/>
+            <a:off x="822960" y="1362455"/>
             <a:ext cx="10058400" cy="274320"/>
           </a:xfrm>
           <a:prstGeom prst="rect">
@@ -2947,7 +2947,7 @@
         </p:nvSpPr>
         <p:spPr>
           <a:xfrm>
-            <a:off x="822960" y="1463040"/>
+            <a:off x="822960" y="1773935"/>
             <a:ext cx="10515600" cy="731520"/>
           </a:xfrm>
           <a:prstGeom prst="rect">
@@ -2982,7 +2982,7 @@
         </p:nvSpPr>
         <p:spPr>
           <a:xfrm>
-            <a:off x="822960" y="2240280"/>
+            <a:off x="822960" y="2551176"/>
             <a:ext cx="10515600" cy="457200"/>
           </a:xfrm>
           <a:prstGeom prst="rect">
@@ -3011,298 +3011,13 @@
       </p:sp>
       <p:sp>
         <p:nvSpPr>
-          <p:cNvPr id="5" name="domain chip RWE"/>
-          <p:cNvSpPr/>
-          <p:nvPr/>
-        </p:nvSpPr>
-        <p:spPr>
-          <a:xfrm>
-            <a:off x="822960" y="3063240"/>
-            <a:ext cx="507491" cy="310896"/>
-          </a:xfrm>
-          <a:prstGeom prst="roundRect">
-            <a:avLst>
-              <a:gd name="adj" fmla="val 50000"/>
-            </a:avLst>
-          </a:prstGeom>
-          <a:solidFill>
-            <a:srgbClr val="E6ECF5"/>
-          </a:solidFill>
-          <a:ln w="9525">
-            <a:solidFill>
-              <a:srgbClr val="002677"/>
-            </a:solidFill>
-          </a:ln>
-          <a:effectLst/>
-        </p:spPr>
-        <p:style>
-          <a:lnRef idx="1">
-            <a:schemeClr val="accent1"/>
-          </a:lnRef>
-          <a:fillRef idx="3">
-            <a:schemeClr val="accent1"/>
-          </a:fillRef>
-          <a:effectRef idx="2">
-            <a:schemeClr val="accent1"/>
-          </a:effectRef>
-          <a:fontRef idx="minor">
-            <a:schemeClr val="lt1"/>
-          </a:fontRef>
-        </p:style>
-        <p:txBody>
-          <a:bodyPr rtlCol="0" anchor="ctr" lIns="0" rIns="0" tIns="0" bIns="0"/>
-          <a:lstStyle/>
-          <a:p>
-            <a:pPr algn="ctr"/>
-            <a:r>
-              <a:rPr sz="1050">
-                <a:solidFill>
-                  <a:srgbClr val="002677"/>
-                </a:solidFill>
-                <a:latin typeface="Arial"/>
-              </a:rPr>
-              <a:t>RWE</a:t>
-            </a:r>
-          </a:p>
-        </p:txBody>
-      </p:sp>
-      <p:sp>
-        <p:nvSpPr>
-          <p:cNvPr id="6" name="domain chip Commercial Intelligence"/>
-          <p:cNvSpPr/>
-          <p:nvPr/>
-        </p:nvSpPr>
-        <p:spPr>
-          <a:xfrm>
-            <a:off x="1458468" y="3063240"/>
-            <a:ext cx="2061972" cy="310896"/>
-          </a:xfrm>
-          <a:prstGeom prst="roundRect">
-            <a:avLst>
-              <a:gd name="adj" fmla="val 50000"/>
-            </a:avLst>
-          </a:prstGeom>
-          <a:solidFill>
-            <a:srgbClr val="E6ECF5"/>
-          </a:solidFill>
-          <a:ln w="9525">
-            <a:solidFill>
-              <a:srgbClr val="002677"/>
-            </a:solidFill>
-          </a:ln>
-          <a:effectLst/>
-        </p:spPr>
-        <p:style>
-          <a:lnRef idx="1">
-            <a:schemeClr val="accent1"/>
-          </a:lnRef>
-          <a:fillRef idx="3">
-            <a:schemeClr val="accent1"/>
-          </a:fillRef>
-          <a:effectRef idx="2">
-            <a:schemeClr val="accent1"/>
-          </a:effectRef>
-          <a:fontRef idx="minor">
-            <a:schemeClr val="lt1"/>
-          </a:fontRef>
-        </p:style>
-        <p:txBody>
-          <a:bodyPr rtlCol="0" anchor="ctr" lIns="0" rIns="0" tIns="0" bIns="0"/>
-          <a:lstStyle/>
-          <a:p>
-            <a:pPr algn="ctr"/>
-            <a:r>
-              <a:rPr sz="1050">
-                <a:solidFill>
-                  <a:srgbClr val="002677"/>
-                </a:solidFill>
-                <a:latin typeface="Arial"/>
-              </a:rPr>
-              <a:t>Commercial Intelligence</a:t>
-            </a:r>
-          </a:p>
-        </p:txBody>
-      </p:sp>
-      <p:sp>
-        <p:nvSpPr>
-          <p:cNvPr id="7" name="domain chip Medical / Regulatory Research"/>
-          <p:cNvSpPr/>
-          <p:nvPr/>
-        </p:nvSpPr>
-        <p:spPr>
-          <a:xfrm>
-            <a:off x="3648456" y="3063240"/>
-            <a:ext cx="2528316" cy="310896"/>
-          </a:xfrm>
-          <a:prstGeom prst="roundRect">
-            <a:avLst>
-              <a:gd name="adj" fmla="val 50000"/>
-            </a:avLst>
-          </a:prstGeom>
-          <a:solidFill>
-            <a:srgbClr val="E6ECF5"/>
-          </a:solidFill>
-          <a:ln w="9525">
-            <a:solidFill>
-              <a:srgbClr val="002677"/>
-            </a:solidFill>
-          </a:ln>
-          <a:effectLst/>
-        </p:spPr>
-        <p:style>
-          <a:lnRef idx="1">
-            <a:schemeClr val="accent1"/>
-          </a:lnRef>
-          <a:fillRef idx="3">
-            <a:schemeClr val="accent1"/>
-          </a:fillRef>
-          <a:effectRef idx="2">
-            <a:schemeClr val="accent1"/>
-          </a:effectRef>
-          <a:fontRef idx="minor">
-            <a:schemeClr val="lt1"/>
-          </a:fontRef>
-        </p:style>
-        <p:txBody>
-          <a:bodyPr rtlCol="0" anchor="ctr" lIns="0" rIns="0" tIns="0" bIns="0"/>
-          <a:lstStyle/>
-          <a:p>
-            <a:pPr algn="ctr"/>
-            <a:r>
-              <a:rPr sz="1050">
-                <a:solidFill>
-                  <a:srgbClr val="002677"/>
-                </a:solidFill>
-                <a:latin typeface="Arial"/>
-              </a:rPr>
-              <a:t>Medical / Regulatory Research</a:t>
-            </a:r>
-          </a:p>
-        </p:txBody>
-      </p:sp>
-      <p:sp>
-        <p:nvSpPr>
-          <p:cNvPr id="8" name="domain chip Clinical Trials"/>
-          <p:cNvSpPr/>
-          <p:nvPr/>
-        </p:nvSpPr>
-        <p:spPr>
-          <a:xfrm>
-            <a:off x="6304788" y="3063240"/>
-            <a:ext cx="1440180" cy="310896"/>
-          </a:xfrm>
-          <a:prstGeom prst="roundRect">
-            <a:avLst>
-              <a:gd name="adj" fmla="val 50000"/>
-            </a:avLst>
-          </a:prstGeom>
-          <a:solidFill>
-            <a:srgbClr val="E6ECF5"/>
-          </a:solidFill>
-          <a:ln w="9525">
-            <a:solidFill>
-              <a:srgbClr val="002677"/>
-            </a:solidFill>
-          </a:ln>
-          <a:effectLst/>
-        </p:spPr>
-        <p:style>
-          <a:lnRef idx="1">
-            <a:schemeClr val="accent1"/>
-          </a:lnRef>
-          <a:fillRef idx="3">
-            <a:schemeClr val="accent1"/>
-          </a:fillRef>
-          <a:effectRef idx="2">
-            <a:schemeClr val="accent1"/>
-          </a:effectRef>
-          <a:fontRef idx="minor">
-            <a:schemeClr val="lt1"/>
-          </a:fontRef>
-        </p:style>
-        <p:txBody>
-          <a:bodyPr rtlCol="0" anchor="ctr" lIns="0" rIns="0" tIns="0" bIns="0"/>
-          <a:lstStyle/>
-          <a:p>
-            <a:pPr algn="ctr"/>
-            <a:r>
-              <a:rPr sz="1050">
-                <a:solidFill>
-                  <a:srgbClr val="002677"/>
-                </a:solidFill>
-                <a:latin typeface="Arial"/>
-              </a:rPr>
-              <a:t>Clinical Trials</a:t>
-            </a:r>
-          </a:p>
-        </p:txBody>
-      </p:sp>
-      <p:sp>
-        <p:nvSpPr>
-          <p:cNvPr id="9" name="domain chip Market Access"/>
-          <p:cNvSpPr/>
-          <p:nvPr/>
-        </p:nvSpPr>
-        <p:spPr>
-          <a:xfrm>
-            <a:off x="7872984" y="3063240"/>
-            <a:ext cx="1284732" cy="310896"/>
-          </a:xfrm>
-          <a:prstGeom prst="roundRect">
-            <a:avLst>
-              <a:gd name="adj" fmla="val 50000"/>
-            </a:avLst>
-          </a:prstGeom>
-          <a:solidFill>
-            <a:srgbClr val="E6ECF5"/>
-          </a:solidFill>
-          <a:ln w="9525">
-            <a:solidFill>
-              <a:srgbClr val="002677"/>
-            </a:solidFill>
-          </a:ln>
-          <a:effectLst/>
-        </p:spPr>
-        <p:style>
-          <a:lnRef idx="1">
-            <a:schemeClr val="accent1"/>
-          </a:lnRef>
-          <a:fillRef idx="3">
-            <a:schemeClr val="accent1"/>
-          </a:fillRef>
-          <a:effectRef idx="2">
-            <a:schemeClr val="accent1"/>
-          </a:effectRef>
-          <a:fontRef idx="minor">
-            <a:schemeClr val="lt1"/>
-          </a:fontRef>
-        </p:style>
-        <p:txBody>
-          <a:bodyPr rtlCol="0" anchor="ctr" lIns="0" rIns="0" tIns="0" bIns="0"/>
-          <a:lstStyle/>
-          <a:p>
-            <a:pPr algn="ctr"/>
-            <a:r>
-              <a:rPr sz="1050">
-                <a:solidFill>
-                  <a:srgbClr val="002677"/>
-                </a:solidFill>
-                <a:latin typeface="Arial"/>
-              </a:rPr>
-              <a:t>Market Access</a:t>
-            </a:r>
-          </a:p>
-        </p:txBody>
-      </p:sp>
-      <p:sp>
-        <p:nvSpPr>
           <p:cNvPr id="10" name="cover scope"/>
           <p:cNvSpPr txBox="1"/>
           <p:nvPr/>
         </p:nvSpPr>
         <p:spPr>
           <a:xfrm>
-            <a:off x="822960" y="3584448"/>
+            <a:off x="822960" y="3072384"/>
             <a:ext cx="10515600" cy="274320"/>
           </a:xfrm>
           <a:prstGeom prst="rect">
@@ -3324,7 +3039,7 @@
                 </a:solidFill>
                 <a:latin typeface="Arial"/>
               </a:rPr>
-              <a:t>Outside-in assessment of publicly marketed conversational AI across five Optum LS-relevant business domains</a:t>
+              <a:t>An outside-in assessment of publicly marketed conversational AI offerings</a:t>
             </a:r>
           </a:p>
         </p:txBody>
@@ -3337,7 +3052,7 @@
         </p:nvCxnSpPr>
         <p:spPr>
           <a:xfrm>
-            <a:off x="822960" y="4343400"/>
+            <a:off x="822960" y="3621024"/>
             <a:ext cx="10543032" cy="0"/>
           </a:xfrm>
           <a:prstGeom prst="line">
@@ -3372,7 +3087,7 @@
         </p:nvSpPr>
         <p:spPr>
           <a:xfrm>
-            <a:off x="822960" y="4526280"/>
+            <a:off x="822960" y="3803904"/>
             <a:ext cx="7315200" cy="274320"/>
           </a:xfrm>
           <a:prstGeom prst="rect">
@@ -3407,7 +3122,7 @@
         </p:nvSpPr>
         <p:spPr>
           <a:xfrm>
-            <a:off x="822960" y="4846320"/>
+            <a:off x="822960" y="4123944"/>
             <a:ext cx="7315200" cy="274320"/>
           </a:xfrm>
           <a:prstGeom prst="rect">
@@ -3442,7 +3157,7 @@
         </p:nvSpPr>
         <p:spPr>
           <a:xfrm>
-            <a:off x="822960" y="5715000"/>
+            <a:off x="822960" y="4992624"/>
             <a:ext cx="10543032" cy="502920"/>
           </a:xfrm>
           <a:prstGeom prst="rect">
@@ -3493,7 +3208,7 @@
         </p:nvSpPr>
         <p:spPr>
           <a:xfrm>
-            <a:off x="822960" y="5138928"/>
+            <a:off x="822960" y="4416552"/>
             <a:ext cx="8229600" cy="274320"/>
           </a:xfrm>
           <a:prstGeom prst="rect">

</xml_diff>

<commit_message>
10.16: numbered four choices, catalyst questions and approach rework, wording fixes
Co-Authored-By: Claude Opus 5.5 <noreply@anthropic.com>
Claude-Session: https://claude.ai/code/session_0198bm9pfzRwgZQBqNvd56W8
</commit_message>
<xml_diff>
--- a/deck/Optum-LS-Conversational-AI-10.16.pptx
+++ b/deck/Optum-LS-Conversational-AI-10.16.pptx
@@ -4988,7 +4988,7 @@
                             <a:schemeClr val="accent1"/>
                           </a:solidFill>
                         </a:rPr>
-                        <a:t>Optum LS is developing or evaluating conversational access it doesn’t yet market</a:t>
+                        <a:t>Optum LS is developing or evaluating conversational AI it doesn’t yet market</a:t>
                       </a:r>
                       <a:endParaRPr lang="en-US" sz="1050" dirty="0"/>
                     </a:p>
@@ -5125,7 +5125,7 @@
                             <a:schemeClr val="accent1"/>
                           </a:solidFill>
                         </a:rPr>
-                        <a:t>Conversational access influences what customers buy</a:t>
+                        <a:t>Conversational AI influences what customers buy</a:t>
                       </a:r>
                       <a:endParaRPr lang="en-US" sz="1050" dirty="0"/>
                     </a:p>
@@ -8630,7 +8630,7 @@
                   <a:schemeClr val="accent2"/>
                 </a:solidFill>
               </a:rPr>
-              <a:t>FOUR CHOICES</a:t>
+              <a:t>THE FOUR CHOICES</a:t>
             </a:r>
             <a:endParaRPr lang="en-US" sz="1000" dirty="0"/>
           </a:p>
@@ -8690,7 +8690,7 @@
                   <a:srgbClr val="002677"/>
                 </a:solidFill>
               </a:rPr>
-              <a:t>WHERE IT SITS</a:t>
+              <a:t>1. WHERE IT SITS</a:t>
             </a:r>
             <a:endParaRPr lang="en-US" sz="1300" dirty="0"/>
           </a:p>
@@ -8836,7 +8836,7 @@
                   <a:srgbClr val="002677"/>
                 </a:solidFill>
               </a:rPr>
-              <a:t>HOW IT SHOWS ITS WORK</a:t>
+              <a:t>2. HOW IT SHOWS ITS WORK</a:t>
             </a:r>
             <a:endParaRPr lang="en-US" sz="1300" dirty="0"/>
           </a:p>
@@ -8982,7 +8982,7 @@
                   <a:srgbClr val="002677"/>
                 </a:solidFill>
               </a:rPr>
-              <a:t>HOW MUCH AUTONOMY</a:t>
+              <a:t>3. HOW MUCH AUTONOMY</a:t>
             </a:r>
             <a:endParaRPr lang="en-US" sz="1300" dirty="0"/>
           </a:p>
@@ -9128,7 +9128,7 @@
                   <a:srgbClr val="002677"/>
                 </a:solidFill>
               </a:rPr>
-              <a:t>BUILT OR PARTNERED</a:t>
+              <a:t>4. BUILT OR PARTNERED</a:t>
             </a:r>
             <a:endParaRPr lang="en-US" sz="1300" dirty="0"/>
           </a:p>
@@ -10208,7 +10208,7 @@
                   <a:srgbClr val="7A7C7E"/>
                 </a:solidFill>
               </a:rPr>
-              <a:t>A publicly marketed interface that lets life-sciences customers use natural language to interact with data, research or business workflows. Exclude patient-facing chatbots, clinician scribes and AI without a natural-language interface.</a:t>
+              <a:t>A publicly marketed interface that lets life-sciences customers use natural language to interact with data, research or business workflows. Excludes patient-facing chatbots, clinician scribes and AI without a natural-language interface.</a:t>
             </a:r>
             <a:endParaRPr lang="en-US" sz="1100" dirty="0"/>
           </a:p>
@@ -10323,8 +10323,8 @@
         </p:nvSpPr>
         <p:spPr>
           <a:xfrm>
-            <a:off x="548640" y="1536192"/>
-            <a:ext cx="7315200" cy="201168"/>
+            <a:off x="548640" y="1389888"/>
+            <a:ext cx="7315200" cy="237744"/>
           </a:xfrm>
           <a:prstGeom prst="rect">
             <a:avLst/>
@@ -10340,7 +10340,7 @@
               <a:buNone/>
             </a:pPr>
             <a:r>
-              <a:rPr lang="en-US" sz="1000" b="1" spc="100" kern="0" dirty="0">
+              <a:rPr lang="en-US" sz="1200" b="1" spc="100" kern="0" dirty="0">
                 <a:solidFill>
                   <a:schemeClr val="accent2"/>
                 </a:solidFill>
@@ -11168,7 +11168,7 @@
         <p:spPr>
           <a:xfrm>
             <a:off x="548640" y="4114800"/>
-            <a:ext cx="5454396" cy="1920240"/>
+            <a:ext cx="7589520" cy="1920240"/>
           </a:xfrm>
           <a:prstGeom prst="rect">
             <a:avLst/>
@@ -11198,8 +11198,8 @@
         </p:nvSpPr>
         <p:spPr>
           <a:xfrm>
-            <a:off x="749808" y="4538472"/>
-            <a:ext cx="5052060" cy="256032"/>
+            <a:off x="749808" y="4389120"/>
+            <a:ext cx="7187184" cy="256032"/>
           </a:xfrm>
           <a:prstGeom prst="rect">
             <a:avLst/>
@@ -11234,8 +11234,8 @@
         </p:nvSpPr>
         <p:spPr>
           <a:xfrm>
-            <a:off x="749808" y="4867656"/>
-            <a:ext cx="5052060" cy="612648"/>
+            <a:off x="749808" y="4754880"/>
+            <a:ext cx="7187184" cy="1143000"/>
           </a:xfrm>
           <a:prstGeom prst="rect">
             <a:avLst/>
@@ -11256,7 +11256,58 @@
                   <a:schemeClr val="accent1"/>
                 </a:solidFill>
               </a:rPr>
-              <a:t>Where else are life sciences vendors marketing conversational AI; what tasks does it serve; and how does that positioning inform potential Optum LS offerings?</a:t>
+              <a:t>1. How widely are life-sciences vendors marketing conversational AI, and in which domains?</a:t>
+            </a:r>
+            <a:endParaRPr lang="en-US" sz="1200" dirty="0"/>
+          </a:p>
+          <a:p>
+            <a:pPr indent="0" marL="0">
+              <a:spcBef>
+                <a:spcPts val="700"/>
+              </a:spcBef>
+              <a:buNone/>
+            </a:pPr>
+            <a:r>
+              <a:rPr lang="en-US" sz="1200" b="1" dirty="0">
+                <a:solidFill>
+                  <a:schemeClr val="accent1"/>
+                </a:solidFill>
+              </a:rPr>
+              <a:t>2. Which customer tasks does it target, and what do vendors promise?</a:t>
+            </a:r>
+            <a:endParaRPr lang="en-US" sz="1200" dirty="0"/>
+          </a:p>
+          <a:p>
+            <a:pPr indent="0" marL="0">
+              <a:spcBef>
+                <a:spcPts val="700"/>
+              </a:spcBef>
+              <a:buNone/>
+            </a:pPr>
+            <a:r>
+              <a:rPr lang="en-US" sz="1200" b="1" dirty="0">
+                <a:solidFill>
+                  <a:schemeClr val="accent1"/>
+                </a:solidFill>
+              </a:rPr>
+              <a:t>3. Who supplies the underlying AI, and could those suppliers become competitors?</a:t>
+            </a:r>
+            <a:endParaRPr lang="en-US" sz="1200" dirty="0"/>
+          </a:p>
+          <a:p>
+            <a:pPr indent="0" marL="0">
+              <a:spcBef>
+                <a:spcPts val="700"/>
+              </a:spcBef>
+              <a:buNone/>
+            </a:pPr>
+            <a:r>
+              <a:rPr lang="en-US" sz="1200" b="1" dirty="0">
+                <a:solidFill>
+                  <a:schemeClr val="accent1"/>
+                </a:solidFill>
+              </a:rPr>
+              <a:t>4. What does that positioning suggest for an Optum LS offering?</a:t>
             </a:r>
             <a:endParaRPr lang="en-US" sz="1200" dirty="0"/>
           </a:p>
@@ -11270,8 +11321,8 @@
         </p:nvSpPr>
         <p:spPr>
           <a:xfrm>
-            <a:off x="6185916" y="4114800"/>
-            <a:ext cx="5454396" cy="1920240"/>
+            <a:off x="8321040" y="4114800"/>
+            <a:ext cx="3319272" cy="1920240"/>
           </a:xfrm>
           <a:prstGeom prst="rect">
             <a:avLst/>
@@ -11301,8 +11352,8 @@
         </p:nvSpPr>
         <p:spPr>
           <a:xfrm>
-            <a:off x="6387084" y="4538472"/>
-            <a:ext cx="5052060" cy="256032"/>
+            <a:off x="8522208" y="4389120"/>
+            <a:ext cx="2916936" cy="256032"/>
           </a:xfrm>
           <a:prstGeom prst="rect">
             <a:avLst/>
@@ -11337,8 +11388,8 @@
         </p:nvSpPr>
         <p:spPr>
           <a:xfrm>
-            <a:off x="6387084" y="4867656"/>
-            <a:ext cx="5052060" cy="798576"/>
+            <a:off x="8522208" y="4754880"/>
+            <a:ext cx="2916936" cy="1143000"/>
           </a:xfrm>
           <a:prstGeom prst="rect">
             <a:avLst/>
@@ -11354,12 +11405,12 @@
               <a:buNone/>
             </a:pPr>
             <a:r>
-              <a:rPr lang="en-US" sz="1200" b="1" dirty="0">
+              <a:rPr lang="en-US" sz="1150" b="1" dirty="0">
                 <a:solidFill>
                   <a:schemeClr val="tx1"/>
                 </a:solidFill>
               </a:rPr>
-              <a:t>This study examines publicly-marketed conversational AI across five business domains. Vendors’ product claims provide observable evidence for competitive positioning without access to internal product data.</a:t>
+              <a:t>Vendors’ public product claims show what competitors choose to promise customers. That makes them direct evidence of competitive positioning—though not of performance, adoption or revenue.</a:t>
             </a:r>
             <a:endParaRPr lang="en-US" sz="1200" dirty="0"/>
           </a:p>

</xml_diff>

<commit_message>
10.16: add Norstella Ella assistants (23 offerings), Veeva data-boundary box, trials/access headline
Co-Authored-By: Claude Opus 5.5 <noreply@anthropic.com>
Claude-Session: https://claude.ai/code/session_0198bm9pfzRwgZQBqNvd56W8
</commit_message>
<xml_diff>
--- a/deck/Optum-LS-Conversational-AI-10.16.pptx
+++ b/deck/Optum-LS-Conversational-AI-10.16.pptx
@@ -6047,7 +6047,7 @@
                   <a:schemeClr val="tx1"/>
                 </a:solidFill>
               </a:rPr>
-              <a:t>43 U.S. competitor groups screened; 15 market 19 qualifying offerings. Domain counts overlap. Fourteen international screens add eight examples; their percentages aren’t national adoption rates.</a:t>
+              <a:t>43 U.S. competitor groups screened; 15 market 23 qualifying offerings. Domain counts overlap. Screens are not exhaustive. Fourteen international screens add eight examples; their percentages aren’t national adoption rates.</a:t>
             </a:r>
             <a:endParaRPr lang="en-US" sz="1000" dirty="0"/>
           </a:p>
@@ -8729,7 +8729,7 @@
                   <a:srgbClr val="4B4D4F"/>
                 </a:solidFill>
               </a:rPr>
-              <a:t>Before purchase, in place of analyst requests, or inside the rep’s CRM</a:t>
+              <a:t>Before purchase, in place of analyst requests, inside CRM, or across a portfolio</a:t>
             </a:r>
             <a:endParaRPr lang="en-US" sz="1100" dirty="0"/>
           </a:p>
@@ -8776,7 +8776,7 @@
                   <a:srgbClr val="7A7C7E"/>
                 </a:solidFill>
               </a:rPr>
-              <a:t>Truven, Flatiron, Verana, IQVIA</a:t>
+              <a:t>Truven, Flatiron, IQVIA, Norstella</a:t>
             </a:r>
             <a:endParaRPr lang="en-US" sz="1100" dirty="0"/>
           </a:p>
@@ -9317,7 +9317,7 @@
                   <a:srgbClr val="FF612B"/>
                 </a:solidFill>
               </a:rPr>
-              <a:t>19</a:t>
+              <a:t>23</a:t>
             </a:r>
             <a:endParaRPr lang="en-US" sz="3400" dirty="0"/>
           </a:p>
@@ -12063,12 +12063,12 @@
               <a:buNone/>
             </a:pPr>
             <a:r>
-              <a:rPr lang="en-US" sz="1050" b="1" dirty="0">
+              <a:rPr lang="en-US" sz="1250" b="1" dirty="0">
                 <a:solidFill>
                   <a:schemeClr val="tx1"/>
                 </a:solidFill>
               </a:rPr>
-              <a:t>RWE has the highest concentration (9 of 34 competitors); trials and market access have one each.</a:t>
+              <a:t>RWE has the highest concentration (9 of 34); market access the lowest (2 of 24).</a:t>
             </a:r>
             <a:endParaRPr lang="en-US" sz="1050" dirty="0"/>
           </a:p>
@@ -12080,12 +12080,12 @@
               <a:buNone/>
             </a:pPr>
             <a:r>
-              <a:rPr lang="en-US" sz="1050" b="1" dirty="0">
+              <a:rPr lang="en-US" sz="1250" b="1" dirty="0">
                 <a:solidFill>
                   <a:schemeClr val="tx1"/>
                 </a:solidFill>
               </a:rPr>
-              <a:t>An Optum LS offering would meet very different competition by domain.</a:t>
+              <a:t>Norstella alone markets Ella-branded assistants in four of five domains.</a:t>
             </a:r>
             <a:endParaRPr lang="en-US" sz="1050" dirty="0"/>
           </a:p>
@@ -12590,7 +12590,7 @@
                             <a:srgbClr val="4B4D4F"/>
                           </a:solidFill>
                         </a:rPr>
-                        <a:t>IQVIA, ZS, Trinity</a:t>
+                        <a:t>IQVIA, ZS, Trinity, Norstella (Evaluate)</a:t>
                       </a:r>
                       <a:endParaRPr lang="en-US" sz="950" dirty="0"/>
                     </a:p>
@@ -12904,21 +12904,22 @@
                             <a:schemeClr val="accent1"/>
                           </a:solidFill>
                         </a:rPr>
-                        <a:t>Clinical Trials</a:t>
-                      </a:r>
-                      <a:endParaRPr lang="en-US" sz="1050" dirty="0"/>
-                    </a:p>
-                    <a:p>
-                      <a:pPr algn="ctr" indent="0" marL="0">
-                        <a:buNone/>
-                      </a:pPr>
-                      <a:r>
-                        <a:rPr lang="en-US" sz="900" dirty="0">
+                        <a:t>Clinical</a:t>
+                      </a:r>
+                      <a:br>
+                        <a:rPr lang="en-US" sz="1050" b="1" dirty="0">
                           <a:solidFill>
                             <a:schemeClr val="accent1"/>
                           </a:solidFill>
                         </a:rPr>
-                        <a:t>(one entrant)</a:t>
+                      </a:br>
+                      <a:r>
+                        <a:rPr lang="en-US" sz="1050" b="1" dirty="0">
+                          <a:solidFill>
+                            <a:schemeClr val="accent1"/>
+                          </a:solidFill>
+                        </a:rPr>
+                        <a:t>Trials</a:t>
                       </a:r>
                       <a:endParaRPr lang="en-US" sz="1050" dirty="0"/>
                     </a:p>
@@ -12973,7 +12974,7 @@
                             <a:srgbClr val="4B4D4F"/>
                           </a:solidFill>
                         </a:rPr>
-                        <a:t>TriNetX</a:t>
+                        <a:t>TriNetX, Norstella (Citeline), Veeva</a:t>
                       </a:r>
                       <a:endParaRPr lang="en-US" sz="950" dirty="0"/>
                     </a:p>
@@ -13013,7 +13014,7 @@
                             <a:srgbClr val="4B4D4F"/>
                           </a:solidFill>
                         </a:rPr>
-                        <a:t>Site selection, not just patient counts</a:t>
+                        <a:t>Site selection; data-bounded EDC chat</a:t>
                       </a:r>
                       <a:endParaRPr lang="en-US" sz="950" dirty="0"/>
                     </a:p>
@@ -13095,21 +13096,22 @@
                             <a:schemeClr val="accent1"/>
                           </a:solidFill>
                         </a:rPr>
-                        <a:t>Market Access</a:t>
-                      </a:r>
-                      <a:endParaRPr lang="en-US" sz="1050" dirty="0"/>
-                    </a:p>
-                    <a:p>
-                      <a:pPr algn="ctr" indent="0" marL="0">
-                        <a:buNone/>
-                      </a:pPr>
-                      <a:r>
-                        <a:rPr lang="en-US" sz="900" dirty="0">
+                        <a:t>Market</a:t>
+                      </a:r>
+                      <a:br>
+                        <a:rPr lang="en-US" sz="1050" b="1" dirty="0">
                           <a:solidFill>
                             <a:schemeClr val="accent1"/>
                           </a:solidFill>
                         </a:rPr>
-                        <a:t>(one entrant)</a:t>
+                      </a:br>
+                      <a:r>
+                        <a:rPr lang="en-US" sz="1050" b="1" dirty="0">
+                          <a:solidFill>
+                            <a:schemeClr val="accent1"/>
+                          </a:solidFill>
+                        </a:rPr>
+                        <a:t>Access</a:t>
                       </a:r>
                       <a:endParaRPr lang="en-US" sz="1050" dirty="0"/>
                     </a:p>
@@ -13164,7 +13166,7 @@
                             <a:srgbClr val="4B4D4F"/>
                           </a:solidFill>
                         </a:rPr>
-                        <a:t>EVERSANA</a:t>
+                        <a:t>EVERSANA, Norstella (MMIT)</a:t>
                       </a:r>
                       <a:endParaRPr lang="en-US" sz="950" dirty="0"/>
                     </a:p>
@@ -13204,7 +13206,7 @@
                             <a:srgbClr val="4B4D4F"/>
                           </a:solidFill>
                         </a:rPr>
-                        <a:t>Moving past chat answers</a:t>
+                        <a:t>Moving past chat answers; queryable payer feedback</a:t>
                       </a:r>
                       <a:endParaRPr lang="en-US" sz="950" dirty="0"/>
                     </a:p>
@@ -18088,7 +18090,7 @@
         </p:nvGraphicFramePr>
         <p:xfrm>
           <a:off x="548640" y="1481328"/>
-          <a:ext cx="11091672" cy="3008375"/>
+          <a:ext cx="11091672" cy="3008374"/>
         </p:xfrm>
         <a:graphic>
           <a:graphicData uri="http://schemas.openxmlformats.org/drawingml/2006/table">
@@ -18212,7 +18214,7 @@
                   </a:tcPr>
                 </a:tc>
               </a:tr>
-              <a:tr h="881667">
+              <a:tr h="1005992">
                 <a:tc>
                   <a:txBody>
                     <a:bodyPr/>
@@ -18330,6 +18332,49 @@
                             </a:solidFill>
                           </a:uFill>
                         </a:rPr>
+                        <a:t>Norstella’s </a:t>
+                      </a:r>
+                      <a:r>
+                        <a:rPr lang="en-US" sz="950" dirty="0" b="1" u="sng">
+                          <a:solidFill>
+                            <a:srgbClr val="002677"/>
+                          </a:solidFill>
+                          <a:uFill>
+                            <a:solidFill>
+                              <a:srgbClr val="9AA8CC"/>
+                            </a:solidFill>
+                          </a:uFill>
+                        </a:rPr>
+                        <a:t>Evaluate Ella</a:t>
+                      </a:r>
+                      <a:r>
+                        <a:rPr lang="en-US" sz="950" dirty="0">
+                          <a:solidFill>
+                            <a:schemeClr val="tx1"/>
+                          </a:solidFill>
+                        </a:rPr>
+                        <a:t>: plain-English questions on pharma markets, deals and forecasts;</a:t>
+                      </a:r>
+                      <a:endParaRPr lang="en-US" sz="950" dirty="0"/>
+                    </a:p>
+                    <a:p>
+                      <a:pPr indent="0" marL="0">
+                        <a:spcBef>
+                          <a:spcPts val="400"/>
+                        </a:spcBef>
+                        <a:buNone/>
+                      </a:pPr>
+                      <a:r>
+                        <a:rPr lang="en-US" sz="950" dirty="0" u="sng">
+                          <a:solidFill>
+                            <a:srgbClr val="002677"/>
+                          </a:solidFill>
+                          <a:uFill>
+                            <a:solidFill>
+                              <a:srgbClr val="9AA8CC"/>
+                            </a:solidFill>
+                          </a:uFill>
+                        </a:rPr>
                         <a:t>GBI Health’s </a:t>
                       </a:r>
                       <a:r>
@@ -18501,7 +18546,7 @@
                   </a:tcPr>
                 </a:tc>
               </a:tr>
-              <a:tr h="1017380">
+              <a:tr h="955217">
                 <a:tc>
                   <a:txBody>
                     <a:bodyPr/>
@@ -18774,7 +18819,7 @@
                   </a:tcPr>
                 </a:tc>
               </a:tr>
-              <a:tr h="780144">
+              <a:tr h="717981">
                 <a:tc>
                   <a:txBody>
                     <a:bodyPr/>
@@ -19402,7 +19447,7 @@
         </p:nvSpPr>
         <p:spPr>
           <a:xfrm>
-            <a:off x="2944075" y="1997571"/>
+            <a:off x="2944075" y="1966253"/>
             <a:ext cx="1060493" cy="134588"/>
           </a:xfrm>
           <a:prstGeom prst="rect">
@@ -19445,7 +19490,7 @@
         </p:nvSpPr>
         <p:spPr>
           <a:xfrm>
-            <a:off x="2944075" y="2184058"/>
+            <a:off x="2944075" y="2339214"/>
             <a:ext cx="1205482" cy="134588"/>
           </a:xfrm>
           <a:prstGeom prst="rect">
@@ -19488,7 +19533,7 @@
         </p:nvSpPr>
         <p:spPr>
           <a:xfrm>
-            <a:off x="2944075" y="2370532"/>
+            <a:off x="2944075" y="2525701"/>
             <a:ext cx="1199225" cy="134588"/>
           </a:xfrm>
           <a:prstGeom prst="rect">
@@ -19531,7 +19576,7 @@
         </p:nvSpPr>
         <p:spPr>
           <a:xfrm>
-            <a:off x="2944075" y="2879218"/>
+            <a:off x="2944075" y="2972093"/>
             <a:ext cx="1475211" cy="134588"/>
           </a:xfrm>
           <a:prstGeom prst="rect">
@@ -19574,7 +19619,7 @@
         </p:nvSpPr>
         <p:spPr>
           <a:xfrm>
-            <a:off x="2944075" y="3065692"/>
+            <a:off x="2944075" y="3158580"/>
             <a:ext cx="2721894" cy="134588"/>
           </a:xfrm>
           <a:prstGeom prst="rect">
@@ -19617,7 +19662,7 @@
         </p:nvSpPr>
         <p:spPr>
           <a:xfrm>
-            <a:off x="2944075" y="3252179"/>
+            <a:off x="2944075" y="3345054"/>
             <a:ext cx="1837400" cy="134588"/>
           </a:xfrm>
           <a:prstGeom prst="rect">
@@ -19652,16 +19697,16 @@
       </p:sp>
       <p:sp>
         <p:nvSpPr>
-          <p:cNvPr id="9727" name="Invisible source link 8: https://trinitylifesciences.com/products/insightsedge-digital-twins/">
-            <a:hlinkClick r:id="rId9"/>
+          <p:cNvPr id="9727" name="Invisible source link 8: https://www.evaluate.com/ask-ella/">
+            <a:hlinkClick r:id="rId11"/>
           </p:cNvPr>
           <p:cNvSpPr/>
           <p:nvPr/>
         </p:nvSpPr>
         <p:spPr>
           <a:xfrm>
-            <a:off x="2944075" y="3939058"/>
-            <a:ext cx="2730885" cy="134588"/>
+            <a:off x="2944075" y="2152740"/>
+            <a:ext cx="1368645" cy="134588"/>
           </a:xfrm>
           <a:prstGeom prst="rect">
             <a:avLst/>
@@ -19695,16 +19740,16 @@
       </p:sp>
       <p:sp>
         <p:nvSpPr>
-          <p:cNvPr id="9728" name="Invisible source link 8: https://www.ipsos.com/en/healthcare/healthcare-personabot">
-            <a:hlinkClick r:id="rId10"/>
+          <p:cNvPr id="9728" name="Invisible source link 8: https://trinitylifesciences.com/products/insightsedge-digital-twins/">
+            <a:hlinkClick r:id="rId9"/>
           </p:cNvPr>
           <p:cNvSpPr/>
           <p:nvPr/>
         </p:nvSpPr>
         <p:spPr>
           <a:xfrm>
-            <a:off x="2944075" y="4125533"/>
-            <a:ext cx="1728934" cy="134588"/>
+            <a:off x="2944075" y="3969653"/>
+            <a:ext cx="2730885" cy="134588"/>
           </a:xfrm>
           <a:prstGeom prst="rect">
             <a:avLst/>
@@ -19738,16 +19783,16 @@
       </p:sp>
       <p:sp>
         <p:nvSpPr>
-          <p:cNvPr id="9729" name="Invisible source link 8: https://www.iqvia.com/solutions/commercialization/commercial-analytics/omnichannel-engagement-and-insights/field-force-agent">
-            <a:hlinkClick r:id="rId11"/>
+          <p:cNvPr id="9729" name="Invisible source link 8: https://www.ipsos.com/en/healthcare/healthcare-personabot">
+            <a:hlinkClick r:id="rId10"/>
           </p:cNvPr>
           <p:cNvSpPr/>
           <p:nvPr/>
         </p:nvSpPr>
         <p:spPr>
           <a:xfrm>
-            <a:off x="2538717" y="5375216"/>
-            <a:ext cx="2106538" cy="148648"/>
+            <a:off x="2944075" y="4156140"/>
+            <a:ext cx="1728934" cy="134588"/>
           </a:xfrm>
           <a:prstGeom prst="rect">
             <a:avLst/>
@@ -19781,16 +19826,16 @@
       </p:sp>
       <p:sp>
         <p:nvSpPr>
-          <p:cNvPr id="9730" name="Invisible source link 8: https://zaidyn.zs.com/products/zaidyn-commercial/conversational-ai">
-            <a:hlinkClick r:id="rId7"/>
+          <p:cNvPr id="9730" name="Invisible source link 8: https://www.iqvia.com/solutions/commercialization/commercial-analytics/omnichannel-engagement-and-insights/field-force-agent">
+            <a:hlinkClick r:id="rId12"/>
           </p:cNvPr>
           <p:cNvSpPr/>
           <p:nvPr/>
         </p:nvSpPr>
         <p:spPr>
           <a:xfrm>
-            <a:off x="1360805" y="5535058"/>
-            <a:ext cx="2357808" cy="148648"/>
+            <a:off x="2538717" y="5375216"/>
+            <a:ext cx="2106538" cy="148648"/>
           </a:xfrm>
           <a:prstGeom prst="rect">
             <a:avLst/>
@@ -19824,16 +19869,16 @@
       </p:sp>
       <p:sp>
         <p:nvSpPr>
-          <p:cNvPr id="9731" name="Invisible source link 8: https://trinitylifesciences.com/company/press-releases/trinity-launches-insightsedge-digital-twins/">
-            <a:hlinkClick r:id="rId12"/>
+          <p:cNvPr id="9731" name="Invisible source link 8: https://zaidyn.zs.com/products/zaidyn-commercial/conversational-ai">
+            <a:hlinkClick r:id="rId7"/>
           </p:cNvPr>
           <p:cNvSpPr/>
           <p:nvPr/>
         </p:nvSpPr>
         <p:spPr>
           <a:xfrm>
-            <a:off x="7497222" y="5375216"/>
-            <a:ext cx="3146128" cy="148648"/>
+            <a:off x="1360805" y="5535058"/>
+            <a:ext cx="2357808" cy="148648"/>
           </a:xfrm>
           <a:prstGeom prst="rect">
             <a:avLst/>
@@ -19867,8 +19912,51 @@
       </p:sp>
       <p:sp>
         <p:nvSpPr>
-          <p:cNvPr id="9732" name="Invisible source link 8: https://www.ipsos.com/en/launch-ipsos-personabot-groundbreaking-ai-powered-solution-enhance-segmentation-research">
+          <p:cNvPr id="9732" name="Invisible source link 8: https://trinitylifesciences.com/company/press-releases/trinity-launches-insightsedge-digital-twins/">
             <a:hlinkClick r:id="rId13"/>
+          </p:cNvPr>
+          <p:cNvSpPr/>
+          <p:nvPr/>
+        </p:nvSpPr>
+        <p:spPr>
+          <a:xfrm>
+            <a:off x="7497222" y="5375216"/>
+            <a:ext cx="3146128" cy="148648"/>
+          </a:xfrm>
+          <a:prstGeom prst="rect">
+            <a:avLst/>
+          </a:prstGeom>
+          <a:noFill/>
+          <a:ln>
+            <a:noFill/>
+          </a:ln>
+        </p:spPr>
+        <p:style>
+          <a:lnRef idx="1">
+            <a:schemeClr val="accent1"/>
+          </a:lnRef>
+          <a:fillRef idx="3">
+            <a:schemeClr val="accent1"/>
+          </a:fillRef>
+          <a:effectRef idx="2">
+            <a:schemeClr val="accent1"/>
+          </a:effectRef>
+          <a:fontRef idx="minor">
+            <a:schemeClr val="lt1"/>
+          </a:fontRef>
+        </p:style>
+        <p:txBody>
+          <a:bodyPr rtlCol="0" anchor="ctr"/>
+          <a:lstStyle/>
+          <a:p>
+            <a:pPr algn="ctr"/>
+          </a:p>
+        </p:txBody>
+      </p:sp>
+      <p:sp>
+        <p:nvSpPr>
+          <p:cNvPr id="9733" name="Invisible source link 8: https://www.ipsos.com/en/launch-ipsos-personabot-groundbreaking-ai-powered-solution-enhance-segmentation-research">
+            <a:hlinkClick r:id="rId14"/>
           </p:cNvPr>
           <p:cNvSpPr/>
           <p:nvPr/>
@@ -22177,7 +22265,7 @@
                   <a:schemeClr val="accent1"/>
                 </a:solidFill>
               </a:rPr>
-              <a:t>Trials and market access have the fewest offerings, and one vendor already says chat answers aren’t enough</a:t>
+              <a:t>In trials and market access, vendors limit what conversational AI can see and how far its answers go</a:t>
             </a:r>
             <a:endParaRPr lang="en-US" sz="2200" dirty="0"/>
           </a:p>
@@ -22959,7 +23047,7 @@
       </p:graphicFrame>
       <p:sp>
         <p:nvSpPr>
-          <p:cNvPr id="18" name="which sites, not just how many card"/>
+          <p:cNvPr id="18" name="defined data boundaries card"/>
           <p:cNvSpPr/>
           <p:nvPr/>
         </p:nvSpPr>
@@ -23018,7 +23106,7 @@
                   <a:schemeClr val="accent2"/>
                 </a:solidFill>
               </a:rPr>
-              <a:t>WHICH SITES, NOT JUST HOW MANY</a:t>
+              <a:t>DEFINED DATA BOUNDARIES</a:t>
             </a:r>
             <a:endParaRPr lang="en-US" sz="1300" dirty="0"/>
           </a:p>
@@ -23054,7 +23142,7 @@
                   <a:schemeClr val="tx1"/>
                 </a:solidFill>
               </a:rPr>
-              <a:t>TriNetX is pushing trial feasibility from patient counts to site selection: it markets Terrain as surfacing “</a:t>
+              <a:t>Veeva draws an explicit line around its new trial assistant: the EDC AI Tab answers questions from study operational data and help pages, but “</a:t>
             </a:r>
             <a:r>
               <a:rPr lang="en-US" sz="1050" b="1" dirty="0" u="sng">
@@ -23067,28 +23155,7 @@
                   </a:solidFill>
                 </a:uFill>
               </a:rPr>
-              <a:t>not just how many patients exist, but where they exist</a:t>
-            </a:r>
-            <a:r>
-              <a:rPr lang="en-US" sz="1050" b="1" dirty="0">
-                <a:solidFill>
-                  <a:schemeClr val="tx1"/>
-                </a:solidFill>
-              </a:rPr>
-              <a:t>,” and treats clinical trial payments data “</a:t>
-            </a:r>
-            <a:r>
-              <a:rPr lang="en-US" sz="1050" b="1" dirty="0" u="sng">
-                <a:solidFill>
-                  <a:srgbClr val="002677"/>
-                </a:solidFill>
-                <a:uFill>
-                  <a:solidFill>
-                    <a:srgbClr val="9AA8CC"/>
-                  </a:solidFill>
-                </a:uFill>
-              </a:rPr>
-              <a:t>as a real-world enrollment signal</a:t>
+              <a:t>no site-entered casebook data is referenced by the AI agent</a:t>
             </a:r>
             <a:r>
               <a:rPr lang="en-US" sz="1050" b="1" dirty="0">
@@ -23413,16 +23480,16 @@
       </p:sp>
       <p:sp>
         <p:nvSpPr>
-          <p:cNvPr id="9726" name="Invisible source link 10: https://trinetx.com/solutions/trinetx-live/terrain/">
-            <a:hlinkClick r:id="rId3"/>
+          <p:cNvPr id="9726" name="Invisible source link 10: https://clinicaldata.veevavault.help/en/lr/rn/limited-releases/26r3/new-features">
+            <a:hlinkClick r:id="rId11"/>
           </p:cNvPr>
           <p:cNvSpPr/>
           <p:nvPr/>
         </p:nvSpPr>
         <p:spPr>
           <a:xfrm>
-            <a:off x="2586444" y="5375216"/>
-            <a:ext cx="3120421" cy="148648"/>
+            <a:off x="5037945" y="5375216"/>
+            <a:ext cx="542086" cy="148648"/>
           </a:xfrm>
           <a:prstGeom prst="rect">
             <a:avLst/>
@@ -23456,8 +23523,8 @@
       </p:sp>
       <p:sp>
         <p:nvSpPr>
-          <p:cNvPr id="9728" name="Invisible source link 10: https://trinetx.com/solutions/trinetx-live/terrain/">
-            <a:hlinkClick r:id="rId3"/>
+          <p:cNvPr id="9728" name="Invisible source link 10: https://clinicaldata.veevavault.help/en/lr/rn/limited-releases/26r3/new-features">
+            <a:hlinkClick r:id="rId11"/>
           </p:cNvPr>
           <p:cNvSpPr/>
           <p:nvPr/>
@@ -23465,7 +23532,7 @@
         <p:spPr>
           <a:xfrm>
             <a:off x="749515" y="5535058"/>
-            <a:ext cx="404916" cy="148648"/>
+            <a:ext cx="3384273" cy="148648"/>
           </a:xfrm>
           <a:prstGeom prst="rect">
             <a:avLst/>
@@ -23499,16 +23566,16 @@
       </p:sp>
       <p:sp>
         <p:nvSpPr>
-          <p:cNvPr id="9728" name="Invisible source link 10: https://trinetx.com/solutions/trinetx-live/terrain/">
-            <a:hlinkClick r:id="rId3"/>
+          <p:cNvPr id="9728" name="Invisible source link 10: https://www.eversana.com/insights/from-ai-answers-to-decision-grade-market-access/">
+            <a:hlinkClick r:id="rId12"/>
           </p:cNvPr>
           <p:cNvSpPr/>
           <p:nvPr/>
         </p:nvSpPr>
         <p:spPr>
           <a:xfrm>
-            <a:off x="3589018" y="5535058"/>
-            <a:ext cx="1710122" cy="148648"/>
+            <a:off x="9793548" y="5375216"/>
+            <a:ext cx="1577539" cy="148648"/>
           </a:xfrm>
           <a:prstGeom prst="rect">
             <a:avLst/>
@@ -23542,16 +23609,16 @@
       </p:sp>
       <p:sp>
         <p:nvSpPr>
-          <p:cNvPr id="9730" name="Invisible source link 10: https://trinetx.com/solutions/trinetx-live/terrain/">
-            <a:hlinkClick r:id="rId3"/>
+          <p:cNvPr id="9730" name="Invisible source link 10: https://www.eversana.com/insights/from-ai-answers-to-decision-grade-market-access/">
+            <a:hlinkClick r:id="rId12"/>
           </p:cNvPr>
           <p:cNvSpPr/>
           <p:nvPr/>
         </p:nvSpPr>
         <p:spPr>
           <a:xfrm>
-            <a:off x="749515" y="5694900"/>
-            <a:ext cx="485917" cy="148648"/>
+            <a:off x="6386753" y="5535058"/>
+            <a:ext cx="2735287" cy="148648"/>
           </a:xfrm>
           <a:prstGeom prst="rect">
             <a:avLst/>
@@ -23586,93 +23653,7 @@
       <p:sp>
         <p:nvSpPr>
           <p:cNvPr id="9730" name="Invisible source link 10: https://www.eversana.com/insights/from-ai-answers-to-decision-grade-market-access/">
-            <a:hlinkClick r:id="rId11"/>
-          </p:cNvPr>
-          <p:cNvSpPr/>
-          <p:nvPr/>
-        </p:nvSpPr>
-        <p:spPr>
-          <a:xfrm>
-            <a:off x="9793548" y="5375216"/>
-            <a:ext cx="1577539" cy="148648"/>
-          </a:xfrm>
-          <a:prstGeom prst="rect">
-            <a:avLst/>
-          </a:prstGeom>
-          <a:noFill/>
-          <a:ln>
-            <a:noFill/>
-          </a:ln>
-        </p:spPr>
-        <p:style>
-          <a:lnRef idx="1">
-            <a:schemeClr val="accent1"/>
-          </a:lnRef>
-          <a:fillRef idx="3">
-            <a:schemeClr val="accent1"/>
-          </a:fillRef>
-          <a:effectRef idx="2">
-            <a:schemeClr val="accent1"/>
-          </a:effectRef>
-          <a:fontRef idx="minor">
-            <a:schemeClr val="lt1"/>
-          </a:fontRef>
-        </p:style>
-        <p:txBody>
-          <a:bodyPr rtlCol="0" anchor="ctr"/>
-          <a:lstStyle/>
-          <a:p>
-            <a:pPr algn="ctr"/>
-          </a:p>
-        </p:txBody>
-      </p:sp>
-      <p:sp>
-        <p:nvSpPr>
-          <p:cNvPr id="9732" name="Invisible source link 10: https://www.eversana.com/insights/from-ai-answers-to-decision-grade-market-access/">
-            <a:hlinkClick r:id="rId11"/>
-          </p:cNvPr>
-          <p:cNvSpPr/>
-          <p:nvPr/>
-        </p:nvSpPr>
-        <p:spPr>
-          <a:xfrm>
-            <a:off x="6386753" y="5535058"/>
-            <a:ext cx="2735287" cy="148648"/>
-          </a:xfrm>
-          <a:prstGeom prst="rect">
-            <a:avLst/>
-          </a:prstGeom>
-          <a:noFill/>
-          <a:ln>
-            <a:noFill/>
-          </a:ln>
-        </p:spPr>
-        <p:style>
-          <a:lnRef idx="1">
-            <a:schemeClr val="accent1"/>
-          </a:lnRef>
-          <a:fillRef idx="3">
-            <a:schemeClr val="accent1"/>
-          </a:fillRef>
-          <a:effectRef idx="2">
-            <a:schemeClr val="accent1"/>
-          </a:effectRef>
-          <a:fontRef idx="minor">
-            <a:schemeClr val="lt1"/>
-          </a:fontRef>
-        </p:style>
-        <p:txBody>
-          <a:bodyPr rtlCol="0" anchor="ctr"/>
-          <a:lstStyle/>
-          <a:p>
-            <a:pPr algn="ctr"/>
-          </a:p>
-        </p:txBody>
-      </p:sp>
-      <p:sp>
-        <p:nvSpPr>
-          <p:cNvPr id="9732" name="Invisible source link 10: https://www.eversana.com/insights/from-ai-answers-to-decision-grade-market-access/">
-            <a:hlinkClick r:id="rId11"/>
+            <a:hlinkClick r:id="rId12"/>
           </p:cNvPr>
           <p:cNvSpPr/>
           <p:nvPr/>

</xml_diff>

<commit_message>
10.16: merge trials/access tables; add Citeline Ella, Veeva EDC AI Tab, MMIT Ella; TriNetX LIVE wording
Co-Authored-By: Claude Opus 5.5 <noreply@anthropic.com>
Claude-Session: https://claude.ai/code/session_0198bm9pfzRwgZQBqNvd56W8
</commit_message>
<xml_diff>
--- a/deck/Optum-LS-Conversational-AI-10.16.pptx
+++ b/deck/Optum-LS-Conversational-AI-10.16.pptx
@@ -22271,42 +22271,6 @@
           </a:p>
         </p:txBody>
       </p:sp>
-      <p:sp>
-        <p:nvSpPr>
-          <p:cNvPr id="14" name="label"/>
-          <p:cNvSpPr txBox="1"/>
-          <p:nvPr/>
-        </p:nvSpPr>
-        <p:spPr>
-          <a:xfrm>
-            <a:off x="548640" y="1481328"/>
-            <a:ext cx="11091672" cy="201168"/>
-          </a:xfrm>
-          <a:prstGeom prst="rect">
-            <a:avLst/>
-          </a:prstGeom>
-          <a:noFill/>
-          <a:ln/>
-        </p:spPr>
-        <p:txBody>
-          <a:bodyPr wrap="square" lIns="0" tIns="0" rIns="0" bIns="0" rtlCol="0" anchor="t"/>
-          <a:lstStyle/>
-          <a:p>
-            <a:pPr indent="0" marL="0">
-              <a:buNone/>
-            </a:pPr>
-            <a:r>
-              <a:rPr lang="en-US" sz="1000" b="1" spc="100" kern="0" dirty="0">
-                <a:solidFill>
-                  <a:schemeClr val="accent2"/>
-                </a:solidFill>
-              </a:rPr>
-              <a:t>CLINICAL TRIALS — COMPETITIVE EXAMPLES</a:t>
-            </a:r>
-            <a:endParaRPr lang="en-US" sz="1000" dirty="0"/>
-          </a:p>
-        </p:txBody>
-      </p:sp>
       <p:graphicFrame>
         <p:nvGraphicFramePr>
           <p:cNvPr id="10" name="task table"/>
@@ -22322,8 +22286,8 @@
           </p:nvPr>
         </p:nvGraphicFramePr>
         <p:xfrm>
-          <a:off x="548640" y="1755648"/>
-          <a:ext cx="11091672" cy="1088859"/>
+          <a:off x="548640" y="1481328"/>
+          <a:ext cx="11091672" cy="3008374"/>
         </p:xfrm>
         <a:graphic>
           <a:graphicData uri="http://schemas.openxmlformats.org/drawingml/2006/table">
@@ -22381,6 +22345,14 @@
                         <a:buNone/>
                       </a:pPr>
                       <a:r>
+                        <a:rPr lang="en-US" sz="1150" b="1" spc="100" kern="0" dirty="0">
+                          <a:solidFill>
+                            <a:srgbClr val="FF612B"/>
+                          </a:solidFill>
+                        </a:rPr>
+                        <a:t>CLINICAL TRIALS: </a:t>
+                      </a:r>
+                      <a:r>
                         <a:rPr lang="en-US" sz="900" b="1" spc="100" kern="0" dirty="0">
                           <a:solidFill>
                             <a:schemeClr val="bg1"/>
@@ -22447,7 +22419,7 @@
                   </a:tcPr>
                 </a:tc>
               </a:tr>
-              <a:tr h="759675">
+              <a:tr h="652932">
                 <a:tc>
                   <a:txBody>
                     <a:bodyPr/>
@@ -22525,7 +22497,7 @@
                         <a:t>TriNetX’s </a:t>
                       </a:r>
                       <a:r>
-                        <a:rPr lang="en-US" sz="950" b="1" dirty="0" u="sng">
+                        <a:rPr lang="en-US" sz="950" dirty="0" b="1" u="sng">
                           <a:solidFill>
                             <a:srgbClr val="002677"/>
                           </a:solidFill>
@@ -22535,7 +22507,7 @@
                             </a:solidFill>
                           </a:uFill>
                         </a:rPr>
-                        <a:t>Terrain AI Assistant</a:t>
+                        <a:t>LIVE Conversational AI + Terrain</a:t>
                       </a:r>
                       <a:r>
                         <a:rPr lang="en-US" sz="950" dirty="0">
@@ -22543,7 +22515,50 @@
                             <a:schemeClr val="tx1"/>
                           </a:solidFill>
                         </a:rPr>
-                        <a:t>: natural-language questions about trial sites, investigator experience and patient populations</a:t>
+                        <a:t>: Natural-language protocol feasibility, clinical-code generation and site/investigator intelligence;</a:t>
+                      </a:r>
+                      <a:endParaRPr lang="en-US" sz="950" dirty="0"/>
+                    </a:p>
+                    <a:p>
+                      <a:pPr indent="0" marL="0">
+                        <a:spcBef>
+                          <a:spcPts val="400"/>
+                        </a:spcBef>
+                        <a:buNone/>
+                      </a:pPr>
+                      <a:r>
+                        <a:rPr lang="en-US" sz="950" dirty="0" u="sng">
+                          <a:solidFill>
+                            <a:srgbClr val="002677"/>
+                          </a:solidFill>
+                          <a:uFill>
+                            <a:solidFill>
+                              <a:srgbClr val="9AA8CC"/>
+                            </a:solidFill>
+                          </a:uFill>
+                        </a:rPr>
+                        <a:t>Norstella’s </a:t>
+                      </a:r>
+                      <a:r>
+                        <a:rPr lang="en-US" sz="950" dirty="0" b="1" u="sng">
+                          <a:solidFill>
+                            <a:srgbClr val="002677"/>
+                          </a:solidFill>
+                          <a:uFill>
+                            <a:solidFill>
+                              <a:srgbClr val="9AA8CC"/>
+                            </a:solidFill>
+                          </a:uFill>
+                        </a:rPr>
+                        <a:t>Citeline Ella</a:t>
+                      </a:r>
+                      <a:r>
+                        <a:rPr lang="en-US" sz="950" dirty="0">
+                          <a:solidFill>
+                            <a:schemeClr val="tx1"/>
+                          </a:solidFill>
+                        </a:rPr>
+                        <a:t>: trial and site search strategies</a:t>
                       </a:r>
                       <a:endParaRPr lang="en-US" sz="950" dirty="0"/>
                     </a:p>
@@ -22642,74 +22657,7 @@
                   </a:tcPr>
                 </a:tc>
               </a:tr>
-            </a:tbl>
-          </a:graphicData>
-        </a:graphic>
-      </p:graphicFrame>
-      <p:sp>
-        <p:nvSpPr>
-          <p:cNvPr id="16" name="label"/>
-          <p:cNvSpPr txBox="1"/>
-          <p:nvPr/>
-        </p:nvSpPr>
-        <p:spPr>
-          <a:xfrm>
-            <a:off x="548640" y="2990811"/>
-            <a:ext cx="11091672" cy="201168"/>
-          </a:xfrm>
-          <a:prstGeom prst="rect">
-            <a:avLst/>
-          </a:prstGeom>
-          <a:noFill/>
-          <a:ln/>
-        </p:spPr>
-        <p:txBody>
-          <a:bodyPr wrap="square" lIns="0" tIns="0" rIns="0" bIns="0" rtlCol="0" anchor="t"/>
-          <a:lstStyle/>
-          <a:p>
-            <a:pPr indent="0" marL="0">
-              <a:buNone/>
-            </a:pPr>
-            <a:r>
-              <a:rPr lang="en-US" sz="1000" b="1" spc="100" kern="0" dirty="0">
-                <a:solidFill>
-                  <a:schemeClr val="accent2"/>
-                </a:solidFill>
-              </a:rPr>
-              <a:t>MARKET ACCESS — COMPETITIVE EXAMPLES</a:t>
-            </a:r>
-            <a:endParaRPr lang="en-US" sz="1000" dirty="0"/>
-          </a:p>
-        </p:txBody>
-      </p:sp>
-      <p:graphicFrame>
-        <p:nvGraphicFramePr>
-          <p:cNvPr id="19" name="task table"/>
-          <p:cNvGraphicFramePr>
-            <a:graphicFrameLocks noGrp="1"/>
-          </p:cNvGraphicFramePr>
-          <p:nvPr>
-            <p:extLst>
-              <p:ext uri="{D42A27DB-BD31-4B8C-83A1-F6EECF244321}">
-                <p14:modId xmlns:p14="http://schemas.microsoft.com/office/powerpoint/2010/main" val="1579011935"/>
-              </p:ext>
-            </p:extLst>
-          </p:nvPr>
-        </p:nvGraphicFramePr>
-        <p:xfrm>
-          <a:off x="548640" y="3265131"/>
-          <a:ext cx="11091672" cy="1224572"/>
-        </p:xfrm>
-        <a:graphic>
-          <a:graphicData uri="http://schemas.openxmlformats.org/drawingml/2006/table">
-            <a:tbl>
-              <a:tblPr/>
-              <a:tblGrid>
-                <a:gridCol w="2286000"/>
-                <a:gridCol w="5760720"/>
-                <a:gridCol w="3044952"/>
-              </a:tblGrid>
-              <a:tr h="329184">
+              <a:tr h="466445">
                 <a:tc>
                   <a:txBody>
                     <a:bodyPr/>
@@ -22719,125 +22667,12 @@
                         <a:buNone/>
                       </a:pPr>
                       <a:r>
-                        <a:rPr lang="en-US" sz="900" b="1" spc="100" kern="0" dirty="0">
-                          <a:solidFill>
-                            <a:schemeClr val="bg1"/>
-                          </a:solidFill>
-                        </a:rPr>
-                        <a:t>CUSTOMER TASK</a:t>
-                      </a:r>
-                      <a:endParaRPr lang="en-US" sz="900" dirty="0"/>
-                    </a:p>
-                  </a:txBody>
-                  <a:tcPr marL="109728" marR="109728" marT="64008" marB="64008" anchor="ctr">
-                    <a:lnL w="0" cap="flat" cmpd="sng" algn="ctr">
-                      <a:noFill/>
-                    </a:lnL>
-                    <a:lnR w="0" cap="flat" cmpd="sng" algn="ctr">
-                      <a:noFill/>
-                    </a:lnR>
-                    <a:lnT w="0" cap="flat" cmpd="sng" algn="ctr">
-                      <a:noFill/>
-                    </a:lnT>
-                    <a:lnB w="0" cap="flat" cmpd="sng" algn="ctr">
-                      <a:noFill/>
-                    </a:lnB>
-                    <a:solidFill>
-                      <a:schemeClr val="accent1"/>
-                    </a:solidFill>
-                  </a:tcPr>
-                </a:tc>
-                <a:tc>
-                  <a:txBody>
-                    <a:bodyPr/>
-                    <a:lstStyle/>
-                    <a:p>
-                      <a:pPr algn="ctr" indent="0" marL="0">
-                        <a:buNone/>
-                      </a:pPr>
-                      <a:r>
-                        <a:rPr lang="en-US" sz="900" b="1" spc="100" kern="0" dirty="0">
-                          <a:solidFill>
-                            <a:schemeClr val="bg1"/>
-                          </a:solidFill>
-                        </a:rPr>
-                        <a:t>CONVERSATIONAL AI OFFERINGS</a:t>
-                      </a:r>
-                      <a:endParaRPr lang="en-US" sz="900" dirty="0"/>
-                    </a:p>
-                  </a:txBody>
-                  <a:tcPr marL="109728" marR="109728" marT="64008" marB="64008" anchor="ctr">
-                    <a:lnL w="0" cap="flat" cmpd="sng" algn="ctr">
-                      <a:noFill/>
-                    </a:lnL>
-                    <a:lnR w="0" cap="flat" cmpd="sng" algn="ctr">
-                      <a:noFill/>
-                    </a:lnR>
-                    <a:lnT w="0" cap="flat" cmpd="sng" algn="ctr">
-                      <a:noFill/>
-                    </a:lnT>
-                    <a:lnB w="0" cap="flat" cmpd="sng" algn="ctr">
-                      <a:noFill/>
-                    </a:lnB>
-                    <a:solidFill>
-                      <a:schemeClr val="accent1"/>
-                    </a:solidFill>
-                  </a:tcPr>
-                </a:tc>
-                <a:tc>
-                  <a:txBody>
-                    <a:bodyPr/>
-                    <a:lstStyle/>
-                    <a:p>
-                      <a:pPr algn="ctr" indent="0" marL="0">
-                        <a:buNone/>
-                      </a:pPr>
-                      <a:r>
-                        <a:rPr lang="en-US" sz="900" b="1" spc="100" kern="0" dirty="0">
-                          <a:solidFill>
-                            <a:schemeClr val="bg1"/>
-                          </a:solidFill>
-                        </a:rPr>
-                        <a:t>RELEVANT OPTUM LS OFFERINGS</a:t>
-                      </a:r>
-                      <a:endParaRPr lang="en-US" sz="900" dirty="0"/>
-                    </a:p>
-                  </a:txBody>
-                  <a:tcPr marL="109728" marR="109728" marT="64008" marB="64008" anchor="ctr">
-                    <a:lnL w="0" cap="flat" cmpd="sng" algn="ctr">
-                      <a:noFill/>
-                    </a:lnL>
-                    <a:lnR w="0" cap="flat" cmpd="sng" algn="ctr">
-                      <a:noFill/>
-                    </a:lnR>
-                    <a:lnT w="0" cap="flat" cmpd="sng" algn="ctr">
-                      <a:noFill/>
-                    </a:lnT>
-                    <a:lnB w="0" cap="flat" cmpd="sng" algn="ctr">
-                      <a:noFill/>
-                    </a:lnB>
-                    <a:solidFill>
-                      <a:schemeClr val="accent1"/>
-                    </a:solidFill>
-                  </a:tcPr>
-                </a:tc>
-              </a:tr>
-              <a:tr h="895388">
-                <a:tc>
-                  <a:txBody>
-                    <a:bodyPr/>
-                    <a:lstStyle/>
-                    <a:p>
-                      <a:pPr algn="ctr" indent="0" marL="0">
-                        <a:buNone/>
-                      </a:pPr>
-                      <a:r>
                         <a:rPr lang="en-US" sz="1050" b="1" dirty="0">
                           <a:solidFill>
                             <a:schemeClr val="accent1"/>
                           </a:solidFill>
                         </a:rPr>
-                        <a:t>Pharmaceutical pricing and market-access intelligence</a:t>
+                        <a:t>Clinical-data operations</a:t>
                       </a:r>
                       <a:endParaRPr lang="en-US" sz="1050" dirty="0"/>
                     </a:p>
@@ -22897,10 +22732,10 @@
                             </a:solidFill>
                           </a:uFill>
                         </a:rPr>
-                        <a:t>EVERSANA’s </a:t>
-                      </a:r>
-                      <a:r>
-                        <a:rPr lang="en-US" sz="950" b="1" dirty="0" u="sng">
+                        <a:t>Veeva’s </a:t>
+                      </a:r>
+                      <a:r>
+                        <a:rPr lang="en-US" sz="950" dirty="0" b="1" u="sng">
                           <a:solidFill>
                             <a:srgbClr val="002677"/>
                           </a:solidFill>
@@ -22910,7 +22745,7 @@
                             </a:solidFill>
                           </a:uFill>
                         </a:rPr>
-                        <a:t>Ask NAVLIN</a:t>
+                        <a:t>EDC AI Tab</a:t>
                       </a:r>
                       <a:r>
                         <a:rPr lang="en-US" sz="950" dirty="0">
@@ -22918,7 +22753,7 @@
                             <a:schemeClr val="tx1"/>
                           </a:solidFill>
                         </a:rPr>
-                        <a:t>: conversational access to pricing, reimbursement and market-access information</a:t>
+                        <a:t>: questions on study operational data and help content, excluding site-entered casebook data</a:t>
                       </a:r>
                       <a:endParaRPr lang="en-US" sz="950" dirty="0"/>
                     </a:p>
@@ -22953,11 +22788,303 @@
                         <a:buNone/>
                       </a:pPr>
                       <a:r>
+                        <a:rPr lang="en-US" sz="950" dirty="0" b="1">
+                          <a:solidFill>
+                            <a:schemeClr val="tx1"/>
+                          </a:solidFill>
+                        </a:rPr>
+                        <a:t>True Source</a:t>
+                      </a:r>
+                      <a:r>
                         <a:rPr lang="en-US" sz="950" dirty="0">
                           <a:solidFill>
                             <a:schemeClr val="tx1"/>
                           </a:solidFill>
                         </a:rPr>
+                        <a:t> (electronic source-data capture); no comparable conversational assistant established</a:t>
+                      </a:r>
+                      <a:endParaRPr lang="en-US" sz="950" dirty="0"/>
+                    </a:p>
+                  </a:txBody>
+                  <a:tcPr marL="109728" marR="109728" marT="64008" marB="64008" anchor="ctr">
+                    <a:lnL w="0" cap="flat" cmpd="sng" algn="ctr">
+                      <a:noFill/>
+                    </a:lnL>
+                    <a:lnR w="0" cap="flat" cmpd="sng" algn="ctr">
+                      <a:noFill/>
+                    </a:lnR>
+                    <a:lnT w="0" cap="flat" cmpd="sng" algn="ctr">
+                      <a:noFill/>
+                    </a:lnT>
+                    <a:lnB w="9525" cap="flat" cmpd="sng" algn="ctr">
+                      <a:solidFill>
+                        <a:srgbClr val="D9D4C7"/>
+                      </a:solidFill>
+                      <a:prstDash val="solid"/>
+                      <a:round/>
+                      <a:headEnd type="none" w="med" len="med"/>
+                      <a:tailEnd type="none" w="med" len="med"/>
+                    </a:lnB>
+                  </a:tcPr>
+                </a:tc>
+              </a:tr>
+              <a:tr h="329184">
+                <a:tc>
+                  <a:txBody>
+                    <a:bodyPr/>
+                    <a:lstStyle/>
+                    <a:p>
+                      <a:pPr algn="ctr" indent="0" marL="0">
+                        <a:buNone/>
+                      </a:pPr>
+                      <a:r>
+                        <a:rPr lang="en-US" sz="900" b="1" spc="100" kern="0" dirty="0">
+                          <a:solidFill>
+                            <a:schemeClr val="bg1"/>
+                          </a:solidFill>
+                        </a:rPr>
+                        <a:t>CUSTOMER TASK</a:t>
+                      </a:r>
+                      <a:endParaRPr lang="en-US" sz="900" dirty="0"/>
+                    </a:p>
+                  </a:txBody>
+                  <a:tcPr marL="109728" marR="109728" marT="64008" marB="64008" anchor="ctr">
+                    <a:lnL w="0" cap="flat" cmpd="sng" algn="ctr">
+                      <a:noFill/>
+                    </a:lnL>
+                    <a:lnR w="0" cap="flat" cmpd="sng" algn="ctr">
+                      <a:noFill/>
+                    </a:lnR>
+                    <a:lnT w="0" cap="flat" cmpd="sng" algn="ctr">
+                      <a:noFill/>
+                    </a:lnT>
+                    <a:lnB w="0" cap="flat" cmpd="sng" algn="ctr">
+                      <a:noFill/>
+                    </a:lnB>
+                    <a:solidFill>
+                      <a:schemeClr val="accent1"/>
+                    </a:solidFill>
+                  </a:tcPr>
+                </a:tc>
+                <a:tc>
+                  <a:txBody>
+                    <a:bodyPr/>
+                    <a:lstStyle/>
+                    <a:p>
+                      <a:pPr algn="ctr" indent="0" marL="0">
+                        <a:buNone/>
+                      </a:pPr>
+                      <a:r>
+                        <a:rPr lang="en-US" sz="1150" b="1" spc="100" kern="0" dirty="0">
+                          <a:solidFill>
+                            <a:srgbClr val="FF612B"/>
+                          </a:solidFill>
+                        </a:rPr>
+                        <a:t>MARKET ACCESS: </a:t>
+                      </a:r>
+                      <a:r>
+                        <a:rPr lang="en-US" sz="900" b="1" spc="100" kern="0" dirty="0">
+                          <a:solidFill>
+                            <a:schemeClr val="bg1"/>
+                          </a:solidFill>
+                        </a:rPr>
+                        <a:t>CONVERSATIONAL AI OFFERINGS</a:t>
+                      </a:r>
+                      <a:endParaRPr lang="en-US" sz="900" dirty="0"/>
+                    </a:p>
+                  </a:txBody>
+                  <a:tcPr marL="109728" marR="109728" marT="64008" marB="64008" anchor="ctr">
+                    <a:lnL w="0" cap="flat" cmpd="sng" algn="ctr">
+                      <a:noFill/>
+                    </a:lnL>
+                    <a:lnR w="0" cap="flat" cmpd="sng" algn="ctr">
+                      <a:noFill/>
+                    </a:lnR>
+                    <a:lnT w="0" cap="flat" cmpd="sng" algn="ctr">
+                      <a:noFill/>
+                    </a:lnT>
+                    <a:lnB w="0" cap="flat" cmpd="sng" algn="ctr">
+                      <a:noFill/>
+                    </a:lnB>
+                    <a:solidFill>
+                      <a:schemeClr val="accent1"/>
+                    </a:solidFill>
+                  </a:tcPr>
+                </a:tc>
+                <a:tc>
+                  <a:txBody>
+                    <a:bodyPr/>
+                    <a:lstStyle/>
+                    <a:p>
+                      <a:pPr algn="ctr" indent="0" marL="0">
+                        <a:buNone/>
+                      </a:pPr>
+                      <a:r>
+                        <a:rPr lang="en-US" sz="900" b="1" spc="100" kern="0" dirty="0">
+                          <a:solidFill>
+                            <a:schemeClr val="bg1"/>
+                          </a:solidFill>
+                        </a:rPr>
+                        <a:t>RELEVANT OPTUM LS OFFERINGS</a:t>
+                      </a:r>
+                      <a:endParaRPr lang="en-US" sz="900" dirty="0"/>
+                    </a:p>
+                  </a:txBody>
+                  <a:tcPr marL="109728" marR="109728" marT="64008" marB="64008" anchor="ctr">
+                    <a:lnL w="0" cap="flat" cmpd="sng" algn="ctr">
+                      <a:noFill/>
+                    </a:lnL>
+                    <a:lnR w="0" cap="flat" cmpd="sng" algn="ctr">
+                      <a:noFill/>
+                    </a:lnR>
+                    <a:lnT w="0" cap="flat" cmpd="sng" algn="ctr">
+                      <a:noFill/>
+                    </a:lnT>
+                    <a:lnB w="0" cap="flat" cmpd="sng" algn="ctr">
+                      <a:noFill/>
+                    </a:lnB>
+                    <a:solidFill>
+                      <a:schemeClr val="accent1"/>
+                    </a:solidFill>
+                  </a:tcPr>
+                </a:tc>
+              </a:tr>
+              <a:tr h="737882">
+                <a:tc>
+                  <a:txBody>
+                    <a:bodyPr/>
+                    <a:lstStyle/>
+                    <a:p>
+                      <a:pPr algn="ctr" indent="0" marL="0">
+                        <a:buNone/>
+                      </a:pPr>
+                      <a:r>
+                        <a:rPr lang="en-US" sz="1050" b="1" dirty="0">
+                          <a:solidFill>
+                            <a:schemeClr val="accent1"/>
+                          </a:solidFill>
+                        </a:rPr>
+                        <a:t>Pharmaceutical pricing and market-access intelligence</a:t>
+                      </a:r>
+                      <a:endParaRPr lang="en-US" sz="1050" dirty="0"/>
+                    </a:p>
+                  </a:txBody>
+                  <a:tcPr marL="109728" marR="109728" marT="64008" marB="64008" anchor="ctr">
+                    <a:lnL w="0" cap="flat" cmpd="sng" algn="ctr">
+                      <a:noFill/>
+                    </a:lnL>
+                    <a:lnR w="25400" cap="flat" cmpd="sng" algn="ctr">
+                      <a:solidFill>
+                        <a:srgbClr val="FFFFFF"/>
+                      </a:solidFill>
+                      <a:prstDash val="solid"/>
+                      <a:round/>
+                      <a:headEnd type="none" w="med" len="med"/>
+                      <a:tailEnd type="none" w="med" len="med"/>
+                    </a:lnR>
+                    <a:lnT w="25400" cap="flat" cmpd="sng" algn="ctr">
+                      <a:solidFill>
+                        <a:srgbClr val="FFFFFF"/>
+                      </a:solidFill>
+                      <a:prstDash val="solid"/>
+                      <a:round/>
+                      <a:headEnd type="none" w="med" len="med"/>
+                      <a:tailEnd type="none" w="med" len="med"/>
+                    </a:lnT>
+                    <a:lnB w="25400" cap="flat" cmpd="sng" algn="ctr">
+                      <a:solidFill>
+                        <a:srgbClr val="FFFFFF"/>
+                      </a:solidFill>
+                      <a:prstDash val="solid"/>
+                      <a:round/>
+                      <a:headEnd type="none" w="med" len="med"/>
+                      <a:tailEnd type="none" w="med" len="med"/>
+                    </a:lnB>
+                    <a:solidFill>
+                      <a:schemeClr val="accent5"/>
+                    </a:solidFill>
+                  </a:tcPr>
+                </a:tc>
+                <a:tc>
+                  <a:txBody>
+                    <a:bodyPr/>
+                    <a:lstStyle/>
+                    <a:p>
+                      <a:pPr indent="0" marL="0">
+                        <a:buNone/>
+                      </a:pPr>
+                      <a:r>
+                        <a:rPr lang="en-US" sz="950" dirty="0" u="sng">
+                          <a:solidFill>
+                            <a:srgbClr val="002677"/>
+                          </a:solidFill>
+                          <a:uFill>
+                            <a:solidFill>
+                              <a:srgbClr val="9AA8CC"/>
+                            </a:solidFill>
+                          </a:uFill>
+                        </a:rPr>
+                        <a:t>EVERSANA’s </a:t>
+                      </a:r>
+                      <a:r>
+                        <a:rPr lang="en-US" sz="950" b="1" dirty="0" u="sng">
+                          <a:solidFill>
+                            <a:srgbClr val="002677"/>
+                          </a:solidFill>
+                          <a:uFill>
+                            <a:solidFill>
+                              <a:srgbClr val="9AA8CC"/>
+                            </a:solidFill>
+                          </a:uFill>
+                        </a:rPr>
+                        <a:t>Ask NAVLIN</a:t>
+                      </a:r>
+                      <a:r>
+                        <a:rPr lang="en-US" sz="950" dirty="0">
+                          <a:solidFill>
+                            <a:schemeClr val="tx1"/>
+                          </a:solidFill>
+                        </a:rPr>
+                        <a:t>: conversational access to pricing, reimbursement and market-access information</a:t>
+                      </a:r>
+                      <a:endParaRPr lang="en-US" sz="950" dirty="0"/>
+                    </a:p>
+                  </a:txBody>
+                  <a:tcPr marL="109728" marR="109728" marT="64008" marB="64008" anchor="ctr">
+                    <a:lnL w="0" cap="flat" cmpd="sng" algn="ctr">
+                      <a:noFill/>
+                    </a:lnL>
+                    <a:lnR w="0" cap="flat" cmpd="sng" algn="ctr">
+                      <a:noFill/>
+                    </a:lnR>
+                    <a:lnT w="0" cap="flat" cmpd="sng" algn="ctr">
+                      <a:noFill/>
+                    </a:lnT>
+                    <a:lnB w="9525" cap="flat" cmpd="sng" algn="ctr">
+                      <a:solidFill>
+                        <a:srgbClr val="D9D4C7"/>
+                      </a:solidFill>
+                      <a:prstDash val="solid"/>
+                      <a:round/>
+                      <a:headEnd type="none" w="med" len="med"/>
+                      <a:tailEnd type="none" w="med" len="med"/>
+                    </a:lnB>
+                  </a:tcPr>
+                </a:tc>
+                <a:tc>
+                  <a:txBody>
+                    <a:bodyPr/>
+                    <a:lstStyle/>
+                    <a:p>
+                      <a:pPr indent="0" marL="0">
+                        <a:buNone/>
+                      </a:pPr>
+                      <a:r>
+                        <a:rPr lang="en-US" sz="950" dirty="0">
+                          <a:solidFill>
+                            <a:schemeClr val="tx1"/>
+                          </a:solidFill>
+                        </a:rPr>
                         <a:t>HEOR/value evidence</a:t>
                       </a:r>
                       <a:r>
@@ -23015,6 +23142,169 @@
                           </a:solidFill>
                         </a:rPr>
                         <a:t> (cost and budget scenarios)</a:t>
+                      </a:r>
+                      <a:endParaRPr lang="en-US" sz="950" dirty="0"/>
+                    </a:p>
+                  </a:txBody>
+                  <a:tcPr marL="109728" marR="109728" marT="64008" marB="64008" anchor="ctr">
+                    <a:lnL w="0" cap="flat" cmpd="sng" algn="ctr">
+                      <a:noFill/>
+                    </a:lnL>
+                    <a:lnR w="0" cap="flat" cmpd="sng" algn="ctr">
+                      <a:noFill/>
+                    </a:lnR>
+                    <a:lnT w="0" cap="flat" cmpd="sng" algn="ctr">
+                      <a:noFill/>
+                    </a:lnT>
+                    <a:lnB w="9525" cap="flat" cmpd="sng" algn="ctr">
+                      <a:solidFill>
+                        <a:srgbClr val="D9D4C7"/>
+                      </a:solidFill>
+                      <a:prstDash val="solid"/>
+                      <a:round/>
+                      <a:headEnd type="none" w="med" len="med"/>
+                      <a:tailEnd type="none" w="med" len="med"/>
+                    </a:lnB>
+                  </a:tcPr>
+                </a:tc>
+              </a:tr>
+              <a:tr h="492747">
+                <a:tc>
+                  <a:txBody>
+                    <a:bodyPr/>
+                    <a:lstStyle/>
+                    <a:p>
+                      <a:pPr algn="ctr" indent="0" marL="0">
+                        <a:buNone/>
+                      </a:pPr>
+                      <a:r>
+                        <a:rPr lang="en-US" sz="1050" b="1" dirty="0">
+                          <a:solidFill>
+                            <a:schemeClr val="accent1"/>
+                          </a:solidFill>
+                        </a:rPr>
+                        <a:t>Payer feedback and coverage intelligence</a:t>
+                      </a:r>
+                      <a:endParaRPr lang="en-US" sz="1050" dirty="0"/>
+                    </a:p>
+                  </a:txBody>
+                  <a:tcPr marL="109728" marR="109728" marT="64008" marB="64008" anchor="ctr">
+                    <a:lnL w="0" cap="flat" cmpd="sng" algn="ctr">
+                      <a:noFill/>
+                    </a:lnL>
+                    <a:lnR w="25400" cap="flat" cmpd="sng" algn="ctr">
+                      <a:solidFill>
+                        <a:srgbClr val="FFFFFF"/>
+                      </a:solidFill>
+                      <a:prstDash val="solid"/>
+                      <a:round/>
+                      <a:headEnd type="none" w="med" len="med"/>
+                      <a:tailEnd type="none" w="med" len="med"/>
+                    </a:lnR>
+                    <a:lnT w="25400" cap="flat" cmpd="sng" algn="ctr">
+                      <a:solidFill>
+                        <a:srgbClr val="FFFFFF"/>
+                      </a:solidFill>
+                      <a:prstDash val="solid"/>
+                      <a:round/>
+                      <a:headEnd type="none" w="med" len="med"/>
+                      <a:tailEnd type="none" w="med" len="med"/>
+                    </a:lnT>
+                    <a:lnB w="25400" cap="flat" cmpd="sng" algn="ctr">
+                      <a:solidFill>
+                        <a:srgbClr val="FFFFFF"/>
+                      </a:solidFill>
+                      <a:prstDash val="solid"/>
+                      <a:round/>
+                      <a:headEnd type="none" w="med" len="med"/>
+                      <a:tailEnd type="none" w="med" len="med"/>
+                    </a:lnB>
+                    <a:solidFill>
+                      <a:schemeClr val="accent5"/>
+                    </a:solidFill>
+                  </a:tcPr>
+                </a:tc>
+                <a:tc>
+                  <a:txBody>
+                    <a:bodyPr/>
+                    <a:lstStyle/>
+                    <a:p>
+                      <a:pPr indent="0" marL="0">
+                        <a:buNone/>
+                      </a:pPr>
+                      <a:r>
+                        <a:rPr lang="en-US" sz="950" dirty="0" u="sng">
+                          <a:solidFill>
+                            <a:srgbClr val="002677"/>
+                          </a:solidFill>
+                          <a:uFill>
+                            <a:solidFill>
+                              <a:srgbClr val="9AA8CC"/>
+                            </a:solidFill>
+                          </a:uFill>
+                        </a:rPr>
+                        <a:t>Norstella’s </a:t>
+                      </a:r>
+                      <a:r>
+                        <a:rPr lang="en-US" sz="950" dirty="0" b="1" u="sng">
+                          <a:solidFill>
+                            <a:srgbClr val="002677"/>
+                          </a:solidFill>
+                          <a:uFill>
+                            <a:solidFill>
+                              <a:srgbClr val="9AA8CC"/>
+                            </a:solidFill>
+                          </a:uFill>
+                        </a:rPr>
+                        <a:t>MMIT Ella</a:t>
+                      </a:r>
+                      <a:r>
+                        <a:rPr lang="en-US" sz="950" dirty="0">
+                          <a:solidFill>
+                            <a:schemeClr val="tx1"/>
+                          </a:solidFill>
+                        </a:rPr>
+                        <a:t>: plain-language answers grounded in formulary, coverage and payer-feedback data</a:t>
+                      </a:r>
+                      <a:endParaRPr lang="en-US" sz="950" dirty="0"/>
+                    </a:p>
+                  </a:txBody>
+                  <a:tcPr marL="109728" marR="109728" marT="64008" marB="64008" anchor="ctr">
+                    <a:lnL w="0" cap="flat" cmpd="sng" algn="ctr">
+                      <a:noFill/>
+                    </a:lnL>
+                    <a:lnR w="0" cap="flat" cmpd="sng" algn="ctr">
+                      <a:noFill/>
+                    </a:lnR>
+                    <a:lnT w="0" cap="flat" cmpd="sng" algn="ctr">
+                      <a:noFill/>
+                    </a:lnT>
+                    <a:lnB w="9525" cap="flat" cmpd="sng" algn="ctr">
+                      <a:solidFill>
+                        <a:srgbClr val="D9D4C7"/>
+                      </a:solidFill>
+                      <a:prstDash val="solid"/>
+                      <a:round/>
+                      <a:headEnd type="none" w="med" len="med"/>
+                      <a:tailEnd type="none" w="med" len="med"/>
+                    </a:lnB>
+                  </a:tcPr>
+                </a:tc>
+                <a:tc>
+                  <a:txBody>
+                    <a:bodyPr/>
+                    <a:lstStyle/>
+                    <a:p>
+                      <a:pPr indent="0" marL="0">
+                        <a:buNone/>
+                      </a:pPr>
+                      <a:r>
+                        <a:rPr lang="en-US" sz="950" dirty="0">
+                          <a:solidFill>
+                            <a:schemeClr val="tx1"/>
+                          </a:solidFill>
+                        </a:rPr>
+                        <a:t>No comparable offering established</a:t>
                       </a:r>
                       <a:endParaRPr lang="en-US" sz="950" dirty="0"/>
                     </a:p>
@@ -23394,7 +23684,7 @@
       </p:sp>
       <p:sp>
         <p:nvSpPr>
-          <p:cNvPr id="9724" name="Invisible source link 10: https://trinetx.com/press-releases/trinetx-unveils-conversational-ai-interface-and-enhanced-api-capabilities/">
+          <p:cNvPr id="9721" name="Invisible source link 10: https://trinetx.com/press-releases/trinetx-unveils-conversational-ai-interface-and-enhanced-api-capabilities/">
             <a:hlinkClick r:id="rId10"/>
           </p:cNvPr>
           <p:cNvSpPr/>
@@ -23402,8 +23692,8 @@
         </p:nvSpPr>
         <p:spPr>
           <a:xfrm>
-            <a:off x="2944075" y="2329499"/>
-            <a:ext cx="1673204" cy="134588"/>
+            <a:off x="2944075" y="1908303"/>
+            <a:ext cx="2410845" cy="134588"/>
           </a:xfrm>
           <a:prstGeom prst="rect">
             <a:avLst/>
@@ -23437,7 +23727,7 @@
       </p:sp>
       <p:sp>
         <p:nvSpPr>
-          <p:cNvPr id="9725" name="Invisible source link 10: https://www.navlin.com/products/tender">
+          <p:cNvPr id="9722" name="Invisible source link 10: https://www.navlin.com/products/tender">
             <a:hlinkClick r:id="rId6"/>
           </p:cNvPr>
           <p:cNvSpPr/>
@@ -23445,7 +23735,7 @@
         </p:nvSpPr>
         <p:spPr>
           <a:xfrm>
-            <a:off x="2944075" y="3906661"/>
+            <a:off x="2944075" y="3491942"/>
             <a:ext cx="1490324" cy="134588"/>
           </a:xfrm>
           <a:prstGeom prst="rect">
@@ -23480,7 +23770,7 @@
       </p:sp>
       <p:sp>
         <p:nvSpPr>
-          <p:cNvPr id="9726" name="Invisible source link 10: https://clinicaldata.veevavault.help/en/lr/rn/limited-releases/26r3/new-features">
+          <p:cNvPr id="9723" name="Invisible source link 10: https://citeline.com/plus">
             <a:hlinkClick r:id="rId11"/>
           </p:cNvPr>
           <p:cNvSpPr/>
@@ -23488,8 +23778,8 @@
         </p:nvSpPr>
         <p:spPr>
           <a:xfrm>
-            <a:off x="5037945" y="5375216"/>
-            <a:ext cx="542086" cy="148648"/>
+            <a:off x="2944075" y="2230502"/>
+            <a:ext cx="1307444" cy="134588"/>
           </a:xfrm>
           <a:prstGeom prst="rect">
             <a:avLst/>
@@ -23523,16 +23813,16 @@
       </p:sp>
       <p:sp>
         <p:nvSpPr>
-          <p:cNvPr id="9728" name="Invisible source link 10: https://clinicaldata.veevavault.help/en/lr/rn/limited-releases/26r3/new-features">
-            <a:hlinkClick r:id="rId11"/>
+          <p:cNvPr id="9724" name="Invisible source link 10: https://clinicaldata.veevavault.help/en/lr/rn/limited-releases/26r3/new-features">
+            <a:hlinkClick r:id="rId12"/>
           </p:cNvPr>
           <p:cNvSpPr/>
           <p:nvPr/>
         </p:nvSpPr>
         <p:spPr>
           <a:xfrm>
-            <a:off x="749515" y="5535058"/>
-            <a:ext cx="3384273" cy="148648"/>
+            <a:off x="2944075" y="2560981"/>
+            <a:ext cx="1127447" cy="134588"/>
           </a:xfrm>
           <a:prstGeom prst="rect">
             <a:avLst/>
@@ -23566,16 +23856,16 @@
       </p:sp>
       <p:sp>
         <p:nvSpPr>
-          <p:cNvPr id="9728" name="Invisible source link 10: https://www.eversana.com/insights/from-ai-answers-to-decision-grade-market-access/">
-            <a:hlinkClick r:id="rId12"/>
+          <p:cNvPr id="9725" name="Invisible source link 10: https://www.mmitnetwork.com/mosaic/">
+            <a:hlinkClick r:id="rId13"/>
           </p:cNvPr>
           <p:cNvSpPr/>
           <p:nvPr/>
         </p:nvSpPr>
         <p:spPr>
           <a:xfrm>
-            <a:off x="9793548" y="5375216"/>
-            <a:ext cx="1577539" cy="148648"/>
+            <a:off x="2944075" y="4107181"/>
+            <a:ext cx="1181092" cy="134588"/>
           </a:xfrm>
           <a:prstGeom prst="rect">
             <a:avLst/>
@@ -23609,7 +23899,7 @@
       </p:sp>
       <p:sp>
         <p:nvSpPr>
-          <p:cNvPr id="9730" name="Invisible source link 10: https://www.eversana.com/insights/from-ai-answers-to-decision-grade-market-access/">
+          <p:cNvPr id="9726" name="Invisible source link 10: https://clinicaldata.veevavault.help/en/lr/rn/limited-releases/26r3/new-features">
             <a:hlinkClick r:id="rId12"/>
           </p:cNvPr>
           <p:cNvSpPr/>
@@ -23617,8 +23907,8 @@
         </p:nvSpPr>
         <p:spPr>
           <a:xfrm>
-            <a:off x="6386753" y="5535058"/>
-            <a:ext cx="2735287" cy="148648"/>
+            <a:off x="5037945" y="5375216"/>
+            <a:ext cx="542086" cy="148648"/>
           </a:xfrm>
           <a:prstGeom prst="rect">
             <a:avLst/>
@@ -23652,8 +23942,137 @@
       </p:sp>
       <p:sp>
         <p:nvSpPr>
+          <p:cNvPr id="9728" name="Invisible source link 10: https://clinicaldata.veevavault.help/en/lr/rn/limited-releases/26r3/new-features">
+            <a:hlinkClick r:id="rId12"/>
+          </p:cNvPr>
+          <p:cNvSpPr/>
+          <p:nvPr/>
+        </p:nvSpPr>
+        <p:spPr>
+          <a:xfrm>
+            <a:off x="749515" y="5535058"/>
+            <a:ext cx="3384273" cy="148648"/>
+          </a:xfrm>
+          <a:prstGeom prst="rect">
+            <a:avLst/>
+          </a:prstGeom>
+          <a:noFill/>
+          <a:ln>
+            <a:noFill/>
+          </a:ln>
+        </p:spPr>
+        <p:style>
+          <a:lnRef idx="1">
+            <a:schemeClr val="accent1"/>
+          </a:lnRef>
+          <a:fillRef idx="3">
+            <a:schemeClr val="accent1"/>
+          </a:fillRef>
+          <a:effectRef idx="2">
+            <a:schemeClr val="accent1"/>
+          </a:effectRef>
+          <a:fontRef idx="minor">
+            <a:schemeClr val="lt1"/>
+          </a:fontRef>
+        </p:style>
+        <p:txBody>
+          <a:bodyPr rtlCol="0" anchor="ctr"/>
+          <a:lstStyle/>
+          <a:p>
+            <a:pPr algn="ctr"/>
+          </a:p>
+        </p:txBody>
+      </p:sp>
+      <p:sp>
+        <p:nvSpPr>
+          <p:cNvPr id="9728" name="Invisible source link 10: https://www.eversana.com/insights/from-ai-answers-to-decision-grade-market-access/">
+            <a:hlinkClick r:id="rId14"/>
+          </p:cNvPr>
+          <p:cNvSpPr/>
+          <p:nvPr/>
+        </p:nvSpPr>
+        <p:spPr>
+          <a:xfrm>
+            <a:off x="9793548" y="5375216"/>
+            <a:ext cx="1577539" cy="148648"/>
+          </a:xfrm>
+          <a:prstGeom prst="rect">
+            <a:avLst/>
+          </a:prstGeom>
+          <a:noFill/>
+          <a:ln>
+            <a:noFill/>
+          </a:ln>
+        </p:spPr>
+        <p:style>
+          <a:lnRef idx="1">
+            <a:schemeClr val="accent1"/>
+          </a:lnRef>
+          <a:fillRef idx="3">
+            <a:schemeClr val="accent1"/>
+          </a:fillRef>
+          <a:effectRef idx="2">
+            <a:schemeClr val="accent1"/>
+          </a:effectRef>
+          <a:fontRef idx="minor">
+            <a:schemeClr val="lt1"/>
+          </a:fontRef>
+        </p:style>
+        <p:txBody>
+          <a:bodyPr rtlCol="0" anchor="ctr"/>
+          <a:lstStyle/>
+          <a:p>
+            <a:pPr algn="ctr"/>
+          </a:p>
+        </p:txBody>
+      </p:sp>
+      <p:sp>
+        <p:nvSpPr>
           <p:cNvPr id="9730" name="Invisible source link 10: https://www.eversana.com/insights/from-ai-answers-to-decision-grade-market-access/">
-            <a:hlinkClick r:id="rId12"/>
+            <a:hlinkClick r:id="rId14"/>
+          </p:cNvPr>
+          <p:cNvSpPr/>
+          <p:nvPr/>
+        </p:nvSpPr>
+        <p:spPr>
+          <a:xfrm>
+            <a:off x="6386753" y="5535058"/>
+            <a:ext cx="2735287" cy="148648"/>
+          </a:xfrm>
+          <a:prstGeom prst="rect">
+            <a:avLst/>
+          </a:prstGeom>
+          <a:noFill/>
+          <a:ln>
+            <a:noFill/>
+          </a:ln>
+        </p:spPr>
+        <p:style>
+          <a:lnRef idx="1">
+            <a:schemeClr val="accent1"/>
+          </a:lnRef>
+          <a:fillRef idx="3">
+            <a:schemeClr val="accent1"/>
+          </a:fillRef>
+          <a:effectRef idx="2">
+            <a:schemeClr val="accent1"/>
+          </a:effectRef>
+          <a:fontRef idx="minor">
+            <a:schemeClr val="lt1"/>
+          </a:fontRef>
+        </p:style>
+        <p:txBody>
+          <a:bodyPr rtlCol="0" anchor="ctr"/>
+          <a:lstStyle/>
+          <a:p>
+            <a:pPr algn="ctr"/>
+          </a:p>
+        </p:txBody>
+      </p:sp>
+      <p:sp>
+        <p:nvSpPr>
+          <p:cNvPr id="9730" name="Invisible source link 10: https://www.eversana.com/insights/from-ai-answers-to-decision-grade-market-access/">
+            <a:hlinkClick r:id="rId14"/>
           </p:cNvPr>
           <p:cNvSpPr/>
           <p:nvPr/>

</xml_diff>

<commit_message>
10.16: add 'how the products are built' slide (four layers, 18 source links)
Co-Authored-By: Claude Opus 5.5 <noreply@anthropic.com>
Claude-Session: https://claude.ai/code/session_0198bm9pfzRwgZQBqNvd56W8
</commit_message>
<xml_diff>
--- a/deck/Optum-LS-Conversational-AI-10.16.pptx
+++ b/deck/Optum-LS-Conversational-AI-10.16.pptx
@@ -14,6 +14,7 @@
     <p:sldId id="262" r:id="rId8"/>
     <p:sldId id="263" r:id="rId9"/>
     <p:sldId id="264" r:id="rId10"/>
+    <p:sldId id="270" r:id="rId20"/>
     <p:sldId id="265" r:id="rId11"/>
     <p:sldId id="269" r:id="rId13"/>
     <p:sldId id="266" r:id="rId12"/>
@@ -3264,22 +3265,15 @@
 </file>
 
 <file path=ppt/slides/slide10.xml><?xml version="1.0" encoding="utf-8"?>
-<p:sld xmlns:a="http://schemas.openxmlformats.org/drawingml/2006/main" xmlns:r="http://schemas.openxmlformats.org/officeDocument/2006/relationships" xmlns:p="http://schemas.openxmlformats.org/presentationml/2006/main">
-  <p:cSld name="Slide 10">
+<p:sld xmlns:a="http://schemas.openxmlformats.org/drawingml/2006/main" xmlns:p="http://schemas.openxmlformats.org/presentationml/2006/main" xmlns:r="http://schemas.openxmlformats.org/officeDocument/2006/relationships">
+  <p:cSld>
     <p:spTree>
       <p:nvGrpSpPr>
         <p:cNvPr id="1" name=""/>
         <p:cNvGrpSpPr/>
         <p:nvPr/>
       </p:nvGrpSpPr>
-      <p:grpSpPr>
-        <a:xfrm>
-          <a:off x="0" y="0"/>
-          <a:ext cx="0" cy="0"/>
-          <a:chOff x="0" y="0"/>
-          <a:chExt cx="0" cy="0"/>
-        </a:xfrm>
-      </p:grpSpPr>
+      <p:grpSpPr/>
       <p:sp>
         <p:nvSpPr>
           <p:cNvPr id="2" name="Text 2"/>
@@ -3312,7 +3306,7 @@
                   <a:schemeClr val="accent2"/>
                 </a:solidFill>
               </a:rPr>
-              <a:t>ADDITIONAL COMPETITIVE DYNAMIC: LLM PROVIDERS EXPAND INTO LIFE SCIENCES</a:t>
+              <a:t>ACROSS ALL FIVE DOMAINS: HOW THE PRODUCTS ARE BUILT</a:t>
             </a:r>
             <a:endParaRPr lang="en-US" sz="1000" dirty="0"/>
           </a:p>
@@ -3350,7 +3344,7 @@
                   <a:schemeClr val="accent1"/>
                 </a:solidFill>
               </a:rPr>
-              <a:t>LLM providers now supply, build and buy their way into life sciences, making them potential partners and rivals</a:t>
+              <a:t>Behind the products, competitors lead with their data and controls; the model, and even the interface, can come from outside</a:t>
             </a:r>
             <a:endParaRPr lang="en-US" sz="2200" dirty="0"/>
           </a:p>
@@ -3386,7 +3380,7 @@
                   <a:schemeClr val="accent2"/>
                 </a:solidFill>
               </a:rPr>
-              <a:t>THREE OBSERVED APPROACHES TO ENTERING LIFE SCIENCES</a:t>
+              <a:t>FOUR LAYERS OF A CONVERSATIONAL AI PRODUCT</a:t>
             </a:r>
             <a:endParaRPr lang="en-US" sz="1000" dirty="0"/>
           </a:p>
@@ -3407,17 +3401,17 @@
           </p:nvPr>
         </p:nvGraphicFramePr>
         <p:xfrm>
-          <a:off x="548640" y="1737360"/>
-          <a:ext cx="11091672" cy="3017518"/>
+          <a:off x="548640" y="1755648"/>
+          <a:ext cx="11091672" cy="2743199"/>
         </p:xfrm>
         <a:graphic>
           <a:graphicData uri="http://schemas.openxmlformats.org/drawingml/2006/table">
             <a:tbl>
               <a:tblPr/>
               <a:tblGrid>
-                <a:gridCol w="1965960"/>
-                <a:gridCol w="5349240"/>
-                <a:gridCol w="3776472"/>
+                <a:gridCol w="2011680"/>
+                <a:gridCol w="6537960"/>
+                <a:gridCol w="2542032"/>
               </a:tblGrid>
               <a:tr h="402336">
                 <a:tc>
@@ -3429,12 +3423,12 @@
                         <a:buNone/>
                       </a:pPr>
                       <a:r>
-                        <a:rPr lang="en-US" sz="900" b="1" spc="0" kern="0" dirty="0">
+                        <a:rPr lang="en-US" sz="900" b="1" spc="100" kern="0" dirty="0">
                           <a:solidFill>
                             <a:schemeClr val="bg1"/>
                           </a:solidFill>
                         </a:rPr>
-                        <a:t>LLM PROVIDER APPROACH</a:t>
+                        <a:t>LAYER</a:t>
                       </a:r>
                       <a:endParaRPr lang="en-US" sz="900" dirty="0"/>
                     </a:p>
@@ -3471,7 +3465,7 @@
                             <a:schemeClr val="bg1"/>
                           </a:solidFill>
                         </a:rPr>
-                        <a:t>SELECTED PUBLIC DEVELOPMENTS</a:t>
+                        <a:t>WHAT COMPETITORS SHOW</a:t>
                       </a:r>
                       <a:endParaRPr lang="en-US" sz="900" dirty="0"/>
                     </a:p>
@@ -3508,7 +3502,7 @@
                             <a:schemeClr val="bg1"/>
                           </a:solidFill>
                         </a:rPr>
-                        <a:t>COMPETITIVE SIGNIFICANCE FOR OPTUM LS</a:t>
+                        <a:t>TAKEAWAY</a:t>
                       </a:r>
                       <a:endParaRPr lang="en-US" sz="900" dirty="0"/>
                     </a:p>
@@ -3532,7 +3526,7 @@
                   </a:tcPr>
                 </a:tc>
               </a:tr>
-              <a:tr h="1050645">
+              <a:tr h="433651">
                 <a:tc>
                   <a:txBody>
                     <a:bodyPr/>
@@ -3542,12 +3536,12 @@
                         <a:buNone/>
                       </a:pPr>
                       <a:r>
-                        <a:rPr lang="en-US" sz="1050" b="1" dirty="0">
+                        <a:rPr lang="en-US" sz="1000" b="1" dirty="0">
                           <a:solidFill>
                             <a:schemeClr val="accent1"/>
                           </a:solidFill>
                         </a:rPr>
-                        <a:t>Partner with established life-sciences vendors</a:t>
+                        <a:t>Model</a:t>
                       </a:r>
                       <a:endParaRPr lang="en-US" sz="1050" dirty="0"/>
                     </a:p>
@@ -3597,6 +3591,2663 @@
                         <a:buNone/>
                       </a:pPr>
                       <a:r>
+                        <a:rPr lang="en-US" sz="1000" dirty="0" u="sng">
+                          <a:solidFill>
+                            <a:srgbClr val="002677"/>
+                          </a:solidFill>
+                          <a:uFill>
+                            <a:solidFill>
+                              <a:srgbClr val="9AA8CC"/>
+                            </a:solidFill>
+                          </a:uFill>
+                        </a:rPr>
+                        <a:t>Veeva uses Anthropic and Amazon models</a:t>
+                      </a:r>
+                      <a:r>
+                        <a:rPr lang="en-US" sz="1000" dirty="0">
+                          <a:solidFill>
+                            <a:schemeClr val="tx1"/>
+                          </a:solidFill>
+                        </a:rPr>
+                        <a:t>; </a:t>
+                      </a:r>
+                      <a:r>
+                        <a:rPr lang="en-US" sz="1000" dirty="0" u="sng">
+                          <a:solidFill>
+                            <a:srgbClr val="002677"/>
+                          </a:solidFill>
+                          <a:uFill>
+                            <a:solidFill>
+                              <a:srgbClr val="9AA8CC"/>
+                            </a:solidFill>
+                          </a:uFill>
+                        </a:rPr>
+                        <a:t>IQVIA.ai uses NVIDIA Nemotron</a:t>
+                      </a:r>
+                      <a:r>
+                        <a:rPr lang="en-US" sz="1000" dirty="0">
+                          <a:solidFill>
+                            <a:schemeClr val="tx1"/>
+                          </a:solidFill>
+                        </a:rPr>
+                        <a:t>, while IQVIA separately </a:t>
+                      </a:r>
+                      <a:r>
+                        <a:rPr lang="en-US" sz="1000" dirty="0" u="sng">
+                          <a:solidFill>
+                            <a:srgbClr val="002677"/>
+                          </a:solidFill>
+                          <a:uFill>
+                            <a:solidFill>
+                              <a:srgbClr val="9AA8CC"/>
+                            </a:solidFill>
+                          </a:uFill>
+                        </a:rPr>
+                        <a:t>developed Med-R1</a:t>
+                      </a:r>
+                      <a:r>
+                        <a:rPr lang="en-US" sz="1000" dirty="0">
+                          <a:solidFill>
+                            <a:schemeClr val="tx1"/>
+                          </a:solidFill>
+                        </a:rPr>
+                        <a:t>; </a:t>
+                      </a:r>
+                      <a:r>
+                        <a:rPr lang="en-US" sz="1000" dirty="0" u="sng">
+                          <a:solidFill>
+                            <a:srgbClr val="002677"/>
+                          </a:solidFill>
+                          <a:uFill>
+                            <a:solidFill>
+                              <a:srgbClr val="9AA8CC"/>
+                            </a:solidFill>
+                          </a:uFill>
+                        </a:rPr>
+                        <a:t>Tempus pairs frontier LLMs with its own oncology models</a:t>
+                      </a:r>
+                      <a:endParaRPr lang="en-US" sz="900" dirty="0"/>
+                    </a:p>
+                  </a:txBody>
+                  <a:tcPr marL="109728" marR="109728" marT="64008" marB="64008" anchor="ctr">
+                    <a:lnL w="0" cap="flat" cmpd="sng" algn="ctr">
+                      <a:noFill/>
+                    </a:lnL>
+                    <a:lnR w="0" cap="flat" cmpd="sng" algn="ctr">
+                      <a:noFill/>
+                    </a:lnR>
+                    <a:lnT w="0" cap="flat" cmpd="sng" algn="ctr">
+                      <a:noFill/>
+                    </a:lnT>
+                    <a:lnB w="19050" cap="flat" cmpd="sng" algn="ctr">
+                      <a:solidFill>
+                        <a:srgbClr val="002677"/>
+                      </a:solidFill>
+                      <a:prstDash val="solid"/>
+                      <a:round/>
+                      <a:headEnd type="none" w="med" len="med"/>
+                      <a:tailEnd type="none" w="med" len="med"/>
+                    </a:lnB>
+                  </a:tcPr>
+                </a:tc>
+                <a:tc>
+                  <a:txBody>
+                    <a:bodyPr/>
+                    <a:lstStyle/>
+                    <a:p>
+                      <a:pPr indent="0" marL="0">
+                        <a:buNone/>
+                      </a:pPr>
+                      <a:r>
+                        <a:rPr lang="en-US" sz="1000" dirty="0" b="1">
+                          <a:solidFill>
+                            <a:srgbClr val="002677"/>
+                          </a:solidFill>
+                        </a:rPr>
+                        <a:t>Often sourced or adapted</a:t>
+                      </a:r>
+                      <a:endParaRPr lang="en-US" sz="900" dirty="0"/>
+                    </a:p>
+                  </a:txBody>
+                  <a:tcPr marL="109728" marR="109728" marT="64008" marB="64008" anchor="ctr">
+                    <a:lnL w="0" cap="flat" cmpd="sng" algn="ctr">
+                      <a:noFill/>
+                    </a:lnL>
+                    <a:lnR w="0" cap="flat" cmpd="sng" algn="ctr">
+                      <a:noFill/>
+                    </a:lnR>
+                    <a:lnT w="0" cap="flat" cmpd="sng" algn="ctr">
+                      <a:noFill/>
+                    </a:lnT>
+                    <a:lnB w="19050" cap="flat" cmpd="sng" algn="ctr">
+                      <a:solidFill>
+                        <a:srgbClr val="002677"/>
+                      </a:solidFill>
+                      <a:prstDash val="solid"/>
+                      <a:round/>
+                      <a:headEnd type="none" w="med" len="med"/>
+                      <a:tailEnd type="none" w="med" len="med"/>
+                    </a:lnB>
+                  </a:tcPr>
+                </a:tc>
+              </a:tr>
+              <a:tr h="651824">
+                <a:tc>
+                  <a:txBody>
+                    <a:bodyPr/>
+                    <a:lstStyle/>
+                    <a:p>
+                      <a:pPr algn="l" indent="0" marL="0">
+                        <a:buNone/>
+                      </a:pPr>
+                      <a:r>
+                        <a:rPr lang="en-US" sz="1000" b="1" dirty="0">
+                          <a:solidFill>
+                            <a:schemeClr val="accent1"/>
+                          </a:solidFill>
+                        </a:rPr>
+                        <a:t>Data and domain intelligence</a:t>
+                      </a:r>
+                      <a:endParaRPr lang="en-US" sz="1050" dirty="0"/>
+                    </a:p>
+                  </a:txBody>
+                  <a:tcPr marL="109728" marR="109728" marT="64008" marB="64008" anchor="ctr">
+                    <a:lnL w="0" cap="flat" cmpd="sng" algn="ctr">
+                      <a:noFill/>
+                    </a:lnL>
+                    <a:lnR w="25400" cap="flat" cmpd="sng" algn="ctr">
+                      <a:solidFill>
+                        <a:srgbClr val="FFFFFF"/>
+                      </a:solidFill>
+                      <a:prstDash val="solid"/>
+                      <a:round/>
+                      <a:headEnd type="none" w="med" len="med"/>
+                      <a:tailEnd type="none" w="med" len="med"/>
+                    </a:lnR>
+                    <a:lnT w="25400" cap="flat" cmpd="sng" algn="ctr">
+                      <a:solidFill>
+                        <a:srgbClr val="FFFFFF"/>
+                      </a:solidFill>
+                      <a:prstDash val="solid"/>
+                      <a:round/>
+                      <a:headEnd type="none" w="med" len="med"/>
+                      <a:tailEnd type="none" w="med" len="med"/>
+                    </a:lnT>
+                    <a:lnB w="25400" cap="flat" cmpd="sng" algn="ctr">
+                      <a:solidFill>
+                        <a:srgbClr val="FFFFFF"/>
+                      </a:solidFill>
+                      <a:prstDash val="solid"/>
+                      <a:round/>
+                      <a:headEnd type="none" w="med" len="med"/>
+                      <a:tailEnd type="none" w="med" len="med"/>
+                    </a:lnB>
+                    <a:solidFill>
+                      <a:schemeClr val="accent5"/>
+                    </a:solidFill>
+                  </a:tcPr>
+                </a:tc>
+                <a:tc>
+                  <a:txBody>
+                    <a:bodyPr/>
+                    <a:lstStyle/>
+                    <a:p>
+                      <a:pPr indent="0" marL="0">
+                        <a:buNone/>
+                      </a:pPr>
+                      <a:r>
+                        <a:rPr lang="en-US" sz="1000" dirty="0" b="1">
+                          <a:solidFill>
+                            <a:schemeClr val="tx1"/>
+                          </a:solidFill>
+                        </a:rPr>
+                        <a:t>Komodo: </a:t>
+                      </a:r>
+                      <a:r>
+                        <a:rPr lang="en-US" sz="1000" dirty="0">
+                          <a:solidFill>
+                            <a:schemeClr val="tx1"/>
+                          </a:solidFill>
+                        </a:rPr>
+                        <a:t>its </a:t>
+                      </a:r>
+                      <a:r>
+                        <a:rPr lang="en-US" sz="1000" dirty="0" u="sng">
+                          <a:solidFill>
+                            <a:srgbClr val="002677"/>
+                          </a:solidFill>
+                          <a:uFill>
+                            <a:solidFill>
+                              <a:srgbClr val="9AA8CC"/>
+                            </a:solidFill>
+                          </a:uFill>
+                        </a:rPr>
+                        <a:t>Healthcare Map of de-identified patient journeys</a:t>
+                      </a:r>
+                      <a:r>
+                        <a:rPr lang="en-US" sz="1000" dirty="0">
+                          <a:solidFill>
+                            <a:schemeClr val="tx1"/>
+                          </a:solidFill>
+                        </a:rPr>
+                        <a:t>, plus </a:t>
+                      </a:r>
+                      <a:r>
+                        <a:rPr lang="en-US" sz="1000" dirty="0" u="sng">
+                          <a:solidFill>
+                            <a:srgbClr val="002677"/>
+                          </a:solidFill>
+                          <a:uFill>
+                            <a:solidFill>
+                              <a:srgbClr val="9AA8CC"/>
+                            </a:solidFill>
+                          </a:uFill>
+                        </a:rPr>
+                        <a:t>a knowledge graph built from prior analyses</a:t>
+                      </a:r>
+                      <a:endParaRPr lang="en-US" sz="900" dirty="0"/>
+                    </a:p>
+                    <a:p>
+                      <a:pPr indent="0" marL="0">
+                        <a:spcBef>
+                          <a:spcPts val="300"/>
+                        </a:spcBef>
+                        <a:buNone/>
+                      </a:pPr>
+                      <a:r>
+                        <a:rPr lang="en-US" sz="1000" dirty="0" b="1">
+                          <a:solidFill>
+                            <a:schemeClr val="tx1"/>
+                          </a:solidFill>
+                        </a:rPr>
+                        <a:t>Truveta: </a:t>
+                      </a:r>
+                      <a:r>
+                        <a:rPr lang="en-US" sz="1000" dirty="0" u="sng">
+                          <a:solidFill>
+                            <a:srgbClr val="002677"/>
+                          </a:solidFill>
+                          <a:uFill>
+                            <a:solidFill>
+                              <a:srgbClr val="9AA8CC"/>
+                            </a:solidFill>
+                          </a:uFill>
+                        </a:rPr>
+                        <a:t>continuously refreshed EHR data from member health systems</a:t>
+                      </a:r>
+                      <a:endParaRPr lang="en-US" sz="900" dirty="0"/>
+                    </a:p>
+                    <a:p>
+                      <a:pPr indent="0" marL="0">
+                        <a:spcBef>
+                          <a:spcPts val="300"/>
+                        </a:spcBef>
+                        <a:buNone/>
+                      </a:pPr>
+                      <a:r>
+                        <a:rPr lang="en-US" sz="1000" dirty="0" b="1">
+                          <a:solidFill>
+                            <a:schemeClr val="tx1"/>
+                          </a:solidFill>
+                        </a:rPr>
+                        <a:t>Norstella: </a:t>
+                      </a:r>
+                      <a:r>
+                        <a:rPr lang="en-US" sz="1000" dirty="0" u="sng">
+                          <a:solidFill>
+                            <a:srgbClr val="002677"/>
+                          </a:solidFill>
+                          <a:uFill>
+                            <a:solidFill>
+                              <a:srgbClr val="9AA8CC"/>
+                            </a:solidFill>
+                          </a:uFill>
+                        </a:rPr>
+                        <a:t>NorstellaLinQ patient data, plus Citeline trial, Evaluate commercial and MMIT payer intelligence</a:t>
+                      </a:r>
+                      <a:endParaRPr lang="en-US" sz="900" dirty="0"/>
+                    </a:p>
+                  </a:txBody>
+                  <a:tcPr marL="109728" marR="109728" marT="64008" marB="64008" anchor="ctr">
+                    <a:lnL w="0" cap="flat" cmpd="sng" algn="ctr">
+                      <a:noFill/>
+                    </a:lnL>
+                    <a:lnR w="0" cap="flat" cmpd="sng" algn="ctr">
+                      <a:noFill/>
+                    </a:lnR>
+                    <a:lnT w="0" cap="flat" cmpd="sng" algn="ctr">
+                      <a:noFill/>
+                    </a:lnT>
+                    <a:lnB w="19050" cap="flat" cmpd="sng" algn="ctr">
+                      <a:solidFill>
+                        <a:srgbClr val="002677"/>
+                      </a:solidFill>
+                      <a:prstDash val="solid"/>
+                      <a:round/>
+                      <a:headEnd type="none" w="med" len="med"/>
+                      <a:tailEnd type="none" w="med" len="med"/>
+                    </a:lnB>
+                  </a:tcPr>
+                </a:tc>
+                <a:tc>
+                  <a:txBody>
+                    <a:bodyPr/>
+                    <a:lstStyle/>
+                    <a:p>
+                      <a:pPr indent="0" marL="0">
+                        <a:buNone/>
+                      </a:pPr>
+                      <a:r>
+                        <a:rPr lang="en-US" sz="1000" dirty="0" b="1">
+                          <a:solidFill>
+                            <a:srgbClr val="002677"/>
+                          </a:solidFill>
+                        </a:rPr>
+                        <a:t>What launches lead with</a:t>
+                      </a:r>
+                      <a:endParaRPr lang="en-US" sz="900" dirty="0"/>
+                    </a:p>
+                  </a:txBody>
+                  <a:tcPr marL="109728" marR="109728" marT="64008" marB="64008" anchor="ctr">
+                    <a:lnL w="0" cap="flat" cmpd="sng" algn="ctr">
+                      <a:noFill/>
+                    </a:lnL>
+                    <a:lnR w="0" cap="flat" cmpd="sng" algn="ctr">
+                      <a:noFill/>
+                    </a:lnR>
+                    <a:lnT w="0" cap="flat" cmpd="sng" algn="ctr">
+                      <a:noFill/>
+                    </a:lnT>
+                    <a:lnB w="19050" cap="flat" cmpd="sng" algn="ctr">
+                      <a:solidFill>
+                        <a:srgbClr val="002677"/>
+                      </a:solidFill>
+                      <a:prstDash val="solid"/>
+                      <a:round/>
+                      <a:headEnd type="none" w="med" len="med"/>
+                      <a:tailEnd type="none" w="med" len="med"/>
+                    </a:lnB>
+                  </a:tcPr>
+                </a:tc>
+              </a:tr>
+              <a:tr h="651811">
+                <a:tc>
+                  <a:txBody>
+                    <a:bodyPr/>
+                    <a:lstStyle/>
+                    <a:p>
+                      <a:pPr algn="l" indent="0" marL="0">
+                        <a:buNone/>
+                      </a:pPr>
+                      <a:r>
+                        <a:rPr lang="en-US" sz="1000" b="1" dirty="0">
+                          <a:solidFill>
+                            <a:schemeClr val="accent1"/>
+                          </a:solidFill>
+                        </a:rPr>
+                        <a:t>Execution and controls</a:t>
+                      </a:r>
+                      <a:endParaRPr lang="en-US" sz="1050" dirty="0"/>
+                    </a:p>
+                  </a:txBody>
+                  <a:tcPr marL="109728" marR="109728" marT="64008" marB="64008" anchor="ctr">
+                    <a:lnL w="0" cap="flat" cmpd="sng" algn="ctr">
+                      <a:noFill/>
+                    </a:lnL>
+                    <a:lnR w="25400" cap="flat" cmpd="sng" algn="ctr">
+                      <a:solidFill>
+                        <a:srgbClr val="FFFFFF"/>
+                      </a:solidFill>
+                      <a:prstDash val="solid"/>
+                      <a:round/>
+                      <a:headEnd type="none" w="med" len="med"/>
+                      <a:tailEnd type="none" w="med" len="med"/>
+                    </a:lnR>
+                    <a:lnT w="25400" cap="flat" cmpd="sng" algn="ctr">
+                      <a:solidFill>
+                        <a:srgbClr val="FFFFFF"/>
+                      </a:solidFill>
+                      <a:prstDash val="solid"/>
+                      <a:round/>
+                      <a:headEnd type="none" w="med" len="med"/>
+                      <a:tailEnd type="none" w="med" len="med"/>
+                    </a:lnT>
+                    <a:lnB w="25400" cap="flat" cmpd="sng" algn="ctr">
+                      <a:solidFill>
+                        <a:srgbClr val="FFFFFF"/>
+                      </a:solidFill>
+                      <a:prstDash val="solid"/>
+                      <a:round/>
+                      <a:headEnd type="none" w="med" len="med"/>
+                      <a:tailEnd type="none" w="med" len="med"/>
+                    </a:lnB>
+                    <a:solidFill>
+                      <a:schemeClr val="accent5"/>
+                    </a:solidFill>
+                  </a:tcPr>
+                </a:tc>
+                <a:tc>
+                  <a:txBody>
+                    <a:bodyPr/>
+                    <a:lstStyle/>
+                    <a:p>
+                      <a:pPr indent="0" marL="0">
+                        <a:buNone/>
+                      </a:pPr>
+                      <a:r>
+                        <a:rPr lang="en-US" sz="1000" dirty="0" b="1">
+                          <a:solidFill>
+                            <a:schemeClr val="tx1"/>
+                          </a:solidFill>
+                        </a:rPr>
+                        <a:t>Komodo: </a:t>
+                      </a:r>
+                      <a:r>
+                        <a:rPr lang="en-US" sz="1000" dirty="0">
+                          <a:solidFill>
+                            <a:schemeClr val="tx1"/>
+                          </a:solidFill>
+                        </a:rPr>
+                        <a:t>“</a:t>
+                      </a:r>
+                      <a:r>
+                        <a:rPr lang="en-US" sz="1000" dirty="0" u="sng">
+                          <a:solidFill>
+                            <a:srgbClr val="002677"/>
+                          </a:solidFill>
+                          <a:uFill>
+                            <a:solidFill>
+                              <a:srgbClr val="9AA8CC"/>
+                            </a:solidFill>
+                          </a:uFill>
+                        </a:rPr>
+                        <a:t>The LLM never touches numbers.</a:t>
+                      </a:r>
+                      <a:r>
+                        <a:rPr lang="en-US" sz="1000" dirty="0">
+                          <a:solidFill>
+                            <a:schemeClr val="tx1"/>
+                          </a:solidFill>
+                        </a:rPr>
+                        <a:t>”</a:t>
+                      </a:r>
+                      <a:endParaRPr lang="en-US" sz="900" dirty="0"/>
+                    </a:p>
+                    <a:p>
+                      <a:pPr indent="0" marL="0">
+                        <a:spcBef>
+                          <a:spcPts val="300"/>
+                        </a:spcBef>
+                        <a:buNone/>
+                      </a:pPr>
+                      <a:r>
+                        <a:rPr lang="en-US" sz="1000" dirty="0" b="1">
+                          <a:solidFill>
+                            <a:schemeClr val="tx1"/>
+                          </a:solidFill>
+                        </a:rPr>
+                        <a:t>HealthVerity’s eXOs: </a:t>
+                      </a:r>
+                      <a:r>
+                        <a:rPr lang="en-US" sz="1000" dirty="0">
+                          <a:solidFill>
+                            <a:schemeClr val="tx1"/>
+                          </a:solidFill>
+                        </a:rPr>
+                        <a:t>“</a:t>
+                      </a:r>
+                      <a:r>
+                        <a:rPr lang="en-US" sz="1000" dirty="0" u="sng">
+                          <a:solidFill>
+                            <a:srgbClr val="002677"/>
+                          </a:solidFill>
+                          <a:uFill>
+                            <a:solidFill>
+                              <a:srgbClr val="9AA8CC"/>
+                            </a:solidFill>
+                          </a:uFill>
+                        </a:rPr>
+                        <a:t>nothing runs until you review, edit and approve it.</a:t>
+                      </a:r>
+                      <a:r>
+                        <a:rPr lang="en-US" sz="1000" dirty="0">
+                          <a:solidFill>
+                            <a:schemeClr val="tx1"/>
+                          </a:solidFill>
+                        </a:rPr>
+                        <a:t>”</a:t>
+                      </a:r>
+                      <a:endParaRPr lang="en-US" sz="900" dirty="0"/>
+                    </a:p>
+                    <a:p>
+                      <a:pPr indent="0" marL="0">
+                        <a:spcBef>
+                          <a:spcPts val="300"/>
+                        </a:spcBef>
+                        <a:buNone/>
+                      </a:pPr>
+                      <a:r>
+                        <a:rPr lang="en-US" sz="1000" dirty="0" u="sng">
+                          <a:solidFill>
+                            <a:srgbClr val="002677"/>
+                          </a:solidFill>
+                          <a:uFill>
+                            <a:solidFill>
+                              <a:srgbClr val="9AA8CC"/>
+                            </a:solidFill>
+                          </a:uFill>
+                        </a:rPr>
+                        <a:t>Veeva’s EDC assistant reads no site-entered casebook data</a:t>
+                      </a:r>
+                      <a:endParaRPr lang="en-US" sz="900" dirty="0"/>
+                    </a:p>
+                  </a:txBody>
+                  <a:tcPr marL="109728" marR="109728" marT="64008" marB="64008" anchor="ctr">
+                    <a:lnL w="0" cap="flat" cmpd="sng" algn="ctr">
+                      <a:noFill/>
+                    </a:lnL>
+                    <a:lnR w="0" cap="flat" cmpd="sng" algn="ctr">
+                      <a:noFill/>
+                    </a:lnR>
+                    <a:lnT w="0" cap="flat" cmpd="sng" algn="ctr">
+                      <a:noFill/>
+                    </a:lnT>
+                    <a:lnB w="19050" cap="flat" cmpd="sng" algn="ctr">
+                      <a:solidFill>
+                        <a:srgbClr val="002677"/>
+                      </a:solidFill>
+                      <a:prstDash val="solid"/>
+                      <a:round/>
+                      <a:headEnd type="none" w="med" len="med"/>
+                      <a:tailEnd type="none" w="med" len="med"/>
+                    </a:lnB>
+                  </a:tcPr>
+                </a:tc>
+                <a:tc>
+                  <a:txBody>
+                    <a:bodyPr/>
+                    <a:lstStyle/>
+                    <a:p>
+                      <a:pPr indent="0" marL="0">
+                        <a:buNone/>
+                      </a:pPr>
+                      <a:r>
+                        <a:rPr lang="en-US" sz="1000" dirty="0" b="1">
+                          <a:solidFill>
+                            <a:srgbClr val="002677"/>
+                          </a:solidFill>
+                        </a:rPr>
+                        <a:t>How AI work is constrained and checked</a:t>
+                      </a:r>
+                      <a:endParaRPr lang="en-US" sz="900" dirty="0"/>
+                    </a:p>
+                  </a:txBody>
+                  <a:tcPr marL="109728" marR="109728" marT="64008" marB="64008" anchor="ctr">
+                    <a:lnL w="0" cap="flat" cmpd="sng" algn="ctr">
+                      <a:noFill/>
+                    </a:lnL>
+                    <a:lnR w="0" cap="flat" cmpd="sng" algn="ctr">
+                      <a:noFill/>
+                    </a:lnR>
+                    <a:lnT w="0" cap="flat" cmpd="sng" algn="ctr">
+                      <a:noFill/>
+                    </a:lnT>
+                    <a:lnB w="19050" cap="flat" cmpd="sng" algn="ctr">
+                      <a:solidFill>
+                        <a:srgbClr val="002677"/>
+                      </a:solidFill>
+                      <a:prstDash val="solid"/>
+                      <a:round/>
+                      <a:headEnd type="none" w="med" len="med"/>
+                      <a:tailEnd type="none" w="med" len="med"/>
+                    </a:lnB>
+                  </a:tcPr>
+                </a:tc>
+              </a:tr>
+              <a:tr h="603577">
+                <a:tc>
+                  <a:txBody>
+                    <a:bodyPr/>
+                    <a:lstStyle/>
+                    <a:p>
+                      <a:pPr algn="l" indent="0" marL="0">
+                        <a:buNone/>
+                      </a:pPr>
+                      <a:r>
+                        <a:rPr lang="en-US" sz="1000" b="1" dirty="0">
+                          <a:solidFill>
+                            <a:schemeClr val="accent1"/>
+                          </a:solidFill>
+                        </a:rPr>
+                        <a:t>Interface</a:t>
+                      </a:r>
+                      <a:endParaRPr lang="en-US" sz="1050" dirty="0"/>
+                    </a:p>
+                  </a:txBody>
+                  <a:tcPr marL="109728" marR="109728" marT="64008" marB="64008" anchor="ctr">
+                    <a:lnL w="0" cap="flat" cmpd="sng" algn="ctr">
+                      <a:noFill/>
+                    </a:lnL>
+                    <a:lnR w="25400" cap="flat" cmpd="sng" algn="ctr">
+                      <a:solidFill>
+                        <a:srgbClr val="FFFFFF"/>
+                      </a:solidFill>
+                      <a:prstDash val="solid"/>
+                      <a:round/>
+                      <a:headEnd type="none" w="med" len="med"/>
+                      <a:tailEnd type="none" w="med" len="med"/>
+                    </a:lnR>
+                    <a:lnT w="25400" cap="flat" cmpd="sng" algn="ctr">
+                      <a:solidFill>
+                        <a:srgbClr val="FFFFFF"/>
+                      </a:solidFill>
+                      <a:prstDash val="solid"/>
+                      <a:round/>
+                      <a:headEnd type="none" w="med" len="med"/>
+                      <a:tailEnd type="none" w="med" len="med"/>
+                    </a:lnT>
+                    <a:lnB w="25400" cap="flat" cmpd="sng" algn="ctr">
+                      <a:solidFill>
+                        <a:srgbClr val="FFFFFF"/>
+                      </a:solidFill>
+                      <a:prstDash val="solid"/>
+                      <a:round/>
+                      <a:headEnd type="none" w="med" len="med"/>
+                      <a:tailEnd type="none" w="med" len="med"/>
+                    </a:lnB>
+                    <a:solidFill>
+                      <a:schemeClr val="accent5"/>
+                    </a:solidFill>
+                  </a:tcPr>
+                </a:tc>
+                <a:tc>
+                  <a:txBody>
+                    <a:bodyPr/>
+                    <a:lstStyle/>
+                    <a:p>
+                      <a:pPr indent="0" marL="0">
+                        <a:buNone/>
+                      </a:pPr>
+                      <a:r>
+                        <a:rPr lang="en-US" sz="1000" dirty="0">
+                          <a:solidFill>
+                            <a:schemeClr val="tx1"/>
+                          </a:solidFill>
+                        </a:rPr>
+                        <a:t>Most build chat into their own products; some also design for other companies’ assistants, platforms or APIs (</a:t>
+                      </a:r>
+                      <a:r>
+                        <a:rPr lang="en-US" sz="1000" dirty="0" u="sng">
+                          <a:solidFill>
+                            <a:srgbClr val="002677"/>
+                          </a:solidFill>
+                          <a:uFill>
+                            <a:solidFill>
+                              <a:srgbClr val="9AA8CC"/>
+                            </a:solidFill>
+                          </a:uFill>
+                        </a:rPr>
+                        <a:t>Verana</a:t>
+                      </a:r>
+                      <a:r>
+                        <a:rPr lang="en-US" sz="1000" dirty="0">
+                          <a:solidFill>
+                            <a:schemeClr val="tx1"/>
+                          </a:solidFill>
+                        </a:rPr>
+                        <a:t>, </a:t>
+                      </a:r>
+                      <a:r>
+                        <a:rPr lang="en-US" sz="1000" dirty="0" u="sng">
+                          <a:solidFill>
+                            <a:srgbClr val="002677"/>
+                          </a:solidFill>
+                          <a:uFill>
+                            <a:solidFill>
+                              <a:srgbClr val="9AA8CC"/>
+                            </a:solidFill>
+                          </a:uFill>
+                        </a:rPr>
+                        <a:t>ZS</a:t>
+                      </a:r>
+                      <a:r>
+                        <a:rPr lang="en-US" sz="1000" dirty="0">
+                          <a:solidFill>
+                            <a:schemeClr val="tx1"/>
+                          </a:solidFill>
+                        </a:rPr>
+                        <a:t>, </a:t>
+                      </a:r>
+                      <a:r>
+                        <a:rPr lang="en-US" sz="1000" dirty="0" u="sng">
+                          <a:solidFill>
+                            <a:srgbClr val="002677"/>
+                          </a:solidFill>
+                          <a:uFill>
+                            <a:solidFill>
+                              <a:srgbClr val="9AA8CC"/>
+                            </a:solidFill>
+                          </a:uFill>
+                        </a:rPr>
+                        <a:t>TriNetX</a:t>
+                      </a:r>
+                      <a:r>
+                        <a:rPr lang="en-US" sz="1000" dirty="0">
+                          <a:solidFill>
+                            <a:schemeClr val="tx1"/>
+                          </a:solidFill>
+                        </a:rPr>
+                        <a:t>)</a:t>
+                      </a:r>
+                      <a:endParaRPr lang="en-US" sz="900" dirty="0"/>
+                    </a:p>
+                  </a:txBody>
+                  <a:tcPr marL="109728" marR="109728" marT="64008" marB="64008" anchor="ctr">
+                    <a:lnL w="0" cap="flat" cmpd="sng" algn="ctr">
+                      <a:noFill/>
+                    </a:lnL>
+                    <a:lnR w="0" cap="flat" cmpd="sng" algn="ctr">
+                      <a:noFill/>
+                    </a:lnR>
+                    <a:lnT w="0" cap="flat" cmpd="sng" algn="ctr">
+                      <a:noFill/>
+                    </a:lnT>
+                    <a:lnB w="19050" cap="flat" cmpd="sng" algn="ctr">
+                      <a:solidFill>
+                        <a:srgbClr val="002677"/>
+                      </a:solidFill>
+                      <a:prstDash val="solid"/>
+                      <a:round/>
+                      <a:headEnd type="none" w="med" len="med"/>
+                      <a:tailEnd type="none" w="med" len="med"/>
+                    </a:lnB>
+                  </a:tcPr>
+                </a:tc>
+                <a:tc>
+                  <a:txBody>
+                    <a:bodyPr/>
+                    <a:lstStyle/>
+                    <a:p>
+                      <a:pPr indent="0" marL="0">
+                        <a:buNone/>
+                      </a:pPr>
+                      <a:r>
+                        <a:rPr lang="en-US" sz="1000" dirty="0" b="1">
+                          <a:solidFill>
+                            <a:srgbClr val="002677"/>
+                          </a:solidFill>
+                        </a:rPr>
+                        <a:t>Not always the vendor’s</a:t>
+                      </a:r>
+                      <a:endParaRPr lang="en-US" sz="900" dirty="0"/>
+                    </a:p>
+                  </a:txBody>
+                  <a:tcPr marL="109728" marR="109728" marT="64008" marB="64008" anchor="ctr">
+                    <a:lnL w="0" cap="flat" cmpd="sng" algn="ctr">
+                      <a:noFill/>
+                    </a:lnL>
+                    <a:lnR w="0" cap="flat" cmpd="sng" algn="ctr">
+                      <a:noFill/>
+                    </a:lnR>
+                    <a:lnT w="0" cap="flat" cmpd="sng" algn="ctr">
+                      <a:noFill/>
+                    </a:lnT>
+                    <a:lnB w="19050" cap="flat" cmpd="sng" algn="ctr">
+                      <a:solidFill>
+                        <a:srgbClr val="002677"/>
+                      </a:solidFill>
+                      <a:prstDash val="solid"/>
+                      <a:round/>
+                      <a:headEnd type="none" w="med" len="med"/>
+                      <a:tailEnd type="none" w="med" len="med"/>
+                    </a:lnB>
+                  </a:tcPr>
+                </a:tc>
+              </a:tr>
+            </a:tbl>
+          </a:graphicData>
+        </a:graphic>
+      </p:graphicFrame>
+      <p:sp>
+        <p:nvSpPr>
+          <p:cNvPr id="25" name="Slide Number Placeholder 0"/>
+          <p:cNvSpPr>
+            <a:spLocks noGrp="1"/>
+          </p:cNvSpPr>
+          <p:nvPr>
+            <p:ph type="sldNum" sz="quarter" idx="4294967295"/>
+          </p:nvPr>
+        </p:nvSpPr>
+        <p:spPr>
+          <a:xfrm>
+            <a:off x="10725912" y="6309360"/>
+            <a:ext cx="914400" cy="201168"/>
+          </a:xfrm>
+          <a:prstGeom prst="rect">
+            <a:avLst/>
+          </a:prstGeom>
+          <a:extLst>
+            <a:ext uri="{C572A759-6A51-4108-AA02-DFA0A04FC94B}">
+              <ma14:wrappingTextBoxFlag xmlns:ma14="http://schemas.microsoft.com/office/mac/drawingml/2011/main" val="0"/>
+            </a:ext>
+          </a:extLst>
+        </p:spPr>
+        <p:txBody>
+          <a:bodyPr lIns="0" tIns="0" rIns="0" bIns="0"/>
+          <a:lstStyle>
+            <a:lvl1pPr>
+              <a:defRPr sz="900">
+                <a:solidFill>
+                  <a:schemeClr val="accent4"/>
+                </a:solidFill>
+              </a:defRPr>
+            </a:lvl1pPr>
+          </a:lstStyle>
+          <a:p>
+            <a:pPr algn="r"/>
+            <a:fld id="{F7021451-1387-4CA6-816F-3879F97B5CBC}" type="slidenum">
+              <a:rPr b="0" lang="en-US"/>
+              <a:t>10</a:t>
+            </a:fld>
+            <a:endParaRPr lang="en-US"/>
+          </a:p>
+        </p:txBody>
+      </p:sp>
+      <p:sp>
+        <p:nvSpPr>
+          <p:cNvPr id="26" name="build card 1"/>
+          <p:cNvSpPr/>
+          <p:nvPr/>
+        </p:nvSpPr>
+        <p:spPr>
+          <a:xfrm>
+            <a:off x="3749039" y="4681728"/>
+            <a:ext cx="3854196" cy="1371600"/>
+          </a:xfrm>
+          <a:prstGeom prst="rect">
+            <a:avLst/>
+          </a:prstGeom>
+          <a:solidFill>
+            <a:schemeClr val="bg1"/>
+          </a:solidFill>
+          <a:ln/>
+          <a:effectLst>
+            <a:outerShdw sx="100000" sy="100000" kx="0" ky="0" algn="bl" rotWithShape="0" blurRad="101600" dist="25400" dir="5400000">
+              <a:srgbClr val="000000">
+                <a:alpha val="10000"/>
+              </a:srgbClr>
+            </a:outerShdw>
+          </a:effectLst>
+        </p:spPr>
+        <p:txBody>
+          <a:bodyPr/>
+          <a:p/>
+        </p:txBody>
+      </p:sp>
+      <p:sp>
+        <p:nvSpPr>
+          <p:cNvPr id="27" name="build label 1"/>
+          <p:cNvSpPr txBox="1"/>
+          <p:nvPr/>
+        </p:nvSpPr>
+        <p:spPr>
+          <a:xfrm>
+            <a:off x="3931920" y="4846320"/>
+            <a:ext cx="3488436" cy="237744"/>
+          </a:xfrm>
+          <a:prstGeom prst="rect">
+            <a:avLst/>
+          </a:prstGeom>
+          <a:noFill/>
+          <a:ln/>
+        </p:spPr>
+        <p:txBody>
+          <a:bodyPr wrap="square" lIns="0" tIns="0" rIns="0" bIns="0" rtlCol="0" anchor="t"/>
+          <a:lstStyle/>
+          <a:p>
+            <a:pPr indent="0" marL="0">
+              <a:buNone/>
+            </a:pPr>
+            <a:r>
+              <a:rPr lang="en-US" sz="1050" b="1" spc="80" kern="0" dirty="0">
+                <a:solidFill>
+                  <a:schemeClr val="accent2"/>
+                </a:solidFill>
+              </a:rPr>
+              <a:t>SUPPLIER AND SELLER</a:t>
+            </a:r>
+            <a:endParaRPr lang="en-US" sz="1300" dirty="0"/>
+          </a:p>
+        </p:txBody>
+      </p:sp>
+      <p:sp>
+        <p:nvSpPr>
+          <p:cNvPr id="28" name="build body 1"/>
+          <p:cNvSpPr txBox="1"/>
+          <p:nvPr/>
+        </p:nvSpPr>
+        <p:spPr>
+          <a:xfrm>
+            <a:off x="3931920" y="5157216"/>
+            <a:ext cx="3488436" cy="804672"/>
+          </a:xfrm>
+          <a:prstGeom prst="rect">
+            <a:avLst/>
+          </a:prstGeom>
+          <a:noFill/>
+          <a:ln/>
+        </p:spPr>
+        <p:txBody>
+          <a:bodyPr wrap="square" lIns="0" tIns="0" rIns="0" bIns="0" rtlCol="0" anchor="t"/>
+          <a:lstStyle/>
+          <a:p>
+            <a:pPr indent="0" marL="0">
+              <a:buNone/>
+            </a:pPr>
+            <a:r>
+              <a:rPr lang="en-US" sz="1000" b="1" dirty="0" u="sng">
+                <a:solidFill>
+                  <a:srgbClr val="002677"/>
+                </a:solidFill>
+                <a:uFill>
+                  <a:solidFill>
+                    <a:srgbClr val="9AA8CC"/>
+                  </a:solidFill>
+                </a:uFill>
+              </a:rPr>
+              <a:t>Medeloop powers HealthVerity’s eXOs</a:t>
+            </a:r>
+            <a:r>
+              <a:rPr lang="en-US" sz="1000" b="1" dirty="0">
+                <a:solidFill>
+                  <a:schemeClr val="tx1"/>
+                </a:solidFill>
+              </a:rPr>
+              <a:t> and also sells its own analytics platform, preloaded with “</a:t>
+            </a:r>
+            <a:r>
+              <a:rPr lang="en-US" sz="1000" b="1" dirty="0" u="sng">
+                <a:solidFill>
+                  <a:srgbClr val="002677"/>
+                </a:solidFill>
+                <a:uFill>
+                  <a:solidFill>
+                    <a:srgbClr val="9AA8CC"/>
+                  </a:solidFill>
+                </a:uFill>
+              </a:rPr>
+              <a:t>38 million de-identified patients from HealthVerity’s all-payer claims dataset</a:t>
+            </a:r>
+            <a:r>
+              <a:rPr lang="en-US" sz="1000" b="1" dirty="0">
+                <a:solidFill>
+                  <a:schemeClr val="tx1"/>
+                </a:solidFill>
+              </a:rPr>
+              <a:t>.”</a:t>
+            </a:r>
+            <a:endParaRPr lang="en-US" sz="1050" dirty="0"/>
+          </a:p>
+        </p:txBody>
+      </p:sp>
+      <p:sp>
+        <p:nvSpPr>
+          <p:cNvPr id="29" name="build card 2"/>
+          <p:cNvSpPr/>
+          <p:nvPr/>
+        </p:nvSpPr>
+        <p:spPr>
+          <a:xfrm>
+            <a:off x="7786116" y="4681728"/>
+            <a:ext cx="3854196" cy="1371600"/>
+          </a:xfrm>
+          <a:prstGeom prst="rect">
+            <a:avLst/>
+          </a:prstGeom>
+          <a:solidFill>
+            <a:schemeClr val="bg1"/>
+          </a:solidFill>
+          <a:ln/>
+          <a:effectLst>
+            <a:outerShdw sx="100000" sy="100000" kx="0" ky="0" algn="bl" rotWithShape="0" blurRad="101600" dist="25400" dir="5400000">
+              <a:srgbClr val="000000">
+                <a:alpha val="10000"/>
+              </a:srgbClr>
+            </a:outerShdw>
+          </a:effectLst>
+        </p:spPr>
+        <p:txBody>
+          <a:bodyPr/>
+          <a:p/>
+        </p:txBody>
+      </p:sp>
+      <p:sp>
+        <p:nvSpPr>
+          <p:cNvPr id="30" name="build label 2"/>
+          <p:cNvSpPr txBox="1"/>
+          <p:nvPr/>
+        </p:nvSpPr>
+        <p:spPr>
+          <a:xfrm>
+            <a:off x="7968996" y="4846320"/>
+            <a:ext cx="3488436" cy="237744"/>
+          </a:xfrm>
+          <a:prstGeom prst="rect">
+            <a:avLst/>
+          </a:prstGeom>
+          <a:noFill/>
+          <a:ln/>
+        </p:spPr>
+        <p:txBody>
+          <a:bodyPr wrap="square" lIns="0" tIns="0" rIns="0" bIns="0" rtlCol="0" anchor="t"/>
+          <a:lstStyle/>
+          <a:p>
+            <a:pPr indent="0" marL="0">
+              <a:buNone/>
+            </a:pPr>
+            <a:r>
+              <a:rPr lang="en-US" sz="1050" b="1" spc="80" kern="0" dirty="0">
+                <a:solidFill>
+                  <a:schemeClr val="accent2"/>
+                </a:solidFill>
+              </a:rPr>
+              <a:t>THE INTERFACE ISN’T ALWAYS THE VENDOR’S</a:t>
+            </a:r>
+            <a:endParaRPr lang="en-US" sz="1300" dirty="0"/>
+          </a:p>
+        </p:txBody>
+      </p:sp>
+      <p:sp>
+        <p:nvSpPr>
+          <p:cNvPr id="31" name="build body 2"/>
+          <p:cNvSpPr txBox="1"/>
+          <p:nvPr/>
+        </p:nvSpPr>
+        <p:spPr>
+          <a:xfrm>
+            <a:off x="7968996" y="5157216"/>
+            <a:ext cx="3488436" cy="804672"/>
+          </a:xfrm>
+          <a:prstGeom prst="rect">
+            <a:avLst/>
+          </a:prstGeom>
+          <a:noFill/>
+          <a:ln/>
+        </p:spPr>
+        <p:txBody>
+          <a:bodyPr wrap="square" lIns="0" tIns="0" rIns="0" bIns="0" rtlCol="0" anchor="t"/>
+          <a:lstStyle/>
+          <a:p>
+            <a:pPr indent="0" marL="0">
+              <a:buNone/>
+            </a:pPr>
+            <a:r>
+              <a:rPr lang="en-US" sz="1000" b="1" dirty="0">
+                <a:solidFill>
+                  <a:schemeClr val="tx1"/>
+                </a:solidFill>
+              </a:rPr>
+              <a:t>Verana markets Agent Claire as </a:t>
+            </a:r>
+            <a:r>
+              <a:rPr lang="en-US" sz="1000" b="1" dirty="0" u="sng">
+                <a:solidFill>
+                  <a:srgbClr val="002677"/>
+                </a:solidFill>
+                <a:uFill>
+                  <a:solidFill>
+                    <a:srgbClr val="9AA8CC"/>
+                  </a:solidFill>
+                </a:uFill>
+              </a:rPr>
+              <a:t>callable from Claude, Gemini and Copilot</a:t>
+            </a:r>
+            <a:r>
+              <a:rPr lang="en-US" sz="1000" b="1" dirty="0">
+                <a:solidFill>
+                  <a:schemeClr val="tx1"/>
+                </a:solidFill>
+              </a:rPr>
+              <a:t>; ZS has announced it is bringing ZAIDYN “</a:t>
+            </a:r>
+            <a:r>
+              <a:rPr lang="en-US" sz="1000" b="1" dirty="0" u="sng">
+                <a:solidFill>
+                  <a:srgbClr val="002677"/>
+                </a:solidFill>
+                <a:uFill>
+                  <a:solidFill>
+                    <a:srgbClr val="9AA8CC"/>
+                  </a:solidFill>
+                </a:uFill>
+              </a:rPr>
+              <a:t>directly into Salesforce’s Agentforce Life Sciences</a:t>
+            </a:r>
+            <a:r>
+              <a:rPr lang="en-US" sz="1000" b="1" dirty="0">
+                <a:solidFill>
+                  <a:schemeClr val="tx1"/>
+                </a:solidFill>
+              </a:rPr>
+              <a:t>.”</a:t>
+            </a:r>
+            <a:endParaRPr lang="en-US" sz="1050" dirty="0"/>
+          </a:p>
+        </p:txBody>
+      </p:sp>
+      <p:sp>
+        <p:nvSpPr>
+          <p:cNvPr id="32" name="aside rule"/>
+          <p:cNvSpPr/>
+          <p:nvPr/>
+        </p:nvSpPr>
+        <p:spPr>
+          <a:xfrm>
+            <a:off x="548640" y="4791456"/>
+            <a:ext cx="32004" cy="1152144"/>
+          </a:xfrm>
+          <a:prstGeom prst="rect">
+            <a:avLst/>
+          </a:prstGeom>
+          <a:solidFill>
+            <a:srgbClr val="D9D4C7"/>
+          </a:solidFill>
+          <a:ln>
+            <a:noFill/>
+          </a:ln>
+          <a:effectLst/>
+        </p:spPr>
+        <p:style>
+          <a:lnRef idx="1">
+            <a:schemeClr val="accent1"/>
+          </a:lnRef>
+          <a:fillRef idx="3">
+            <a:schemeClr val="accent1"/>
+          </a:fillRef>
+          <a:effectRef idx="2">
+            <a:schemeClr val="accent1"/>
+          </a:effectRef>
+          <a:fontRef idx="minor">
+            <a:schemeClr val="lt1"/>
+          </a:fontRef>
+        </p:style>
+        <p:txBody>
+          <a:bodyPr rtlCol="0" anchor="ctr"/>
+          <a:lstStyle/>
+          <a:p>
+            <a:pPr algn="ctr"/>
+          </a:p>
+        </p:txBody>
+      </p:sp>
+      <p:sp>
+        <p:nvSpPr>
+          <p:cNvPr id="33" name="aside label"/>
+          <p:cNvSpPr txBox="1"/>
+          <p:nvPr/>
+        </p:nvSpPr>
+        <p:spPr>
+          <a:xfrm>
+            <a:off x="694944" y="4791456"/>
+            <a:ext cx="2788920" cy="201168"/>
+          </a:xfrm>
+          <a:prstGeom prst="rect">
+            <a:avLst/>
+          </a:prstGeom>
+          <a:noFill/>
+          <a:ln/>
+        </p:spPr>
+        <p:txBody>
+          <a:bodyPr wrap="square" lIns="0" tIns="0" rIns="0" bIns="0" rtlCol="0" anchor="t"/>
+          <a:lstStyle/>
+          <a:p>
+            <a:pPr indent="0" marL="0">
+              <a:buNone/>
+            </a:pPr>
+            <a:r>
+              <a:rPr lang="en-US" sz="900" b="1" spc="100" kern="0" dirty="0">
+                <a:solidFill>
+                  <a:srgbClr val="7A7C7E"/>
+                </a:solidFill>
+              </a:rPr>
+              <a:t>COMPANIES REVIEWED</a:t>
+            </a:r>
+            <a:endParaRPr lang="en-US" sz="1300" dirty="0"/>
+          </a:p>
+        </p:txBody>
+      </p:sp>
+      <p:sp>
+        <p:nvSpPr>
+          <p:cNvPr id="34" name="aside body"/>
+          <p:cNvSpPr txBox="1"/>
+          <p:nvPr/>
+        </p:nvSpPr>
+        <p:spPr>
+          <a:xfrm>
+            <a:off x="694944" y="5047488"/>
+            <a:ext cx="2788920" cy="914400"/>
+          </a:xfrm>
+          <a:prstGeom prst="rect">
+            <a:avLst/>
+          </a:prstGeom>
+          <a:noFill/>
+          <a:ln/>
+        </p:spPr>
+        <p:txBody>
+          <a:bodyPr wrap="square" lIns="0" tIns="0" rIns="0" bIns="0" rtlCol="0" anchor="t"/>
+          <a:lstStyle/>
+          <a:p>
+            <a:pPr indent="0" marL="0">
+              <a:buNone/>
+            </a:pPr>
+            <a:r>
+              <a:rPr lang="en-US" sz="900" b="1" dirty="0">
+                <a:solidFill>
+                  <a:srgbClr val="7A7C7E"/>
+                </a:solidFill>
+              </a:rPr>
+              <a:t>U.S.: </a:t>
+            </a:r>
+            <a:r>
+              <a:rPr lang="en-US" sz="900" dirty="0">
+                <a:solidFill>
+                  <a:srgbClr val="7A7C7E"/>
+                </a:solidFill>
+              </a:rPr>
+              <a:t>Komodo · Truveta · Flatiron · Tempus · HealthVerity · Norstella · Truven · ConcertAI · Verana · IQVIA · ZS · Trinity · Veeva · TriNetX · EVERSANA</a:t>
+            </a:r>
+            <a:endParaRPr lang="en-US" sz="1050" dirty="0"/>
+          </a:p>
+          <a:p>
+            <a:pPr indent="0" marL="0">
+              <a:spcBef>
+                <a:spcPts val="400"/>
+              </a:spcBef>
+              <a:buNone/>
+            </a:pPr>
+            <a:r>
+              <a:rPr lang="en-US" sz="900" b="1" dirty="0">
+                <a:solidFill>
+                  <a:srgbClr val="7A7C7E"/>
+                </a:solidFill>
+              </a:rPr>
+              <a:t>International: </a:t>
+            </a:r>
+            <a:r>
+              <a:rPr lang="en-US" sz="900" dirty="0">
+                <a:solidFill>
+                  <a:srgbClr val="7A7C7E"/>
+                </a:solidFill>
+              </a:rPr>
+              <a:t>Briya · BC Platforms · MDClone · GBI Health · Prospection · Close-Up International · Ipsos · Evidenze</a:t>
+            </a:r>
+            <a:endParaRPr lang="en-US" sz="1050" dirty="0"/>
+          </a:p>
+        </p:txBody>
+      </p:sp>
+      <p:sp>
+        <p:nvSpPr>
+          <p:cNvPr id="35" name="link legend"/>
+          <p:cNvSpPr txBox="1"/>
+          <p:nvPr/>
+        </p:nvSpPr>
+        <p:spPr>
+          <a:xfrm>
+            <a:off x="2944368" y="6309360"/>
+            <a:ext cx="4572000" cy="201168"/>
+          </a:xfrm>
+          <a:prstGeom prst="rect">
+            <a:avLst/>
+          </a:prstGeom>
+          <a:noFill/>
+        </p:spPr>
+        <p:txBody>
+          <a:bodyPr wrap="square" lIns="0" tIns="0" rIns="0" bIns="0" anchor="ctr">
+            <a:spAutoFit/>
+          </a:bodyPr>
+          <a:lstStyle/>
+          <a:p>
+            <a:r>
+              <a:rPr sz="900">
+                <a:solidFill>
+                  <a:schemeClr val="accent4"/>
+                </a:solidFill>
+              </a:rPr>
+              <a:t>·  Underlined text links to public sources</a:t>
+            </a:r>
+          </a:p>
+        </p:txBody>
+      </p:sp>
+      <p:sp>
+        <p:nvSpPr>
+          <p:cNvPr id="9715" name="Invisible source link 14: https://www.veeva.com/products/vault-ai/">
+            <a:hlinkClick r:id="rId2"/>
+          </p:cNvPr>
+          <p:cNvSpPr/>
+          <p:nvPr/>
+        </p:nvSpPr>
+        <p:spPr>
+          <a:xfrm>
+            <a:off x="2669755" y="2232197"/>
+            <a:ext cx="2432439" cy="141817"/>
+          </a:xfrm>
+          <a:prstGeom prst="rect">
+            <a:avLst/>
+          </a:prstGeom>
+          <a:noFill/>
+          <a:ln>
+            <a:noFill/>
+          </a:ln>
+        </p:spPr>
+        <p:style>
+          <a:lnRef idx="1">
+            <a:schemeClr val="accent1"/>
+          </a:lnRef>
+          <a:fillRef idx="3">
+            <a:schemeClr val="accent1"/>
+          </a:fillRef>
+          <a:effectRef idx="2">
+            <a:schemeClr val="accent1"/>
+          </a:effectRef>
+          <a:fontRef idx="minor">
+            <a:schemeClr val="lt1"/>
+          </a:fontRef>
+        </p:style>
+        <p:txBody>
+          <a:bodyPr rtlCol="0" anchor="ctr"/>
+          <a:lstStyle/>
+          <a:p>
+            <a:pPr algn="ctr"/>
+          </a:p>
+        </p:txBody>
+      </p:sp>
+      <p:sp>
+        <p:nvSpPr>
+          <p:cNvPr id="9716" name="Invisible source link 14: https://www.iqvia.com/newsroom/2026/03/iqvia-unveils-iqvia-ai-a-unified-agentic-ai-platform">
+            <a:hlinkClick r:id="rId3"/>
+          </p:cNvPr>
+          <p:cNvSpPr/>
+          <p:nvPr/>
+        </p:nvSpPr>
+        <p:spPr>
+          <a:xfrm>
+            <a:off x="5137200" y="2232197"/>
+            <a:ext cx="1848874" cy="141817"/>
+          </a:xfrm>
+          <a:prstGeom prst="rect">
+            <a:avLst/>
+          </a:prstGeom>
+          <a:noFill/>
+          <a:ln>
+            <a:noFill/>
+          </a:ln>
+        </p:spPr>
+        <p:style>
+          <a:lnRef idx="1">
+            <a:schemeClr val="accent1"/>
+          </a:lnRef>
+          <a:fillRef idx="3">
+            <a:schemeClr val="accent1"/>
+          </a:fillRef>
+          <a:effectRef idx="2">
+            <a:schemeClr val="accent1"/>
+          </a:effectRef>
+          <a:fontRef idx="minor">
+            <a:schemeClr val="lt1"/>
+          </a:fontRef>
+        </p:style>
+        <p:txBody>
+          <a:bodyPr rtlCol="0" anchor="ctr"/>
+          <a:lstStyle/>
+          <a:p>
+            <a:pPr algn="ctr"/>
+          </a:p>
+        </p:txBody>
+      </p:sp>
+      <p:sp>
+        <p:nvSpPr>
+          <p:cNvPr id="9717" name="Invisible source link 14: https://www.iqvia.com/blogs/2025/12/introducing-iqvia-med-r1-deep-research-agent">
+            <a:hlinkClick r:id="rId4"/>
+          </p:cNvPr>
+          <p:cNvSpPr/>
+          <p:nvPr/>
+        </p:nvSpPr>
+        <p:spPr>
+          <a:xfrm>
+            <a:off x="8328596" y="2232197"/>
+            <a:ext cx="582898" cy="141817"/>
+          </a:xfrm>
+          <a:prstGeom prst="rect">
+            <a:avLst/>
+          </a:prstGeom>
+          <a:noFill/>
+          <a:ln>
+            <a:noFill/>
+          </a:ln>
+        </p:spPr>
+        <p:style>
+          <a:lnRef idx="1">
+            <a:schemeClr val="accent1"/>
+          </a:lnRef>
+          <a:fillRef idx="3">
+            <a:schemeClr val="accent1"/>
+          </a:fillRef>
+          <a:effectRef idx="2">
+            <a:schemeClr val="accent1"/>
+          </a:effectRef>
+          <a:fontRef idx="minor">
+            <a:schemeClr val="lt1"/>
+          </a:fontRef>
+        </p:style>
+        <p:txBody>
+          <a:bodyPr rtlCol="0" anchor="ctr"/>
+          <a:lstStyle/>
+          <a:p>
+            <a:pPr algn="ctr"/>
+          </a:p>
+        </p:txBody>
+      </p:sp>
+      <p:sp>
+        <p:nvSpPr>
+          <p:cNvPr id="9719" name="Invisible source link 14: https://www.iqvia.com/blogs/2025/12/introducing-iqvia-med-r1-deep-research-agent">
+            <a:hlinkClick r:id="rId4"/>
+          </p:cNvPr>
+          <p:cNvSpPr/>
+          <p:nvPr/>
+        </p:nvSpPr>
+        <p:spPr>
+          <a:xfrm>
+            <a:off x="2669755" y="2374030"/>
+            <a:ext cx="484843" cy="141817"/>
+          </a:xfrm>
+          <a:prstGeom prst="rect">
+            <a:avLst/>
+          </a:prstGeom>
+          <a:noFill/>
+          <a:ln>
+            <a:noFill/>
+          </a:ln>
+        </p:spPr>
+        <p:style>
+          <a:lnRef idx="1">
+            <a:schemeClr val="accent1"/>
+          </a:lnRef>
+          <a:fillRef idx="3">
+            <a:schemeClr val="accent1"/>
+          </a:fillRef>
+          <a:effectRef idx="2">
+            <a:schemeClr val="accent1"/>
+          </a:effectRef>
+          <a:fontRef idx="minor">
+            <a:schemeClr val="lt1"/>
+          </a:fontRef>
+        </p:style>
+        <p:txBody>
+          <a:bodyPr rtlCol="0" anchor="ctr"/>
+          <a:lstStyle/>
+          <a:p>
+            <a:pPr algn="ctr"/>
+          </a:p>
+        </p:txBody>
+      </p:sp>
+      <p:sp>
+        <p:nvSpPr>
+          <p:cNvPr id="9719" name="Invisible source link 14: https://lens.tempus.com/">
+            <a:hlinkClick r:id="rId5"/>
+          </p:cNvPr>
+          <p:cNvSpPr/>
+          <p:nvPr/>
+        </p:nvSpPr>
+        <p:spPr>
+          <a:xfrm>
+            <a:off x="3189605" y="2374030"/>
+            <a:ext cx="3198507" cy="141817"/>
+          </a:xfrm>
+          <a:prstGeom prst="rect">
+            <a:avLst/>
+          </a:prstGeom>
+          <a:noFill/>
+          <a:ln>
+            <a:noFill/>
+          </a:ln>
+        </p:spPr>
+        <p:style>
+          <a:lnRef idx="1">
+            <a:schemeClr val="accent1"/>
+          </a:lnRef>
+          <a:fillRef idx="3">
+            <a:schemeClr val="accent1"/>
+          </a:fillRef>
+          <a:effectRef idx="2">
+            <a:schemeClr val="accent1"/>
+          </a:effectRef>
+          <a:fontRef idx="minor">
+            <a:schemeClr val="lt1"/>
+          </a:fontRef>
+        </p:style>
+        <p:txBody>
+          <a:bodyPr rtlCol="0" anchor="ctr"/>
+          <a:lstStyle/>
+          <a:p>
+            <a:pPr algn="ctr"/>
+          </a:p>
+        </p:txBody>
+      </p:sp>
+      <p:sp>
+        <p:nvSpPr>
+          <p:cNvPr id="9720" name="Invisible source link 14: https://www.komodohealth.com/product/healthcare-map/">
+            <a:hlinkClick r:id="rId6"/>
+          </p:cNvPr>
+          <p:cNvSpPr/>
+          <p:nvPr/>
+        </p:nvSpPr>
+        <p:spPr>
+          <a:xfrm>
+            <a:off x="3421075" y="2665635"/>
+            <a:ext cx="2720450" cy="141817"/>
+          </a:xfrm>
+          <a:prstGeom prst="rect">
+            <a:avLst/>
+          </a:prstGeom>
+          <a:noFill/>
+          <a:ln>
+            <a:noFill/>
+          </a:ln>
+        </p:spPr>
+        <p:style>
+          <a:lnRef idx="1">
+            <a:schemeClr val="accent1"/>
+          </a:lnRef>
+          <a:fillRef idx="3">
+            <a:schemeClr val="accent1"/>
+          </a:fillRef>
+          <a:effectRef idx="2">
+            <a:schemeClr val="accent1"/>
+          </a:effectRef>
+          <a:fontRef idx="minor">
+            <a:schemeClr val="lt1"/>
+          </a:fontRef>
+        </p:style>
+        <p:txBody>
+          <a:bodyPr rtlCol="0" anchor="ctr"/>
+          <a:lstStyle/>
+          <a:p>
+            <a:pPr algn="ctr"/>
+          </a:p>
+        </p:txBody>
+      </p:sp>
+      <p:sp>
+        <p:nvSpPr>
+          <p:cNvPr id="9721" name="Invisible source link 14: https://www.komodohealth.com/press/komodo-health-introduces-marmot-the-ai-built-to-accelerate-healthcare-innovation/">
+            <a:hlinkClick r:id="rId7"/>
+          </p:cNvPr>
+          <p:cNvSpPr/>
+          <p:nvPr/>
+        </p:nvSpPr>
+        <p:spPr>
+          <a:xfrm>
+            <a:off x="6443281" y="2665635"/>
+            <a:ext cx="2447360" cy="141817"/>
+          </a:xfrm>
+          <a:prstGeom prst="rect">
+            <a:avLst/>
+          </a:prstGeom>
+          <a:noFill/>
+          <a:ln>
+            <a:noFill/>
+          </a:ln>
+        </p:spPr>
+        <p:style>
+          <a:lnRef idx="1">
+            <a:schemeClr val="accent1"/>
+          </a:lnRef>
+          <a:fillRef idx="3">
+            <a:schemeClr val="accent1"/>
+          </a:fillRef>
+          <a:effectRef idx="2">
+            <a:schemeClr val="accent1"/>
+          </a:effectRef>
+          <a:fontRef idx="minor">
+            <a:schemeClr val="lt1"/>
+          </a:fontRef>
+        </p:style>
+        <p:txBody>
+          <a:bodyPr rtlCol="0" anchor="ctr"/>
+          <a:lstStyle/>
+          <a:p>
+            <a:pPr algn="ctr"/>
+          </a:p>
+        </p:txBody>
+      </p:sp>
+      <p:sp>
+        <p:nvSpPr>
+          <p:cNvPr id="9722" name="Invisible source link 14: https://www.truveta.com/blog/data/approach-to-real-world-data-quality/">
+            <a:hlinkClick r:id="rId8"/>
+          </p:cNvPr>
+          <p:cNvSpPr/>
+          <p:nvPr/>
+        </p:nvSpPr>
+        <p:spPr>
+          <a:xfrm>
+            <a:off x="3195713" y="2845632"/>
+            <a:ext cx="3521916" cy="141817"/>
+          </a:xfrm>
+          <a:prstGeom prst="rect">
+            <a:avLst/>
+          </a:prstGeom>
+          <a:noFill/>
+          <a:ln>
+            <a:noFill/>
+          </a:ln>
+        </p:spPr>
+        <p:style>
+          <a:lnRef idx="1">
+            <a:schemeClr val="accent1"/>
+          </a:lnRef>
+          <a:fillRef idx="3">
+            <a:schemeClr val="accent1"/>
+          </a:fillRef>
+          <a:effectRef idx="2">
+            <a:schemeClr val="accent1"/>
+          </a:effectRef>
+          <a:fontRef idx="minor">
+            <a:schemeClr val="lt1"/>
+          </a:fontRef>
+        </p:style>
+        <p:txBody>
+          <a:bodyPr rtlCol="0" anchor="ctr"/>
+          <a:lstStyle/>
+          <a:p>
+            <a:pPr algn="ctr"/>
+          </a:p>
+        </p:txBody>
+      </p:sp>
+      <p:sp>
+        <p:nvSpPr>
+          <p:cNvPr id="9723" name="Invisible source link 14: https://www.norstella.com/press-releases/norstella-introduces-norstellalinq/">
+            <a:hlinkClick r:id="rId9"/>
+          </p:cNvPr>
+          <p:cNvSpPr/>
+          <p:nvPr/>
+        </p:nvSpPr>
+        <p:spPr>
+          <a:xfrm>
+            <a:off x="3287153" y="3025629"/>
+            <a:ext cx="5327542" cy="141817"/>
+          </a:xfrm>
+          <a:prstGeom prst="rect">
+            <a:avLst/>
+          </a:prstGeom>
+          <a:noFill/>
+          <a:ln>
+            <a:noFill/>
+          </a:ln>
+        </p:spPr>
+        <p:style>
+          <a:lnRef idx="1">
+            <a:schemeClr val="accent1"/>
+          </a:lnRef>
+          <a:fillRef idx="3">
+            <a:schemeClr val="accent1"/>
+          </a:fillRef>
+          <a:effectRef idx="2">
+            <a:schemeClr val="accent1"/>
+          </a:effectRef>
+          <a:fontRef idx="minor">
+            <a:schemeClr val="lt1"/>
+          </a:fontRef>
+        </p:style>
+        <p:txBody>
+          <a:bodyPr rtlCol="0" anchor="ctr"/>
+          <a:lstStyle/>
+          <a:p>
+            <a:pPr algn="ctr"/>
+          </a:p>
+        </p:txBody>
+      </p:sp>
+      <p:sp>
+        <p:nvSpPr>
+          <p:cNvPr id="9724" name="Invisible source link 14: https://www.komodohealth.com/perspectives/building-the-framework-for-trusted-ai-in-healthcare/">
+            <a:hlinkClick r:id="rId10"/>
+          </p:cNvPr>
+          <p:cNvSpPr/>
+          <p:nvPr/>
+        </p:nvSpPr>
+        <p:spPr>
+          <a:xfrm>
+            <a:off x="3259442" y="3317234"/>
+            <a:ext cx="1974799" cy="141817"/>
+          </a:xfrm>
+          <a:prstGeom prst="rect">
+            <a:avLst/>
+          </a:prstGeom>
+          <a:noFill/>
+          <a:ln>
+            <a:noFill/>
+          </a:ln>
+        </p:spPr>
+        <p:style>
+          <a:lnRef idx="1">
+            <a:schemeClr val="accent1"/>
+          </a:lnRef>
+          <a:fillRef idx="3">
+            <a:schemeClr val="accent1"/>
+          </a:fillRef>
+          <a:effectRef idx="2">
+            <a:schemeClr val="accent1"/>
+          </a:effectRef>
+          <a:fontRef idx="minor">
+            <a:schemeClr val="lt1"/>
+          </a:fontRef>
+        </p:style>
+        <p:txBody>
+          <a:bodyPr rtlCol="0" anchor="ctr"/>
+          <a:lstStyle/>
+          <a:p>
+            <a:pPr algn="ctr"/>
+          </a:p>
+        </p:txBody>
+      </p:sp>
+      <p:sp>
+        <p:nvSpPr>
+          <p:cNvPr id="9725" name="Invisible source link 14: https://healthverity.com/exos/">
+            <a:hlinkClick r:id="rId11"/>
+          </p:cNvPr>
+          <p:cNvSpPr/>
+          <p:nvPr/>
+        </p:nvSpPr>
+        <p:spPr>
+          <a:xfrm>
+            <a:off x="3936237" y="3497231"/>
+            <a:ext cx="2825114" cy="141817"/>
+          </a:xfrm>
+          <a:prstGeom prst="rect">
+            <a:avLst/>
+          </a:prstGeom>
+          <a:noFill/>
+          <a:ln>
+            <a:noFill/>
+          </a:ln>
+        </p:spPr>
+        <p:style>
+          <a:lnRef idx="1">
+            <a:schemeClr val="accent1"/>
+          </a:lnRef>
+          <a:fillRef idx="3">
+            <a:schemeClr val="accent1"/>
+          </a:fillRef>
+          <a:effectRef idx="2">
+            <a:schemeClr val="accent1"/>
+          </a:effectRef>
+          <a:fontRef idx="minor">
+            <a:schemeClr val="lt1"/>
+          </a:fontRef>
+        </p:style>
+        <p:txBody>
+          <a:bodyPr rtlCol="0" anchor="ctr"/>
+          <a:lstStyle/>
+          <a:p>
+            <a:pPr algn="ctr"/>
+          </a:p>
+        </p:txBody>
+      </p:sp>
+      <p:sp>
+        <p:nvSpPr>
+          <p:cNvPr id="9726" name="Invisible source link 14: https://clinicaldata.veevavault.help/en/lr/rn/limited-releases/26r3/new-features/">
+            <a:hlinkClick r:id="rId12"/>
+          </p:cNvPr>
+          <p:cNvSpPr/>
+          <p:nvPr/>
+        </p:nvSpPr>
+        <p:spPr>
+          <a:xfrm>
+            <a:off x="2669755" y="3677241"/>
+            <a:ext cx="3365486" cy="141817"/>
+          </a:xfrm>
+          <a:prstGeom prst="rect">
+            <a:avLst/>
+          </a:prstGeom>
+          <a:noFill/>
+          <a:ln>
+            <a:noFill/>
+          </a:ln>
+        </p:spPr>
+        <p:style>
+          <a:lnRef idx="1">
+            <a:schemeClr val="accent1"/>
+          </a:lnRef>
+          <a:fillRef idx="3">
+            <a:schemeClr val="accent1"/>
+          </a:fillRef>
+          <a:effectRef idx="2">
+            <a:schemeClr val="accent1"/>
+          </a:effectRef>
+          <a:fontRef idx="minor">
+            <a:schemeClr val="lt1"/>
+          </a:fontRef>
+        </p:style>
+        <p:txBody>
+          <a:bodyPr rtlCol="0" anchor="ctr"/>
+          <a:lstStyle/>
+          <a:p>
+            <a:pPr algn="ctr"/>
+          </a:p>
+        </p:txBody>
+      </p:sp>
+      <p:sp>
+        <p:nvSpPr>
+          <p:cNvPr id="9727" name="Invisible source link 14: https://veranahealth.com/verana-health-introduces-new-ai-agents-to-expedite-and-streamline-rd-tasks/">
+            <a:hlinkClick r:id="rId13"/>
+          </p:cNvPr>
+          <p:cNvSpPr/>
+          <p:nvPr/>
+        </p:nvSpPr>
+        <p:spPr>
+          <a:xfrm>
+            <a:off x="2669755" y="4195630"/>
+            <a:ext cx="476918" cy="141817"/>
+          </a:xfrm>
+          <a:prstGeom prst="rect">
+            <a:avLst/>
+          </a:prstGeom>
+          <a:noFill/>
+          <a:ln>
+            <a:noFill/>
+          </a:ln>
+        </p:spPr>
+        <p:style>
+          <a:lnRef idx="1">
+            <a:schemeClr val="accent1"/>
+          </a:lnRef>
+          <a:fillRef idx="3">
+            <a:schemeClr val="accent1"/>
+          </a:fillRef>
+          <a:effectRef idx="2">
+            <a:schemeClr val="accent1"/>
+          </a:effectRef>
+          <a:fontRef idx="minor">
+            <a:schemeClr val="lt1"/>
+          </a:fontRef>
+        </p:style>
+        <p:txBody>
+          <a:bodyPr rtlCol="0" anchor="ctr"/>
+          <a:lstStyle/>
+          <a:p>
+            <a:pPr algn="ctr"/>
+          </a:p>
+        </p:txBody>
+      </p:sp>
+      <p:sp>
+        <p:nvSpPr>
+          <p:cNvPr id="9728" name="Invisible source link 14: https://www.zs.com/about/newsroom/zs-press-salesforce-zaidyn-crm">
+            <a:hlinkClick r:id="rId14"/>
+          </p:cNvPr>
+          <p:cNvSpPr/>
+          <p:nvPr/>
+        </p:nvSpPr>
+        <p:spPr>
+          <a:xfrm>
+            <a:off x="3181680" y="4195630"/>
+            <a:ext cx="196845" cy="141817"/>
+          </a:xfrm>
+          <a:prstGeom prst="rect">
+            <a:avLst/>
+          </a:prstGeom>
+          <a:noFill/>
+          <a:ln>
+            <a:noFill/>
+          </a:ln>
+        </p:spPr>
+        <p:style>
+          <a:lnRef idx="1">
+            <a:schemeClr val="accent1"/>
+          </a:lnRef>
+          <a:fillRef idx="3">
+            <a:schemeClr val="accent1"/>
+          </a:fillRef>
+          <a:effectRef idx="2">
+            <a:schemeClr val="accent1"/>
+          </a:effectRef>
+          <a:fontRef idx="minor">
+            <a:schemeClr val="lt1"/>
+          </a:fontRef>
+        </p:style>
+        <p:txBody>
+          <a:bodyPr rtlCol="0" anchor="ctr"/>
+          <a:lstStyle/>
+          <a:p>
+            <a:pPr algn="ctr"/>
+          </a:p>
+        </p:txBody>
+      </p:sp>
+      <p:sp>
+        <p:nvSpPr>
+          <p:cNvPr id="9729" name="Invisible source link 14: https://trinetx.com/blog/trinetx-named-best-of-show-finalist-at-scope-advancing-clinical-trial-planning-with-conversational-ai-and-enhanced-api-capabilities/">
+            <a:hlinkClick r:id="rId15"/>
+          </p:cNvPr>
+          <p:cNvSpPr/>
+          <p:nvPr/>
+        </p:nvSpPr>
+        <p:spPr>
+          <a:xfrm>
+            <a:off x="3413518" y="4195630"/>
+            <a:ext cx="466039" cy="141817"/>
+          </a:xfrm>
+          <a:prstGeom prst="rect">
+            <a:avLst/>
+          </a:prstGeom>
+          <a:noFill/>
+          <a:ln>
+            <a:noFill/>
+          </a:ln>
+        </p:spPr>
+        <p:style>
+          <a:lnRef idx="1">
+            <a:schemeClr val="accent1"/>
+          </a:lnRef>
+          <a:fillRef idx="3">
+            <a:schemeClr val="accent1"/>
+          </a:fillRef>
+          <a:effectRef idx="2">
+            <a:schemeClr val="accent1"/>
+          </a:effectRef>
+          <a:fontRef idx="minor">
+            <a:schemeClr val="lt1"/>
+          </a:fontRef>
+        </p:style>
+        <p:txBody>
+          <a:bodyPr rtlCol="0" anchor="ctr"/>
+          <a:lstStyle/>
+          <a:p>
+            <a:pPr algn="ctr"/>
+          </a:p>
+        </p:txBody>
+      </p:sp>
+      <p:sp>
+        <p:nvSpPr>
+          <p:cNvPr id="9730" name="Invisible source link 14: https://healthverity.com/news/announcing-healthverity-exos/">
+            <a:hlinkClick r:id="rId16"/>
+          </p:cNvPr>
+          <p:cNvSpPr/>
+          <p:nvPr/>
+        </p:nvSpPr>
+        <p:spPr>
+          <a:xfrm>
+            <a:off x="3931564" y="5169440"/>
+            <a:ext cx="2293852" cy="141817"/>
+          </a:xfrm>
+          <a:prstGeom prst="rect">
+            <a:avLst/>
+          </a:prstGeom>
+          <a:noFill/>
+          <a:ln>
+            <a:noFill/>
+          </a:ln>
+        </p:spPr>
+        <p:style>
+          <a:lnRef idx="1">
+            <a:schemeClr val="accent1"/>
+          </a:lnRef>
+          <a:fillRef idx="3">
+            <a:schemeClr val="accent1"/>
+          </a:fillRef>
+          <a:effectRef idx="2">
+            <a:schemeClr val="accent1"/>
+          </a:effectRef>
+          <a:fontRef idx="minor">
+            <a:schemeClr val="lt1"/>
+          </a:fontRef>
+        </p:style>
+        <p:txBody>
+          <a:bodyPr rtlCol="0" anchor="ctr"/>
+          <a:lstStyle/>
+          <a:p>
+            <a:pPr algn="ctr"/>
+          </a:p>
+        </p:txBody>
+      </p:sp>
+      <p:sp>
+        <p:nvSpPr>
+          <p:cNvPr id="9731" name="Invisible source link 14: https://medeloop.ai/analytics">
+            <a:hlinkClick r:id="rId17"/>
+          </p:cNvPr>
+          <p:cNvSpPr/>
+          <p:nvPr/>
+        </p:nvSpPr>
+        <p:spPr>
+          <a:xfrm>
+            <a:off x="6299121" y="5322081"/>
+            <a:ext cx="870474" cy="141817"/>
+          </a:xfrm>
+          <a:prstGeom prst="rect">
+            <a:avLst/>
+          </a:prstGeom>
+          <a:noFill/>
+          <a:ln>
+            <a:noFill/>
+          </a:ln>
+        </p:spPr>
+        <p:style>
+          <a:lnRef idx="1">
+            <a:schemeClr val="accent1"/>
+          </a:lnRef>
+          <a:fillRef idx="3">
+            <a:schemeClr val="accent1"/>
+          </a:fillRef>
+          <a:effectRef idx="2">
+            <a:schemeClr val="accent1"/>
+          </a:effectRef>
+          <a:fontRef idx="minor">
+            <a:schemeClr val="lt1"/>
+          </a:fontRef>
+        </p:style>
+        <p:txBody>
+          <a:bodyPr rtlCol="0" anchor="ctr"/>
+          <a:lstStyle/>
+          <a:p>
+            <a:pPr algn="ctr"/>
+          </a:p>
+        </p:txBody>
+      </p:sp>
+      <p:sp>
+        <p:nvSpPr>
+          <p:cNvPr id="9733" name="Invisible source link 14: https://medeloop.ai/analytics">
+            <a:hlinkClick r:id="rId17"/>
+          </p:cNvPr>
+          <p:cNvSpPr/>
+          <p:nvPr/>
+        </p:nvSpPr>
+        <p:spPr>
+          <a:xfrm>
+            <a:off x="3931564" y="5474710"/>
+            <a:ext cx="3249592" cy="141817"/>
+          </a:xfrm>
+          <a:prstGeom prst="rect">
+            <a:avLst/>
+          </a:prstGeom>
+          <a:noFill/>
+          <a:ln>
+            <a:noFill/>
+          </a:ln>
+        </p:spPr>
+        <p:style>
+          <a:lnRef idx="1">
+            <a:schemeClr val="accent1"/>
+          </a:lnRef>
+          <a:fillRef idx="3">
+            <a:schemeClr val="accent1"/>
+          </a:fillRef>
+          <a:effectRef idx="2">
+            <a:schemeClr val="accent1"/>
+          </a:effectRef>
+          <a:fontRef idx="minor">
+            <a:schemeClr val="lt1"/>
+          </a:fontRef>
+        </p:style>
+        <p:txBody>
+          <a:bodyPr rtlCol="0" anchor="ctr"/>
+          <a:lstStyle/>
+          <a:p>
+            <a:pPr algn="ctr"/>
+          </a:p>
+        </p:txBody>
+      </p:sp>
+      <p:sp>
+        <p:nvSpPr>
+          <p:cNvPr id="9735" name="Invisible source link 14: https://medeloop.ai/analytics">
+            <a:hlinkClick r:id="rId17"/>
+          </p:cNvPr>
+          <p:cNvSpPr/>
+          <p:nvPr/>
+        </p:nvSpPr>
+        <p:spPr>
+          <a:xfrm>
+            <a:off x="3931564" y="5627351"/>
+            <a:ext cx="540558" cy="141817"/>
+          </a:xfrm>
+          <a:prstGeom prst="rect">
+            <a:avLst/>
+          </a:prstGeom>
+          <a:noFill/>
+          <a:ln>
+            <a:noFill/>
+          </a:ln>
+        </p:spPr>
+        <p:style>
+          <a:lnRef idx="1">
+            <a:schemeClr val="accent1"/>
+          </a:lnRef>
+          <a:fillRef idx="3">
+            <a:schemeClr val="accent1"/>
+          </a:fillRef>
+          <a:effectRef idx="2">
+            <a:schemeClr val="accent1"/>
+          </a:effectRef>
+          <a:fontRef idx="minor">
+            <a:schemeClr val="lt1"/>
+          </a:fontRef>
+        </p:style>
+        <p:txBody>
+          <a:bodyPr rtlCol="0" anchor="ctr"/>
+          <a:lstStyle/>
+          <a:p>
+            <a:pPr algn="ctr"/>
+          </a:p>
+        </p:txBody>
+      </p:sp>
+      <p:sp>
+        <p:nvSpPr>
+          <p:cNvPr id="9734" name="Invisible source link 14: https://veranahealth.com/verana-health-introduces-new-ai-agents-to-expedite-and-streamline-rd-tasks/">
+            <a:hlinkClick r:id="rId13"/>
+          </p:cNvPr>
+          <p:cNvSpPr/>
+          <p:nvPr/>
+        </p:nvSpPr>
+        <p:spPr>
+          <a:xfrm>
+            <a:off x="9890277" y="5169440"/>
+            <a:ext cx="1271143" cy="141817"/>
+          </a:xfrm>
+          <a:prstGeom prst="rect">
+            <a:avLst/>
+          </a:prstGeom>
+          <a:noFill/>
+          <a:ln>
+            <a:noFill/>
+          </a:ln>
+        </p:spPr>
+        <p:style>
+          <a:lnRef idx="1">
+            <a:schemeClr val="accent1"/>
+          </a:lnRef>
+          <a:fillRef idx="3">
+            <a:schemeClr val="accent1"/>
+          </a:fillRef>
+          <a:effectRef idx="2">
+            <a:schemeClr val="accent1"/>
+          </a:effectRef>
+          <a:fontRef idx="minor">
+            <a:schemeClr val="lt1"/>
+          </a:fontRef>
+        </p:style>
+        <p:txBody>
+          <a:bodyPr rtlCol="0" anchor="ctr"/>
+          <a:lstStyle/>
+          <a:p>
+            <a:pPr algn="ctr"/>
+          </a:p>
+        </p:txBody>
+      </p:sp>
+      <p:sp>
+        <p:nvSpPr>
+          <p:cNvPr id="9736" name="Invisible source link 14: https://veranahealth.com/verana-health-introduces-new-ai-agents-to-expedite-and-streamline-rd-tasks/">
+            <a:hlinkClick r:id="rId13"/>
+          </p:cNvPr>
+          <p:cNvSpPr/>
+          <p:nvPr/>
+        </p:nvSpPr>
+        <p:spPr>
+          <a:xfrm>
+            <a:off x="7968602" y="5322081"/>
+            <a:ext cx="1200429" cy="141817"/>
+          </a:xfrm>
+          <a:prstGeom prst="rect">
+            <a:avLst/>
+          </a:prstGeom>
+          <a:noFill/>
+          <a:ln>
+            <a:noFill/>
+          </a:ln>
+        </p:spPr>
+        <p:style>
+          <a:lnRef idx="1">
+            <a:schemeClr val="accent1"/>
+          </a:lnRef>
+          <a:fillRef idx="3">
+            <a:schemeClr val="accent1"/>
+          </a:fillRef>
+          <a:effectRef idx="2">
+            <a:schemeClr val="accent1"/>
+          </a:effectRef>
+          <a:fontRef idx="minor">
+            <a:schemeClr val="lt1"/>
+          </a:fontRef>
+        </p:style>
+        <p:txBody>
+          <a:bodyPr rtlCol="0" anchor="ctr"/>
+          <a:lstStyle/>
+          <a:p>
+            <a:pPr algn="ctr"/>
+          </a:p>
+        </p:txBody>
+      </p:sp>
+      <p:sp>
+        <p:nvSpPr>
+          <p:cNvPr id="9736" name="Invisible source link 14: https://www.zs.com/about/newsroom/zs-press-salesforce-zaidyn-crm">
+            <a:hlinkClick r:id="rId14"/>
+          </p:cNvPr>
+          <p:cNvSpPr/>
+          <p:nvPr/>
+        </p:nvSpPr>
+        <p:spPr>
+          <a:xfrm>
+            <a:off x="8474492" y="5474710"/>
+            <a:ext cx="2513086" cy="141817"/>
+          </a:xfrm>
+          <a:prstGeom prst="rect">
+            <a:avLst/>
+          </a:prstGeom>
+          <a:noFill/>
+          <a:ln>
+            <a:noFill/>
+          </a:ln>
+        </p:spPr>
+        <p:style>
+          <a:lnRef idx="1">
+            <a:schemeClr val="accent1"/>
+          </a:lnRef>
+          <a:fillRef idx="3">
+            <a:schemeClr val="accent1"/>
+          </a:fillRef>
+          <a:effectRef idx="2">
+            <a:schemeClr val="accent1"/>
+          </a:effectRef>
+          <a:fontRef idx="minor">
+            <a:schemeClr val="lt1"/>
+          </a:fontRef>
+        </p:style>
+        <p:txBody>
+          <a:bodyPr rtlCol="0" anchor="ctr"/>
+          <a:lstStyle/>
+          <a:p>
+            <a:pPr algn="ctr"/>
+          </a:p>
+        </p:txBody>
+      </p:sp>
+      <p:sp>
+        <p:nvSpPr>
+          <p:cNvPr id="9738" name="Invisible source link 14: https://www.zs.com/about/newsroom/zs-press-salesforce-zaidyn-crm">
+            <a:hlinkClick r:id="rId14"/>
+          </p:cNvPr>
+          <p:cNvSpPr/>
+          <p:nvPr/>
+        </p:nvSpPr>
+        <p:spPr>
+          <a:xfrm>
+            <a:off x="7968602" y="5627351"/>
+            <a:ext cx="645676" cy="141817"/>
+          </a:xfrm>
+          <a:prstGeom prst="rect">
+            <a:avLst/>
+          </a:prstGeom>
+          <a:noFill/>
+          <a:ln>
+            <a:noFill/>
+          </a:ln>
+        </p:spPr>
+        <p:style>
+          <a:lnRef idx="1">
+            <a:schemeClr val="accent1"/>
+          </a:lnRef>
+          <a:fillRef idx="3">
+            <a:schemeClr val="accent1"/>
+          </a:fillRef>
+          <a:effectRef idx="2">
+            <a:schemeClr val="accent1"/>
+          </a:effectRef>
+          <a:fontRef idx="minor">
+            <a:schemeClr val="lt1"/>
+          </a:fontRef>
+        </p:style>
+        <p:txBody>
+          <a:bodyPr rtlCol="0" anchor="ctr"/>
+          <a:lstStyle/>
+          <a:p>
+            <a:pPr algn="ctr"/>
+          </a:p>
+        </p:txBody>
+      </p:sp>
+    </p:spTree>
+  </p:cSld>
+  <p:clrMapOvr>
+    <a:masterClrMapping/>
+  </p:clrMapOvr>
+</p:sld>
+</file>
+
+<file path=ppt/slides/slide11.xml><?xml version="1.0" encoding="utf-8"?>
+<p:sld xmlns:a="http://schemas.openxmlformats.org/drawingml/2006/main" xmlns:r="http://schemas.openxmlformats.org/officeDocument/2006/relationships" xmlns:p="http://schemas.openxmlformats.org/presentationml/2006/main">
+  <p:cSld name="Slide 10">
+    <p:spTree>
+      <p:nvGrpSpPr>
+        <p:cNvPr id="1" name=""/>
+        <p:cNvGrpSpPr/>
+        <p:nvPr/>
+      </p:nvGrpSpPr>
+      <p:grpSpPr>
+        <a:xfrm>
+          <a:off x="0" y="0"/>
+          <a:ext cx="0" cy="0"/>
+          <a:chOff x="0" y="0"/>
+          <a:chExt cx="0" cy="0"/>
+        </a:xfrm>
+      </p:grpSpPr>
+      <p:sp>
+        <p:nvSpPr>
+          <p:cNvPr id="2" name="Text 2"/>
+          <p:cNvSpPr/>
+          <p:nvPr>
+            <p:ph idx="102" type="body" hasCustomPrompt="1"/>
+          </p:nvPr>
+        </p:nvSpPr>
+        <p:spPr>
+          <a:xfrm>
+            <a:off x="548640" y="384048"/>
+            <a:ext cx="8229600" cy="219456"/>
+          </a:xfrm>
+          <a:prstGeom prst="rect">
+            <a:avLst/>
+          </a:prstGeom>
+          <a:noFill/>
+          <a:ln/>
+        </p:spPr>
+        <p:txBody>
+          <a:bodyPr wrap="square" lIns="0" tIns="0" rIns="0" bIns="0" rtlCol="0" anchor="t"/>
+          <a:lstStyle/>
+          <a:p>
+            <a:pPr indent="0" marL="0">
+              <a:buNone/>
+            </a:pPr>
+            <a:r>
+              <a:rPr lang="en-US" sz="1000" b="1" spc="100" kern="0" dirty="0">
+                <a:solidFill>
+                  <a:schemeClr val="accent2"/>
+                </a:solidFill>
+              </a:rPr>
+              <a:t>ADDITIONAL COMPETITIVE DYNAMIC: LLM PROVIDERS EXPAND INTO LIFE SCIENCES</a:t>
+            </a:r>
+            <a:endParaRPr lang="en-US" sz="1000" dirty="0"/>
+          </a:p>
+        </p:txBody>
+      </p:sp>
+      <p:sp>
+        <p:nvSpPr>
+          <p:cNvPr id="3" name="Text 2"/>
+          <p:cNvSpPr/>
+          <p:nvPr>
+            <p:ph idx="103" type="title" hasCustomPrompt="1"/>
+          </p:nvPr>
+        </p:nvSpPr>
+        <p:spPr>
+          <a:xfrm>
+            <a:off x="548640" y="640080"/>
+            <a:ext cx="11091672" cy="749808"/>
+          </a:xfrm>
+          <a:prstGeom prst="rect">
+            <a:avLst/>
+          </a:prstGeom>
+          <a:noFill/>
+          <a:ln/>
+        </p:spPr>
+        <p:txBody>
+          <a:bodyPr wrap="square" lIns="0" tIns="0" rIns="0" bIns="0" rtlCol="0" anchor="t"/>
+          <a:lstStyle/>
+          <a:p>
+            <a:pPr algn="l" indent="0" marL="0">
+              <a:buNone/>
+            </a:pPr>
+            <a:r>
+              <a:rPr lang="en-US" sz="2200" b="1" dirty="0">
+                <a:solidFill>
+                  <a:schemeClr val="accent1"/>
+                </a:solidFill>
+              </a:rPr>
+              <a:t>LLM providers now supply, build and buy their way into life sciences, making them potential partners and rivals</a:t>
+            </a:r>
+            <a:endParaRPr lang="en-US" sz="2200" dirty="0"/>
+          </a:p>
+        </p:txBody>
+      </p:sp>
+      <p:sp>
+        <p:nvSpPr>
+          <p:cNvPr id="4" name="label"/>
+          <p:cNvSpPr txBox="1"/>
+          <p:nvPr/>
+        </p:nvSpPr>
+        <p:spPr>
+          <a:xfrm>
+            <a:off x="548640" y="1481328"/>
+            <a:ext cx="7315200" cy="201168"/>
+          </a:xfrm>
+          <a:prstGeom prst="rect">
+            <a:avLst/>
+          </a:prstGeom>
+          <a:noFill/>
+          <a:ln/>
+        </p:spPr>
+        <p:txBody>
+          <a:bodyPr wrap="square" lIns="0" tIns="0" rIns="0" bIns="0" rtlCol="0" anchor="t"/>
+          <a:lstStyle/>
+          <a:p>
+            <a:pPr indent="0" marL="0">
+              <a:buNone/>
+            </a:pPr>
+            <a:r>
+              <a:rPr lang="en-US" sz="1000" b="1" spc="100" kern="0" dirty="0">
+                <a:solidFill>
+                  <a:schemeClr val="accent2"/>
+                </a:solidFill>
+              </a:rPr>
+              <a:t>THREE OBSERVED APPROACHES TO ENTERING LIFE SCIENCES</a:t>
+            </a:r>
+            <a:endParaRPr lang="en-US" sz="1000" dirty="0"/>
+          </a:p>
+        </p:txBody>
+      </p:sp>
+      <p:graphicFrame>
+        <p:nvGraphicFramePr>
+          <p:cNvPr id="11" name="task table"/>
+          <p:cNvGraphicFramePr>
+            <a:graphicFrameLocks noGrp="1"/>
+          </p:cNvGraphicFramePr>
+          <p:nvPr>
+            <p:extLst>
+              <p:ext uri="{D42A27DB-BD31-4B8C-83A1-F6EECF244321}">
+                <p14:modId xmlns:p14="http://schemas.microsoft.com/office/powerpoint/2010/main" val="1579011935"/>
+              </p:ext>
+            </p:extLst>
+          </p:nvPr>
+        </p:nvGraphicFramePr>
+        <p:xfrm>
+          <a:off x="548640" y="1737360"/>
+          <a:ext cx="11091672" cy="3017518"/>
+        </p:xfrm>
+        <a:graphic>
+          <a:graphicData uri="http://schemas.openxmlformats.org/drawingml/2006/table">
+            <a:tbl>
+              <a:tblPr/>
+              <a:tblGrid>
+                <a:gridCol w="1965960"/>
+                <a:gridCol w="5349240"/>
+                <a:gridCol w="3776472"/>
+              </a:tblGrid>
+              <a:tr h="402336">
+                <a:tc>
+                  <a:txBody>
+                    <a:bodyPr/>
+                    <a:lstStyle/>
+                    <a:p>
+                      <a:pPr indent="0" marL="0">
+                        <a:buNone/>
+                      </a:pPr>
+                      <a:r>
+                        <a:rPr lang="en-US" sz="900" b="1" spc="0" kern="0" dirty="0">
+                          <a:solidFill>
+                            <a:schemeClr val="bg1"/>
+                          </a:solidFill>
+                        </a:rPr>
+                        <a:t>LLM PROVIDER APPROACH</a:t>
+                      </a:r>
+                      <a:endParaRPr lang="en-US" sz="900" dirty="0"/>
+                    </a:p>
+                  </a:txBody>
+                  <a:tcPr marL="109728" marR="109728" marT="64008" marB="64008" anchor="ctr">
+                    <a:lnL w="0" cap="flat" cmpd="sng" algn="ctr">
+                      <a:noFill/>
+                    </a:lnL>
+                    <a:lnR w="0" cap="flat" cmpd="sng" algn="ctr">
+                      <a:noFill/>
+                    </a:lnR>
+                    <a:lnT w="0" cap="flat" cmpd="sng" algn="ctr">
+                      <a:noFill/>
+                    </a:lnT>
+                    <a:lnB w="0" cap="flat" cmpd="sng" algn="ctr">
+                      <a:noFill/>
+                    </a:lnB>
+                    <a:solidFill>
+                      <a:schemeClr val="accent1"/>
+                    </a:solidFill>
+                  </a:tcPr>
+                </a:tc>
+                <a:tc>
+                  <a:txBody>
+                    <a:bodyPr/>
+                    <a:lstStyle/>
+                    <a:p>
+                      <a:pPr indent="0" marL="0">
+                        <a:buNone/>
+                      </a:pPr>
+                      <a:r>
+                        <a:rPr lang="en-US" sz="900" b="1" spc="100" kern="0" dirty="0">
+                          <a:solidFill>
+                            <a:schemeClr val="bg1"/>
+                          </a:solidFill>
+                        </a:rPr>
+                        <a:t>SELECTED PUBLIC DEVELOPMENTS</a:t>
+                      </a:r>
+                      <a:endParaRPr lang="en-US" sz="900" dirty="0"/>
+                    </a:p>
+                  </a:txBody>
+                  <a:tcPr marL="109728" marR="109728" marT="64008" marB="64008" anchor="ctr">
+                    <a:lnL w="0" cap="flat" cmpd="sng" algn="ctr">
+                      <a:noFill/>
+                    </a:lnL>
+                    <a:lnR w="0" cap="flat" cmpd="sng" algn="ctr">
+                      <a:noFill/>
+                    </a:lnR>
+                    <a:lnT w="0" cap="flat" cmpd="sng" algn="ctr">
+                      <a:noFill/>
+                    </a:lnT>
+                    <a:lnB w="0" cap="flat" cmpd="sng" algn="ctr">
+                      <a:noFill/>
+                    </a:lnB>
+                    <a:solidFill>
+                      <a:schemeClr val="accent1"/>
+                    </a:solidFill>
+                  </a:tcPr>
+                </a:tc>
+                <a:tc>
+                  <a:txBody>
+                    <a:bodyPr/>
+                    <a:lstStyle/>
+                    <a:p>
+                      <a:pPr indent="0" marL="0">
+                        <a:buNone/>
+                      </a:pPr>
+                      <a:r>
+                        <a:rPr lang="en-US" sz="900" b="1" spc="100" kern="0" dirty="0">
+                          <a:solidFill>
+                            <a:schemeClr val="bg1"/>
+                          </a:solidFill>
+                        </a:rPr>
+                        <a:t>COMPETITIVE SIGNIFICANCE FOR OPTUM LS</a:t>
+                      </a:r>
+                      <a:endParaRPr lang="en-US" sz="900" dirty="0"/>
+                    </a:p>
+                  </a:txBody>
+                  <a:tcPr marL="109728" marR="109728" marT="64008" marB="64008" anchor="ctr">
+                    <a:lnL w="0" cap="flat" cmpd="sng" algn="ctr">
+                      <a:noFill/>
+                    </a:lnL>
+                    <a:lnR w="0" cap="flat" cmpd="sng" algn="ctr">
+                      <a:noFill/>
+                    </a:lnR>
+                    <a:lnT w="0" cap="flat" cmpd="sng" algn="ctr">
+                      <a:noFill/>
+                    </a:lnT>
+                    <a:lnB w="0" cap="flat" cmpd="sng" algn="ctr">
+                      <a:noFill/>
+                    </a:lnB>
+                    <a:solidFill>
+                      <a:schemeClr val="accent1"/>
+                    </a:solidFill>
+                  </a:tcPr>
+                </a:tc>
+              </a:tr>
+              <a:tr h="1050645">
+                <a:tc>
+                  <a:txBody>
+                    <a:bodyPr/>
+                    <a:lstStyle/>
+                    <a:p>
+                      <a:pPr algn="l" indent="0" marL="0">
+                        <a:buNone/>
+                      </a:pPr>
+                      <a:r>
+                        <a:rPr lang="en-US" sz="1050" b="1" dirty="0">
+                          <a:solidFill>
+                            <a:schemeClr val="accent1"/>
+                          </a:solidFill>
+                        </a:rPr>
+                        <a:t>Partner with established life-sciences vendors</a:t>
+                      </a:r>
+                      <a:endParaRPr lang="en-US" sz="1050" dirty="0"/>
+                    </a:p>
+                  </a:txBody>
+                  <a:tcPr marL="109728" marR="109728" marT="64008" marB="64008" anchor="ctr">
+                    <a:lnL w="0" cap="flat" cmpd="sng" algn="ctr">
+                      <a:noFill/>
+                    </a:lnL>
+                    <a:lnR w="25400" cap="flat" cmpd="sng" algn="ctr">
+                      <a:solidFill>
+                        <a:srgbClr val="FFFFFF"/>
+                      </a:solidFill>
+                      <a:prstDash val="solid"/>
+                      <a:round/>
+                      <a:headEnd type="none" w="med" len="med"/>
+                      <a:tailEnd type="none" w="med" len="med"/>
+                    </a:lnR>
+                    <a:lnT w="25400" cap="flat" cmpd="sng" algn="ctr">
+                      <a:solidFill>
+                        <a:srgbClr val="FFFFFF"/>
+                      </a:solidFill>
+                      <a:prstDash val="solid"/>
+                      <a:round/>
+                      <a:headEnd type="none" w="med" len="med"/>
+                      <a:tailEnd type="none" w="med" len="med"/>
+                    </a:lnT>
+                    <a:lnB w="25400" cap="flat" cmpd="sng" algn="ctr">
+                      <a:solidFill>
+                        <a:srgbClr val="FFFFFF"/>
+                      </a:solidFill>
+                      <a:prstDash val="solid"/>
+                      <a:round/>
+                      <a:headEnd type="none" w="med" len="med"/>
+                      <a:tailEnd type="none" w="med" len="med"/>
+                    </a:lnB>
+                    <a:solidFill>
+                      <a:schemeClr val="accent5"/>
+                    </a:solidFill>
+                  </a:tcPr>
+                </a:tc>
+                <a:tc>
+                  <a:txBody>
+                    <a:bodyPr/>
+                    <a:lstStyle/>
+                    <a:p>
+                      <a:pPr indent="0" marL="0">
+                        <a:buNone/>
+                      </a:pPr>
+                      <a:r>
                         <a:rPr lang="en-US" sz="900" b="1" dirty="0" u="sng">
                           <a:solidFill>
                             <a:srgbClr val="002677"/>
@@ -4356,7 +7007,7 @@
             <a:pPr algn="r"/>
             <a:fld id="{F7021451-1387-4CA6-816F-3879F97B5CBC}" type="slidenum">
               <a:rPr b="0" lang="en-US"/>
-              <a:t>10</a:t>
+              <a:t>11</a:t>
             </a:fld>
             <a:endParaRPr lang="en-US"/>
           </a:p>
@@ -4747,7 +7398,7 @@
 </p:sld>
 </file>
 
-<file path=ppt/slides/slide11.xml><?xml version="1.0" encoding="utf-8"?>
+<file path=ppt/slides/slide12.xml><?xml version="1.0" encoding="utf-8"?>
 <p:sld xmlns:a="http://schemas.openxmlformats.org/drawingml/2006/main" xmlns:p="http://schemas.openxmlformats.org/presentationml/2006/main" xmlns:r="http://schemas.openxmlformats.org/officeDocument/2006/relationships">
   <p:cSld>
     <p:spTree>
@@ -5572,7 +8223,7 @@
             <a:pPr algn="r"/>
             <a:fld id="{F7021451-1387-4CA6-816F-3879F97B5CBC}" type="slidenum">
               <a:rPr b="0" lang="en-US"/>
-              <a:t>11</a:t>
+              <a:t>12</a:t>
             </a:fld>
             <a:endParaRPr lang="en-US"/>
           </a:p>
@@ -5586,7 +8237,7 @@
 </p:sld>
 </file>
 
-<file path=ppt/slides/slide12.xml><?xml version="1.0" encoding="utf-8"?>
+<file path=ppt/slides/slide13.xml><?xml version="1.0" encoding="utf-8"?>
 <p:sld xmlns:a="http://schemas.openxmlformats.org/drawingml/2006/main" xmlns:r="http://schemas.openxmlformats.org/officeDocument/2006/relationships" xmlns:p="http://schemas.openxmlformats.org/presentationml/2006/main">
   <p:cSld name="Slide 11">
     <p:spTree>
@@ -6233,7 +8884,7 @@
             <a:pPr algn="r"/>
             <a:fld id="{F7021451-1387-4CA6-816F-3879F97B5CBC}" type="slidenum">
               <a:rPr b="0" lang="en-US"/>
-              <a:t>12</a:t>
+              <a:t>13</a:t>
             </a:fld>
             <a:endParaRPr lang="en-US"/>
           </a:p>
@@ -6247,7 +8898,7 @@
 </p:sld>
 </file>
 
-<file path=ppt/slides/slide13.xml><?xml version="1.0" encoding="utf-8"?>
+<file path=ppt/slides/slide14.xml><?xml version="1.0" encoding="utf-8"?>
 <p:sld xmlns:a="http://schemas.openxmlformats.org/drawingml/2006/main" xmlns:r="http://schemas.openxmlformats.org/officeDocument/2006/relationships" xmlns:p="http://schemas.openxmlformats.org/presentationml/2006/main">
   <p:cSld name="Slide 4">
     <p:spTree>
@@ -8448,7 +11099,7 @@
             <a:pPr algn="r"/>
             <a:fld id="{F7021451-1387-4CA6-816F-3879F97B5CBC}" type="slidenum">
               <a:rPr b="0" lang="en-US"/>
-              <a:t>13</a:t>
+              <a:t>14</a:t>
             </a:fld>
             <a:endParaRPr lang="en-US"/>
           </a:p>

</xml_diff>

<commit_message>
10.16: replace LLM providers slide (model suppliers, three routes into pharma, 21 source links)
Co-Authored-By: Claude Opus 5.5 <noreply@anthropic.com>
Claude-Session: https://claude.ai/code/session_0198bm9pfzRwgZQBqNvd56W8
</commit_message>
<xml_diff>
--- a/deck/Optum-LS-Conversational-AI-10.16.pptx
+++ b/deck/Optum-LS-Conversational-AI-10.16.pptx
@@ -5963,7 +5963,7 @@
                   <a:schemeClr val="accent2"/>
                 </a:solidFill>
               </a:rPr>
-              <a:t>ADDITIONAL COMPETITIVE DYNAMIC: LLM PROVIDERS EXPAND INTO LIFE SCIENCES</a:t>
+              <a:t>THE MODEL SUPPLIERS: LLM PROVIDERS IN LIFE SCIENCES</a:t>
             </a:r>
             <a:endParaRPr lang="en-US" sz="1000" dirty="0"/>
           </a:p>
@@ -6001,7 +6001,7 @@
                   <a:schemeClr val="accent1"/>
                 </a:solidFill>
               </a:rPr>
-              <a:t>LLM providers now supply, build and buy their way into life sciences, making them potential partners and rivals</a:t>
+              <a:t>LLM providers are entering pharma through research workbenches and enterprise deployments, not patient-level data</a:t>
             </a:r>
             <a:endParaRPr lang="en-US" sz="2200" dirty="0"/>
           </a:p>
@@ -6015,7 +6015,7 @@
         </p:nvSpPr>
         <p:spPr>
           <a:xfrm>
-            <a:off x="548640" y="1481328"/>
+            <a:off x="548640" y="1828800"/>
             <a:ext cx="7315200" cy="201168"/>
           </a:xfrm>
           <a:prstGeom prst="rect">
@@ -6037,7 +6037,7 @@
                   <a:schemeClr val="accent2"/>
                 </a:solidFill>
               </a:rPr>
-              <a:t>THREE OBSERVED APPROACHES TO ENTERING LIFE SCIENCES</a:t>
+              <a:t>THREE WAYS LLM PROVIDERS REACH OPTUM LS’S CUSTOMERS</a:t>
             </a:r>
             <a:endParaRPr lang="en-US" sz="1000" dirty="0"/>
           </a:p>
@@ -6058,17 +6058,18 @@
           </p:nvPr>
         </p:nvGraphicFramePr>
         <p:xfrm>
-          <a:off x="548640" y="1737360"/>
-          <a:ext cx="11091672" cy="3017518"/>
+          <a:off x="548640" y="2075688"/>
+          <a:ext cx="11091672" cy="2679190"/>
         </p:xfrm>
         <a:graphic>
           <a:graphicData uri="http://schemas.openxmlformats.org/drawingml/2006/table">
             <a:tbl>
               <a:tblPr/>
               <a:tblGrid>
-                <a:gridCol w="1965960"/>
-                <a:gridCol w="5349240"/>
-                <a:gridCol w="3776472"/>
+                <a:gridCol w="1554480"/>
+                <a:gridCol w="1234440"/>
+                <a:gridCol w="5029200"/>
+                <a:gridCol w="3273552"/>
               </a:tblGrid>
               <a:tr h="402336">
                 <a:tc>
@@ -6080,12 +6081,12 @@
                         <a:buNone/>
                       </a:pPr>
                       <a:r>
-                        <a:rPr lang="en-US" sz="900" b="1" spc="0" kern="0" dirty="0">
+                        <a:rPr lang="en-US" sz="850" b="1" spc="100" kern="0" dirty="0">
                           <a:solidFill>
                             <a:schemeClr val="bg1"/>
                           </a:solidFill>
                         </a:rPr>
-                        <a:t>LLM PROVIDER APPROACH</a:t>
+                        <a:t>APPROACH</a:t>
                       </a:r>
                       <a:endParaRPr lang="en-US" sz="900" dirty="0"/>
                     </a:p>
@@ -6117,12 +6118,12 @@
                         <a:buNone/>
                       </a:pPr>
                       <a:r>
-                        <a:rPr lang="en-US" sz="900" b="1" spc="100" kern="0" dirty="0">
+                        <a:rPr lang="en-US" sz="850" b="1" spc="100" kern="0" dirty="0">
                           <a:solidFill>
                             <a:schemeClr val="bg1"/>
                           </a:solidFill>
                         </a:rPr>
-                        <a:t>SELECTED PUBLIC DEVELOPMENTS</a:t>
+                        <a:t>LAYER REACHED</a:t>
                       </a:r>
                       <a:endParaRPr lang="en-US" sz="900" dirty="0"/>
                     </a:p>
@@ -6154,7 +6155,44 @@
                         <a:buNone/>
                       </a:pPr>
                       <a:r>
-                        <a:rPr lang="en-US" sz="900" b="1" spc="100" kern="0" dirty="0">
+                        <a:rPr lang="en-US" sz="850" b="1" spc="100" kern="0" dirty="0">
+                          <a:solidFill>
+                            <a:schemeClr val="bg1"/>
+                          </a:solidFill>
+                        </a:rPr>
+                        <a:t>SELECTED PUBLIC DEVELOPMENTS</a:t>
+                      </a:r>
+                      <a:endParaRPr lang="en-US" sz="900" dirty="0"/>
+                    </a:p>
+                  </a:txBody>
+                  <a:tcPr marL="109728" marR="109728" marT="64008" marB="64008" anchor="ctr">
+                    <a:lnL w="0" cap="flat" cmpd="sng" algn="ctr">
+                      <a:noFill/>
+                    </a:lnL>
+                    <a:lnR w="0" cap="flat" cmpd="sng" algn="ctr">
+                      <a:noFill/>
+                    </a:lnR>
+                    <a:lnT w="0" cap="flat" cmpd="sng" algn="ctr">
+                      <a:noFill/>
+                    </a:lnT>
+                    <a:lnB w="0" cap="flat" cmpd="sng" algn="ctr">
+                      <a:noFill/>
+                    </a:lnB>
+                    <a:solidFill>
+                      <a:schemeClr val="accent1"/>
+                    </a:solidFill>
+                  </a:tcPr>
+                </a:tc>
+                <a:tc>
+                  <a:txBody>
+                    <a:bodyPr/>
+                    <a:lstStyle/>
+                    <a:p>
+                      <a:pPr indent="0" marL="0">
+                        <a:buNone/>
+                      </a:pPr>
+                      <a:r>
+                        <a:rPr lang="en-US" sz="850" b="1" spc="100" kern="0" dirty="0">
                           <a:solidFill>
                             <a:schemeClr val="bg1"/>
                           </a:solidFill>
@@ -6183,7 +6221,7 @@
                   </a:tcPr>
                 </a:tc>
               </a:tr>
-              <a:tr h="1050645">
+              <a:tr h="878471">
                 <a:tc>
                   <a:txBody>
                     <a:bodyPr/>
@@ -6193,12 +6231,12 @@
                         <a:buNone/>
                       </a:pPr>
                       <a:r>
-                        <a:rPr lang="en-US" sz="1050" b="1" dirty="0">
+                        <a:rPr lang="en-US" sz="1000" b="1" dirty="0">
                           <a:solidFill>
                             <a:schemeClr val="accent1"/>
                           </a:solidFill>
                         </a:rPr>
-                        <a:t>Partner with established life-sciences vendors</a:t>
+                        <a:t>Own research workbenches</a:t>
                       </a:r>
                       <a:endParaRPr lang="en-US" sz="1050" dirty="0"/>
                     </a:p>
@@ -6248,130 +6286,12 @@
                         <a:buNone/>
                       </a:pPr>
                       <a:r>
-                        <a:rPr lang="en-US" sz="900" b="1" dirty="0" u="sng">
+                        <a:rPr lang="en-US" sz="900" dirty="0">
                           <a:solidFill>
                             <a:srgbClr val="002677"/>
                           </a:solidFill>
-                          <a:uFill>
-                            <a:solidFill>
-                              <a:srgbClr val="9AA8CC"/>
-                            </a:solidFill>
-                          </a:uFill>
-                        </a:rPr>
-                        <a:t>Anthropic + Komodo Health</a:t>
-                      </a:r>
-                      <a:r>
-                        <a:rPr lang="en-US" sz="900" b="1" dirty="0">
-                          <a:solidFill>
-                            <a:schemeClr val="tx1"/>
-                          </a:solidFill>
-                        </a:rPr>
-                        <a:t>:</a:t>
-                      </a:r>
-                      <a:r>
-                        <a:rPr lang="en-US" sz="900" dirty="0">
-                          <a:solidFill>
-                            <a:schemeClr val="tx1"/>
-                          </a:solidFill>
-                        </a:rPr>
-                        <a:t> A documented partnership supporting AI-enabled healthcare analytics;</a:t>
-                      </a:r>
-                      <a:endParaRPr lang="en-US" sz="900" dirty="0"/>
-                    </a:p>
-                    <a:p>
-                      <a:pPr indent="0" marL="0">
-                        <a:spcBef>
-                          <a:spcPts val="400"/>
-                        </a:spcBef>
-                        <a:buNone/>
-                      </a:pPr>
-                      <a:r>
-                        <a:rPr lang="en-US" sz="900" b="1" dirty="0" u="sng">
-                          <a:solidFill>
-                            <a:srgbClr val="002677"/>
-                          </a:solidFill>
-                          <a:uFill>
-                            <a:solidFill>
-                              <a:srgbClr val="9AA8CC"/>
-                            </a:solidFill>
-                          </a:uFill>
-                        </a:rPr>
-                        <a:t>Anthropic + Veeva</a:t>
-                      </a:r>
-                      <a:r>
-                        <a:rPr lang="en-US" sz="900" b="1" dirty="0">
-                          <a:solidFill>
-                            <a:schemeClr val="tx1"/>
-                          </a:solidFill>
-                        </a:rPr>
-                        <a:t>:</a:t>
-                      </a:r>
-                      <a:r>
-                        <a:rPr lang="en-US" sz="900" dirty="0">
-                          <a:solidFill>
-                            <a:schemeClr val="tx1"/>
-                          </a:solidFill>
-                        </a:rPr>
-                        <a:t> Claude incorporated into Veeva’s industry-specific AI offerings;</a:t>
-                      </a:r>
-                      <a:endParaRPr lang="en-US" sz="900" dirty="0"/>
-                    </a:p>
-                    <a:p>
-                      <a:pPr indent="0" marL="0">
-                        <a:spcBef>
-                          <a:spcPts val="400"/>
-                        </a:spcBef>
-                        <a:buNone/>
-                      </a:pPr>
-                      <a:r>
-                        <a:rPr lang="en-US" sz="900" b="1" dirty="0" u="sng">
-                          <a:solidFill>
-                            <a:srgbClr val="002677"/>
-                          </a:solidFill>
-                          <a:uFill>
-                            <a:solidFill>
-                              <a:srgbClr val="9AA8CC"/>
-                            </a:solidFill>
-                          </a:uFill>
-                        </a:rPr>
-                        <a:t>AWS + Datavant</a:t>
-                      </a:r>
-                      <a:r>
-                        <a:rPr lang="en-US" sz="900" b="1" dirty="0">
-                          <a:solidFill>
-                            <a:schemeClr val="tx1"/>
-                          </a:solidFill>
-                        </a:rPr>
-                        <a:t>:</a:t>
-                      </a:r>
-                      <a:r>
-                        <a:rPr lang="en-US" sz="900" dirty="0">
-                          <a:solidFill>
-                            <a:schemeClr val="tx1"/>
-                          </a:solidFill>
-                        </a:rPr>
-                        <a:t> </a:t>
-                      </a:r>
-                      <a:r>
-                        <a:rPr lang="en-US" sz="900" dirty="0" u="sng">
-                          <a:solidFill>
-                            <a:srgbClr val="002677"/>
-                          </a:solidFill>
-                          <a:uFill>
-                            <a:solidFill>
-                              <a:srgbClr val="9AA8CC"/>
-                            </a:solidFill>
-                          </a:uFill>
-                        </a:rPr>
-                        <a:t>Explore Assistant</a:t>
-                      </a:r>
-                      <a:r>
-                        <a:rPr lang="en-US" sz="900" dirty="0">
-                          <a:solidFill>
-                            <a:schemeClr val="tx1"/>
-                          </a:solidFill>
-                        </a:rPr>
-                        <a:t>, publicly described in February 2026, uses Bedrock and AWS Clean Rooms to support natural-language assessment of healthcare datasets and research feasibility.</a:t>
+                        </a:rPr>
+                        <a:t>Interface</a:t>
                       </a:r>
                       <a:endParaRPr lang="en-US" sz="900" dirty="0"/>
                     </a:p>
@@ -6406,12 +6326,200 @@
                         <a:buNone/>
                       </a:pPr>
                       <a:r>
+                        <a:rPr lang="en-US" sz="900" dirty="0" b="1">
+                          <a:solidFill>
+                            <a:schemeClr val="tx1"/>
+                          </a:solidFill>
+                        </a:rPr>
+                        <a:t>Anthropic’s </a:t>
+                      </a:r>
+                      <a:r>
+                        <a:rPr lang="en-US" sz="900" dirty="0" b="1" u="sng">
+                          <a:solidFill>
+                            <a:srgbClr val="002677"/>
+                          </a:solidFill>
+                          <a:uFill>
+                            <a:solidFill>
+                              <a:srgbClr val="9AA8CC"/>
+                            </a:solidFill>
+                          </a:uFill>
+                        </a:rPr>
+                        <a:t>Claude Science</a:t>
+                      </a:r>
+                      <a:r>
                         <a:rPr lang="en-US" sz="900" dirty="0">
                           <a:solidFill>
                             <a:schemeClr val="tx1"/>
                           </a:solidFill>
                         </a:rPr>
-                        <a:t>LLM providers supply the model while partners keep the data, applications and customer relationships; Komodo and Veeva already appear in this analysis.</a:t>
+                        <a:t> (beta, June 2026): “</a:t>
+                      </a:r>
+                      <a:r>
+                        <a:rPr lang="en-US" sz="900" dirty="0" u="sng">
+                          <a:solidFill>
+                            <a:srgbClr val="002677"/>
+                          </a:solidFill>
+                          <a:uFill>
+                            <a:solidFill>
+                              <a:srgbClr val="9AA8CC"/>
+                            </a:solidFill>
+                          </a:uFill>
+                        </a:rPr>
+                        <a:t>over 60 curated skills and connectors</a:t>
+                      </a:r>
+                      <a:r>
+                        <a:rPr lang="en-US" sz="900" dirty="0">
+                          <a:solidFill>
+                            <a:schemeClr val="tx1"/>
+                          </a:solidFill>
+                        </a:rPr>
+                        <a:t>,” drawing on public databases such as UniProt and ClinVar plus users’ own data.</a:t>
+                      </a:r>
+                      <a:endParaRPr lang="en-US" sz="900" dirty="0"/>
+                    </a:p>
+                    <a:p>
+                      <a:pPr indent="0" marL="0">
+                        <a:spcBef>
+                          <a:spcPts val="200"/>
+                        </a:spcBef>
+                        <a:buNone/>
+                      </a:pPr>
+                      <a:r>
+                        <a:rPr lang="en-US" sz="900" dirty="0" b="1">
+                          <a:solidFill>
+                            <a:schemeClr val="tx1"/>
+                          </a:solidFill>
+                        </a:rPr>
+                        <a:t>OpenAI’s </a:t>
+                      </a:r>
+                      <a:r>
+                        <a:rPr lang="en-US" sz="900" dirty="0" b="1" u="sng">
+                          <a:solidFill>
+                            <a:srgbClr val="002677"/>
+                          </a:solidFill>
+                          <a:uFill>
+                            <a:solidFill>
+                              <a:srgbClr val="9AA8CC"/>
+                            </a:solidFill>
+                          </a:uFill>
+                        </a:rPr>
+                        <a:t>GPT-Rosalind</a:t>
+                      </a:r>
+                      <a:r>
+                        <a:rPr lang="en-US" sz="900" dirty="0">
+                          <a:solidFill>
+                            <a:schemeClr val="tx1"/>
+                          </a:solidFill>
+                        </a:rPr>
+                        <a:t>: trusted access for eligible organizations since September 2026.</a:t>
+                      </a:r>
+                      <a:endParaRPr lang="en-US" sz="900" dirty="0"/>
+                    </a:p>
+                    <a:p>
+                      <a:pPr indent="0" marL="0">
+                        <a:spcBef>
+                          <a:spcPts val="200"/>
+                        </a:spcBef>
+                        <a:buNone/>
+                      </a:pPr>
+                      <a:r>
+                        <a:rPr lang="en-US" sz="900" dirty="0" b="1" u="sng">
+                          <a:solidFill>
+                            <a:srgbClr val="002677"/>
+                          </a:solidFill>
+                          <a:uFill>
+                            <a:solidFill>
+                              <a:srgbClr val="9AA8CC"/>
+                            </a:solidFill>
+                          </a:uFill>
+                        </a:rPr>
+                        <a:t>Microsoft Discovery</a:t>
+                      </a:r>
+                      <a:r>
+                        <a:rPr lang="en-US" sz="900" dirty="0">
+                          <a:solidFill>
+                            <a:schemeClr val="tx1"/>
+                          </a:solidFill>
+                        </a:rPr>
+                        <a:t>: generally available June 2026, with GSK named.</a:t>
+                      </a:r>
+                      <a:endParaRPr lang="en-US" sz="900" dirty="0"/>
+                    </a:p>
+                    <a:p>
+                      <a:pPr indent="0" marL="0">
+                        <a:spcBef>
+                          <a:spcPts val="200"/>
+                        </a:spcBef>
+                        <a:buNone/>
+                      </a:pPr>
+                      <a:r>
+                        <a:rPr lang="en-US" sz="900" dirty="0" b="1">
+                          <a:solidFill>
+                            <a:schemeClr val="tx1"/>
+                          </a:solidFill>
+                        </a:rPr>
+                        <a:t>Google’s </a:t>
+                      </a:r>
+                      <a:r>
+                        <a:rPr lang="en-US" sz="900" dirty="0" b="1" u="sng">
+                          <a:solidFill>
+                            <a:srgbClr val="002677"/>
+                          </a:solidFill>
+                          <a:uFill>
+                            <a:solidFill>
+                              <a:srgbClr val="9AA8CC"/>
+                            </a:solidFill>
+                          </a:uFill>
+                        </a:rPr>
+                        <a:t>Co-Scientist</a:t>
+                      </a:r>
+                      <a:r>
+                        <a:rPr lang="en-US" sz="900" dirty="0">
+                          <a:solidFill>
+                            <a:schemeClr val="tx1"/>
+                          </a:solidFill>
+                        </a:rPr>
+                        <a:t>: enterprise preview that includes Daiichi Sankyo.</a:t>
+                      </a:r>
+                      <a:endParaRPr lang="en-US" sz="900" dirty="0"/>
+                    </a:p>
+                  </a:txBody>
+                  <a:tcPr marL="109728" marR="109728" marT="64008" marB="64008" anchor="ctr">
+                    <a:lnL w="0" cap="flat" cmpd="sng" algn="ctr">
+                      <a:noFill/>
+                    </a:lnL>
+                    <a:lnR w="0" cap="flat" cmpd="sng" algn="ctr">
+                      <a:noFill/>
+                    </a:lnR>
+                    <a:lnT w="0" cap="flat" cmpd="sng" algn="ctr">
+                      <a:noFill/>
+                    </a:lnT>
+                    <a:lnB w="19050" cap="flat" cmpd="sng" algn="ctr">
+                      <a:solidFill>
+                        <a:srgbClr val="002677"/>
+                      </a:solidFill>
+                      <a:prstDash val="solid"/>
+                      <a:round/>
+                      <a:headEnd type="none" w="med" len="med"/>
+                      <a:tailEnd type="none" w="med" len="med"/>
+                    </a:lnB>
+                  </a:tcPr>
+                </a:tc>
+                <a:tc>
+                  <a:txBody>
+                    <a:bodyPr/>
+                    <a:lstStyle/>
+                    <a:p>
+                      <a:pPr indent="0" marL="0">
+                        <a:buNone/>
+                      </a:pPr>
+                      <a:r>
+                        <a:rPr lang="en-US" sz="900" dirty="0">
+                          <a:solidFill>
+                            <a:schemeClr val="tx1"/>
+                          </a:solidFill>
+                        </a:rPr>
+                        <a:t>Discovery-stage research on public and customer data; little overlap with RWE, commercial or HEOR.</a:t>
                       </a:r>
                       <a:endParaRPr lang="en-US" sz="900" dirty="0"/>
                     </a:p>
@@ -6438,7 +6546,7 @@
                   </a:tcPr>
                 </a:tc>
               </a:tr>
-              <a:tr h="871727">
+              <a:tr h="699198">
                 <a:tc>
                   <a:txBody>
                     <a:bodyPr/>
@@ -6448,12 +6556,12 @@
                         <a:buNone/>
                       </a:pPr>
                       <a:r>
-                        <a:rPr lang="en-US" sz="1050" b="1" dirty="0">
-                          <a:solidFill>
-                            <a:schemeClr val="bg1"/>
-                          </a:solidFill>
-                        </a:rPr>
-                        <a:t>Develop their own life-sciences-specific products and tools</a:t>
+                        <a:rPr lang="en-US" sz="1000" b="1" dirty="0">
+                          <a:solidFill>
+                            <a:schemeClr val="accent1"/>
+                          </a:solidFill>
+                        </a:rPr>
+                        <a:t>Become pharma’s enterprise layer</a:t>
                       </a:r>
                       <a:endParaRPr lang="en-US" sz="1050" dirty="0"/>
                     </a:p>
@@ -6490,7 +6598,7 @@
                       <a:tailEnd type="none" w="med" len="med"/>
                     </a:lnB>
                     <a:solidFill>
-                      <a:schemeClr val="accent1"/>
+                      <a:schemeClr val="accent5"/>
                     </a:solidFill>
                   </a:tcPr>
                 </a:tc>
@@ -6503,71 +6611,12 @@
                         <a:buNone/>
                       </a:pPr>
                       <a:r>
-                        <a:rPr lang="en-US" sz="900" b="1" dirty="0" u="sng">
+                        <a:rPr lang="en-US" sz="900" dirty="0">
                           <a:solidFill>
                             <a:srgbClr val="002677"/>
                           </a:solidFill>
-                          <a:uFill>
-                            <a:solidFill>
-                              <a:srgbClr val="9AA8CC"/>
-                            </a:solidFill>
-                          </a:uFill>
-                        </a:rPr>
-                        <a:t>Anthropic’s Claude for Life Sciences</a:t>
-                      </a:r>
-                      <a:r>
-                        <a:rPr lang="en-US" sz="900" b="1" dirty="0">
-                          <a:solidFill>
-                            <a:schemeClr val="tx1"/>
-                          </a:solidFill>
-                        </a:rPr>
-                        <a:t>:</a:t>
-                      </a:r>
-                      <a:r>
-                        <a:rPr lang="en-US" sz="900" dirty="0">
-                          <a:solidFill>
-                            <a:schemeClr val="tx1"/>
-                          </a:solidFill>
-                        </a:rPr>
-                        <a:t> Specialized scientific tools and integrations supporting research, clinical trials and regulatory workflows;</a:t>
-                      </a:r>
-                      <a:endParaRPr lang="en-US" sz="900" dirty="0"/>
-                    </a:p>
-                    <a:p>
-                      <a:pPr indent="0" marL="0">
-                        <a:spcBef>
-                          <a:spcPts val="400"/>
-                        </a:spcBef>
-                        <a:buNone/>
-                      </a:pPr>
-                      <a:r>
-                        <a:rPr lang="en-US" sz="900" b="1" dirty="0" u="sng">
-                          <a:solidFill>
-                            <a:srgbClr val="002677"/>
-                          </a:solidFill>
-                          <a:uFill>
-                            <a:solidFill>
-                              <a:srgbClr val="9AA8CC"/>
-                            </a:solidFill>
-                          </a:uFill>
-                        </a:rPr>
-                        <a:t>OpenAI’s GPT-Rosalind</a:t>
-                      </a:r>
-                      <a:r>
-                        <a:rPr lang="en-US" sz="900" b="1" dirty="0">
-                          <a:solidFill>
-                            <a:schemeClr val="tx1"/>
-                          </a:solidFill>
-                        </a:rPr>
-                        <a:t>:</a:t>
-                      </a:r>
-                      <a:r>
-                        <a:rPr lang="en-US" sz="900" dirty="0">
-                          <a:solidFill>
-                            <a:schemeClr val="tx1"/>
-                          </a:solidFill>
-                        </a:rPr>
-                        <a:t> A purpose-built model for biology, drug discovery and translational research, with access expanded to eligible organizations in September 2026.</a:t>
+                        </a:rPr>
+                        <a:t>Interface and workflow</a:t>
                       </a:r>
                       <a:endParaRPr lang="en-US" sz="900" dirty="0"/>
                     </a:p>
@@ -6602,12 +6651,195 @@
                         <a:buNone/>
                       </a:pPr>
                       <a:r>
+                        <a:rPr lang="en-US" sz="900" dirty="0" b="1" u="sng">
+                          <a:solidFill>
+                            <a:srgbClr val="002677"/>
+                          </a:solidFill>
+                          <a:uFill>
+                            <a:solidFill>
+                              <a:srgbClr val="9AA8CC"/>
+                            </a:solidFill>
+                          </a:uFill>
+                        </a:rPr>
+                        <a:t>BMS</a:t>
+                      </a:r>
+                      <a:r>
                         <a:rPr lang="en-US" sz="900" dirty="0">
                           <a:solidFill>
                             <a:schemeClr val="tx1"/>
                           </a:solidFill>
                         </a:rPr>
-                        <a:t>LLM providers are building products aimed directly at life-sciences users, reaching into workflows adjacent to Optum LS’s RWE and healthcare-data offerings.</a:t>
+                        <a:t>: positions “</a:t>
+                      </a:r>
+                      <a:r>
+                        <a:rPr lang="en-US" sz="900" dirty="0" u="sng">
+                          <a:solidFill>
+                            <a:srgbClr val="002677"/>
+                          </a:solidFill>
+                          <a:uFill>
+                            <a:solidFill>
+                              <a:srgbClr val="9AA8CC"/>
+                            </a:solidFill>
+                          </a:uFill>
+                        </a:rPr>
+                        <a:t>Claude Enterprise as the Shared Intelligence Platform</a:t>
+                      </a:r>
+                      <a:r>
+                        <a:rPr lang="en-US" sz="900" dirty="0">
+                          <a:solidFill>
+                            <a:schemeClr val="tx1"/>
+                          </a:solidFill>
+                        </a:rPr>
+                        <a:t>” for more than 30,000 employees, including “</a:t>
+                      </a:r>
+                      <a:r>
+                        <a:rPr lang="en-US" sz="900" dirty="0" u="sng">
+                          <a:solidFill>
+                            <a:srgbClr val="002677"/>
+                          </a:solidFill>
+                          <a:uFill>
+                            <a:solidFill>
+                              <a:srgbClr val="9AA8CC"/>
+                            </a:solidFill>
+                          </a:uFill>
+                        </a:rPr>
+                        <a:t>turning field insights into structured intelligence</a:t>
+                      </a:r>
+                      <a:r>
+                        <a:rPr lang="en-US" sz="900" dirty="0">
+                          <a:solidFill>
+                            <a:schemeClr val="tx1"/>
+                          </a:solidFill>
+                        </a:rPr>
+                        <a:t>” for HCP engagement.</a:t>
+                      </a:r>
+                      <a:endParaRPr lang="en-US" sz="900" dirty="0"/>
+                    </a:p>
+                    <a:p>
+                      <a:pPr indent="0" marL="0">
+                        <a:spcBef>
+                          <a:spcPts val="200"/>
+                        </a:spcBef>
+                        <a:buNone/>
+                      </a:pPr>
+                      <a:r>
+                        <a:rPr lang="en-US" sz="900" dirty="0" b="1">
+                          <a:solidFill>
+                            <a:schemeClr val="tx1"/>
+                          </a:solidFill>
+                        </a:rPr>
+                        <a:t>Novo Nordisk</a:t>
+                      </a:r>
+                      <a:r>
+                        <a:rPr lang="en-US" sz="900" dirty="0">
+                          <a:solidFill>
+                            <a:schemeClr val="tx1"/>
+                          </a:solidFill>
+                        </a:rPr>
+                        <a:t>: partnered with </a:t>
+                      </a:r>
+                      <a:r>
+                        <a:rPr lang="en-US" sz="900" dirty="0" u="sng">
+                          <a:solidFill>
+                            <a:srgbClr val="002677"/>
+                          </a:solidFill>
+                          <a:uFill>
+                            <a:solidFill>
+                              <a:srgbClr val="9AA8CC"/>
+                            </a:solidFill>
+                          </a:uFill>
+                        </a:rPr>
+                        <a:t>OpenAI</a:t>
+                      </a:r>
+                      <a:r>
+                        <a:rPr lang="en-US" sz="900" dirty="0">
+                          <a:solidFill>
+                            <a:schemeClr val="tx1"/>
+                          </a:solidFill>
+                        </a:rPr>
+                        <a:t> (April 2026, reaching into “</a:t>
+                      </a:r>
+                      <a:r>
+                        <a:rPr lang="en-US" sz="900" dirty="0" u="sng">
+                          <a:solidFill>
+                            <a:srgbClr val="002677"/>
+                          </a:solidFill>
+                          <a:uFill>
+                            <a:solidFill>
+                              <a:srgbClr val="9AA8CC"/>
+                            </a:solidFill>
+                          </a:uFill>
+                        </a:rPr>
+                        <a:t>commercial execution</a:t>
+                      </a:r>
+                      <a:r>
+                        <a:rPr lang="en-US" sz="900" dirty="0">
+                          <a:solidFill>
+                            <a:schemeClr val="tx1"/>
+                          </a:solidFill>
+                        </a:rPr>
+                        <a:t>”) and with </a:t>
+                      </a:r>
+                      <a:r>
+                        <a:rPr lang="en-US" sz="900" dirty="0" u="sng">
+                          <a:solidFill>
+                            <a:srgbClr val="002677"/>
+                          </a:solidFill>
+                          <a:uFill>
+                            <a:solidFill>
+                              <a:srgbClr val="9AA8CC"/>
+                            </a:solidFill>
+                          </a:uFill>
+                        </a:rPr>
+                        <a:t>Anthropic</a:t>
+                      </a:r>
+                      <a:r>
+                        <a:rPr lang="en-US" sz="900" dirty="0">
+                          <a:solidFill>
+                            <a:schemeClr val="tx1"/>
+                          </a:solidFill>
+                        </a:rPr>
+                        <a:t> (September 2026).</a:t>
+                      </a:r>
+                      <a:endParaRPr lang="en-US" sz="900" dirty="0"/>
+                    </a:p>
+                  </a:txBody>
+                  <a:tcPr marL="109728" marR="109728" marT="64008" marB="64008" anchor="ctr">
+                    <a:lnL w="0" cap="flat" cmpd="sng" algn="ctr">
+                      <a:noFill/>
+                    </a:lnL>
+                    <a:lnR w="0" cap="flat" cmpd="sng" algn="ctr">
+                      <a:noFill/>
+                    </a:lnR>
+                    <a:lnT w="0" cap="flat" cmpd="sng" algn="ctr">
+                      <a:noFill/>
+                    </a:lnT>
+                    <a:lnB w="9525" cap="flat" cmpd="sng" algn="ctr">
+                      <a:solidFill>
+                        <a:srgbClr val="D9D4C7"/>
+                      </a:solidFill>
+                      <a:prstDash val="solid"/>
+                      <a:round/>
+                      <a:headEnd type="none" w="med" len="med"/>
+                      <a:tailEnd type="none" w="med" len="med"/>
+                    </a:lnB>
+                  </a:tcPr>
+                </a:tc>
+                <a:tc>
+                  <a:txBody>
+                    <a:bodyPr/>
+                    <a:lstStyle/>
+                    <a:p>
+                      <a:pPr indent="0" marL="0">
+                        <a:buNone/>
+                      </a:pPr>
+                      <a:r>
+                        <a:rPr lang="en-US" sz="900" dirty="0">
+                          <a:solidFill>
+                            <a:schemeClr val="tx1"/>
+                          </a:solidFill>
+                        </a:rPr>
+                        <a:t>The closest overlap with Optum LS: pharma companies analyze their own data and systems inside the provider’s assistant, including in commercial functions.</a:t>
                       </a:r>
                       <a:endParaRPr lang="en-US" sz="900" dirty="0"/>
                     </a:p>
@@ -6634,7 +6866,7 @@
                   </a:tcPr>
                 </a:tc>
               </a:tr>
-              <a:tr h="692810">
+              <a:tr h="699185">
                 <a:tc>
                   <a:txBody>
                     <a:bodyPr/>
@@ -6644,12 +6876,12 @@
                         <a:buNone/>
                       </a:pPr>
                       <a:r>
-                        <a:rPr lang="en-US" sz="1050" b="1" dirty="0">
-                          <a:solidFill>
-                            <a:schemeClr val="bg1"/>
-                          </a:solidFill>
-                        </a:rPr>
-                        <a:t>Acquire specialized life-sciences capabilities</a:t>
+                        <a:rPr lang="en-US" sz="1000" b="1" dirty="0">
+                          <a:solidFill>
+                            <a:schemeClr val="accent1"/>
+                          </a:solidFill>
+                        </a:rPr>
+                        <a:t>Acquire research capability and customers</a:t>
                       </a:r>
                       <a:endParaRPr lang="en-US" sz="1050" dirty="0"/>
                     </a:p>
@@ -6686,7 +6918,7 @@
                       <a:tailEnd type="none" w="med" len="med"/>
                     </a:lnB>
                     <a:solidFill>
-                      <a:schemeClr val="accent1"/>
+                      <a:schemeClr val="accent5"/>
                     </a:solidFill>
                   </a:tcPr>
                 </a:tc>
@@ -6699,54 +6931,12 @@
                         <a:buNone/>
                       </a:pPr>
                       <a:r>
-                        <a:rPr lang="en-US" sz="900" b="1" dirty="0" u="sng">
+                        <a:rPr lang="en-US" sz="900" dirty="0">
                           <a:solidFill>
                             <a:srgbClr val="002677"/>
                           </a:solidFill>
-                          <a:uFill>
-                            <a:solidFill>
-                              <a:srgbClr val="9AA8CC"/>
-                            </a:solidFill>
-                          </a:uFill>
-                        </a:rPr>
-                        <a:t>Cohere + Reliant AI</a:t>
-                      </a:r>
-                      <a:r>
-                        <a:rPr lang="en-US" sz="900" b="1" dirty="0">
-                          <a:solidFill>
-                            <a:schemeClr val="tx1"/>
-                          </a:solidFill>
-                        </a:rPr>
-                        <a:t>:</a:t>
-                      </a:r>
-                      <a:r>
-                        <a:rPr lang="en-US" sz="900" dirty="0">
-                          <a:solidFill>
-                            <a:schemeClr val="tx1"/>
-                          </a:solidFill>
-                        </a:rPr>
-                        <a:t> In May 2026, Cohere acquired a biopharma AI company offering literature review, competitive landscaping and scientific/regulatory information extraction. The acquisition supports development of </a:t>
-                      </a:r>
-                      <a:r>
-                        <a:rPr lang="en-US" sz="900" dirty="0" u="sng">
-                          <a:solidFill>
-                            <a:srgbClr val="002677"/>
-                          </a:solidFill>
-                          <a:uFill>
-                            <a:solidFill>
-                              <a:srgbClr val="9AA8CC"/>
-                            </a:solidFill>
-                          </a:uFill>
-                        </a:rPr>
-                        <a:t>North for Pharma</a:t>
-                      </a:r>
-                      <a:r>
-                        <a:rPr lang="en-US" sz="900" dirty="0">
-                          <a:solidFill>
-                            <a:schemeClr val="tx1"/>
-                          </a:solidFill>
-                        </a:rPr>
-                        <a:t>, a planned specialized agentic offering.</a:t>
+                        </a:rPr>
+                        <a:t>Domain expertise</a:t>
                       </a:r>
                       <a:endParaRPr lang="en-US" sz="900" dirty="0"/>
                     </a:p>
@@ -6781,12 +6971,158 @@
                         <a:buNone/>
                       </a:pPr>
                       <a:r>
+                        <a:rPr lang="en-US" sz="900" dirty="0" b="1" u="sng">
+                          <a:solidFill>
+                            <a:srgbClr val="002677"/>
+                          </a:solidFill>
+                          <a:uFill>
+                            <a:solidFill>
+                              <a:srgbClr val="9AA8CC"/>
+                            </a:solidFill>
+                          </a:uFill>
+                        </a:rPr>
+                        <a:t>Cohere + Reliant AI</a:t>
+                      </a:r>
+                      <a:r>
                         <a:rPr lang="en-US" sz="900" dirty="0">
                           <a:solidFill>
                             <a:schemeClr val="tx1"/>
                           </a:solidFill>
                         </a:rPr>
-                        <a:t>Acquisitions give LLM providers industry-specific technology, expertise and pharmaceutical customer relationships in one step.</a:t>
+                        <a:t> (May 2026): adds “</a:t>
+                      </a:r>
+                      <a:r>
+                        <a:rPr lang="en-US" sz="900" dirty="0" u="sng">
+                          <a:solidFill>
+                            <a:srgbClr val="002677"/>
+                          </a:solidFill>
+                          <a:uFill>
+                            <a:solidFill>
+                              <a:srgbClr val="9AA8CC"/>
+                            </a:solidFill>
+                          </a:uFill>
+                        </a:rPr>
+                        <a:t>proprietary biomedical datasets</a:t>
+                      </a:r>
+                      <a:r>
+                        <a:rPr lang="en-US" sz="900" dirty="0">
+                          <a:solidFill>
+                            <a:schemeClr val="tx1"/>
+                          </a:solidFill>
+                        </a:rPr>
+                        <a:t>” and customers “</a:t>
+                      </a:r>
+                      <a:r>
+                        <a:rPr lang="en-US" sz="900" dirty="0" u="sng">
+                          <a:solidFill>
+                            <a:srgbClr val="002677"/>
+                          </a:solidFill>
+                          <a:uFill>
+                            <a:solidFill>
+                              <a:srgbClr val="9AA8CC"/>
+                            </a:solidFill>
+                          </a:uFill>
+                        </a:rPr>
+                        <a:t>including GSK, Medicus Pharma, and Kyowa Kirin</a:t>
+                      </a:r>
+                      <a:r>
+                        <a:rPr lang="en-US" sz="900" dirty="0">
+                          <a:solidFill>
+                            <a:schemeClr val="tx1"/>
+                          </a:solidFill>
+                        </a:rPr>
+                        <a:t>”; North for Pharma is announced.</a:t>
+                      </a:r>
+                      <a:endParaRPr lang="en-US" sz="900" dirty="0"/>
+                    </a:p>
+                    <a:p>
+                      <a:pPr indent="0" marL="0">
+                        <a:spcBef>
+                          <a:spcPts val="200"/>
+                        </a:spcBef>
+                        <a:buNone/>
+                      </a:pPr>
+                      <a:r>
+                        <a:rPr lang="en-US" sz="900" dirty="0" b="1" u="sng">
+                          <a:solidFill>
+                            <a:srgbClr val="002677"/>
+                          </a:solidFill>
+                          <a:uFill>
+                            <a:solidFill>
+                              <a:srgbClr val="9AA8CC"/>
+                            </a:solidFill>
+                          </a:uFill>
+                        </a:rPr>
+                        <a:t>Anthropic + Coefficient Bio</a:t>
+                      </a:r>
+                      <a:r>
+                        <a:rPr lang="en-US" sz="900" dirty="0">
+                          <a:solidFill>
+                            <a:schemeClr val="tx1"/>
+                          </a:solidFill>
+                        </a:rPr>
+                        <a:t> (April 2026): a team of </a:t>
+                      </a:r>
+                      <a:r>
+                        <a:rPr lang="en-US" sz="900" dirty="0" u="sng">
+                          <a:solidFill>
+                            <a:srgbClr val="002677"/>
+                          </a:solidFill>
+                          <a:uFill>
+                            <a:solidFill>
+                              <a:srgbClr val="9AA8CC"/>
+                            </a:solidFill>
+                          </a:uFill>
+                        </a:rPr>
+                        <a:t>fewer than 10</a:t>
+                      </a:r>
+                      <a:r>
+                        <a:rPr lang="en-US" sz="900" dirty="0">
+                          <a:solidFill>
+                            <a:schemeClr val="tx1"/>
+                          </a:solidFill>
+                        </a:rPr>
+                        <a:t> building biology-specific models.</a:t>
+                      </a:r>
+                      <a:endParaRPr lang="en-US" sz="900" dirty="0"/>
+                    </a:p>
+                  </a:txBody>
+                  <a:tcPr marL="109728" marR="109728" marT="64008" marB="64008" anchor="ctr">
+                    <a:lnL w="0" cap="flat" cmpd="sng" algn="ctr">
+                      <a:noFill/>
+                    </a:lnL>
+                    <a:lnR w="0" cap="flat" cmpd="sng" algn="ctr">
+                      <a:noFill/>
+                    </a:lnR>
+                    <a:lnT w="0" cap="flat" cmpd="sng" algn="ctr">
+                      <a:noFill/>
+                    </a:lnT>
+                    <a:lnB w="9525" cap="flat" cmpd="sng" algn="ctr">
+                      <a:solidFill>
+                        <a:srgbClr val="D9D4C7"/>
+                      </a:solidFill>
+                      <a:prstDash val="solid"/>
+                      <a:round/>
+                      <a:headEnd type="none" w="med" len="med"/>
+                      <a:tailEnd type="none" w="med" len="med"/>
+                    </a:lnB>
+                  </a:tcPr>
+                </a:tc>
+                <a:tc>
+                  <a:txBody>
+                    <a:bodyPr/>
+                    <a:lstStyle/>
+                    <a:p>
+                      <a:pPr indent="0" marL="0">
+                        <a:buNone/>
+                      </a:pPr>
+                      <a:r>
+                        <a:rPr lang="en-US" sz="900" dirty="0">
+                          <a:solidFill>
+                            <a:schemeClr val="tx1"/>
+                          </a:solidFill>
+                        </a:rPr>
+                        <a:t>Research teams, literature-derived data and pharma accounts, not patient-level RWD.</a:t>
                       </a:r>
                       <a:endParaRPr lang="en-US" sz="900" dirty="0"/>
                     </a:p>
@@ -6926,7 +7262,7 @@
                   <a:schemeClr val="accent2"/>
                 </a:solidFill>
               </a:rPr>
-              <a:t>PARTNER, SUPPLIER OR RIVAL</a:t>
+              <a:t>THE OVERLAP IS THE INTERFACE, NOT THE DATA</a:t>
             </a:r>
             <a:endParaRPr lang="en-US" sz="1300" dirty="0"/>
           </a:p>
@@ -6962,7 +7298,49 @@
                   <a:schemeClr val="accent1"/>
                 </a:solidFill>
               </a:rPr>
-              <a:t>Anthropic already works with two competitors in this deck (Komodo and Veeva) while selling its own Claude for Life Sciences; Cohere bought its way in. For any Optum LS offering, the model provider may also be pursuing the same pharmaceutical customers.</a:t>
+              <a:t>None of these products markets patient-level RWD of its own. But BMS is making Claude its “</a:t>
+            </a:r>
+            <a:r>
+              <a:rPr lang="en-US" sz="1100" b="1" dirty="0" u="sng">
+                <a:solidFill>
+                  <a:srgbClr val="002677"/>
+                </a:solidFill>
+                <a:uFill>
+                  <a:solidFill>
+                    <a:srgbClr val="9AA8CC"/>
+                  </a:solidFill>
+                </a:uFill>
+              </a:rPr>
+              <a:t>shared intelligence platform</a:t>
+            </a:r>
+            <a:r>
+              <a:rPr lang="en-US" sz="1100" b="1" dirty="0">
+                <a:solidFill>
+                  <a:schemeClr val="accent1"/>
+                </a:solidFill>
+              </a:rPr>
+              <a:t>,” and Veeva’s newest agent “</a:t>
+            </a:r>
+            <a:r>
+              <a:rPr lang="en-US" sz="1100" b="1" dirty="0" u="sng">
+                <a:solidFill>
+                  <a:srgbClr val="002677"/>
+                </a:solidFill>
+                <a:uFill>
+                  <a:solidFill>
+                    <a:srgbClr val="9AA8CC"/>
+                  </a:solidFill>
+                </a:uFill>
+              </a:rPr>
+              <a:t>is delivered as a Claude Cowork plugin</a:t>
+            </a:r>
+            <a:r>
+              <a:rPr lang="en-US" sz="1100" b="1" dirty="0">
+                <a:solidFill>
+                  <a:schemeClr val="accent1"/>
+                </a:solidFill>
+              </a:rPr>
+              <a:t>.” The near-term overlap with Optum LS is where pharma teams do the analysis.</a:t>
             </a:r>
             <a:endParaRPr lang="en-US" sz="1100" dirty="0"/>
           </a:p>
@@ -7015,57 +7393,25 @@
       </p:sp>
       <p:sp>
         <p:nvSpPr>
-          <p:cNvPr id="26" name="link legend"/>
-          <p:cNvSpPr txBox="1"/>
-          <p:nvPr/>
-        </p:nvSpPr>
-        <p:spPr>
-          <a:xfrm>
-            <a:off x="2944368" y="6309360"/>
-            <a:ext cx="4572000" cy="201168"/>
-          </a:xfrm>
-          <a:prstGeom prst="rect">
-            <a:avLst/>
-          </a:prstGeom>
-          <a:noFill/>
-        </p:spPr>
-        <p:txBody>
-          <a:bodyPr wrap="square" lIns="0" tIns="0" rIns="0" bIns="0" anchor="ctr">
-            <a:spAutoFit/>
-          </a:bodyPr>
-          <a:lstStyle/>
-          <a:p>
-            <a:r>
-              <a:rPr sz="900">
-                <a:solidFill>
-                  <a:schemeClr val="accent4"/>
-                </a:solidFill>
-              </a:rPr>
-              <a:t>·  Underlined text links to public sources</a:t>
-            </a:r>
-          </a:p>
-        </p:txBody>
-      </p:sp>
-      <p:sp>
-        <p:nvSpPr>
-          <p:cNvPr id="9711" name="Invisible source link 11: https://www.anthropic.com/news/claude-for-life-sciences">
-            <a:hlinkClick r:id="rId4"/>
-          </p:cNvPr>
+          <p:cNvPr id="26" name="starting point band"/>
           <p:cNvSpPr/>
           <p:nvPr/>
         </p:nvSpPr>
         <p:spPr>
           <a:xfrm>
-            <a:off x="2624035" y="2293636"/>
-            <a:ext cx="1551567" cy="127757"/>
-          </a:xfrm>
-          <a:prstGeom prst="rect">
-            <a:avLst/>
-          </a:prstGeom>
-          <a:noFill/>
+            <a:off x="548640" y="1481328"/>
+            <a:ext cx="11091672" cy="274320"/>
+          </a:xfrm>
+          <a:prstGeom prst="rect">
+            <a:avLst/>
+          </a:prstGeom>
+          <a:solidFill>
+            <a:srgbClr val="E6ECF5"/>
+          </a:solidFill>
           <a:ln>
             <a:noFill/>
           </a:ln>
+          <a:effectLst/>
         </p:spPr>
         <p:style>
           <a:lnRef idx="1">
@@ -7091,16 +7437,153 @@
       </p:sp>
       <p:sp>
         <p:nvSpPr>
-          <p:cNvPr id="9712" name="Invisible source link 11: https://www.anthropic.com/news/healthcare-life-sciences">
-            <a:hlinkClick r:id="rId5"/>
+          <p:cNvPr id="27" name="starting point"/>
+          <p:cNvSpPr txBox="1"/>
+          <p:nvPr/>
+        </p:nvSpPr>
+        <p:spPr>
+          <a:xfrm>
+            <a:off x="731520" y="1481328"/>
+            <a:ext cx="10789920" cy="274320"/>
+          </a:xfrm>
+          <a:prstGeom prst="rect">
+            <a:avLst/>
+          </a:prstGeom>
+          <a:noFill/>
+        </p:spPr>
+        <p:txBody>
+          <a:bodyPr wrap="square" anchor="ctr" lIns="0" tIns="0" rIns="0" bIns="0">
+            <a:spAutoFit/>
+          </a:bodyPr>
+          <a:lstStyle/>
+          <a:p>
+            <a:r>
+              <a:rPr sz="1050" b="1">
+                <a:solidFill>
+                  <a:srgbClr val="002677"/>
+                </a:solidFill>
+              </a:rPr>
+              <a:t>STARTING POINT: </a:t>
+            </a:r>
+            <a:r>
+              <a:rPr sz="1050">
+                <a:solidFill>
+                  <a:srgbClr val="002677"/>
+                </a:solidFill>
+              </a:rPr>
+              <a:t>LLM providers already supply the model to </a:t>
+            </a:r>
+            <a:r>
+              <a:rPr sz="1050" u="sng">
+                <a:solidFill>
+                  <a:srgbClr val="002677"/>
+                </a:solidFill>
+                <a:uFill>
+                  <a:solidFill>
+                    <a:srgbClr val="9AA8CC"/>
+                  </a:solidFill>
+                </a:uFill>
+              </a:rPr>
+              <a:t>Veeva</a:t>
+            </a:r>
+            <a:r>
+              <a:rPr sz="1050">
+                <a:solidFill>
+                  <a:srgbClr val="002677"/>
+                </a:solidFill>
+              </a:rPr>
+              <a:t>, </a:t>
+            </a:r>
+            <a:r>
+              <a:rPr sz="1050" u="sng">
+                <a:solidFill>
+                  <a:srgbClr val="002677"/>
+                </a:solidFill>
+                <a:uFill>
+                  <a:solidFill>
+                    <a:srgbClr val="9AA8CC"/>
+                  </a:solidFill>
+                </a:uFill>
+              </a:rPr>
+              <a:t>Komodo</a:t>
+            </a:r>
+            <a:r>
+              <a:rPr sz="1050">
+                <a:solidFill>
+                  <a:srgbClr val="002677"/>
+                </a:solidFill>
+              </a:rPr>
+              <a:t> and </a:t>
+            </a:r>
+            <a:r>
+              <a:rPr sz="1050" u="sng">
+                <a:solidFill>
+                  <a:srgbClr val="002677"/>
+                </a:solidFill>
+                <a:uFill>
+                  <a:solidFill>
+                    <a:srgbClr val="9AA8CC"/>
+                  </a:solidFill>
+                </a:uFill>
+              </a:rPr>
+              <a:t>Datavant</a:t>
+            </a:r>
+            <a:r>
+              <a:rPr sz="1050">
+                <a:solidFill>
+                  <a:srgbClr val="002677"/>
+                </a:solidFill>
+              </a:rPr>
+              <a:t> (previous slide).</a:t>
+            </a:r>
+          </a:p>
+        </p:txBody>
+      </p:sp>
+      <p:sp>
+        <p:nvSpPr>
+          <p:cNvPr id="28" name="link legend"/>
+          <p:cNvSpPr txBox="1"/>
+          <p:nvPr/>
+        </p:nvSpPr>
+        <p:spPr>
+          <a:xfrm>
+            <a:off x="2944368" y="6309360"/>
+            <a:ext cx="4572000" cy="201168"/>
+          </a:xfrm>
+          <a:prstGeom prst="rect">
+            <a:avLst/>
+          </a:prstGeom>
+          <a:noFill/>
+        </p:spPr>
+        <p:txBody>
+          <a:bodyPr wrap="square" lIns="0" tIns="0" rIns="0" bIns="0" anchor="ctr">
+            <a:spAutoFit/>
+          </a:bodyPr>
+          <a:lstStyle/>
+          <a:p>
+            <a:r>
+              <a:rPr sz="900">
+                <a:solidFill>
+                  <a:schemeClr val="accent4"/>
+                </a:solidFill>
+              </a:rPr>
+              <a:t>·  Underlined text links to public sources</a:t>
+            </a:r>
+          </a:p>
+        </p:txBody>
+      </p:sp>
+      <p:sp>
+        <p:nvSpPr>
+          <p:cNvPr id="9713" name="Invisible source link 11: https://www.veeva.com/products/veeva-ai/">
+            <a:hlinkClick r:id="rId9"/>
           </p:cNvPr>
           <p:cNvSpPr/>
           <p:nvPr/>
         </p:nvSpPr>
         <p:spPr>
           <a:xfrm>
-            <a:off x="2624035" y="2472554"/>
-            <a:ext cx="1031731" cy="127757"/>
+            <a:off x="4440605" y="1550941"/>
+            <a:ext cx="404090" cy="148648"/>
           </a:xfrm>
           <a:prstGeom prst="rect">
             <a:avLst/>
@@ -7134,16 +7617,16 @@
       </p:sp>
       <p:sp>
         <p:nvSpPr>
-          <p:cNvPr id="9713" name="Invisible source link 11: https://www.datavant.com/blog/how-ai-is-powering-smarter-privacy-preserving-data-discovery-for-life-sciences">
-            <a:hlinkClick r:id="rId6"/>
+          <p:cNvPr id="9714" name="Invisible source link 11: https://www.anthropic.com/news/claude-for-life-sciences">
+            <a:hlinkClick r:id="rId4"/>
           </p:cNvPr>
           <p:cNvSpPr/>
           <p:nvPr/>
         </p:nvSpPr>
         <p:spPr>
           <a:xfrm>
-            <a:off x="2624035" y="2651472"/>
-            <a:ext cx="911487" cy="127757"/>
+            <a:off x="4880876" y="1550941"/>
+            <a:ext cx="492431" cy="148648"/>
           </a:xfrm>
           <a:prstGeom prst="rect">
             <a:avLst/>
@@ -7177,7 +7660,7 @@
       </p:sp>
       <p:sp>
         <p:nvSpPr>
-          <p:cNvPr id="9714" name="Invisible source link 11: https://www.datavant.com/blog/how-ai-is-powering-smarter-privacy-preserving-data-discovery-for-life-sciences">
+          <p:cNvPr id="9715" name="Invisible source link 11: https://www.datavant.com/blog/how-ai-is-powering-smarter-privacy-preserving-data-discovery-for-life-sciences">
             <a:hlinkClick r:id="rId6"/>
           </p:cNvPr>
           <p:cNvSpPr/>
@@ -7185,8 +7668,8 @@
         </p:nvSpPr>
         <p:spPr>
           <a:xfrm>
-            <a:off x="3564724" y="2651472"/>
-            <a:ext cx="907946" cy="127757"/>
+            <a:off x="5668924" y="1550941"/>
+            <a:ext cx="529860" cy="148648"/>
           </a:xfrm>
           <a:prstGeom prst="rect">
             <a:avLst/>
@@ -7220,16 +7703,16 @@
       </p:sp>
       <p:sp>
         <p:nvSpPr>
-          <p:cNvPr id="9715" name="Invisible source link 11: https://www.anthropic.com/news/claude-for-life-sciences">
-            <a:hlinkClick r:id="rId4"/>
+          <p:cNvPr id="9716" name="Invisible source link 11: https://www.anthropic.com/news/claude-science-ai-workbench">
+            <a:hlinkClick r:id="rId10"/>
           </p:cNvPr>
           <p:cNvSpPr/>
           <p:nvPr/>
         </p:nvSpPr>
         <p:spPr>
           <a:xfrm>
-            <a:off x="2624035" y="3344117"/>
-            <a:ext cx="2027118" cy="127757"/>
+            <a:off x="4108323" y="2558241"/>
+            <a:ext cx="843815" cy="127757"/>
           </a:xfrm>
           <a:prstGeom prst="rect">
             <a:avLst/>
@@ -7263,16 +7746,16 @@
       </p:sp>
       <p:sp>
         <p:nvSpPr>
-          <p:cNvPr id="9716" name="Invisible source link 11: https://openai.com/index/introducing-gpt-rosalind/">
-            <a:hlinkClick r:id="rId7"/>
+          <p:cNvPr id="9717" name="Invisible source link 11: https://www.anthropic.com/news/claude-science-ai-workbench">
+            <a:hlinkClick r:id="rId10"/>
           </p:cNvPr>
           <p:cNvSpPr/>
           <p:nvPr/>
         </p:nvSpPr>
         <p:spPr>
           <a:xfrm>
-            <a:off x="2624035" y="3651203"/>
-            <a:ext cx="1315410" cy="127757"/>
+            <a:off x="5943093" y="2558241"/>
+            <a:ext cx="1993865" cy="127757"/>
           </a:xfrm>
           <a:prstGeom prst="rect">
             <a:avLst/>
@@ -7306,16 +7789,16 @@
       </p:sp>
       <p:sp>
         <p:nvSpPr>
-          <p:cNvPr id="9717" name="Invisible source link 11: https://cohere.com/blog/cohere-acquires-reliant-ai-expand-sovereign-enterprise-ai">
-            <a:hlinkClick r:id="rId8"/>
+          <p:cNvPr id="9718" name="Invisible source link 11: https://openai.com/index/introducing-gpt-rosalind">
+            <a:hlinkClick r:id="rId11"/>
           </p:cNvPr>
           <p:cNvSpPr/>
           <p:nvPr/>
         </p:nvSpPr>
         <p:spPr>
           <a:xfrm>
-            <a:off x="2624035" y="4215680"/>
-            <a:ext cx="1083559" cy="127757"/>
+            <a:off x="3975836" y="2840117"/>
+            <a:ext cx="780159" cy="127757"/>
           </a:xfrm>
           <a:prstGeom prst="rect">
             <a:avLst/>
@@ -7349,16 +7832,618 @@
       </p:sp>
       <p:sp>
         <p:nvSpPr>
-          <p:cNvPr id="9718" name="Invisible source link 11: https://cohere.com/blog/cohere-acquires-reliant-ai-expand-sovereign-enterprise-ai">
-            <a:hlinkClick r:id="rId8"/>
+          <p:cNvPr id="9719" name="Invisible source link 11: https://azure.microsoft.com/en-us/blog/announcing-microsoft-discovery-general-availability-and-microsoft-discovery-app-preview/">
+            <a:hlinkClick r:id="rId12"/>
           </p:cNvPr>
           <p:cNvSpPr/>
           <p:nvPr/>
         </p:nvSpPr>
         <p:spPr>
           <a:xfrm>
-            <a:off x="3907078" y="4471991"/>
-            <a:ext cx="907946" cy="127757"/>
+            <a:off x="3446995" y="2993838"/>
+            <a:ext cx="1122868" cy="127757"/>
+          </a:xfrm>
+          <a:prstGeom prst="rect">
+            <a:avLst/>
+          </a:prstGeom>
+          <a:noFill/>
+          <a:ln>
+            <a:noFill/>
+          </a:ln>
+        </p:spPr>
+        <p:style>
+          <a:lnRef idx="1">
+            <a:schemeClr val="accent1"/>
+          </a:lnRef>
+          <a:fillRef idx="3">
+            <a:schemeClr val="accent1"/>
+          </a:fillRef>
+          <a:effectRef idx="2">
+            <a:schemeClr val="accent1"/>
+          </a:effectRef>
+          <a:fontRef idx="minor">
+            <a:schemeClr val="lt1"/>
+          </a:fontRef>
+        </p:style>
+        <p:txBody>
+          <a:bodyPr rtlCol="0" anchor="ctr"/>
+          <a:lstStyle/>
+          <a:p>
+            <a:pPr algn="ctr"/>
+          </a:p>
+        </p:txBody>
+      </p:sp>
+      <p:sp>
+        <p:nvSpPr>
+          <p:cNvPr id="9720" name="Invisible source link 11: https://deepmind.google/blog/co-scientist-a-multi-agent-ai-partner-to-accelerate-research/">
+            <a:hlinkClick r:id="rId13"/>
+          </p:cNvPr>
+          <p:cNvSpPr/>
+          <p:nvPr/>
+        </p:nvSpPr>
+        <p:spPr>
+          <a:xfrm>
+            <a:off x="3962158" y="3147559"/>
+            <a:ext cx="697711" cy="127757"/>
+          </a:xfrm>
+          <a:prstGeom prst="rect">
+            <a:avLst/>
+          </a:prstGeom>
+          <a:noFill/>
+          <a:ln>
+            <a:noFill/>
+          </a:ln>
+        </p:spPr>
+        <p:style>
+          <a:lnRef idx="1">
+            <a:schemeClr val="accent1"/>
+          </a:lnRef>
+          <a:fillRef idx="3">
+            <a:schemeClr val="accent1"/>
+          </a:fillRef>
+          <a:effectRef idx="2">
+            <a:schemeClr val="accent1"/>
+          </a:effectRef>
+          <a:fontRef idx="minor">
+            <a:schemeClr val="lt1"/>
+          </a:fontRef>
+        </p:style>
+        <p:txBody>
+          <a:bodyPr rtlCol="0" anchor="ctr"/>
+          <a:lstStyle/>
+          <a:p>
+            <a:pPr algn="ctr"/>
+          </a:p>
+        </p:txBody>
+      </p:sp>
+      <p:sp>
+        <p:nvSpPr>
+          <p:cNvPr id="9721" name="Invisible source link 11: https://news.bms.com/news/details/2026/Bristol-Myers-Squibb-Announces-Strategic-Agreement-with-Anthropic-to-Position-Claude-Enterprise-as-the-Shared-Intelligence-Platform-Across-Its-Global-Operations/default.aspx">
+            <a:hlinkClick r:id="rId14"/>
+          </p:cNvPr>
+          <p:cNvSpPr/>
+          <p:nvPr/>
+        </p:nvSpPr>
+        <p:spPr>
+          <a:xfrm>
+            <a:off x="3446995" y="3436636"/>
+            <a:ext cx="284795" cy="127757"/>
+          </a:xfrm>
+          <a:prstGeom prst="rect">
+            <a:avLst/>
+          </a:prstGeom>
+          <a:noFill/>
+          <a:ln>
+            <a:noFill/>
+          </a:ln>
+        </p:spPr>
+        <p:style>
+          <a:lnRef idx="1">
+            <a:schemeClr val="accent1"/>
+          </a:lnRef>
+          <a:fillRef idx="3">
+            <a:schemeClr val="accent1"/>
+          </a:fillRef>
+          <a:effectRef idx="2">
+            <a:schemeClr val="accent1"/>
+          </a:effectRef>
+          <a:fontRef idx="minor">
+            <a:schemeClr val="lt1"/>
+          </a:fontRef>
+        </p:style>
+        <p:txBody>
+          <a:bodyPr rtlCol="0" anchor="ctr"/>
+          <a:lstStyle/>
+          <a:p>
+            <a:pPr algn="ctr"/>
+          </a:p>
+        </p:txBody>
+      </p:sp>
+      <p:sp>
+        <p:nvSpPr>
+          <p:cNvPr id="9722" name="Invisible source link 11: https://news.bms.com/news/details/2026/Bristol-Myers-Squibb-Announces-Strategic-Agreement-with-Anthropic-to-Position-Claude-Enterprise-as-the-Shared-Intelligence-Platform-Across-Its-Global-Operations/default.aspx">
+            <a:hlinkClick r:id="rId14"/>
+          </p:cNvPr>
+          <p:cNvSpPr/>
+          <p:nvPr/>
+        </p:nvSpPr>
+        <p:spPr>
+          <a:xfrm>
+            <a:off x="4245682" y="3436636"/>
+            <a:ext cx="2800920" cy="127757"/>
+          </a:xfrm>
+          <a:prstGeom prst="rect">
+            <a:avLst/>
+          </a:prstGeom>
+          <a:noFill/>
+          <a:ln>
+            <a:noFill/>
+          </a:ln>
+        </p:spPr>
+        <p:style>
+          <a:lnRef idx="1">
+            <a:schemeClr val="accent1"/>
+          </a:lnRef>
+          <a:fillRef idx="3">
+            <a:schemeClr val="accent1"/>
+          </a:fillRef>
+          <a:effectRef idx="2">
+            <a:schemeClr val="accent1"/>
+          </a:effectRef>
+          <a:fontRef idx="minor">
+            <a:schemeClr val="lt1"/>
+          </a:fontRef>
+        </p:style>
+        <p:txBody>
+          <a:bodyPr rtlCol="0" anchor="ctr"/>
+          <a:lstStyle/>
+          <a:p>
+            <a:pPr algn="ctr"/>
+          </a:p>
+        </p:txBody>
+      </p:sp>
+      <p:sp>
+        <p:nvSpPr>
+          <p:cNvPr id="9723" name="Invisible source link 11: https://news.bms.com/news/details/2026/Bristol-Myers-Squibb-Announces-Strategic-Agreement-with-Anthropic-to-Position-Claude-Enterprise-as-the-Shared-Intelligence-Platform-Across-Its-Global-Operations/default.aspx">
+            <a:hlinkClick r:id="rId14"/>
+          </p:cNvPr>
+          <p:cNvSpPr/>
+          <p:nvPr/>
+        </p:nvSpPr>
+        <p:spPr>
+          <a:xfrm>
+            <a:off x="4545868" y="3564792"/>
+            <a:ext cx="2446010" cy="127757"/>
+          </a:xfrm>
+          <a:prstGeom prst="rect">
+            <a:avLst/>
+          </a:prstGeom>
+          <a:noFill/>
+          <a:ln>
+            <a:noFill/>
+          </a:ln>
+        </p:spPr>
+        <p:style>
+          <a:lnRef idx="1">
+            <a:schemeClr val="accent1"/>
+          </a:lnRef>
+          <a:fillRef idx="3">
+            <a:schemeClr val="accent1"/>
+          </a:fillRef>
+          <a:effectRef idx="2">
+            <a:schemeClr val="accent1"/>
+          </a:effectRef>
+          <a:fontRef idx="minor">
+            <a:schemeClr val="lt1"/>
+          </a:fontRef>
+        </p:style>
+        <p:txBody>
+          <a:bodyPr rtlCol="0" anchor="ctr"/>
+          <a:lstStyle/>
+          <a:p>
+            <a:pPr algn="ctr"/>
+          </a:p>
+        </p:txBody>
+      </p:sp>
+      <p:sp>
+        <p:nvSpPr>
+          <p:cNvPr id="9724" name="Invisible source link 11: https://www.biopharminternational.com/view/novo-nordisk-partners-with-openai-for-drug-discovery">
+            <a:hlinkClick r:id="rId15"/>
+          </p:cNvPr>
+          <p:cNvSpPr/>
+          <p:nvPr/>
+        </p:nvSpPr>
+        <p:spPr>
+          <a:xfrm>
+            <a:off x="5007597" y="3718513"/>
+            <a:ext cx="387049" cy="127757"/>
+          </a:xfrm>
+          <a:prstGeom prst="rect">
+            <a:avLst/>
+          </a:prstGeom>
+          <a:noFill/>
+          <a:ln>
+            <a:noFill/>
+          </a:ln>
+        </p:spPr>
+        <p:style>
+          <a:lnRef idx="1">
+            <a:schemeClr val="accent1"/>
+          </a:lnRef>
+          <a:fillRef idx="3">
+            <a:schemeClr val="accent1"/>
+          </a:fillRef>
+          <a:effectRef idx="2">
+            <a:schemeClr val="accent1"/>
+          </a:effectRef>
+          <a:fontRef idx="minor">
+            <a:schemeClr val="lt1"/>
+          </a:fontRef>
+        </p:style>
+        <p:txBody>
+          <a:bodyPr rtlCol="0" anchor="ctr"/>
+          <a:lstStyle/>
+          <a:p>
+            <a:pPr algn="ctr"/>
+          </a:p>
+        </p:txBody>
+      </p:sp>
+      <p:sp>
+        <p:nvSpPr>
+          <p:cNvPr id="9725" name="Invisible source link 11: https://www.biopharminternational.com/view/novo-nordisk-partners-with-openai-for-drug-discovery">
+            <a:hlinkClick r:id="rId15"/>
+          </p:cNvPr>
+          <p:cNvSpPr/>
+          <p:nvPr/>
+        </p:nvSpPr>
+        <p:spPr>
+          <a:xfrm>
+            <a:off x="6728156" y="3718513"/>
+            <a:ext cx="1217753" cy="127757"/>
+          </a:xfrm>
+          <a:prstGeom prst="rect">
+            <a:avLst/>
+          </a:prstGeom>
+          <a:noFill/>
+          <a:ln>
+            <a:noFill/>
+          </a:ln>
+        </p:spPr>
+        <p:style>
+          <a:lnRef idx="1">
+            <a:schemeClr val="accent1"/>
+          </a:lnRef>
+          <a:fillRef idx="3">
+            <a:schemeClr val="accent1"/>
+          </a:fillRef>
+          <a:effectRef idx="2">
+            <a:schemeClr val="accent1"/>
+          </a:effectRef>
+          <a:fontRef idx="minor">
+            <a:schemeClr val="lt1"/>
+          </a:fontRef>
+        </p:style>
+        <p:txBody>
+          <a:bodyPr rtlCol="0" anchor="ctr"/>
+          <a:lstStyle/>
+          <a:p>
+            <a:pPr algn="ctr"/>
+          </a:p>
+        </p:txBody>
+      </p:sp>
+      <p:sp>
+        <p:nvSpPr>
+          <p:cNvPr id="9726" name="Invisible source link 11: https://www.novonordisk.com/news-and-media/news-and-ir-materials/news-details.html?id=916768">
+            <a:hlinkClick r:id="rId16"/>
+          </p:cNvPr>
+          <p:cNvSpPr/>
+          <p:nvPr/>
+        </p:nvSpPr>
+        <p:spPr>
+          <a:xfrm>
+            <a:off x="3681717" y="3846681"/>
+            <a:ext cx="482523" cy="127757"/>
+          </a:xfrm>
+          <a:prstGeom prst="rect">
+            <a:avLst/>
+          </a:prstGeom>
+          <a:noFill/>
+          <a:ln>
+            <a:noFill/>
+          </a:ln>
+        </p:spPr>
+        <p:style>
+          <a:lnRef idx="1">
+            <a:schemeClr val="accent1"/>
+          </a:lnRef>
+          <a:fillRef idx="3">
+            <a:schemeClr val="accent1"/>
+          </a:fillRef>
+          <a:effectRef idx="2">
+            <a:schemeClr val="accent1"/>
+          </a:effectRef>
+          <a:fontRef idx="minor">
+            <a:schemeClr val="lt1"/>
+          </a:fontRef>
+        </p:style>
+        <p:txBody>
+          <a:bodyPr rtlCol="0" anchor="ctr"/>
+          <a:lstStyle/>
+          <a:p>
+            <a:pPr algn="ctr"/>
+          </a:p>
+        </p:txBody>
+      </p:sp>
+      <p:sp>
+        <p:nvSpPr>
+          <p:cNvPr id="9727" name="Invisible source link 11: https://www.hpcwire.com/aiwire/2026/05/19/cohere-acquires-reliant-ai-to-expand-sovereign-enterprise-ai-for-global-biopharma-and-healthcare-sectors/">
+            <a:hlinkClick r:id="rId17"/>
+          </p:cNvPr>
+          <p:cNvSpPr/>
+          <p:nvPr/>
+        </p:nvSpPr>
+        <p:spPr>
+          <a:xfrm>
+            <a:off x="3446995" y="4135759"/>
+            <a:ext cx="1047128" cy="127757"/>
+          </a:xfrm>
+          <a:prstGeom prst="rect">
+            <a:avLst/>
+          </a:prstGeom>
+          <a:noFill/>
+          <a:ln>
+            <a:noFill/>
+          </a:ln>
+        </p:spPr>
+        <p:style>
+          <a:lnRef idx="1">
+            <a:schemeClr val="accent1"/>
+          </a:lnRef>
+          <a:fillRef idx="3">
+            <a:schemeClr val="accent1"/>
+          </a:fillRef>
+          <a:effectRef idx="2">
+            <a:schemeClr val="accent1"/>
+          </a:effectRef>
+          <a:fontRef idx="minor">
+            <a:schemeClr val="lt1"/>
+          </a:fontRef>
+        </p:style>
+        <p:txBody>
+          <a:bodyPr rtlCol="0" anchor="ctr"/>
+          <a:lstStyle/>
+          <a:p>
+            <a:pPr algn="ctr"/>
+          </a:p>
+        </p:txBody>
+      </p:sp>
+      <p:sp>
+        <p:nvSpPr>
+          <p:cNvPr id="9728" name="Invisible source link 11: https://www.hpcwire.com/aiwire/2026/05/19/cohere-acquires-reliant-ai-to-expand-sovereign-enterprise-ai-for-global-biopharma-and-healthcare-sectors/">
+            <a:hlinkClick r:id="rId17"/>
+          </p:cNvPr>
+          <p:cNvSpPr/>
+          <p:nvPr/>
+        </p:nvSpPr>
+        <p:spPr>
+          <a:xfrm>
+            <a:off x="5445233" y="4135759"/>
+            <a:ext cx="1664006" cy="127757"/>
+          </a:xfrm>
+          <a:prstGeom prst="rect">
+            <a:avLst/>
+          </a:prstGeom>
+          <a:noFill/>
+          <a:ln>
+            <a:noFill/>
+          </a:ln>
+        </p:spPr>
+        <p:style>
+          <a:lnRef idx="1">
+            <a:schemeClr val="accent1"/>
+          </a:lnRef>
+          <a:fillRef idx="3">
+            <a:schemeClr val="accent1"/>
+          </a:fillRef>
+          <a:effectRef idx="2">
+            <a:schemeClr val="accent1"/>
+          </a:effectRef>
+          <a:fontRef idx="minor">
+            <a:schemeClr val="lt1"/>
+          </a:fontRef>
+        </p:style>
+        <p:txBody>
+          <a:bodyPr rtlCol="0" anchor="ctr"/>
+          <a:lstStyle/>
+          <a:p>
+            <a:pPr algn="ctr"/>
+          </a:p>
+        </p:txBody>
+      </p:sp>
+      <p:sp>
+        <p:nvSpPr>
+          <p:cNvPr id="9729" name="Invisible source link 11: https://www.hpcwire.com/aiwire/2026/05/19/cohere-acquires-reliant-ai-to-expand-sovereign-enterprise-ai-for-global-biopharma-and-healthcare-sectors/">
+            <a:hlinkClick r:id="rId17"/>
+          </p:cNvPr>
+          <p:cNvSpPr/>
+          <p:nvPr/>
+        </p:nvSpPr>
+        <p:spPr>
+          <a:xfrm>
+            <a:off x="3446995" y="4263914"/>
+            <a:ext cx="2639585" cy="127757"/>
+          </a:xfrm>
+          <a:prstGeom prst="rect">
+            <a:avLst/>
+          </a:prstGeom>
+          <a:noFill/>
+          <a:ln>
+            <a:noFill/>
+          </a:ln>
+        </p:spPr>
+        <p:style>
+          <a:lnRef idx="1">
+            <a:schemeClr val="accent1"/>
+          </a:lnRef>
+          <a:fillRef idx="3">
+            <a:schemeClr val="accent1"/>
+          </a:fillRef>
+          <a:effectRef idx="2">
+            <a:schemeClr val="accent1"/>
+          </a:effectRef>
+          <a:fontRef idx="minor">
+            <a:schemeClr val="lt1"/>
+          </a:fontRef>
+        </p:style>
+        <p:txBody>
+          <a:bodyPr rtlCol="0" anchor="ctr"/>
+          <a:lstStyle/>
+          <a:p>
+            <a:pPr algn="ctr"/>
+          </a:p>
+        </p:txBody>
+      </p:sp>
+      <p:sp>
+        <p:nvSpPr>
+          <p:cNvPr id="9730" name="Invisible source link 11: https://www.fiercebiotech.com/biotech/anthropic-acquires-stealth-ai-startup-coefficient-bio-400m-deal">
+            <a:hlinkClick r:id="rId18"/>
+          </p:cNvPr>
+          <p:cNvSpPr/>
+          <p:nvPr/>
+        </p:nvSpPr>
+        <p:spPr>
+          <a:xfrm>
+            <a:off x="3446995" y="4417635"/>
+            <a:ext cx="1475160" cy="127757"/>
+          </a:xfrm>
+          <a:prstGeom prst="rect">
+            <a:avLst/>
+          </a:prstGeom>
+          <a:noFill/>
+          <a:ln>
+            <a:noFill/>
+          </a:ln>
+        </p:spPr>
+        <p:style>
+          <a:lnRef idx="1">
+            <a:schemeClr val="accent1"/>
+          </a:lnRef>
+          <a:fillRef idx="3">
+            <a:schemeClr val="accent1"/>
+          </a:fillRef>
+          <a:effectRef idx="2">
+            <a:schemeClr val="accent1"/>
+          </a:effectRef>
+          <a:fontRef idx="minor">
+            <a:schemeClr val="lt1"/>
+          </a:fontRef>
+        </p:style>
+        <p:txBody>
+          <a:bodyPr rtlCol="0" anchor="ctr"/>
+          <a:lstStyle/>
+          <a:p>
+            <a:pPr algn="ctr"/>
+          </a:p>
+        </p:txBody>
+      </p:sp>
+      <p:sp>
+        <p:nvSpPr>
+          <p:cNvPr id="9731" name="Invisible source link 11: https://www.rdworldonline.com/anthropics-400m-acquisition-of-coefficient-bio-signals-a-deeper-push-into-drug-discovery/">
+            <a:hlinkClick r:id="rId19"/>
+          </p:cNvPr>
+          <p:cNvSpPr/>
+          <p:nvPr/>
+        </p:nvSpPr>
+        <p:spPr>
+          <a:xfrm>
+            <a:off x="6115685" y="4417635"/>
+            <a:ext cx="691560" cy="127757"/>
+          </a:xfrm>
+          <a:prstGeom prst="rect">
+            <a:avLst/>
+          </a:prstGeom>
+          <a:noFill/>
+          <a:ln>
+            <a:noFill/>
+          </a:ln>
+        </p:spPr>
+        <p:style>
+          <a:lnRef idx="1">
+            <a:schemeClr val="accent1"/>
+          </a:lnRef>
+          <a:fillRef idx="3">
+            <a:schemeClr val="accent1"/>
+          </a:fillRef>
+          <a:effectRef idx="2">
+            <a:schemeClr val="accent1"/>
+          </a:effectRef>
+          <a:fontRef idx="minor">
+            <a:schemeClr val="lt1"/>
+          </a:fontRef>
+        </p:style>
+        <p:txBody>
+          <a:bodyPr rtlCol="0" anchor="ctr"/>
+          <a:lstStyle/>
+          <a:p>
+            <a:pPr algn="ctr"/>
+          </a:p>
+        </p:txBody>
+      </p:sp>
+      <p:sp>
+        <p:nvSpPr>
+          <p:cNvPr id="9732" name="Invisible source link 11: https://news.bms.com/news/details/2026/Bristol-Myers-Squibb-Announces-Strategic-Agreement-with-Anthropic-to-Position-Claude-Enterprise-as-the-Shared-Intelligence-Platform-Across-Its-Global-Operations/default.aspx">
+            <a:hlinkClick r:id="rId14"/>
+          </p:cNvPr>
+          <p:cNvSpPr/>
+          <p:nvPr/>
+        </p:nvSpPr>
+        <p:spPr>
+          <a:xfrm>
+            <a:off x="7429613" y="5499669"/>
+            <a:ext cx="2055641" cy="155876"/>
+          </a:xfrm>
+          <a:prstGeom prst="rect">
+            <a:avLst/>
+          </a:prstGeom>
+          <a:noFill/>
+          <a:ln>
+            <a:noFill/>
+          </a:ln>
+        </p:spPr>
+        <p:style>
+          <a:lnRef idx="1">
+            <a:schemeClr val="accent1"/>
+          </a:lnRef>
+          <a:fillRef idx="3">
+            <a:schemeClr val="accent1"/>
+          </a:fillRef>
+          <a:effectRef idx="2">
+            <a:schemeClr val="accent1"/>
+          </a:effectRef>
+          <a:fontRef idx="minor">
+            <a:schemeClr val="lt1"/>
+          </a:fontRef>
+        </p:style>
+        <p:txBody>
+          <a:bodyPr rtlCol="0" anchor="ctr"/>
+          <a:lstStyle/>
+          <a:p>
+            <a:pPr algn="ctr"/>
+          </a:p>
+        </p:txBody>
+      </p:sp>
+      <p:sp>
+        <p:nvSpPr>
+          <p:cNvPr id="9733" name="Invisible source link 11: https://www.veeva.com/resources/new-veeva-study-builder-agent-to-configure-clinical-studies-in-as-little-as-one-day/">
+            <a:hlinkClick r:id="rId20"/>
+          </p:cNvPr>
+          <p:cNvSpPr/>
+          <p:nvPr/>
+        </p:nvSpPr>
+        <p:spPr>
+          <a:xfrm>
+            <a:off x="1280160" y="5667436"/>
+            <a:ext cx="2779527" cy="155876"/>
           </a:xfrm>
           <a:prstGeom prst="rect">
             <a:avLst/>

</xml_diff>

<commit_message>
10.16: restyle 'how the products are built' slide to match domain slides
Co-Authored-By: Claude Opus 5.5 <noreply@anthropic.com>
Claude-Session: https://claude.ai/code/session_0198bm9pfzRwgZQBqNvd56W8
</commit_message>
<xml_diff>
--- a/deck/Optum-LS-Conversational-AI-10.16.pptx
+++ b/deck/Optum-LS-Conversational-AI-10.16.pptx
@@ -3344,7 +3344,22 @@
                   <a:schemeClr val="accent1"/>
                 </a:solidFill>
               </a:rPr>
-              <a:t>Behind the products, competitors lead with their data and controls; the model, and even the interface, can come from outside</a:t>
+              <a:t>Behind the products, competitors lead with their data and controls;</a:t>
+            </a:r>
+            <a:br>
+              <a:rPr lang="en-US" sz="2200" b="1" dirty="0">
+                <a:solidFill>
+                  <a:schemeClr val="accent1"/>
+                </a:solidFill>
+              </a:rPr>
+            </a:br>
+            <a:r>
+              <a:rPr lang="en-US" sz="2200" b="1" dirty="0">
+                <a:solidFill>
+                  <a:schemeClr val="accent1"/>
+                </a:solidFill>
+              </a:rPr>
+              <a:t>the model, and even the interface, can come from outside</a:t>
             </a:r>
             <a:endParaRPr lang="en-US" sz="2200" dirty="0"/>
           </a:p>
@@ -3352,43 +3367,52 @@
       </p:sp>
       <p:sp>
         <p:nvSpPr>
-          <p:cNvPr id="4" name="label"/>
-          <p:cNvSpPr txBox="1"/>
-          <p:nvPr/>
-        </p:nvSpPr>
-        <p:spPr>
-          <a:xfrm>
-            <a:off x="548640" y="1481328"/>
-            <a:ext cx="7315200" cy="201168"/>
-          </a:xfrm>
-          <a:prstGeom prst="rect">
-            <a:avLst/>
-          </a:prstGeom>
-          <a:noFill/>
-          <a:ln/>
-        </p:spPr>
-        <p:txBody>
-          <a:bodyPr wrap="square" lIns="0" tIns="0" rIns="0" bIns="0" rtlCol="0" anchor="t"/>
-          <a:lstStyle/>
-          <a:p>
-            <a:pPr indent="0" marL="0">
-              <a:buNone/>
-            </a:pPr>
-            <a:r>
-              <a:rPr lang="en-US" sz="1000" b="1" spc="100" kern="0" dirty="0">
-                <a:solidFill>
-                  <a:schemeClr val="accent2"/>
-                </a:solidFill>
-              </a:rPr>
-              <a:t>FOUR LAYERS OF A CONVERSATIONAL AI PRODUCT</a:t>
-            </a:r>
-            <a:endParaRPr lang="en-US" sz="1000" dirty="0"/>
+          <p:cNvPr id="25" name="Slide Number Placeholder 0"/>
+          <p:cNvSpPr>
+            <a:spLocks noGrp="1"/>
+          </p:cNvSpPr>
+          <p:nvPr>
+            <p:ph type="sldNum" sz="quarter" idx="4294967295"/>
+          </p:nvPr>
+        </p:nvSpPr>
+        <p:spPr>
+          <a:xfrm>
+            <a:off x="10725912" y="6309360"/>
+            <a:ext cx="914400" cy="201168"/>
+          </a:xfrm>
+          <a:prstGeom prst="rect">
+            <a:avLst/>
+          </a:prstGeom>
+          <a:extLst>
+            <a:ext uri="{C572A759-6A51-4108-AA02-DFA0A04FC94B}">
+              <ma14:wrappingTextBoxFlag xmlns:ma14="http://schemas.microsoft.com/office/mac/drawingml/2011/main" val="0"/>
+            </a:ext>
+          </a:extLst>
+        </p:spPr>
+        <p:txBody>
+          <a:bodyPr lIns="0" tIns="0" rIns="0" bIns="0"/>
+          <a:lstStyle>
+            <a:lvl1pPr>
+              <a:defRPr sz="900">
+                <a:solidFill>
+                  <a:schemeClr val="accent4"/>
+                </a:solidFill>
+              </a:defRPr>
+            </a:lvl1pPr>
+          </a:lstStyle>
+          <a:p>
+            <a:pPr algn="r"/>
+            <a:fld id="{F7021451-1387-4CA6-816F-3879F97B5CBC}" type="slidenum">
+              <a:rPr b="0" lang="en-US"/>
+              <a:t>10</a:t>
+            </a:fld>
+            <a:endParaRPr lang="en-US"/>
           </a:p>
         </p:txBody>
       </p:sp>
       <p:graphicFrame>
         <p:nvGraphicFramePr>
-          <p:cNvPr id="11" name="task table"/>
+          <p:cNvPr id="26" name="task table"/>
           <p:cNvGraphicFramePr>
             <a:graphicFrameLocks noGrp="1"/>
           </p:cNvGraphicFramePr>
@@ -3401,25 +3425,25 @@
           </p:nvPr>
         </p:nvGraphicFramePr>
         <p:xfrm>
-          <a:off x="548640" y="1755648"/>
-          <a:ext cx="11091672" cy="2743199"/>
+          <a:off x="548640" y="1481328"/>
+          <a:ext cx="11091672" cy="3168395"/>
         </p:xfrm>
         <a:graphic>
           <a:graphicData uri="http://schemas.openxmlformats.org/drawingml/2006/table">
             <a:tbl>
               <a:tblPr/>
               <a:tblGrid>
-                <a:gridCol w="2011680"/>
-                <a:gridCol w="6537960"/>
-                <a:gridCol w="2542032"/>
+                <a:gridCol w="1737360"/>
+                <a:gridCol w="7086600"/>
+                <a:gridCol w="2267712"/>
               </a:tblGrid>
-              <a:tr h="402336">
+              <a:tr h="329184">
                 <a:tc>
                   <a:txBody>
                     <a:bodyPr/>
                     <a:lstStyle/>
                     <a:p>
-                      <a:pPr indent="0" marL="0">
+                      <a:pPr algn="ctr" indent="0" marL="0">
                         <a:buNone/>
                       </a:pPr>
                       <a:r>
@@ -3456,7 +3480,7 @@
                     <a:bodyPr/>
                     <a:lstStyle/>
                     <a:p>
-                      <a:pPr indent="0" marL="0">
+                      <a:pPr algn="ctr" indent="0" marL="0">
                         <a:buNone/>
                       </a:pPr>
                       <a:r>
@@ -3493,7 +3517,7 @@
                     <a:bodyPr/>
                     <a:lstStyle/>
                     <a:p>
-                      <a:pPr indent="0" marL="0">
+                      <a:pPr algn="ctr" indent="0" marL="0">
                         <a:buNone/>
                       </a:pPr>
                       <a:r>
@@ -3526,17 +3550,17 @@
                   </a:tcPr>
                 </a:tc>
               </a:tr>
-              <a:tr h="433651">
+              <a:tr h="748506">
                 <a:tc>
                   <a:txBody>
                     <a:bodyPr/>
                     <a:lstStyle/>
                     <a:p>
-                      <a:pPr algn="l" indent="0" marL="0">
+                      <a:pPr algn="ctr" indent="0" marL="0">
                         <a:buNone/>
                       </a:pPr>
                       <a:r>
-                        <a:rPr lang="en-US" sz="1000" b="1" dirty="0">
+                        <a:rPr lang="en-US" sz="1050" b="1" dirty="0">
                           <a:solidFill>
                             <a:schemeClr val="accent1"/>
                           </a:solidFill>
@@ -3591,7 +3615,7 @@
                         <a:buNone/>
                       </a:pPr>
                       <a:r>
-                        <a:rPr lang="en-US" sz="1000" dirty="0" u="sng">
+                        <a:rPr lang="en-US" sz="950" dirty="0" u="sng">
                           <a:solidFill>
                             <a:srgbClr val="002677"/>
                           </a:solidFill>
@@ -3601,18 +3625,10 @@
                             </a:solidFill>
                           </a:uFill>
                         </a:rPr>
-                        <a:t>Veeva uses Anthropic and Amazon models</a:t>
-                      </a:r>
-                      <a:r>
-                        <a:rPr lang="en-US" sz="1000" dirty="0">
-                          <a:solidFill>
-                            <a:schemeClr val="tx1"/>
-                          </a:solidFill>
-                        </a:rPr>
-                        <a:t>; </a:t>
-                      </a:r>
-                      <a:r>
-                        <a:rPr lang="en-US" sz="1000" dirty="0" u="sng">
+                        <a:t>Veeva’s </a:t>
+                      </a:r>
+                      <a:r>
+                        <a:rPr lang="en-US" sz="950" dirty="0" b="1" u="sng">
                           <a:solidFill>
                             <a:srgbClr val="002677"/>
                           </a:solidFill>
@@ -3622,18 +3638,27 @@
                             </a:solidFill>
                           </a:uFill>
                         </a:rPr>
-                        <a:t>IQVIA.ai uses NVIDIA Nemotron</a:t>
-                      </a:r>
-                      <a:r>
-                        <a:rPr lang="en-US" sz="1000" dirty="0">
+                        <a:t>Vault AI</a:t>
+                      </a:r>
+                      <a:r>
+                        <a:rPr lang="en-US" sz="950" dirty="0">
                           <a:solidFill>
                             <a:schemeClr val="tx1"/>
                           </a:solidFill>
                         </a:rPr>
-                        <a:t>, while IQVIA separately </a:t>
-                      </a:r>
-                      <a:r>
-                        <a:rPr lang="en-US" sz="1000" dirty="0" u="sng">
+                        <a:t>: Anthropic and Amazon models;</a:t>
+                      </a:r>
+                      <a:endParaRPr lang="en-US" sz="950" dirty="0"/>
+                    </a:p>
+                    <a:p>
+                      <a:pPr indent="0" marL="0">
+                        <a:spcBef>
+                          <a:spcPts val="150"/>
+                        </a:spcBef>
+                        <a:buNone/>
+                      </a:pPr>
+                      <a:r>
+                        <a:rPr lang="en-US" sz="950" dirty="0" u="sng">
                           <a:solidFill>
                             <a:srgbClr val="002677"/>
                           </a:solidFill>
@@ -3643,18 +3668,10 @@
                             </a:solidFill>
                           </a:uFill>
                         </a:rPr>
-                        <a:t>developed Med-R1</a:t>
-                      </a:r>
-                      <a:r>
-                        <a:rPr lang="en-US" sz="1000" dirty="0">
-                          <a:solidFill>
-                            <a:schemeClr val="tx1"/>
-                          </a:solidFill>
-                        </a:rPr>
-                        <a:t>; </a:t>
-                      </a:r>
-                      <a:r>
-                        <a:rPr lang="en-US" sz="1000" dirty="0" u="sng">
+                        <a:t>IQVIA’s </a:t>
+                      </a:r>
+                      <a:r>
+                        <a:rPr lang="en-US" sz="950" dirty="0" b="1" u="sng">
                           <a:solidFill>
                             <a:srgbClr val="002677"/>
                           </a:solidFill>
@@ -3664,9 +3681,103 @@
                             </a:solidFill>
                           </a:uFill>
                         </a:rPr>
-                        <a:t>Tempus pairs frontier LLMs with its own oncology models</a:t>
-                      </a:r>
-                      <a:endParaRPr lang="en-US" sz="900" dirty="0"/>
+                        <a:t>IQVIA.ai</a:t>
+                      </a:r>
+                      <a:r>
+                        <a:rPr lang="en-US" sz="950" dirty="0">
+                          <a:solidFill>
+                            <a:schemeClr val="tx1"/>
+                          </a:solidFill>
+                        </a:rPr>
+                        <a:t>: NVIDIA Nemotron;</a:t>
+                      </a:r>
+                      <a:endParaRPr lang="en-US" sz="950" dirty="0"/>
+                    </a:p>
+                    <a:p>
+                      <a:pPr indent="0" marL="0">
+                        <a:spcBef>
+                          <a:spcPts val="150"/>
+                        </a:spcBef>
+                        <a:buNone/>
+                      </a:pPr>
+                      <a:r>
+                        <a:rPr lang="en-US" sz="950" dirty="0" u="sng">
+                          <a:solidFill>
+                            <a:srgbClr val="002677"/>
+                          </a:solidFill>
+                          <a:uFill>
+                            <a:solidFill>
+                              <a:srgbClr val="9AA8CC"/>
+                            </a:solidFill>
+                          </a:uFill>
+                        </a:rPr>
+                        <a:t>IQVIA’s </a:t>
+                      </a:r>
+                      <a:r>
+                        <a:rPr lang="en-US" sz="950" dirty="0" b="1" u="sng">
+                          <a:solidFill>
+                            <a:srgbClr val="002677"/>
+                          </a:solidFill>
+                          <a:uFill>
+                            <a:solidFill>
+                              <a:srgbClr val="9AA8CC"/>
+                            </a:solidFill>
+                          </a:uFill>
+                        </a:rPr>
+                        <a:t>Med-R1</a:t>
+                      </a:r>
+                      <a:r>
+                        <a:rPr lang="en-US" sz="950" dirty="0">
+                          <a:solidFill>
+                            <a:schemeClr val="tx1"/>
+                          </a:solidFill>
+                        </a:rPr>
+                        <a:t>: developed separately by IQVIA;</a:t>
+                      </a:r>
+                      <a:endParaRPr lang="en-US" sz="950" dirty="0"/>
+                    </a:p>
+                    <a:p>
+                      <a:pPr indent="0" marL="0">
+                        <a:spcBef>
+                          <a:spcPts val="150"/>
+                        </a:spcBef>
+                        <a:buNone/>
+                      </a:pPr>
+                      <a:r>
+                        <a:rPr lang="en-US" sz="950" dirty="0" u="sng">
+                          <a:solidFill>
+                            <a:srgbClr val="002677"/>
+                          </a:solidFill>
+                          <a:uFill>
+                            <a:solidFill>
+                              <a:srgbClr val="9AA8CC"/>
+                            </a:solidFill>
+                          </a:uFill>
+                        </a:rPr>
+                        <a:t>Tempus’s </a:t>
+                      </a:r>
+                      <a:r>
+                        <a:rPr lang="en-US" sz="950" dirty="0" b="1" u="sng">
+                          <a:solidFill>
+                            <a:srgbClr val="002677"/>
+                          </a:solidFill>
+                          <a:uFill>
+                            <a:solidFill>
+                              <a:srgbClr val="9AA8CC"/>
+                            </a:solidFill>
+                          </a:uFill>
+                        </a:rPr>
+                        <a:t>Lens</a:t>
+                      </a:r>
+                      <a:r>
+                        <a:rPr lang="en-US" sz="950" dirty="0">
+                          <a:solidFill>
+                            <a:schemeClr val="tx1"/>
+                          </a:solidFill>
+                        </a:rPr>
+                        <a:t>: frontier LLMs paired with its own oncology models</a:t>
+                      </a:r>
+                      <a:endParaRPr lang="en-US" sz="950" dirty="0"/>
                     </a:p>
                   </a:txBody>
                   <a:tcPr marL="109728" marR="109728" marT="64008" marB="64008" anchor="ctr">
@@ -3679,9 +3790,9 @@
                     <a:lnT w="0" cap="flat" cmpd="sng" algn="ctr">
                       <a:noFill/>
                     </a:lnT>
-                    <a:lnB w="19050" cap="flat" cmpd="sng" algn="ctr">
+                    <a:lnB w="9525" cap="flat" cmpd="sng" algn="ctr">
                       <a:solidFill>
-                        <a:srgbClr val="002677"/>
+                        <a:srgbClr val="D9D4C7"/>
                       </a:solidFill>
                       <a:prstDash val="solid"/>
                       <a:round/>
@@ -3699,14 +3810,14 @@
                         <a:buNone/>
                       </a:pPr>
                       <a:r>
-                        <a:rPr lang="en-US" sz="1000" dirty="0" b="1">
-                          <a:solidFill>
-                            <a:srgbClr val="002677"/>
+                        <a:rPr lang="en-US" sz="950" dirty="0" b="1">
+                          <a:solidFill>
+                            <a:srgbClr val="1A1A1A"/>
                           </a:solidFill>
                         </a:rPr>
                         <a:t>Often sourced or adapted</a:t>
                       </a:r>
-                      <a:endParaRPr lang="en-US" sz="900" dirty="0"/>
+                      <a:endParaRPr lang="en-US" sz="950" dirty="0"/>
                     </a:p>
                   </a:txBody>
                   <a:tcPr marL="109728" marR="109728" marT="64008" marB="64008" anchor="ctr">
@@ -3719,9 +3830,9 @@
                     <a:lnT w="0" cap="flat" cmpd="sng" algn="ctr">
                       <a:noFill/>
                     </a:lnT>
-                    <a:lnB w="19050" cap="flat" cmpd="sng" algn="ctr">
+                    <a:lnB w="9525" cap="flat" cmpd="sng" algn="ctr">
                       <a:solidFill>
-                        <a:srgbClr val="002677"/>
+                        <a:srgbClr val="D9D4C7"/>
                       </a:solidFill>
                       <a:prstDash val="solid"/>
                       <a:round/>
@@ -3731,22 +3842,37 @@
                   </a:tcPr>
                 </a:tc>
               </a:tr>
-              <a:tr h="651824">
+              <a:tr h="748506">
                 <a:tc>
                   <a:txBody>
                     <a:bodyPr/>
                     <a:lstStyle/>
                     <a:p>
-                      <a:pPr algn="l" indent="0" marL="0">
+                      <a:pPr algn="ctr" indent="0" marL="0">
                         <a:buNone/>
                       </a:pPr>
                       <a:r>
-                        <a:rPr lang="en-US" sz="1000" b="1" dirty="0">
+                        <a:rPr lang="en-US" sz="1050" b="1" dirty="0">
                           <a:solidFill>
                             <a:schemeClr val="accent1"/>
                           </a:solidFill>
                         </a:rPr>
-                        <a:t>Data and domain intelligence</a:t>
+                        <a:t>Data and domain</a:t>
+                      </a:r>
+                      <a:br>
+                        <a:rPr lang="en-US" sz="1050" b="1" dirty="0">
+                          <a:solidFill>
+                            <a:schemeClr val="accent1"/>
+                          </a:solidFill>
+                        </a:rPr>
+                      </a:br>
+                      <a:r>
+                        <a:rPr lang="en-US" sz="1050" b="1" dirty="0">
+                          <a:solidFill>
+                            <a:schemeClr val="accent1"/>
+                          </a:solidFill>
+                        </a:rPr>
+                        <a:t>intelligence</a:t>
                       </a:r>
                       <a:endParaRPr lang="en-US" sz="1050" dirty="0"/>
                     </a:p>
@@ -3796,23 +3922,7 @@
                         <a:buNone/>
                       </a:pPr>
                       <a:r>
-                        <a:rPr lang="en-US" sz="1000" dirty="0" b="1">
-                          <a:solidFill>
-                            <a:schemeClr val="tx1"/>
-                          </a:solidFill>
-                        </a:rPr>
-                        <a:t>Komodo: </a:t>
-                      </a:r>
-                      <a:r>
-                        <a:rPr lang="en-US" sz="1000" dirty="0">
-                          <a:solidFill>
-                            <a:schemeClr val="tx1"/>
-                          </a:solidFill>
-                        </a:rPr>
-                        <a:t>its </a:t>
-                      </a:r>
-                      <a:r>
-                        <a:rPr lang="en-US" sz="1000" dirty="0" u="sng">
+                        <a:rPr lang="en-US" sz="950" dirty="0" u="sng">
                           <a:solidFill>
                             <a:srgbClr val="002677"/>
                           </a:solidFill>
@@ -3822,18 +3932,10 @@
                             </a:solidFill>
                           </a:uFill>
                         </a:rPr>
-                        <a:t>Healthcare Map of de-identified patient journeys</a:t>
-                      </a:r>
-                      <a:r>
-                        <a:rPr lang="en-US" sz="1000" dirty="0">
-                          <a:solidFill>
-                            <a:schemeClr val="tx1"/>
-                          </a:solidFill>
-                        </a:rPr>
-                        <a:t>, plus </a:t>
-                      </a:r>
-                      <a:r>
-                        <a:rPr lang="en-US" sz="1000" dirty="0" u="sng">
+                        <a:t>Komodo Health’s </a:t>
+                      </a:r>
+                      <a:r>
+                        <a:rPr lang="en-US" sz="950" dirty="0" b="1" u="sng">
                           <a:solidFill>
                             <a:srgbClr val="002677"/>
                           </a:solidFill>
@@ -3843,27 +3945,27 @@
                             </a:solidFill>
                           </a:uFill>
                         </a:rPr>
-                        <a:t>a knowledge graph built from prior analyses</a:t>
-                      </a:r>
-                      <a:endParaRPr lang="en-US" sz="900" dirty="0"/>
+                        <a:t>Healthcare Map</a:t>
+                      </a:r>
+                      <a:r>
+                        <a:rPr lang="en-US" sz="950" dirty="0">
+                          <a:solidFill>
+                            <a:schemeClr val="tx1"/>
+                          </a:solidFill>
+                        </a:rPr>
+                        <a:t>: de-identified patient journeys;</a:t>
+                      </a:r>
+                      <a:endParaRPr lang="en-US" sz="950" dirty="0"/>
                     </a:p>
                     <a:p>
                       <a:pPr indent="0" marL="0">
                         <a:spcBef>
-                          <a:spcPts val="300"/>
+                          <a:spcPts val="150"/>
                         </a:spcBef>
                         <a:buNone/>
                       </a:pPr>
                       <a:r>
-                        <a:rPr lang="en-US" sz="1000" dirty="0" b="1">
-                          <a:solidFill>
-                            <a:schemeClr val="tx1"/>
-                          </a:solidFill>
-                        </a:rPr>
-                        <a:t>Truveta: </a:t>
-                      </a:r>
-                      <a:r>
-                        <a:rPr lang="en-US" sz="1000" dirty="0" u="sng">
+                        <a:rPr lang="en-US" sz="950" dirty="0" u="sng">
                           <a:solidFill>
                             <a:srgbClr val="002677"/>
                           </a:solidFill>
@@ -3873,27 +3975,10 @@
                             </a:solidFill>
                           </a:uFill>
                         </a:rPr>
-                        <a:t>continuously refreshed EHR data from member health systems</a:t>
-                      </a:r>
-                      <a:endParaRPr lang="en-US" sz="900" dirty="0"/>
-                    </a:p>
-                    <a:p>
-                      <a:pPr indent="0" marL="0">
-                        <a:spcBef>
-                          <a:spcPts val="300"/>
-                        </a:spcBef>
-                        <a:buNone/>
-                      </a:pPr>
-                      <a:r>
-                        <a:rPr lang="en-US" sz="1000" dirty="0" b="1">
-                          <a:solidFill>
-                            <a:schemeClr val="tx1"/>
-                          </a:solidFill>
-                        </a:rPr>
-                        <a:t>Norstella: </a:t>
-                      </a:r>
-                      <a:r>
-                        <a:rPr lang="en-US" sz="1000" dirty="0" u="sng">
+                        <a:t>Komodo Health’s </a:t>
+                      </a:r>
+                      <a:r>
+                        <a:rPr lang="en-US" sz="950" dirty="0" b="1" u="sng">
                           <a:solidFill>
                             <a:srgbClr val="002677"/>
                           </a:solidFill>
@@ -3903,9 +3988,103 @@
                             </a:solidFill>
                           </a:uFill>
                         </a:rPr>
-                        <a:t>NorstellaLinQ patient data, plus Citeline trial, Evaluate commercial and MMIT payer intelligence</a:t>
-                      </a:r>
-                      <a:endParaRPr lang="en-US" sz="900" dirty="0"/>
+                        <a:t>Marmot</a:t>
+                      </a:r>
+                      <a:r>
+                        <a:rPr lang="en-US" sz="950" dirty="0">
+                          <a:solidFill>
+                            <a:schemeClr val="tx1"/>
+                          </a:solidFill>
+                        </a:rPr>
+                        <a:t>: a knowledge graph built from prior analyses;</a:t>
+                      </a:r>
+                      <a:endParaRPr lang="en-US" sz="950" dirty="0"/>
+                    </a:p>
+                    <a:p>
+                      <a:pPr indent="0" marL="0">
+                        <a:spcBef>
+                          <a:spcPts val="150"/>
+                        </a:spcBef>
+                        <a:buNone/>
+                      </a:pPr>
+                      <a:r>
+                        <a:rPr lang="en-US" sz="950" dirty="0" u="sng">
+                          <a:solidFill>
+                            <a:srgbClr val="002677"/>
+                          </a:solidFill>
+                          <a:uFill>
+                            <a:solidFill>
+                              <a:srgbClr val="9AA8CC"/>
+                            </a:solidFill>
+                          </a:uFill>
+                        </a:rPr>
+                        <a:t>Truveta’s </a:t>
+                      </a:r>
+                      <a:r>
+                        <a:rPr lang="en-US" sz="950" dirty="0" b="1" u="sng">
+                          <a:solidFill>
+                            <a:srgbClr val="002677"/>
+                          </a:solidFill>
+                          <a:uFill>
+                            <a:solidFill>
+                              <a:srgbClr val="9AA8CC"/>
+                            </a:solidFill>
+                          </a:uFill>
+                        </a:rPr>
+                        <a:t>Truveta Data</a:t>
+                      </a:r>
+                      <a:r>
+                        <a:rPr lang="en-US" sz="950" dirty="0">
+                          <a:solidFill>
+                            <a:schemeClr val="tx1"/>
+                          </a:solidFill>
+                        </a:rPr>
+                        <a:t>: continuously refreshed EHR data from member health systems;</a:t>
+                      </a:r>
+                      <a:endParaRPr lang="en-US" sz="950" dirty="0"/>
+                    </a:p>
+                    <a:p>
+                      <a:pPr indent="0" marL="0">
+                        <a:spcBef>
+                          <a:spcPts val="150"/>
+                        </a:spcBef>
+                        <a:buNone/>
+                      </a:pPr>
+                      <a:r>
+                        <a:rPr lang="en-US" sz="950" dirty="0" u="sng">
+                          <a:solidFill>
+                            <a:srgbClr val="002677"/>
+                          </a:solidFill>
+                          <a:uFill>
+                            <a:solidFill>
+                              <a:srgbClr val="9AA8CC"/>
+                            </a:solidFill>
+                          </a:uFill>
+                        </a:rPr>
+                        <a:t>Norstella’s </a:t>
+                      </a:r>
+                      <a:r>
+                        <a:rPr lang="en-US" sz="950" dirty="0" b="1" u="sng">
+                          <a:solidFill>
+                            <a:srgbClr val="002677"/>
+                          </a:solidFill>
+                          <a:uFill>
+                            <a:solidFill>
+                              <a:srgbClr val="9AA8CC"/>
+                            </a:solidFill>
+                          </a:uFill>
+                        </a:rPr>
+                        <a:t>NorstellaLinQ</a:t>
+                      </a:r>
+                      <a:r>
+                        <a:rPr lang="en-US" sz="950" dirty="0">
+                          <a:solidFill>
+                            <a:schemeClr val="tx1"/>
+                          </a:solidFill>
+                        </a:rPr>
+                        <a:t>: patient data, plus Citeline trial, Evaluate commercial and MMIT payer intelligence</a:t>
+                      </a:r>
+                      <a:endParaRPr lang="en-US" sz="950" dirty="0"/>
                     </a:p>
                   </a:txBody>
                   <a:tcPr marL="109728" marR="109728" marT="64008" marB="64008" anchor="ctr">
@@ -3918,9 +4097,9 @@
                     <a:lnT w="0" cap="flat" cmpd="sng" algn="ctr">
                       <a:noFill/>
                     </a:lnT>
-                    <a:lnB w="19050" cap="flat" cmpd="sng" algn="ctr">
+                    <a:lnB w="9525" cap="flat" cmpd="sng" algn="ctr">
                       <a:solidFill>
-                        <a:srgbClr val="002677"/>
+                        <a:srgbClr val="D9D4C7"/>
                       </a:solidFill>
                       <a:prstDash val="solid"/>
                       <a:round/>
@@ -3938,14 +4117,14 @@
                         <a:buNone/>
                       </a:pPr>
                       <a:r>
-                        <a:rPr lang="en-US" sz="1000" dirty="0" b="1">
-                          <a:solidFill>
-                            <a:srgbClr val="002677"/>
+                        <a:rPr lang="en-US" sz="950" dirty="0" b="1">
+                          <a:solidFill>
+                            <a:srgbClr val="1A1A1A"/>
                           </a:solidFill>
                         </a:rPr>
                         <a:t>What launches lead with</a:t>
                       </a:r>
-                      <a:endParaRPr lang="en-US" sz="900" dirty="0"/>
+                      <a:endParaRPr lang="en-US" sz="950" dirty="0"/>
                     </a:p>
                   </a:txBody>
                   <a:tcPr marL="109728" marR="109728" marT="64008" marB="64008" anchor="ctr">
@@ -3958,9 +4137,9 @@
                     <a:lnT w="0" cap="flat" cmpd="sng" algn="ctr">
                       <a:noFill/>
                     </a:lnT>
-                    <a:lnB w="19050" cap="flat" cmpd="sng" algn="ctr">
+                    <a:lnB w="9525" cap="flat" cmpd="sng" algn="ctr">
                       <a:solidFill>
-                        <a:srgbClr val="002677"/>
+                        <a:srgbClr val="D9D4C7"/>
                       </a:solidFill>
                       <a:prstDash val="solid"/>
                       <a:round/>
@@ -3970,22 +4149,37 @@
                   </a:tcPr>
                 </a:tc>
               </a:tr>
-              <a:tr h="651811">
+              <a:tr h="593693">
                 <a:tc>
                   <a:txBody>
                     <a:bodyPr/>
                     <a:lstStyle/>
                     <a:p>
-                      <a:pPr algn="l" indent="0" marL="0">
+                      <a:pPr algn="ctr" indent="0" marL="0">
                         <a:buNone/>
                       </a:pPr>
                       <a:r>
-                        <a:rPr lang="en-US" sz="1000" b="1" dirty="0">
+                        <a:rPr lang="en-US" sz="1050" b="1" dirty="0">
                           <a:solidFill>
                             <a:schemeClr val="accent1"/>
                           </a:solidFill>
                         </a:rPr>
-                        <a:t>Execution and controls</a:t>
+                        <a:t>Execution and</a:t>
+                      </a:r>
+                      <a:br>
+                        <a:rPr lang="en-US" sz="1050" b="1" dirty="0">
+                          <a:solidFill>
+                            <a:schemeClr val="accent1"/>
+                          </a:solidFill>
+                        </a:rPr>
+                      </a:br>
+                      <a:r>
+                        <a:rPr lang="en-US" sz="1050" b="1" dirty="0">
+                          <a:solidFill>
+                            <a:schemeClr val="accent1"/>
+                          </a:solidFill>
+                        </a:rPr>
+                        <a:t>controls</a:t>
                       </a:r>
                       <a:endParaRPr lang="en-US" sz="1050" dirty="0"/>
                     </a:p>
@@ -4035,23 +4229,7 @@
                         <a:buNone/>
                       </a:pPr>
                       <a:r>
-                        <a:rPr lang="en-US" sz="1000" dirty="0" b="1">
-                          <a:solidFill>
-                            <a:schemeClr val="tx1"/>
-                          </a:solidFill>
-                        </a:rPr>
-                        <a:t>Komodo: </a:t>
-                      </a:r>
-                      <a:r>
-                        <a:rPr lang="en-US" sz="1000" dirty="0">
-                          <a:solidFill>
-                            <a:schemeClr val="tx1"/>
-                          </a:solidFill>
-                        </a:rPr>
-                        <a:t>“</a:t>
-                      </a:r>
-                      <a:r>
-                        <a:rPr lang="en-US" sz="1000" dirty="0" u="sng">
+                        <a:rPr lang="en-US" sz="950" dirty="0" u="sng">
                           <a:solidFill>
                             <a:srgbClr val="002677"/>
                           </a:solidFill>
@@ -4061,43 +4239,10 @@
                             </a:solidFill>
                           </a:uFill>
                         </a:rPr>
-                        <a:t>The LLM never touches numbers.</a:t>
-                      </a:r>
-                      <a:r>
-                        <a:rPr lang="en-US" sz="1000" dirty="0">
-                          <a:solidFill>
-                            <a:schemeClr val="tx1"/>
-                          </a:solidFill>
-                        </a:rPr>
-                        <a:t>”</a:t>
-                      </a:r>
-                      <a:endParaRPr lang="en-US" sz="900" dirty="0"/>
-                    </a:p>
-                    <a:p>
-                      <a:pPr indent="0" marL="0">
-                        <a:spcBef>
-                          <a:spcPts val="300"/>
-                        </a:spcBef>
-                        <a:buNone/>
-                      </a:pPr>
-                      <a:r>
-                        <a:rPr lang="en-US" sz="1000" dirty="0" b="1">
-                          <a:solidFill>
-                            <a:schemeClr val="tx1"/>
-                          </a:solidFill>
-                        </a:rPr>
-                        <a:t>HealthVerity’s eXOs: </a:t>
-                      </a:r>
-                      <a:r>
-                        <a:rPr lang="en-US" sz="1000" dirty="0">
-                          <a:solidFill>
-                            <a:schemeClr val="tx1"/>
-                          </a:solidFill>
-                        </a:rPr>
-                        <a:t>“</a:t>
-                      </a:r>
-                      <a:r>
-                        <a:rPr lang="en-US" sz="1000" dirty="0" u="sng">
+                        <a:t>Komodo Health’s </a:t>
+                      </a:r>
+                      <a:r>
+                        <a:rPr lang="en-US" sz="950" dirty="0" b="1" u="sng">
                           <a:solidFill>
                             <a:srgbClr val="002677"/>
                           </a:solidFill>
@@ -4107,27 +4252,27 @@
                             </a:solidFill>
                           </a:uFill>
                         </a:rPr>
-                        <a:t>nothing runs until you review, edit and approve it.</a:t>
-                      </a:r>
-                      <a:r>
-                        <a:rPr lang="en-US" sz="1000" dirty="0">
+                        <a:t>Marmot</a:t>
+                      </a:r>
+                      <a:r>
+                        <a:rPr lang="en-US" sz="950" dirty="0">
                           <a:solidFill>
                             <a:schemeClr val="tx1"/>
                           </a:solidFill>
                         </a:rPr>
-                        <a:t>”</a:t>
-                      </a:r>
-                      <a:endParaRPr lang="en-US" sz="900" dirty="0"/>
+                        <a:t>: “The LLM never touches numbers.”;</a:t>
+                      </a:r>
+                      <a:endParaRPr lang="en-US" sz="950" dirty="0"/>
                     </a:p>
                     <a:p>
                       <a:pPr indent="0" marL="0">
                         <a:spcBef>
-                          <a:spcPts val="300"/>
+                          <a:spcPts val="150"/>
                         </a:spcBef>
                         <a:buNone/>
                       </a:pPr>
                       <a:r>
-                        <a:rPr lang="en-US" sz="1000" dirty="0" u="sng">
+                        <a:rPr lang="en-US" sz="950" dirty="0" u="sng">
                           <a:solidFill>
                             <a:srgbClr val="002677"/>
                           </a:solidFill>
@@ -4137,9 +4282,73 @@
                             </a:solidFill>
                           </a:uFill>
                         </a:rPr>
-                        <a:t>Veeva’s EDC assistant reads no site-entered casebook data</a:t>
-                      </a:r>
-                      <a:endParaRPr lang="en-US" sz="900" dirty="0"/>
+                        <a:t>HealthVerity’s </a:t>
+                      </a:r>
+                      <a:r>
+                        <a:rPr lang="en-US" sz="950" dirty="0" b="1" u="sng">
+                          <a:solidFill>
+                            <a:srgbClr val="002677"/>
+                          </a:solidFill>
+                          <a:uFill>
+                            <a:solidFill>
+                              <a:srgbClr val="9AA8CC"/>
+                            </a:solidFill>
+                          </a:uFill>
+                        </a:rPr>
+                        <a:t>eXOs</a:t>
+                      </a:r>
+                      <a:r>
+                        <a:rPr lang="en-US" sz="950" dirty="0">
+                          <a:solidFill>
+                            <a:schemeClr val="tx1"/>
+                          </a:solidFill>
+                        </a:rPr>
+                        <a:t>: “nothing runs until you review, edit and approve it.”;</a:t>
+                      </a:r>
+                      <a:endParaRPr lang="en-US" sz="950" dirty="0"/>
+                    </a:p>
+                    <a:p>
+                      <a:pPr indent="0" marL="0">
+                        <a:spcBef>
+                          <a:spcPts val="150"/>
+                        </a:spcBef>
+                        <a:buNone/>
+                      </a:pPr>
+                      <a:r>
+                        <a:rPr lang="en-US" sz="950" dirty="0" u="sng">
+                          <a:solidFill>
+                            <a:srgbClr val="002677"/>
+                          </a:solidFill>
+                          <a:uFill>
+                            <a:solidFill>
+                              <a:srgbClr val="9AA8CC"/>
+                            </a:solidFill>
+                          </a:uFill>
+                        </a:rPr>
+                        <a:t>Veeva’s </a:t>
+                      </a:r>
+                      <a:r>
+                        <a:rPr lang="en-US" sz="950" dirty="0" b="1" u="sng">
+                          <a:solidFill>
+                            <a:srgbClr val="002677"/>
+                          </a:solidFill>
+                          <a:uFill>
+                            <a:solidFill>
+                              <a:srgbClr val="9AA8CC"/>
+                            </a:solidFill>
+                          </a:uFill>
+                        </a:rPr>
+                        <a:t>EDC AI Tab</a:t>
+                      </a:r>
+                      <a:r>
+                        <a:rPr lang="en-US" sz="950" dirty="0">
+                          <a:solidFill>
+                            <a:schemeClr val="tx1"/>
+                          </a:solidFill>
+                        </a:rPr>
+                        <a:t>: reads no site-entered casebook data</a:t>
+                      </a:r>
+                      <a:endParaRPr lang="en-US" sz="950" dirty="0"/>
                     </a:p>
                   </a:txBody>
                   <a:tcPr marL="109728" marR="109728" marT="64008" marB="64008" anchor="ctr">
@@ -4152,9 +4361,9 @@
                     <a:lnT w="0" cap="flat" cmpd="sng" algn="ctr">
                       <a:noFill/>
                     </a:lnT>
-                    <a:lnB w="19050" cap="flat" cmpd="sng" algn="ctr">
+                    <a:lnB w="9525" cap="flat" cmpd="sng" algn="ctr">
                       <a:solidFill>
-                        <a:srgbClr val="002677"/>
+                        <a:srgbClr val="D9D4C7"/>
                       </a:solidFill>
                       <a:prstDash val="solid"/>
                       <a:round/>
@@ -4172,14 +4381,14 @@
                         <a:buNone/>
                       </a:pPr>
                       <a:r>
-                        <a:rPr lang="en-US" sz="1000" dirty="0" b="1">
-                          <a:solidFill>
-                            <a:srgbClr val="002677"/>
+                        <a:rPr lang="en-US" sz="950" dirty="0" b="1">
+                          <a:solidFill>
+                            <a:srgbClr val="1A1A1A"/>
                           </a:solidFill>
                         </a:rPr>
                         <a:t>How AI work is constrained and checked</a:t>
                       </a:r>
-                      <a:endParaRPr lang="en-US" sz="900" dirty="0"/>
+                      <a:endParaRPr lang="en-US" sz="950" dirty="0"/>
                     </a:p>
                   </a:txBody>
                   <a:tcPr marL="109728" marR="109728" marT="64008" marB="64008" anchor="ctr">
@@ -4192,9 +4401,9 @@
                     <a:lnT w="0" cap="flat" cmpd="sng" algn="ctr">
                       <a:noFill/>
                     </a:lnT>
-                    <a:lnB w="19050" cap="flat" cmpd="sng" algn="ctr">
+                    <a:lnB w="9525" cap="flat" cmpd="sng" algn="ctr">
                       <a:solidFill>
-                        <a:srgbClr val="002677"/>
+                        <a:srgbClr val="D9D4C7"/>
                       </a:solidFill>
                       <a:prstDash val="solid"/>
                       <a:round/>
@@ -4204,17 +4413,17 @@
                   </a:tcPr>
                 </a:tc>
               </a:tr>
-              <a:tr h="603577">
+              <a:tr h="748506">
                 <a:tc>
                   <a:txBody>
                     <a:bodyPr/>
                     <a:lstStyle/>
                     <a:p>
-                      <a:pPr algn="l" indent="0" marL="0">
+                      <a:pPr algn="ctr" indent="0" marL="0">
                         <a:buNone/>
                       </a:pPr>
                       <a:r>
-                        <a:rPr lang="en-US" sz="1000" b="1" dirty="0">
+                        <a:rPr lang="en-US" sz="1050" b="1" dirty="0">
                           <a:solidFill>
                             <a:schemeClr val="accent1"/>
                           </a:solidFill>
@@ -4269,15 +4478,24 @@
                         <a:buNone/>
                       </a:pPr>
                       <a:r>
-                        <a:rPr lang="en-US" sz="1000" dirty="0">
+                        <a:rPr lang="en-US" sz="950" dirty="0">
                           <a:solidFill>
                             <a:schemeClr val="tx1"/>
                           </a:solidFill>
                         </a:rPr>
-                        <a:t>Most build chat into their own products; some also design for other companies’ assistants, platforms or APIs (</a:t>
-                      </a:r>
-                      <a:r>
-                        <a:rPr lang="en-US" sz="1000" dirty="0" u="sng">
+                        <a:t>Most build chat into their own products; some also design for other companies’ assistants, platforms or APIs:</a:t>
+                      </a:r>
+                      <a:endParaRPr lang="en-US" sz="950" dirty="0"/>
+                    </a:p>
+                    <a:p>
+                      <a:pPr indent="0" marL="0">
+                        <a:spcBef>
+                          <a:spcPts val="150"/>
+                        </a:spcBef>
+                        <a:buNone/>
+                      </a:pPr>
+                      <a:r>
+                        <a:rPr lang="en-US" sz="950" dirty="0" u="sng">
                           <a:solidFill>
                             <a:srgbClr val="002677"/>
                           </a:solidFill>
@@ -4287,18 +4505,10 @@
                             </a:solidFill>
                           </a:uFill>
                         </a:rPr>
-                        <a:t>Verana</a:t>
-                      </a:r>
-                      <a:r>
-                        <a:rPr lang="en-US" sz="1000" dirty="0">
-                          <a:solidFill>
-                            <a:schemeClr val="tx1"/>
-                          </a:solidFill>
-                        </a:rPr>
-                        <a:t>, </a:t>
-                      </a:r>
-                      <a:r>
-                        <a:rPr lang="en-US" sz="1000" dirty="0" u="sng">
+                        <a:t>Verana Health’s </a:t>
+                      </a:r>
+                      <a:r>
+                        <a:rPr lang="en-US" sz="950" dirty="0" b="1" u="sng">
                           <a:solidFill>
                             <a:srgbClr val="002677"/>
                           </a:solidFill>
@@ -4308,18 +4518,27 @@
                             </a:solidFill>
                           </a:uFill>
                         </a:rPr>
-                        <a:t>ZS</a:t>
-                      </a:r>
-                      <a:r>
-                        <a:rPr lang="en-US" sz="1000" dirty="0">
+                        <a:t>Agent Claire</a:t>
+                      </a:r>
+                      <a:r>
+                        <a:rPr lang="en-US" sz="950" dirty="0">
                           <a:solidFill>
                             <a:schemeClr val="tx1"/>
                           </a:solidFill>
                         </a:rPr>
-                        <a:t>, </a:t>
-                      </a:r>
-                      <a:r>
-                        <a:rPr lang="en-US" sz="1000" dirty="0" u="sng">
+                        <a:t>: callable from Claude, Gemini and Copilot;</a:t>
+                      </a:r>
+                      <a:endParaRPr lang="en-US" sz="950" dirty="0"/>
+                    </a:p>
+                    <a:p>
+                      <a:pPr indent="0" marL="0">
+                        <a:spcBef>
+                          <a:spcPts val="150"/>
+                        </a:spcBef>
+                        <a:buNone/>
+                      </a:pPr>
+                      <a:r>
+                        <a:rPr lang="en-US" sz="950" dirty="0" u="sng">
                           <a:solidFill>
                             <a:srgbClr val="002677"/>
                           </a:solidFill>
@@ -4329,17 +4548,73 @@
                             </a:solidFill>
                           </a:uFill>
                         </a:rPr>
-                        <a:t>TriNetX</a:t>
-                      </a:r>
-                      <a:r>
-                        <a:rPr lang="en-US" sz="1000" dirty="0">
+                        <a:t>ZS’s </a:t>
+                      </a:r>
+                      <a:r>
+                        <a:rPr lang="en-US" sz="950" dirty="0" b="1" u="sng">
+                          <a:solidFill>
+                            <a:srgbClr val="002677"/>
+                          </a:solidFill>
+                          <a:uFill>
+                            <a:solidFill>
+                              <a:srgbClr val="9AA8CC"/>
+                            </a:solidFill>
+                          </a:uFill>
+                        </a:rPr>
+                        <a:t>ZAIDYN</a:t>
+                      </a:r>
+                      <a:r>
+                        <a:rPr lang="en-US" sz="950" dirty="0">
                           <a:solidFill>
                             <a:schemeClr val="tx1"/>
                           </a:solidFill>
                         </a:rPr>
-                        <a:t>)</a:t>
-                      </a:r>
-                      <a:endParaRPr lang="en-US" sz="900" dirty="0"/>
+                        <a:t>: brought into Salesforce’s Agentforce Life Sciences;</a:t>
+                      </a:r>
+                      <a:endParaRPr lang="en-US" sz="950" dirty="0"/>
+                    </a:p>
+                    <a:p>
+                      <a:pPr indent="0" marL="0">
+                        <a:spcBef>
+                          <a:spcPts val="150"/>
+                        </a:spcBef>
+                        <a:buNone/>
+                      </a:pPr>
+                      <a:r>
+                        <a:rPr lang="en-US" sz="950" dirty="0" u="sng">
+                          <a:solidFill>
+                            <a:srgbClr val="002677"/>
+                          </a:solidFill>
+                          <a:uFill>
+                            <a:solidFill>
+                              <a:srgbClr val="9AA8CC"/>
+                            </a:solidFill>
+                          </a:uFill>
+                        </a:rPr>
+                        <a:t>TriNetX’s </a:t>
+                      </a:r>
+                      <a:r>
+                        <a:rPr lang="en-US" sz="950" dirty="0" b="1" u="sng">
+                          <a:solidFill>
+                            <a:srgbClr val="002677"/>
+                          </a:solidFill>
+                          <a:uFill>
+                            <a:solidFill>
+                              <a:srgbClr val="9AA8CC"/>
+                            </a:solidFill>
+                          </a:uFill>
+                        </a:rPr>
+                        <a:t>LIVE API</a:t>
+                      </a:r>
+                      <a:r>
+                        <a:rPr lang="en-US" sz="950" dirty="0">
+                          <a:solidFill>
+                            <a:schemeClr val="tx1"/>
+                          </a:solidFill>
+                        </a:rPr>
+                        <a:t>: conversational AI integration through enhanced API capabilities</a:t>
+                      </a:r>
+                      <a:endParaRPr lang="en-US" sz="950" dirty="0"/>
                     </a:p>
                   </a:txBody>
                   <a:tcPr marL="109728" marR="109728" marT="64008" marB="64008" anchor="ctr">
@@ -4352,9 +4627,9 @@
                     <a:lnT w="0" cap="flat" cmpd="sng" algn="ctr">
                       <a:noFill/>
                     </a:lnT>
-                    <a:lnB w="19050" cap="flat" cmpd="sng" algn="ctr">
+                    <a:lnB w="9525" cap="flat" cmpd="sng" algn="ctr">
                       <a:solidFill>
-                        <a:srgbClr val="002677"/>
+                        <a:srgbClr val="D9D4C7"/>
                       </a:solidFill>
                       <a:prstDash val="solid"/>
                       <a:round/>
@@ -4372,14 +4647,14 @@
                         <a:buNone/>
                       </a:pPr>
                       <a:r>
-                        <a:rPr lang="en-US" sz="1000" dirty="0" b="1">
-                          <a:solidFill>
-                            <a:srgbClr val="002677"/>
+                        <a:rPr lang="en-US" sz="950" dirty="0" b="1">
+                          <a:solidFill>
+                            <a:srgbClr val="1A1A1A"/>
                           </a:solidFill>
                         </a:rPr>
                         <a:t>Not always the vendor’s</a:t>
                       </a:r>
-                      <a:endParaRPr lang="en-US" sz="900" dirty="0"/>
+                      <a:endParaRPr lang="en-US" sz="950" dirty="0"/>
                     </a:p>
                   </a:txBody>
                   <a:tcPr marL="109728" marR="109728" marT="64008" marB="64008" anchor="ctr">
@@ -4392,9 +4667,9 @@
                     <a:lnT w="0" cap="flat" cmpd="sng" algn="ctr">
                       <a:noFill/>
                     </a:lnT>
-                    <a:lnB w="19050" cap="flat" cmpd="sng" algn="ctr">
+                    <a:lnB w="9525" cap="flat" cmpd="sng" algn="ctr">
                       <a:solidFill>
-                        <a:srgbClr val="002677"/>
+                        <a:srgbClr val="D9D4C7"/>
                       </a:solidFill>
                       <a:prstDash val="solid"/>
                       <a:round/>
@@ -4410,59 +4685,14 @@
       </p:graphicFrame>
       <p:sp>
         <p:nvSpPr>
-          <p:cNvPr id="25" name="Slide Number Placeholder 0"/>
-          <p:cNvSpPr>
-            <a:spLocks noGrp="1"/>
-          </p:cNvSpPr>
-          <p:nvPr>
-            <p:ph type="sldNum" sz="quarter" idx="4294967295"/>
-          </p:nvPr>
-        </p:nvSpPr>
-        <p:spPr>
-          <a:xfrm>
-            <a:off x="10725912" y="6309360"/>
-            <a:ext cx="914400" cy="201168"/>
-          </a:xfrm>
-          <a:prstGeom prst="rect">
-            <a:avLst/>
-          </a:prstGeom>
-          <a:extLst>
-            <a:ext uri="{C572A759-6A51-4108-AA02-DFA0A04FC94B}">
-              <ma14:wrappingTextBoxFlag xmlns:ma14="http://schemas.microsoft.com/office/mac/drawingml/2011/main" val="0"/>
-            </a:ext>
-          </a:extLst>
-        </p:spPr>
-        <p:txBody>
-          <a:bodyPr lIns="0" tIns="0" rIns="0" bIns="0"/>
-          <a:lstStyle>
-            <a:lvl1pPr>
-              <a:defRPr sz="900">
-                <a:solidFill>
-                  <a:schemeClr val="accent4"/>
-                </a:solidFill>
-              </a:defRPr>
-            </a:lvl1pPr>
-          </a:lstStyle>
-          <a:p>
-            <a:pPr algn="r"/>
-            <a:fld id="{F7021451-1387-4CA6-816F-3879F97B5CBC}" type="slidenum">
-              <a:rPr b="0" lang="en-US"/>
-              <a:t>10</a:t>
-            </a:fld>
-            <a:endParaRPr lang="en-US"/>
-          </a:p>
-        </p:txBody>
-      </p:sp>
-      <p:sp>
-        <p:nvSpPr>
-          <p:cNvPr id="26" name="build card 1"/>
+          <p:cNvPr id="27" name="supplier and seller card"/>
           <p:cNvSpPr/>
           <p:nvPr/>
         </p:nvSpPr>
         <p:spPr>
           <a:xfrm>
-            <a:off x="3749039" y="4681728"/>
-            <a:ext cx="3854196" cy="1371600"/>
+            <a:off x="548640" y="4832604"/>
+            <a:ext cx="5454396" cy="1220724"/>
           </a:xfrm>
           <a:prstGeom prst="rect">
             <a:avLst/>
@@ -4486,14 +4716,14 @@
       </p:sp>
       <p:sp>
         <p:nvSpPr>
-          <p:cNvPr id="27" name="build label 1"/>
+          <p:cNvPr id="28" name="label"/>
           <p:cNvSpPr txBox="1"/>
           <p:nvPr/>
         </p:nvSpPr>
         <p:spPr>
           <a:xfrm>
-            <a:off x="3931920" y="4846320"/>
-            <a:ext cx="3488436" cy="237744"/>
+            <a:off x="749808" y="5015484"/>
+            <a:ext cx="5052060" cy="256032"/>
           </a:xfrm>
           <a:prstGeom prst="rect">
             <a:avLst/>
@@ -4509,7 +4739,7 @@
               <a:buNone/>
             </a:pPr>
             <a:r>
-              <a:rPr lang="en-US" sz="1050" b="1" spc="80" kern="0" dirty="0">
+              <a:rPr lang="en-US" sz="1300" b="1" spc="150" kern="0" dirty="0">
                 <a:solidFill>
                   <a:schemeClr val="accent2"/>
                 </a:solidFill>
@@ -4522,14 +4752,14 @@
       </p:sp>
       <p:sp>
         <p:nvSpPr>
-          <p:cNvPr id="28" name="build body 1"/>
+          <p:cNvPr id="29" name="Text 14"/>
           <p:cNvSpPr txBox="1"/>
           <p:nvPr/>
         </p:nvSpPr>
         <p:spPr>
           <a:xfrm>
-            <a:off x="3931920" y="5157216"/>
-            <a:ext cx="3488436" cy="804672"/>
+            <a:off x="749808" y="5362956"/>
+            <a:ext cx="5052060" cy="507491"/>
           </a:xfrm>
           <a:prstGeom prst="rect">
             <a:avLst/>
@@ -4545,7 +4775,7 @@
               <a:buNone/>
             </a:pPr>
             <a:r>
-              <a:rPr lang="en-US" sz="1000" b="1" dirty="0" u="sng">
+              <a:rPr lang="en-US" sz="1050" b="1" dirty="0" u="sng">
                 <a:solidFill>
                   <a:srgbClr val="002677"/>
                 </a:solidFill>
@@ -4558,7 +4788,7 @@
               <a:t>Medeloop powers HealthVerity’s eXOs</a:t>
             </a:r>
             <a:r>
-              <a:rPr lang="en-US" sz="1000" b="1" dirty="0">
+              <a:rPr lang="en-US" sz="1050" b="1" dirty="0">
                 <a:solidFill>
                   <a:schemeClr val="tx1"/>
                 </a:solidFill>
@@ -4566,7 +4796,7 @@
               <a:t> and also sells its own analytics platform, preloaded with “</a:t>
             </a:r>
             <a:r>
-              <a:rPr lang="en-US" sz="1000" b="1" dirty="0" u="sng">
+              <a:rPr lang="en-US" sz="1050" b="1" dirty="0" u="sng">
                 <a:solidFill>
                   <a:srgbClr val="002677"/>
                 </a:solidFill>
@@ -4579,7 +4809,7 @@
               <a:t>38 million de-identified patients from HealthVerity’s all-payer claims dataset</a:t>
             </a:r>
             <a:r>
-              <a:rPr lang="en-US" sz="1000" b="1" dirty="0">
+              <a:rPr lang="en-US" sz="1050" b="1" dirty="0">
                 <a:solidFill>
                   <a:schemeClr val="tx1"/>
                 </a:solidFill>
@@ -4592,14 +4822,14 @@
       </p:sp>
       <p:sp>
         <p:nvSpPr>
-          <p:cNvPr id="29" name="build card 2"/>
+          <p:cNvPr id="30" name="the interface isn’t always the vendor’s card"/>
           <p:cNvSpPr/>
           <p:nvPr/>
         </p:nvSpPr>
         <p:spPr>
           <a:xfrm>
-            <a:off x="7786116" y="4681728"/>
-            <a:ext cx="3854196" cy="1371600"/>
+            <a:off x="6185916" y="4832604"/>
+            <a:ext cx="5454396" cy="1220724"/>
           </a:xfrm>
           <a:prstGeom prst="rect">
             <a:avLst/>
@@ -4623,14 +4853,14 @@
       </p:sp>
       <p:sp>
         <p:nvSpPr>
-          <p:cNvPr id="30" name="build label 2"/>
+          <p:cNvPr id="31" name="label"/>
           <p:cNvSpPr txBox="1"/>
           <p:nvPr/>
         </p:nvSpPr>
         <p:spPr>
           <a:xfrm>
-            <a:off x="7968996" y="4846320"/>
-            <a:ext cx="3488436" cy="237744"/>
+            <a:off x="6387084" y="5015484"/>
+            <a:ext cx="5052060" cy="256032"/>
           </a:xfrm>
           <a:prstGeom prst="rect">
             <a:avLst/>
@@ -4646,7 +4876,7 @@
               <a:buNone/>
             </a:pPr>
             <a:r>
-              <a:rPr lang="en-US" sz="1050" b="1" spc="80" kern="0" dirty="0">
+              <a:rPr lang="en-US" sz="1300" b="1" spc="150" kern="0" dirty="0">
                 <a:solidFill>
                   <a:schemeClr val="accent2"/>
                 </a:solidFill>
@@ -4659,14 +4889,14 @@
       </p:sp>
       <p:sp>
         <p:nvSpPr>
-          <p:cNvPr id="31" name="build body 2"/>
+          <p:cNvPr id="32" name="Text 14"/>
           <p:cNvSpPr txBox="1"/>
           <p:nvPr/>
         </p:nvSpPr>
         <p:spPr>
           <a:xfrm>
-            <a:off x="7968996" y="5157216"/>
-            <a:ext cx="3488436" cy="804672"/>
+            <a:off x="6387084" y="5362956"/>
+            <a:ext cx="5052060" cy="507491"/>
           </a:xfrm>
           <a:prstGeom prst="rect">
             <a:avLst/>
@@ -4682,7 +4912,7 @@
               <a:buNone/>
             </a:pPr>
             <a:r>
-              <a:rPr lang="en-US" sz="1000" b="1" dirty="0">
+              <a:rPr lang="en-US" sz="1050" b="1" dirty="0">
                 <a:solidFill>
                   <a:schemeClr val="tx1"/>
                 </a:solidFill>
@@ -4690,7 +4920,7 @@
               <a:t>Verana markets Agent Claire as </a:t>
             </a:r>
             <a:r>
-              <a:rPr lang="en-US" sz="1000" b="1" dirty="0" u="sng">
+              <a:rPr lang="en-US" sz="1050" b="1" dirty="0" u="sng">
                 <a:solidFill>
                   <a:srgbClr val="002677"/>
                 </a:solidFill>
@@ -4703,7 +4933,7 @@
               <a:t>callable from Claude, Gemini and Copilot</a:t>
             </a:r>
             <a:r>
-              <a:rPr lang="en-US" sz="1000" b="1" dirty="0">
+              <a:rPr lang="en-US" sz="1050" b="1" dirty="0">
                 <a:solidFill>
                   <a:schemeClr val="tx1"/>
                 </a:solidFill>
@@ -4711,7 +4941,7 @@
               <a:t>; ZS has announced it is bringing ZAIDYN “</a:t>
             </a:r>
             <a:r>
-              <a:rPr lang="en-US" sz="1000" b="1" dirty="0" u="sng">
+              <a:rPr lang="en-US" sz="1050" b="1" dirty="0" u="sng">
                 <a:solidFill>
                   <a:srgbClr val="002677"/>
                 </a:solidFill>
@@ -4724,7 +4954,7 @@
               <a:t>directly into Salesforce’s Agentforce Life Sciences</a:t>
             </a:r>
             <a:r>
-              <a:rPr lang="en-US" sz="1000" b="1" dirty="0">
+              <a:rPr lang="en-US" sz="1050" b="1" dirty="0">
                 <a:solidFill>
                   <a:schemeClr val="tx1"/>
                 </a:solidFill>
@@ -4737,25 +4967,57 @@
       </p:sp>
       <p:sp>
         <p:nvSpPr>
-          <p:cNvPr id="32" name="aside rule"/>
+          <p:cNvPr id="33" name="link legend"/>
+          <p:cNvSpPr txBox="1"/>
+          <p:nvPr/>
+        </p:nvSpPr>
+        <p:spPr>
+          <a:xfrm>
+            <a:off x="2944368" y="6309360"/>
+            <a:ext cx="4572000" cy="201168"/>
+          </a:xfrm>
+          <a:prstGeom prst="rect">
+            <a:avLst/>
+          </a:prstGeom>
+          <a:noFill/>
+        </p:spPr>
+        <p:txBody>
+          <a:bodyPr wrap="square" lIns="0" tIns="0" rIns="0" bIns="0" anchor="ctr">
+            <a:spAutoFit/>
+          </a:bodyPr>
+          <a:lstStyle/>
+          <a:p>
+            <a:r>
+              <a:rPr sz="900">
+                <a:solidFill>
+                  <a:schemeClr val="accent4"/>
+                </a:solidFill>
+              </a:rPr>
+              <a:t>·  Underlined text links to public sources</a:t>
+            </a:r>
+          </a:p>
+        </p:txBody>
+      </p:sp>
+      <p:sp>
+        <p:nvSpPr>
+          <p:cNvPr id="9711" name="Invisible source link 14: https://www.veeva.com/products/vault-ai/">
+            <a:hlinkClick r:id="rId2"/>
+          </p:cNvPr>
           <p:cNvSpPr/>
           <p:nvPr/>
         </p:nvSpPr>
         <p:spPr>
           <a:xfrm>
-            <a:off x="548640" y="4791456"/>
-            <a:ext cx="32004" cy="1152144"/>
-          </a:xfrm>
-          <a:prstGeom prst="rect">
-            <a:avLst/>
-          </a:prstGeom>
-          <a:solidFill>
-            <a:srgbClr val="D9D4C7"/>
-          </a:solidFill>
+            <a:off x="2395435" y="1885253"/>
+            <a:ext cx="921885" cy="134588"/>
+          </a:xfrm>
+          <a:prstGeom prst="rect">
+            <a:avLst/>
+          </a:prstGeom>
+          <a:noFill/>
           <a:ln>
             <a:noFill/>
           </a:ln>
-          <a:effectLst/>
         </p:spPr>
         <p:style>
           <a:lnRef idx="1">
@@ -4781,154 +5043,16 @@
       </p:sp>
       <p:sp>
         <p:nvSpPr>
-          <p:cNvPr id="33" name="aside label"/>
-          <p:cNvSpPr txBox="1"/>
-          <p:nvPr/>
-        </p:nvSpPr>
-        <p:spPr>
-          <a:xfrm>
-            <a:off x="694944" y="4791456"/>
-            <a:ext cx="2788920" cy="201168"/>
-          </a:xfrm>
-          <a:prstGeom prst="rect">
-            <a:avLst/>
-          </a:prstGeom>
-          <a:noFill/>
-          <a:ln/>
-        </p:spPr>
-        <p:txBody>
-          <a:bodyPr wrap="square" lIns="0" tIns="0" rIns="0" bIns="0" rtlCol="0" anchor="t"/>
-          <a:lstStyle/>
-          <a:p>
-            <a:pPr indent="0" marL="0">
-              <a:buNone/>
-            </a:pPr>
-            <a:r>
-              <a:rPr lang="en-US" sz="900" b="1" spc="100" kern="0" dirty="0">
-                <a:solidFill>
-                  <a:srgbClr val="7A7C7E"/>
-                </a:solidFill>
-              </a:rPr>
-              <a:t>COMPANIES REVIEWED</a:t>
-            </a:r>
-            <a:endParaRPr lang="en-US" sz="1300" dirty="0"/>
-          </a:p>
-        </p:txBody>
-      </p:sp>
-      <p:sp>
-        <p:nvSpPr>
-          <p:cNvPr id="34" name="aside body"/>
-          <p:cNvSpPr txBox="1"/>
-          <p:nvPr/>
-        </p:nvSpPr>
-        <p:spPr>
-          <a:xfrm>
-            <a:off x="694944" y="5047488"/>
-            <a:ext cx="2788920" cy="914400"/>
-          </a:xfrm>
-          <a:prstGeom prst="rect">
-            <a:avLst/>
-          </a:prstGeom>
-          <a:noFill/>
-          <a:ln/>
-        </p:spPr>
-        <p:txBody>
-          <a:bodyPr wrap="square" lIns="0" tIns="0" rIns="0" bIns="0" rtlCol="0" anchor="t"/>
-          <a:lstStyle/>
-          <a:p>
-            <a:pPr indent="0" marL="0">
-              <a:buNone/>
-            </a:pPr>
-            <a:r>
-              <a:rPr lang="en-US" sz="900" b="1" dirty="0">
-                <a:solidFill>
-                  <a:srgbClr val="7A7C7E"/>
-                </a:solidFill>
-              </a:rPr>
-              <a:t>U.S.: </a:t>
-            </a:r>
-            <a:r>
-              <a:rPr lang="en-US" sz="900" dirty="0">
-                <a:solidFill>
-                  <a:srgbClr val="7A7C7E"/>
-                </a:solidFill>
-              </a:rPr>
-              <a:t>Komodo · Truveta · Flatiron · Tempus · HealthVerity · Norstella · Truven · ConcertAI · Verana · IQVIA · ZS · Trinity · Veeva · TriNetX · EVERSANA</a:t>
-            </a:r>
-            <a:endParaRPr lang="en-US" sz="1050" dirty="0"/>
-          </a:p>
-          <a:p>
-            <a:pPr indent="0" marL="0">
-              <a:spcBef>
-                <a:spcPts val="400"/>
-              </a:spcBef>
-              <a:buNone/>
-            </a:pPr>
-            <a:r>
-              <a:rPr lang="en-US" sz="900" b="1" dirty="0">
-                <a:solidFill>
-                  <a:srgbClr val="7A7C7E"/>
-                </a:solidFill>
-              </a:rPr>
-              <a:t>International: </a:t>
-            </a:r>
-            <a:r>
-              <a:rPr lang="en-US" sz="900" dirty="0">
-                <a:solidFill>
-                  <a:srgbClr val="7A7C7E"/>
-                </a:solidFill>
-              </a:rPr>
-              <a:t>Briya · BC Platforms · MDClone · GBI Health · Prospection · Close-Up International · Ipsos · Evidenze</a:t>
-            </a:r>
-            <a:endParaRPr lang="en-US" sz="1050" dirty="0"/>
-          </a:p>
-        </p:txBody>
-      </p:sp>
-      <p:sp>
-        <p:nvSpPr>
-          <p:cNvPr id="35" name="link legend"/>
-          <p:cNvSpPr txBox="1"/>
-          <p:nvPr/>
-        </p:nvSpPr>
-        <p:spPr>
-          <a:xfrm>
-            <a:off x="2944368" y="6309360"/>
-            <a:ext cx="4572000" cy="201168"/>
-          </a:xfrm>
-          <a:prstGeom prst="rect">
-            <a:avLst/>
-          </a:prstGeom>
-          <a:noFill/>
-        </p:spPr>
-        <p:txBody>
-          <a:bodyPr wrap="square" lIns="0" tIns="0" rIns="0" bIns="0" anchor="ctr">
-            <a:spAutoFit/>
-          </a:bodyPr>
-          <a:lstStyle/>
-          <a:p>
-            <a:r>
-              <a:rPr sz="900">
-                <a:solidFill>
-                  <a:schemeClr val="accent4"/>
-                </a:solidFill>
-              </a:rPr>
-              <a:t>·  Underlined text links to public sources</a:t>
-            </a:r>
-          </a:p>
-        </p:txBody>
-      </p:sp>
-      <p:sp>
-        <p:nvSpPr>
-          <p:cNvPr id="9715" name="Invisible source link 14: https://www.veeva.com/products/vault-ai/">
-            <a:hlinkClick r:id="rId2"/>
+          <p:cNvPr id="9712" name="Invisible source link 14: https://www.iqvia.com/newsroom/2026/03/iqvia-unveils-iqvia-ai-a-unified-agentic-ai-platform">
+            <a:hlinkClick r:id="rId3"/>
           </p:cNvPr>
           <p:cNvSpPr/>
           <p:nvPr/>
         </p:nvSpPr>
         <p:spPr>
           <a:xfrm>
-            <a:off x="2669755" y="2232197"/>
-            <a:ext cx="2432439" cy="141817"/>
+            <a:off x="2395435" y="2040053"/>
+            <a:ext cx="923333" cy="134588"/>
           </a:xfrm>
           <a:prstGeom prst="rect">
             <a:avLst/>
@@ -4962,16 +5086,16 @@
       </p:sp>
       <p:sp>
         <p:nvSpPr>
-          <p:cNvPr id="9716" name="Invisible source link 14: https://www.iqvia.com/newsroom/2026/03/iqvia-unveils-iqvia-ai-a-unified-agentic-ai-platform">
-            <a:hlinkClick r:id="rId3"/>
+          <p:cNvPr id="9713" name="Invisible source link 14: https://www.iqvia.com/blogs/2025/12/introducing-iqvia-med-r1-deep-research-agent">
+            <a:hlinkClick r:id="rId4"/>
           </p:cNvPr>
           <p:cNvSpPr/>
           <p:nvPr/>
         </p:nvSpPr>
         <p:spPr>
           <a:xfrm>
-            <a:off x="5137200" y="2232197"/>
-            <a:ext cx="1848874" cy="141817"/>
+            <a:off x="2395435" y="2194853"/>
+            <a:ext cx="897767" cy="134588"/>
           </a:xfrm>
           <a:prstGeom prst="rect">
             <a:avLst/>
@@ -5005,16 +5129,16 @@
       </p:sp>
       <p:sp>
         <p:nvSpPr>
-          <p:cNvPr id="9717" name="Invisible source link 14: https://www.iqvia.com/blogs/2025/12/introducing-iqvia-med-r1-deep-research-agent">
-            <a:hlinkClick r:id="rId4"/>
+          <p:cNvPr id="9714" name="Invisible source link 14: https://lens.tempus.com/">
+            <a:hlinkClick r:id="rId5"/>
           </p:cNvPr>
           <p:cNvSpPr/>
           <p:nvPr/>
         </p:nvSpPr>
         <p:spPr>
           <a:xfrm>
-            <a:off x="8328596" y="2232197"/>
-            <a:ext cx="582898" cy="141817"/>
+            <a:off x="2395435" y="2349653"/>
+            <a:ext cx="853495" cy="134588"/>
           </a:xfrm>
           <a:prstGeom prst="rect">
             <a:avLst/>
@@ -5048,16 +5172,16 @@
       </p:sp>
       <p:sp>
         <p:nvSpPr>
-          <p:cNvPr id="9719" name="Invisible source link 14: https://www.iqvia.com/blogs/2025/12/introducing-iqvia-med-r1-deep-research-agent">
-            <a:hlinkClick r:id="rId4"/>
+          <p:cNvPr id="9715" name="Invisible source link 14: https://www.komodohealth.com/product/healthcare-map/">
+            <a:hlinkClick r:id="rId6"/>
           </p:cNvPr>
           <p:cNvSpPr/>
           <p:nvPr/>
         </p:nvSpPr>
         <p:spPr>
           <a:xfrm>
-            <a:off x="2669755" y="2374030"/>
-            <a:ext cx="484843" cy="141817"/>
+            <a:off x="2395435" y="2633702"/>
+            <a:ext cx="1869775" cy="134588"/>
           </a:xfrm>
           <a:prstGeom prst="rect">
             <a:avLst/>
@@ -5091,16 +5215,16 @@
       </p:sp>
       <p:sp>
         <p:nvSpPr>
-          <p:cNvPr id="9719" name="Invisible source link 14: https://lens.tempus.com/">
-            <a:hlinkClick r:id="rId5"/>
+          <p:cNvPr id="9716" name="Invisible source link 14: https://www.komodohealth.com/press/komodo-health-introduces-marmot-the-ai-built-to-accelerate-healthcare-innovation/">
+            <a:hlinkClick r:id="rId7"/>
           </p:cNvPr>
           <p:cNvSpPr/>
           <p:nvPr/>
         </p:nvSpPr>
         <p:spPr>
           <a:xfrm>
-            <a:off x="3189605" y="2374030"/>
-            <a:ext cx="3198507" cy="141817"/>
+            <a:off x="2395435" y="2788502"/>
+            <a:ext cx="1415813" cy="134588"/>
           </a:xfrm>
           <a:prstGeom prst="rect">
             <a:avLst/>
@@ -5134,16 +5258,16 @@
       </p:sp>
       <p:sp>
         <p:nvSpPr>
-          <p:cNvPr id="9720" name="Invisible source link 14: https://www.komodohealth.com/product/healthcare-map/">
-            <a:hlinkClick r:id="rId6"/>
+          <p:cNvPr id="9717" name="Invisible source link 14: https://www.truveta.com/blog/data/approach-to-real-world-data-quality/">
+            <a:hlinkClick r:id="rId8"/>
           </p:cNvPr>
           <p:cNvSpPr/>
           <p:nvPr/>
         </p:nvSpPr>
         <p:spPr>
           <a:xfrm>
-            <a:off x="3421075" y="2665635"/>
-            <a:ext cx="2720450" cy="141817"/>
+            <a:off x="2395435" y="2943302"/>
+            <a:ext cx="1277205" cy="134588"/>
           </a:xfrm>
           <a:prstGeom prst="rect">
             <a:avLst/>
@@ -5177,16 +5301,16 @@
       </p:sp>
       <p:sp>
         <p:nvSpPr>
-          <p:cNvPr id="9721" name="Invisible source link 14: https://www.komodohealth.com/press/komodo-health-introduces-marmot-the-ai-built-to-accelerate-healthcare-innovation/">
-            <a:hlinkClick r:id="rId7"/>
+          <p:cNvPr id="9718" name="Invisible source link 14: https://www.norstella.com/press-releases/norstella-introduces-norstellalinq/">
+            <a:hlinkClick r:id="rId9"/>
           </p:cNvPr>
           <p:cNvSpPr/>
           <p:nvPr/>
         </p:nvSpPr>
         <p:spPr>
           <a:xfrm>
-            <a:off x="6443281" y="2665635"/>
-            <a:ext cx="2447360" cy="141817"/>
+            <a:off x="2395435" y="3098103"/>
+            <a:ext cx="1414365" cy="134588"/>
           </a:xfrm>
           <a:prstGeom prst="rect">
             <a:avLst/>
@@ -5220,16 +5344,16 @@
       </p:sp>
       <p:sp>
         <p:nvSpPr>
-          <p:cNvPr id="9722" name="Invisible source link 14: https://www.truveta.com/blog/data/approach-to-real-world-data-quality/">
-            <a:hlinkClick r:id="rId8"/>
+          <p:cNvPr id="9719" name="Invisible source link 14: https://www.komodohealth.com/perspectives/building-the-framework-for-trusted-ai-in-healthcare/">
+            <a:hlinkClick r:id="rId10"/>
           </p:cNvPr>
           <p:cNvSpPr/>
           <p:nvPr/>
         </p:nvSpPr>
         <p:spPr>
           <a:xfrm>
-            <a:off x="3195713" y="2845632"/>
-            <a:ext cx="3521916" cy="141817"/>
+            <a:off x="2395435" y="3382138"/>
+            <a:ext cx="1415813" cy="134588"/>
           </a:xfrm>
           <a:prstGeom prst="rect">
             <a:avLst/>
@@ -5263,16 +5387,16 @@
       </p:sp>
       <p:sp>
         <p:nvSpPr>
-          <p:cNvPr id="9723" name="Invisible source link 14: https://www.norstella.com/press-releases/norstella-introduces-norstellalinq/">
-            <a:hlinkClick r:id="rId9"/>
+          <p:cNvPr id="9720" name="Invisible source link 14: https://healthverity.com/exos/">
+            <a:hlinkClick r:id="rId11"/>
           </p:cNvPr>
           <p:cNvSpPr/>
           <p:nvPr/>
         </p:nvSpPr>
         <p:spPr>
           <a:xfrm>
-            <a:off x="3287153" y="3025629"/>
-            <a:ext cx="5327542" cy="141817"/>
+            <a:off x="2395435" y="3536938"/>
+            <a:ext cx="1107648" cy="134588"/>
           </a:xfrm>
           <a:prstGeom prst="rect">
             <a:avLst/>
@@ -5306,16 +5430,16 @@
       </p:sp>
       <p:sp>
         <p:nvSpPr>
-          <p:cNvPr id="9724" name="Invisible source link 14: https://www.komodohealth.com/perspectives/building-the-framework-for-trusted-ai-in-healthcare/">
-            <a:hlinkClick r:id="rId10"/>
+          <p:cNvPr id="9721" name="Invisible source link 14: https://clinicaldata.veevavault.help/en/lr/rn/limited-releases/26r3/new-features/">
+            <a:hlinkClick r:id="rId12"/>
           </p:cNvPr>
           <p:cNvSpPr/>
           <p:nvPr/>
         </p:nvSpPr>
         <p:spPr>
           <a:xfrm>
-            <a:off x="3259442" y="3317234"/>
-            <a:ext cx="1974799" cy="141817"/>
+            <a:off x="2395435" y="3691739"/>
+            <a:ext cx="1127447" cy="134588"/>
           </a:xfrm>
           <a:prstGeom prst="rect">
             <a:avLst/>
@@ -5349,16 +5473,16 @@
       </p:sp>
       <p:sp>
         <p:nvSpPr>
-          <p:cNvPr id="9725" name="Invisible source link 14: https://healthverity.com/exos/">
-            <a:hlinkClick r:id="rId11"/>
+          <p:cNvPr id="9722" name="Invisible source link 14: https://veranahealth.com/verana-health-introduces-new-ai-agents-to-expedite-and-streamline-rd-tasks/">
+            <a:hlinkClick r:id="rId13"/>
           </p:cNvPr>
           <p:cNvSpPr/>
           <p:nvPr/>
         </p:nvSpPr>
         <p:spPr>
           <a:xfrm>
-            <a:off x="3936237" y="3497231"/>
-            <a:ext cx="2825114" cy="141817"/>
+            <a:off x="2395435" y="4130574"/>
+            <a:ext cx="1623166" cy="134588"/>
           </a:xfrm>
           <a:prstGeom prst="rect">
             <a:avLst/>
@@ -5392,16 +5516,16 @@
       </p:sp>
       <p:sp>
         <p:nvSpPr>
-          <p:cNvPr id="9726" name="Invisible source link 14: https://clinicaldata.veevavault.help/en/lr/rn/limited-releases/26r3/new-features/">
-            <a:hlinkClick r:id="rId12"/>
+          <p:cNvPr id="9723" name="Invisible source link 14: https://www.zs.com/about/newsroom/zs-press-salesforce-zaidyn-crm">
+            <a:hlinkClick r:id="rId14"/>
           </p:cNvPr>
           <p:cNvSpPr/>
           <p:nvPr/>
         </p:nvSpPr>
         <p:spPr>
           <a:xfrm>
-            <a:off x="2669755" y="3677241"/>
-            <a:ext cx="3365486" cy="141817"/>
+            <a:off x="2395435" y="4285375"/>
+            <a:ext cx="753051" cy="134588"/>
           </a:xfrm>
           <a:prstGeom prst="rect">
             <a:avLst/>
@@ -5435,16 +5559,16 @@
       </p:sp>
       <p:sp>
         <p:nvSpPr>
-          <p:cNvPr id="9727" name="Invisible source link 14: https://veranahealth.com/verana-health-introduces-new-ai-agents-to-expedite-and-streamline-rd-tasks/">
-            <a:hlinkClick r:id="rId13"/>
+          <p:cNvPr id="9724" name="Invisible source link 14: https://trinetx.com/blog/trinetx-named-best-of-show-finalist-at-scope-advancing-clinical-trial-planning-with-conversational-ai-and-enhanced-api-capabilities/">
+            <a:hlinkClick r:id="rId15"/>
           </p:cNvPr>
           <p:cNvSpPr/>
           <p:nvPr/>
         </p:nvSpPr>
         <p:spPr>
           <a:xfrm>
-            <a:off x="2669755" y="4195630"/>
-            <a:ext cx="476918" cy="141817"/>
+            <a:off x="2395435" y="4440175"/>
+            <a:ext cx="1051488" cy="134588"/>
           </a:xfrm>
           <a:prstGeom prst="rect">
             <a:avLst/>
@@ -5478,16 +5602,16 @@
       </p:sp>
       <p:sp>
         <p:nvSpPr>
-          <p:cNvPr id="9728" name="Invisible source link 14: https://www.zs.com/about/newsroom/zs-press-salesforce-zaidyn-crm">
-            <a:hlinkClick r:id="rId14"/>
+          <p:cNvPr id="9725" name="Invisible source link 14: https://healthverity.com/news/announcing-healthverity-exos/">
+            <a:hlinkClick r:id="rId16"/>
           </p:cNvPr>
           <p:cNvSpPr/>
           <p:nvPr/>
         </p:nvSpPr>
         <p:spPr>
           <a:xfrm>
-            <a:off x="3181680" y="4195630"/>
-            <a:ext cx="196845" cy="141817"/>
+            <a:off x="749515" y="5375216"/>
+            <a:ext cx="2400886" cy="148648"/>
           </a:xfrm>
           <a:prstGeom prst="rect">
             <a:avLst/>
@@ -5521,16 +5645,16 @@
       </p:sp>
       <p:sp>
         <p:nvSpPr>
-          <p:cNvPr id="9729" name="Invisible source link 14: https://trinetx.com/blog/trinetx-named-best-of-show-finalist-at-scope-advancing-clinical-trial-planning-with-conversational-ai-and-enhanced-api-capabilities/">
-            <a:hlinkClick r:id="rId15"/>
+          <p:cNvPr id="9726" name="Invisible source link 14: https://medeloop.ai/analytics">
+            <a:hlinkClick r:id="rId17"/>
           </p:cNvPr>
           <p:cNvSpPr/>
           <p:nvPr/>
         </p:nvSpPr>
         <p:spPr>
           <a:xfrm>
-            <a:off x="3413518" y="4195630"/>
-            <a:ext cx="466039" cy="141817"/>
+            <a:off x="1720659" y="5535058"/>
+            <a:ext cx="3864068" cy="148648"/>
           </a:xfrm>
           <a:prstGeom prst="rect">
             <a:avLst/>
@@ -5564,16 +5688,16 @@
       </p:sp>
       <p:sp>
         <p:nvSpPr>
-          <p:cNvPr id="9730" name="Invisible source link 14: https://healthverity.com/news/announcing-healthverity-exos/">
-            <a:hlinkClick r:id="rId16"/>
+          <p:cNvPr id="9728" name="Invisible source link 14: https://medeloop.ai/analytics">
+            <a:hlinkClick r:id="rId17"/>
           </p:cNvPr>
           <p:cNvSpPr/>
           <p:nvPr/>
         </p:nvSpPr>
         <p:spPr>
           <a:xfrm>
-            <a:off x="3931564" y="5169440"/>
-            <a:ext cx="2293852" cy="141817"/>
+            <a:off x="749515" y="5694900"/>
+            <a:ext cx="1016193" cy="148648"/>
           </a:xfrm>
           <a:prstGeom prst="rect">
             <a:avLst/>
@@ -5607,16 +5731,16 @@
       </p:sp>
       <p:sp>
         <p:nvSpPr>
-          <p:cNvPr id="9731" name="Invisible source link 14: https://medeloop.ai/analytics">
-            <a:hlinkClick r:id="rId17"/>
+          <p:cNvPr id="9728" name="Invisible source link 14: https://veranahealth.com/verana-health-introduces-new-ai-agents-to-expedite-and-streamline-rd-tasks/">
+            <a:hlinkClick r:id="rId13"/>
           </p:cNvPr>
           <p:cNvSpPr/>
           <p:nvPr/>
         </p:nvSpPr>
         <p:spPr>
           <a:xfrm>
-            <a:off x="6299121" y="5322081"/>
-            <a:ext cx="870474" cy="141817"/>
+            <a:off x="8399881" y="5375216"/>
+            <a:ext cx="2629147" cy="148648"/>
           </a:xfrm>
           <a:prstGeom prst="rect">
             <a:avLst/>
@@ -5650,16 +5774,16 @@
       </p:sp>
       <p:sp>
         <p:nvSpPr>
-          <p:cNvPr id="9733" name="Invisible source link 14: https://medeloop.ai/analytics">
-            <a:hlinkClick r:id="rId17"/>
+          <p:cNvPr id="9729" name="Invisible source link 14: https://www.zs.com/about/newsroom/zs-press-salesforce-zaidyn-crm">
+            <a:hlinkClick r:id="rId14"/>
           </p:cNvPr>
           <p:cNvSpPr/>
           <p:nvPr/>
         </p:nvSpPr>
         <p:spPr>
           <a:xfrm>
-            <a:off x="3931564" y="5474710"/>
-            <a:ext cx="3249592" cy="141817"/>
+            <a:off x="8754607" y="5535058"/>
+            <a:ext cx="2633983" cy="148648"/>
           </a:xfrm>
           <a:prstGeom prst="rect">
             <a:avLst/>
@@ -5693,136 +5817,7 @@
       </p:sp>
       <p:sp>
         <p:nvSpPr>
-          <p:cNvPr id="9735" name="Invisible source link 14: https://medeloop.ai/analytics">
-            <a:hlinkClick r:id="rId17"/>
-          </p:cNvPr>
-          <p:cNvSpPr/>
-          <p:nvPr/>
-        </p:nvSpPr>
-        <p:spPr>
-          <a:xfrm>
-            <a:off x="3931564" y="5627351"/>
-            <a:ext cx="540558" cy="141817"/>
-          </a:xfrm>
-          <a:prstGeom prst="rect">
-            <a:avLst/>
-          </a:prstGeom>
-          <a:noFill/>
-          <a:ln>
-            <a:noFill/>
-          </a:ln>
-        </p:spPr>
-        <p:style>
-          <a:lnRef idx="1">
-            <a:schemeClr val="accent1"/>
-          </a:lnRef>
-          <a:fillRef idx="3">
-            <a:schemeClr val="accent1"/>
-          </a:fillRef>
-          <a:effectRef idx="2">
-            <a:schemeClr val="accent1"/>
-          </a:effectRef>
-          <a:fontRef idx="minor">
-            <a:schemeClr val="lt1"/>
-          </a:fontRef>
-        </p:style>
-        <p:txBody>
-          <a:bodyPr rtlCol="0" anchor="ctr"/>
-          <a:lstStyle/>
-          <a:p>
-            <a:pPr algn="ctr"/>
-          </a:p>
-        </p:txBody>
-      </p:sp>
-      <p:sp>
-        <p:nvSpPr>
-          <p:cNvPr id="9734" name="Invisible source link 14: https://veranahealth.com/verana-health-introduces-new-ai-agents-to-expedite-and-streamline-rd-tasks/">
-            <a:hlinkClick r:id="rId13"/>
-          </p:cNvPr>
-          <p:cNvSpPr/>
-          <p:nvPr/>
-        </p:nvSpPr>
-        <p:spPr>
-          <a:xfrm>
-            <a:off x="9890277" y="5169440"/>
-            <a:ext cx="1271143" cy="141817"/>
-          </a:xfrm>
-          <a:prstGeom prst="rect">
-            <a:avLst/>
-          </a:prstGeom>
-          <a:noFill/>
-          <a:ln>
-            <a:noFill/>
-          </a:ln>
-        </p:spPr>
-        <p:style>
-          <a:lnRef idx="1">
-            <a:schemeClr val="accent1"/>
-          </a:lnRef>
-          <a:fillRef idx="3">
-            <a:schemeClr val="accent1"/>
-          </a:fillRef>
-          <a:effectRef idx="2">
-            <a:schemeClr val="accent1"/>
-          </a:effectRef>
-          <a:fontRef idx="minor">
-            <a:schemeClr val="lt1"/>
-          </a:fontRef>
-        </p:style>
-        <p:txBody>
-          <a:bodyPr rtlCol="0" anchor="ctr"/>
-          <a:lstStyle/>
-          <a:p>
-            <a:pPr algn="ctr"/>
-          </a:p>
-        </p:txBody>
-      </p:sp>
-      <p:sp>
-        <p:nvSpPr>
-          <p:cNvPr id="9736" name="Invisible source link 14: https://veranahealth.com/verana-health-introduces-new-ai-agents-to-expedite-and-streamline-rd-tasks/">
-            <a:hlinkClick r:id="rId13"/>
-          </p:cNvPr>
-          <p:cNvSpPr/>
-          <p:nvPr/>
-        </p:nvSpPr>
-        <p:spPr>
-          <a:xfrm>
-            <a:off x="7968602" y="5322081"/>
-            <a:ext cx="1200429" cy="141817"/>
-          </a:xfrm>
-          <a:prstGeom prst="rect">
-            <a:avLst/>
-          </a:prstGeom>
-          <a:noFill/>
-          <a:ln>
-            <a:noFill/>
-          </a:ln>
-        </p:spPr>
-        <p:style>
-          <a:lnRef idx="1">
-            <a:schemeClr val="accent1"/>
-          </a:lnRef>
-          <a:fillRef idx="3">
-            <a:schemeClr val="accent1"/>
-          </a:fillRef>
-          <a:effectRef idx="2">
-            <a:schemeClr val="accent1"/>
-          </a:effectRef>
-          <a:fontRef idx="minor">
-            <a:schemeClr val="lt1"/>
-          </a:fontRef>
-        </p:style>
-        <p:txBody>
-          <a:bodyPr rtlCol="0" anchor="ctr"/>
-          <a:lstStyle/>
-          <a:p>
-            <a:pPr algn="ctr"/>
-          </a:p>
-        </p:txBody>
-      </p:sp>
-      <p:sp>
-        <p:nvSpPr>
-          <p:cNvPr id="9736" name="Invisible source link 14: https://www.zs.com/about/newsroom/zs-press-salesforce-zaidyn-crm">
+          <p:cNvPr id="9731" name="Invisible source link 14: https://www.zs.com/about/newsroom/zs-press-salesforce-zaidyn-crm">
             <a:hlinkClick r:id="rId14"/>
           </p:cNvPr>
           <p:cNvSpPr/>
@@ -5830,51 +5825,8 @@
         </p:nvSpPr>
         <p:spPr>
           <a:xfrm>
-            <a:off x="8474492" y="5474710"/>
-            <a:ext cx="2513086" cy="141817"/>
-          </a:xfrm>
-          <a:prstGeom prst="rect">
-            <a:avLst/>
-          </a:prstGeom>
-          <a:noFill/>
-          <a:ln>
-            <a:noFill/>
-          </a:ln>
-        </p:spPr>
-        <p:style>
-          <a:lnRef idx="1">
-            <a:schemeClr val="accent1"/>
-          </a:lnRef>
-          <a:fillRef idx="3">
-            <a:schemeClr val="accent1"/>
-          </a:fillRef>
-          <a:effectRef idx="2">
-            <a:schemeClr val="accent1"/>
-          </a:effectRef>
-          <a:fontRef idx="minor">
-            <a:schemeClr val="lt1"/>
-          </a:fontRef>
-        </p:style>
-        <p:txBody>
-          <a:bodyPr rtlCol="0" anchor="ctr"/>
-          <a:lstStyle/>
-          <a:p>
-            <a:pPr algn="ctr"/>
-          </a:p>
-        </p:txBody>
-      </p:sp>
-      <p:sp>
-        <p:nvSpPr>
-          <p:cNvPr id="9738" name="Invisible source link 14: https://www.zs.com/about/newsroom/zs-press-salesforce-zaidyn-crm">
-            <a:hlinkClick r:id="rId14"/>
-          </p:cNvPr>
-          <p:cNvSpPr/>
-          <p:nvPr/>
-        </p:nvSpPr>
-        <p:spPr>
-          <a:xfrm>
-            <a:off x="7968602" y="5627351"/>
-            <a:ext cx="645676" cy="141817"/>
+            <a:off x="6386753" y="5694900"/>
+            <a:ext cx="677788" cy="148648"/>
           </a:xfrm>
           <a:prstGeom prst="rect">
             <a:avLst/>

</xml_diff>

<commit_message>
10.16: one line per competitor on slide 10; centred, restyled columns on slide 11
Co-Authored-By: Claude Opus 5.5 <noreply@anthropic.com>
Claude-Session: https://claude.ai/code/session_0198bm9pfzRwgZQBqNvd56W8
</commit_message>
<xml_diff>
--- a/deck/Optum-LS-Conversational-AI-10.16.pptx
+++ b/deck/Optum-LS-Conversational-AI-10.16.pptx
@@ -3550,7 +3550,7 @@
                   </a:tcPr>
                 </a:tc>
               </a:tr>
-              <a:tr h="748506">
+              <a:tr h="663181">
                 <a:tc>
                   <a:txBody>
                     <a:bodyPr/>
@@ -3653,7 +3653,7 @@
                     <a:p>
                       <a:pPr indent="0" marL="0">
                         <a:spcBef>
-                          <a:spcPts val="150"/>
+                          <a:spcPts val="400"/>
                         </a:spcBef>
                         <a:buNone/>
                       </a:pPr>
@@ -3689,57 +3689,35 @@
                             <a:schemeClr val="tx1"/>
                           </a:solidFill>
                         </a:rPr>
-                        <a:t>: NVIDIA Nemotron;</a:t>
+                        <a:t>: NVIDIA Nemotron; </a:t>
+                      </a:r>
+                      <a:r>
+                        <a:rPr lang="en-US" sz="950" dirty="0" b="1" u="sng">
+                          <a:solidFill>
+                            <a:srgbClr val="002677"/>
+                          </a:solidFill>
+                          <a:uFill>
+                            <a:solidFill>
+                              <a:srgbClr val="9AA8CC"/>
+                            </a:solidFill>
+                          </a:uFill>
+                        </a:rPr>
+                        <a:t>Med-R1</a:t>
+                      </a:r>
+                      <a:r>
+                        <a:rPr lang="en-US" sz="950" dirty="0">
+                          <a:solidFill>
+                            <a:schemeClr val="tx1"/>
+                          </a:solidFill>
+                        </a:rPr>
+                        <a:t>: developed separately;</a:t>
                       </a:r>
                       <a:endParaRPr lang="en-US" sz="950" dirty="0"/>
                     </a:p>
                     <a:p>
                       <a:pPr indent="0" marL="0">
                         <a:spcBef>
-                          <a:spcPts val="150"/>
-                        </a:spcBef>
-                        <a:buNone/>
-                      </a:pPr>
-                      <a:r>
-                        <a:rPr lang="en-US" sz="950" dirty="0" u="sng">
-                          <a:solidFill>
-                            <a:srgbClr val="002677"/>
-                          </a:solidFill>
-                          <a:uFill>
-                            <a:solidFill>
-                              <a:srgbClr val="9AA8CC"/>
-                            </a:solidFill>
-                          </a:uFill>
-                        </a:rPr>
-                        <a:t>IQVIA’s </a:t>
-                      </a:r>
-                      <a:r>
-                        <a:rPr lang="en-US" sz="950" dirty="0" b="1" u="sng">
-                          <a:solidFill>
-                            <a:srgbClr val="002677"/>
-                          </a:solidFill>
-                          <a:uFill>
-                            <a:solidFill>
-                              <a:srgbClr val="9AA8CC"/>
-                            </a:solidFill>
-                          </a:uFill>
-                        </a:rPr>
-                        <a:t>Med-R1</a:t>
-                      </a:r>
-                      <a:r>
-                        <a:rPr lang="en-US" sz="950" dirty="0">
-                          <a:solidFill>
-                            <a:schemeClr val="tx1"/>
-                          </a:solidFill>
-                        </a:rPr>
-                        <a:t>: developed separately by IQVIA;</a:t>
-                      </a:r>
-                      <a:endParaRPr lang="en-US" sz="950" dirty="0"/>
-                    </a:p>
-                    <a:p>
-                      <a:pPr indent="0" marL="0">
-                        <a:spcBef>
-                          <a:spcPts val="150"/>
+                          <a:spcPts val="400"/>
                         </a:spcBef>
                         <a:buNone/>
                       </a:pPr>
@@ -3842,7 +3820,7 @@
                   </a:tcPr>
                 </a:tc>
               </a:tr>
-              <a:tr h="748506">
+              <a:tr h="663181">
                 <a:tc>
                   <a:txBody>
                     <a:bodyPr/>
@@ -3953,14 +3931,35 @@
                             <a:schemeClr val="tx1"/>
                           </a:solidFill>
                         </a:rPr>
-                        <a:t>: de-identified patient journeys;</a:t>
+                        <a:t>: de-identified patient journeys; </a:t>
+                      </a:r>
+                      <a:r>
+                        <a:rPr lang="en-US" sz="950" dirty="0" b="1" u="sng">
+                          <a:solidFill>
+                            <a:srgbClr val="002677"/>
+                          </a:solidFill>
+                          <a:uFill>
+                            <a:solidFill>
+                              <a:srgbClr val="9AA8CC"/>
+                            </a:solidFill>
+                          </a:uFill>
+                        </a:rPr>
+                        <a:t>Marmot</a:t>
+                      </a:r>
+                      <a:r>
+                        <a:rPr lang="en-US" sz="950" dirty="0">
+                          <a:solidFill>
+                            <a:schemeClr val="tx1"/>
+                          </a:solidFill>
+                        </a:rPr>
+                        <a:t>: a knowledge graph built from prior analyses;</a:t>
                       </a:r>
                       <a:endParaRPr lang="en-US" sz="950" dirty="0"/>
                     </a:p>
                     <a:p>
                       <a:pPr indent="0" marL="0">
                         <a:spcBef>
-                          <a:spcPts val="150"/>
+                          <a:spcPts val="400"/>
                         </a:spcBef>
                         <a:buNone/>
                       </a:pPr>
@@ -3975,7 +3974,7 @@
                             </a:solidFill>
                           </a:uFill>
                         </a:rPr>
-                        <a:t>Komodo Health’s </a:t>
+                        <a:t>Truveta’s </a:t>
                       </a:r>
                       <a:r>
                         <a:rPr lang="en-US" sz="950" dirty="0" b="1" u="sng">
@@ -3988,7 +3987,7 @@
                             </a:solidFill>
                           </a:uFill>
                         </a:rPr>
-                        <a:t>Marmot</a:t>
+                        <a:t>Truveta Data</a:t>
                       </a:r>
                       <a:r>
                         <a:rPr lang="en-US" sz="950" dirty="0">
@@ -3996,57 +3995,14 @@
                             <a:schemeClr val="tx1"/>
                           </a:solidFill>
                         </a:rPr>
-                        <a:t>: a knowledge graph built from prior analyses;</a:t>
+                        <a:t>: continuously refreshed EHR data from member health systems;</a:t>
                       </a:r>
                       <a:endParaRPr lang="en-US" sz="950" dirty="0"/>
                     </a:p>
                     <a:p>
                       <a:pPr indent="0" marL="0">
                         <a:spcBef>
-                          <a:spcPts val="150"/>
-                        </a:spcBef>
-                        <a:buNone/>
-                      </a:pPr>
-                      <a:r>
-                        <a:rPr lang="en-US" sz="950" dirty="0" u="sng">
-                          <a:solidFill>
-                            <a:srgbClr val="002677"/>
-                          </a:solidFill>
-                          <a:uFill>
-                            <a:solidFill>
-                              <a:srgbClr val="9AA8CC"/>
-                            </a:solidFill>
-                          </a:uFill>
-                        </a:rPr>
-                        <a:t>Truveta’s </a:t>
-                      </a:r>
-                      <a:r>
-                        <a:rPr lang="en-US" sz="950" dirty="0" b="1" u="sng">
-                          <a:solidFill>
-                            <a:srgbClr val="002677"/>
-                          </a:solidFill>
-                          <a:uFill>
-                            <a:solidFill>
-                              <a:srgbClr val="9AA8CC"/>
-                            </a:solidFill>
-                          </a:uFill>
-                        </a:rPr>
-                        <a:t>Truveta Data</a:t>
-                      </a:r>
-                      <a:r>
-                        <a:rPr lang="en-US" sz="950" dirty="0">
-                          <a:solidFill>
-                            <a:schemeClr val="tx1"/>
-                          </a:solidFill>
-                        </a:rPr>
-                        <a:t>: continuously refreshed EHR data from member health systems;</a:t>
-                      </a:r>
-                      <a:endParaRPr lang="en-US" sz="950" dirty="0"/>
-                    </a:p>
-                    <a:p>
-                      <a:pPr indent="0" marL="0">
-                        <a:spcBef>
-                          <a:spcPts val="150"/>
+                          <a:spcPts val="400"/>
                         </a:spcBef>
                         <a:buNone/>
                       </a:pPr>
@@ -4149,7 +4105,7 @@
                   </a:tcPr>
                 </a:tc>
               </a:tr>
-              <a:tr h="593693">
+              <a:tr h="663181">
                 <a:tc>
                   <a:txBody>
                     <a:bodyPr/>
@@ -4267,7 +4223,7 @@
                     <a:p>
                       <a:pPr indent="0" marL="0">
                         <a:spcBef>
-                          <a:spcPts val="150"/>
+                          <a:spcPts val="400"/>
                         </a:spcBef>
                         <a:buNone/>
                       </a:pPr>
@@ -4310,7 +4266,7 @@
                     <a:p>
                       <a:pPr indent="0" marL="0">
                         <a:spcBef>
-                          <a:spcPts val="150"/>
+                          <a:spcPts val="400"/>
                         </a:spcBef>
                         <a:buNone/>
                       </a:pPr>
@@ -4413,7 +4369,7 @@
                   </a:tcPr>
                 </a:tc>
               </a:tr>
-              <a:tr h="748506">
+              <a:tr h="849668">
                 <a:tc>
                   <a:txBody>
                     <a:bodyPr/>
@@ -4490,7 +4446,7 @@
                     <a:p>
                       <a:pPr indent="0" marL="0">
                         <a:spcBef>
-                          <a:spcPts val="150"/>
+                          <a:spcPts val="400"/>
                         </a:spcBef>
                         <a:buNone/>
                       </a:pPr>
@@ -4533,7 +4489,7 @@
                     <a:p>
                       <a:pPr indent="0" marL="0">
                         <a:spcBef>
-                          <a:spcPts val="150"/>
+                          <a:spcPts val="400"/>
                         </a:spcBef>
                         <a:buNone/>
                       </a:pPr>
@@ -4576,7 +4532,7 @@
                     <a:p>
                       <a:pPr indent="0" marL="0">
                         <a:spcBef>
-                          <a:spcPts val="150"/>
+                          <a:spcPts val="400"/>
                         </a:spcBef>
                         <a:buNone/>
                       </a:pPr>
@@ -5008,7 +4964,7 @@
         </p:nvSpPr>
         <p:spPr>
           <a:xfrm>
-            <a:off x="2395435" y="1885253"/>
+            <a:off x="2395435" y="1888135"/>
             <a:ext cx="921885" cy="134588"/>
           </a:xfrm>
           <a:prstGeom prst="rect">
@@ -5051,7 +5007,7 @@
         </p:nvSpPr>
         <p:spPr>
           <a:xfrm>
-            <a:off x="2395435" y="2040053"/>
+            <a:off x="2395435" y="2074622"/>
             <a:ext cx="923333" cy="134588"/>
           </a:xfrm>
           <a:prstGeom prst="rect">
@@ -5094,8 +5050,8 @@
         </p:nvSpPr>
         <p:spPr>
           <a:xfrm>
-            <a:off x="2395435" y="2194853"/>
-            <a:ext cx="897767" cy="134588"/>
+            <a:off x="4375073" y="2074622"/>
+            <a:ext cx="467936" cy="134588"/>
           </a:xfrm>
           <a:prstGeom prst="rect">
             <a:avLst/>
@@ -5137,7 +5093,7 @@
         </p:nvSpPr>
         <p:spPr>
           <a:xfrm>
-            <a:off x="2395435" y="2349653"/>
+            <a:off x="2395435" y="2261096"/>
             <a:ext cx="853495" cy="134588"/>
           </a:xfrm>
           <a:prstGeom prst="rect">
@@ -5180,7 +5136,7 @@
         </p:nvSpPr>
         <p:spPr>
           <a:xfrm>
-            <a:off x="2395435" y="2633702"/>
+            <a:off x="2395435" y="2551253"/>
             <a:ext cx="1869775" cy="134588"/>
           </a:xfrm>
           <a:prstGeom prst="rect">
@@ -5223,8 +5179,8 @@
         </p:nvSpPr>
         <p:spPr>
           <a:xfrm>
-            <a:off x="2395435" y="2788502"/>
-            <a:ext cx="1415813" cy="134588"/>
+            <a:off x="5903645" y="2551253"/>
+            <a:ext cx="467923" cy="134588"/>
           </a:xfrm>
           <a:prstGeom prst="rect">
             <a:avLst/>
@@ -5266,7 +5222,7 @@
         </p:nvSpPr>
         <p:spPr>
           <a:xfrm>
-            <a:off x="2395435" y="2943302"/>
+            <a:off x="2395435" y="2737740"/>
             <a:ext cx="1277205" cy="134588"/>
           </a:xfrm>
           <a:prstGeom prst="rect">
@@ -5309,7 +5265,7 @@
         </p:nvSpPr>
         <p:spPr>
           <a:xfrm>
-            <a:off x="2395435" y="3098103"/>
+            <a:off x="2395435" y="2924214"/>
             <a:ext cx="1414365" cy="134588"/>
           </a:xfrm>
           <a:prstGeom prst="rect">
@@ -5352,7 +5308,7 @@
         </p:nvSpPr>
         <p:spPr>
           <a:xfrm>
-            <a:off x="2395435" y="3382138"/>
+            <a:off x="2395435" y="3214371"/>
             <a:ext cx="1415813" cy="134588"/>
           </a:xfrm>
           <a:prstGeom prst="rect">
@@ -5395,7 +5351,7 @@
         </p:nvSpPr>
         <p:spPr>
           <a:xfrm>
-            <a:off x="2395435" y="3536938"/>
+            <a:off x="2395435" y="3400858"/>
             <a:ext cx="1107648" cy="134588"/>
           </a:xfrm>
           <a:prstGeom prst="rect">
@@ -5438,7 +5394,7 @@
         </p:nvSpPr>
         <p:spPr>
           <a:xfrm>
-            <a:off x="2395435" y="3691739"/>
+            <a:off x="2395435" y="3587332"/>
             <a:ext cx="1127447" cy="134588"/>
           </a:xfrm>
           <a:prstGeom prst="rect">
@@ -5481,7 +5437,7 @@
         </p:nvSpPr>
         <p:spPr>
           <a:xfrm>
-            <a:off x="2395435" y="4130574"/>
+            <a:off x="2395435" y="4063976"/>
             <a:ext cx="1623166" cy="134588"/>
           </a:xfrm>
           <a:prstGeom prst="rect">
@@ -5524,7 +5480,7 @@
         </p:nvSpPr>
         <p:spPr>
           <a:xfrm>
-            <a:off x="2395435" y="4285375"/>
+            <a:off x="2395435" y="4250462"/>
             <a:ext cx="753051" cy="134588"/>
           </a:xfrm>
           <a:prstGeom prst="rect">
@@ -5567,7 +5523,7 @@
         </p:nvSpPr>
         <p:spPr>
           <a:xfrm>
-            <a:off x="2395435" y="4440175"/>
+            <a:off x="2395435" y="4436937"/>
             <a:ext cx="1051488" cy="134588"/>
           </a:xfrm>
           <a:prstGeom prst="rect">
@@ -6011,7 +5967,7 @@
         </p:nvGraphicFramePr>
         <p:xfrm>
           <a:off x="548640" y="2075688"/>
-          <a:ext cx="11091672" cy="2679190"/>
+          <a:ext cx="11091672" cy="2679191"/>
         </p:xfrm>
         <a:graphic>
           <a:graphicData uri="http://schemas.openxmlformats.org/drawingml/2006/table">
@@ -6029,7 +5985,7 @@
                     <a:bodyPr/>
                     <a:lstStyle/>
                     <a:p>
-                      <a:pPr indent="0" marL="0">
+                      <a:pPr indent="0" marL="0" algn="ctr">
                         <a:buNone/>
                       </a:pPr>
                       <a:r>
@@ -6066,7 +6022,7 @@
                     <a:bodyPr/>
                     <a:lstStyle/>
                     <a:p>
-                      <a:pPr indent="0" marL="0">
+                      <a:pPr indent="0" marL="0" algn="ctr">
                         <a:buNone/>
                       </a:pPr>
                       <a:r>
@@ -6103,7 +6059,7 @@
                     <a:bodyPr/>
                     <a:lstStyle/>
                     <a:p>
-                      <a:pPr indent="0" marL="0">
+                      <a:pPr indent="0" marL="0" algn="ctr">
                         <a:buNone/>
                       </a:pPr>
                       <a:r>
@@ -6140,7 +6096,7 @@
                     <a:bodyPr/>
                     <a:lstStyle/>
                     <a:p>
-                      <a:pPr indent="0" marL="0">
+                      <a:pPr indent="0" marL="0" algn="ctr">
                         <a:buNone/>
                       </a:pPr>
                       <a:r>
@@ -6173,13 +6129,13 @@
                   </a:tcPr>
                 </a:tc>
               </a:tr>
-              <a:tr h="878471">
+              <a:tr h="860230">
                 <a:tc>
                   <a:txBody>
                     <a:bodyPr/>
                     <a:lstStyle/>
                     <a:p>
-                      <a:pPr algn="l" indent="0" marL="0">
+                      <a:pPr algn="ctr" indent="0" marL="0">
                         <a:buNone/>
                       </a:pPr>
                       <a:r>
@@ -6234,13 +6190,13 @@
                     <a:bodyPr/>
                     <a:lstStyle/>
                     <a:p>
-                      <a:pPr indent="0" marL="0">
+                      <a:pPr indent="0" marL="0" algn="ctr">
                         <a:buNone/>
                       </a:pPr>
                       <a:r>
-                        <a:rPr lang="en-US" sz="900" dirty="0">
-                          <a:solidFill>
-                            <a:srgbClr val="002677"/>
+                        <a:rPr lang="en-US" sz="950" dirty="0" b="1">
+                          <a:solidFill>
+                            <a:srgbClr val="1A1A1A"/>
                           </a:solidFill>
                         </a:rPr>
                         <a:t>Interface</a:t>
@@ -6466,7 +6422,7 @@
                         <a:buNone/>
                       </a:pPr>
                       <a:r>
-                        <a:rPr lang="en-US" sz="900" dirty="0">
+                        <a:rPr lang="en-US" sz="1050" dirty="0">
                           <a:solidFill>
                             <a:schemeClr val="tx1"/>
                           </a:solidFill>
@@ -6498,13 +6454,13 @@
                   </a:tcPr>
                 </a:tc>
               </a:tr>
-              <a:tr h="699198">
+              <a:tr h="735681">
                 <a:tc>
                   <a:txBody>
                     <a:bodyPr/>
                     <a:lstStyle/>
                     <a:p>
-                      <a:pPr algn="l" indent="0" marL="0">
+                      <a:pPr algn="ctr" indent="0" marL="0">
                         <a:buNone/>
                       </a:pPr>
                       <a:r>
@@ -6559,13 +6515,13 @@
                     <a:bodyPr/>
                     <a:lstStyle/>
                     <a:p>
-                      <a:pPr indent="0" marL="0">
+                      <a:pPr indent="0" marL="0" algn="ctr">
                         <a:buNone/>
                       </a:pPr>
                       <a:r>
-                        <a:rPr lang="en-US" sz="900" dirty="0">
-                          <a:solidFill>
-                            <a:srgbClr val="002677"/>
+                        <a:rPr lang="en-US" sz="950" dirty="0" b="1">
+                          <a:solidFill>
+                            <a:srgbClr val="1A1A1A"/>
                           </a:solidFill>
                         </a:rPr>
                         <a:t>Interface and workflow</a:t>
@@ -6786,7 +6742,7 @@
                         <a:buNone/>
                       </a:pPr>
                       <a:r>
-                        <a:rPr lang="en-US" sz="900" dirty="0">
+                        <a:rPr lang="en-US" sz="1050" dirty="0">
                           <a:solidFill>
                             <a:schemeClr val="tx1"/>
                           </a:solidFill>
@@ -6818,13 +6774,13 @@
                   </a:tcPr>
                 </a:tc>
               </a:tr>
-              <a:tr h="699185">
+              <a:tr h="680944">
                 <a:tc>
                   <a:txBody>
                     <a:bodyPr/>
                     <a:lstStyle/>
                     <a:p>
-                      <a:pPr algn="l" indent="0" marL="0">
+                      <a:pPr algn="ctr" indent="0" marL="0">
                         <a:buNone/>
                       </a:pPr>
                       <a:r>
@@ -6879,13 +6835,13 @@
                     <a:bodyPr/>
                     <a:lstStyle/>
                     <a:p>
-                      <a:pPr indent="0" marL="0">
+                      <a:pPr indent="0" marL="0" algn="ctr">
                         <a:buNone/>
                       </a:pPr>
                       <a:r>
-                        <a:rPr lang="en-US" sz="900" dirty="0">
-                          <a:solidFill>
-                            <a:srgbClr val="002677"/>
+                        <a:rPr lang="en-US" sz="950" dirty="0" b="1">
+                          <a:solidFill>
+                            <a:srgbClr val="1A1A1A"/>
                           </a:solidFill>
                         </a:rPr>
                         <a:t>Domain expertise</a:t>
@@ -7069,7 +7025,7 @@
                         <a:buNone/>
                       </a:pPr>
                       <a:r>
-                        <a:rPr lang="en-US" sz="900" dirty="0">
+                        <a:rPr lang="en-US" sz="1050" dirty="0">
                           <a:solidFill>
                             <a:schemeClr val="tx1"/>
                           </a:solidFill>
@@ -7663,7 +7619,7 @@
         </p:nvSpPr>
         <p:spPr>
           <a:xfrm>
-            <a:off x="4108323" y="2558241"/>
+            <a:off x="4108323" y="2549237"/>
             <a:ext cx="843815" cy="127757"/>
           </a:xfrm>
           <a:prstGeom prst="rect">
@@ -7706,7 +7662,7 @@
         </p:nvSpPr>
         <p:spPr>
           <a:xfrm>
-            <a:off x="5943093" y="2558241"/>
+            <a:off x="5943093" y="2549237"/>
             <a:ext cx="1993865" cy="127757"/>
           </a:xfrm>
           <a:prstGeom prst="rect">
@@ -7749,7 +7705,7 @@
         </p:nvSpPr>
         <p:spPr>
           <a:xfrm>
-            <a:off x="3975836" y="2840117"/>
+            <a:off x="3975836" y="2831113"/>
             <a:ext cx="780159" cy="127757"/>
           </a:xfrm>
           <a:prstGeom prst="rect">
@@ -7792,7 +7748,7 @@
         </p:nvSpPr>
         <p:spPr>
           <a:xfrm>
-            <a:off x="3446995" y="2993838"/>
+            <a:off x="3446995" y="2984834"/>
             <a:ext cx="1122868" cy="127757"/>
           </a:xfrm>
           <a:prstGeom prst="rect">
@@ -7835,7 +7791,7 @@
         </p:nvSpPr>
         <p:spPr>
           <a:xfrm>
-            <a:off x="3962158" y="3147559"/>
+            <a:off x="3962158" y="3138555"/>
             <a:ext cx="697711" cy="127757"/>
           </a:xfrm>
           <a:prstGeom prst="rect">
@@ -8136,7 +8092,7 @@
         </p:nvSpPr>
         <p:spPr>
           <a:xfrm>
-            <a:off x="3446995" y="4135759"/>
+            <a:off x="3446995" y="4144763"/>
             <a:ext cx="1047128" cy="127757"/>
           </a:xfrm>
           <a:prstGeom prst="rect">
@@ -8179,7 +8135,7 @@
         </p:nvSpPr>
         <p:spPr>
           <a:xfrm>
-            <a:off x="5445233" y="4135759"/>
+            <a:off x="5445233" y="4144763"/>
             <a:ext cx="1664006" cy="127757"/>
           </a:xfrm>
           <a:prstGeom prst="rect">
@@ -8222,7 +8178,7 @@
         </p:nvSpPr>
         <p:spPr>
           <a:xfrm>
-            <a:off x="3446995" y="4263914"/>
+            <a:off x="3446995" y="4272919"/>
             <a:ext cx="2639585" cy="127757"/>
           </a:xfrm>
           <a:prstGeom prst="rect">
@@ -8265,7 +8221,7 @@
         </p:nvSpPr>
         <p:spPr>
           <a:xfrm>
-            <a:off x="3446995" y="4417635"/>
+            <a:off x="3446995" y="4426639"/>
             <a:ext cx="1475160" cy="127757"/>
           </a:xfrm>
           <a:prstGeom prst="rect">
@@ -8308,7 +8264,7 @@
         </p:nvSpPr>
         <p:spPr>
           <a:xfrm>
-            <a:off x="6115685" y="4417635"/>
+            <a:off x="6115685" y="4426639"/>
             <a:ext cx="691560" cy="127757"/>
           </a:xfrm>
           <a:prstGeom prst="rect">

</xml_diff>

<commit_message>
10.16: title line breaks, lower cover block, slide 10 title and quote links, slide 11 punctuation and tighter box
Co-Authored-By: Claude Opus 5.5 <noreply@anthropic.com>
Claude-Session: https://claude.ai/code/session_0198bm9pfzRwgZQBqNvd56W8
</commit_message>
<xml_diff>
--- a/deck/Optum-LS-Conversational-AI-10.16.pptx
+++ b/deck/Optum-LS-Conversational-AI-10.16.pptx
@@ -2913,7 +2913,7 @@
         </p:nvSpPr>
         <p:spPr>
           <a:xfrm>
-            <a:off x="822960" y="1362455"/>
+            <a:off x="822960" y="1682495"/>
             <a:ext cx="10058400" cy="274320"/>
           </a:xfrm>
           <a:prstGeom prst="rect">
@@ -2948,7 +2948,7 @@
         </p:nvSpPr>
         <p:spPr>
           <a:xfrm>
-            <a:off x="822960" y="1773935"/>
+            <a:off x="822960" y="2093976"/>
             <a:ext cx="10515600" cy="731520"/>
           </a:xfrm>
           <a:prstGeom prst="rect">
@@ -2983,7 +2983,7 @@
         </p:nvSpPr>
         <p:spPr>
           <a:xfrm>
-            <a:off x="822960" y="2551176"/>
+            <a:off x="822960" y="2871215"/>
             <a:ext cx="10515600" cy="457200"/>
           </a:xfrm>
           <a:prstGeom prst="rect">
@@ -3018,7 +3018,7 @@
         </p:nvSpPr>
         <p:spPr>
           <a:xfrm>
-            <a:off x="822960" y="3072384"/>
+            <a:off x="822960" y="3392424"/>
             <a:ext cx="10515600" cy="274320"/>
           </a:xfrm>
           <a:prstGeom prst="rect">
@@ -3053,7 +3053,7 @@
         </p:nvCxnSpPr>
         <p:spPr>
           <a:xfrm>
-            <a:off x="822960" y="3621024"/>
+            <a:off x="822960" y="3941064"/>
             <a:ext cx="10543032" cy="0"/>
           </a:xfrm>
           <a:prstGeom prst="line">
@@ -3088,7 +3088,7 @@
         </p:nvSpPr>
         <p:spPr>
           <a:xfrm>
-            <a:off x="822960" y="3803904"/>
+            <a:off x="822960" y="4123944"/>
             <a:ext cx="7315200" cy="274320"/>
           </a:xfrm>
           <a:prstGeom prst="rect">
@@ -3123,7 +3123,7 @@
         </p:nvSpPr>
         <p:spPr>
           <a:xfrm>
-            <a:off x="822960" y="4123944"/>
+            <a:off x="822960" y="4443983"/>
             <a:ext cx="7315200" cy="274320"/>
           </a:xfrm>
           <a:prstGeom prst="rect">
@@ -3158,7 +3158,7 @@
         </p:nvSpPr>
         <p:spPr>
           <a:xfrm>
-            <a:off x="822960" y="4992624"/>
+            <a:off x="822960" y="5312664"/>
             <a:ext cx="10543032" cy="502920"/>
           </a:xfrm>
           <a:prstGeom prst="rect">
@@ -3209,7 +3209,7 @@
         </p:nvSpPr>
         <p:spPr>
           <a:xfrm>
-            <a:off x="822960" y="4416552"/>
+            <a:off x="822960" y="4736592"/>
             <a:ext cx="8229600" cy="274320"/>
           </a:xfrm>
           <a:prstGeom prst="rect">
@@ -3359,7 +3359,7 @@
                   <a:schemeClr val="accent1"/>
                 </a:solidFill>
               </a:rPr>
-              <a:t>the model, and even the interface, can come from outside</a:t>
+              <a:t>outside suppliers can provide the model, and even the interface</a:t>
             </a:r>
             <a:endParaRPr lang="en-US" sz="2200" dirty="0"/>
           </a:p>
@@ -4216,7 +4216,28 @@
                             <a:schemeClr val="tx1"/>
                           </a:solidFill>
                         </a:rPr>
-                        <a:t>: “The LLM never touches numbers.”;</a:t>
+                        <a:t>: “</a:t>
+                      </a:r>
+                      <a:r>
+                        <a:rPr lang="en-US" sz="950" dirty="0" u="sng">
+                          <a:solidFill>
+                            <a:srgbClr val="002677"/>
+                          </a:solidFill>
+                          <a:uFill>
+                            <a:solidFill>
+                              <a:srgbClr val="9AA8CC"/>
+                            </a:solidFill>
+                          </a:uFill>
+                        </a:rPr>
+                        <a:t>The LLM never touches numbers.</a:t>
+                      </a:r>
+                      <a:r>
+                        <a:rPr lang="en-US" sz="950" dirty="0">
+                          <a:solidFill>
+                            <a:schemeClr val="tx1"/>
+                          </a:solidFill>
+                        </a:rPr>
+                        <a:t>”;</a:t>
                       </a:r>
                       <a:endParaRPr lang="en-US" sz="950" dirty="0"/>
                     </a:p>
@@ -4259,7 +4280,28 @@
                             <a:schemeClr val="tx1"/>
                           </a:solidFill>
                         </a:rPr>
-                        <a:t>: “nothing runs until you review, edit and approve it.”;</a:t>
+                        <a:t>: “</a:t>
+                      </a:r>
+                      <a:r>
+                        <a:rPr lang="en-US" sz="950" dirty="0" u="sng">
+                          <a:solidFill>
+                            <a:srgbClr val="002677"/>
+                          </a:solidFill>
+                          <a:uFill>
+                            <a:solidFill>
+                              <a:srgbClr val="9AA8CC"/>
+                            </a:solidFill>
+                          </a:uFill>
+                        </a:rPr>
+                        <a:t>nothing runs until you review, edit and approve it.</a:t>
+                      </a:r>
+                      <a:r>
+                        <a:rPr lang="en-US" sz="950" dirty="0">
+                          <a:solidFill>
+                            <a:schemeClr val="tx1"/>
+                          </a:solidFill>
+                        </a:rPr>
+                        <a:t>”;</a:t>
                       </a:r>
                       <a:endParaRPr lang="en-US" sz="950" dirty="0"/>
                     </a:p>
@@ -5814,6 +5856,92 @@
           </a:p>
         </p:txBody>
       </p:sp>
+      <p:sp>
+        <p:nvSpPr>
+          <p:cNvPr id="9731" name="Invisible source link 14: https://www.komodohealth.com/perspectives/building-the-framework-for-trusted-ai-in-healthcare/">
+            <a:hlinkClick r:id="rId10"/>
+          </p:cNvPr>
+          <p:cNvSpPr/>
+          <p:nvPr/>
+        </p:nvSpPr>
+        <p:spPr>
+          <a:xfrm>
+            <a:off x="3843328" y="3214371"/>
+            <a:ext cx="1914039" cy="134588"/>
+          </a:xfrm>
+          <a:prstGeom prst="rect">
+            <a:avLst/>
+          </a:prstGeom>
+          <a:noFill/>
+          <a:ln>
+            <a:noFill/>
+          </a:ln>
+        </p:spPr>
+        <p:style>
+          <a:lnRef idx="1">
+            <a:schemeClr val="accent1"/>
+          </a:lnRef>
+          <a:fillRef idx="3">
+            <a:schemeClr val="accent1"/>
+          </a:fillRef>
+          <a:effectRef idx="2">
+            <a:schemeClr val="accent1"/>
+          </a:effectRef>
+          <a:fontRef idx="minor">
+            <a:schemeClr val="lt1"/>
+          </a:fontRef>
+        </p:style>
+        <p:txBody>
+          <a:bodyPr rtlCol="0" anchor="ctr"/>
+          <a:lstStyle/>
+          <a:p>
+            <a:pPr algn="ctr"/>
+          </a:p>
+        </p:txBody>
+      </p:sp>
+      <p:sp>
+        <p:nvSpPr>
+          <p:cNvPr id="9732" name="Invisible source link 14: https://healthverity.com/exos/">
+            <a:hlinkClick r:id="rId11"/>
+          </p:cNvPr>
+          <p:cNvSpPr/>
+          <p:nvPr/>
+        </p:nvSpPr>
+        <p:spPr>
+          <a:xfrm>
+            <a:off x="3535163" y="3400858"/>
+            <a:ext cx="2722953" cy="134588"/>
+          </a:xfrm>
+          <a:prstGeom prst="rect">
+            <a:avLst/>
+          </a:prstGeom>
+          <a:noFill/>
+          <a:ln>
+            <a:noFill/>
+          </a:ln>
+        </p:spPr>
+        <p:style>
+          <a:lnRef idx="1">
+            <a:schemeClr val="accent1"/>
+          </a:lnRef>
+          <a:fillRef idx="3">
+            <a:schemeClr val="accent1"/>
+          </a:fillRef>
+          <a:effectRef idx="2">
+            <a:schemeClr val="accent1"/>
+          </a:effectRef>
+          <a:fontRef idx="minor">
+            <a:schemeClr val="lt1"/>
+          </a:fontRef>
+        </p:style>
+        <p:txBody>
+          <a:bodyPr rtlCol="0" anchor="ctr"/>
+          <a:lstStyle/>
+          <a:p>
+            <a:pPr algn="ctr"/>
+          </a:p>
+        </p:txBody>
+      </p:sp>
     </p:spTree>
   </p:cSld>
   <p:clrMapOvr>
@@ -5909,7 +6037,22 @@
                   <a:schemeClr val="accent1"/>
                 </a:solidFill>
               </a:rPr>
-              <a:t>LLM providers are entering pharma through research workbenches and enterprise deployments, not patient-level data</a:t>
+              <a:t>LLM providers are entering pharma through research workbenches</a:t>
+            </a:r>
+            <a:br>
+              <a:rPr lang="en-US" sz="2200" b="1" dirty="0">
+                <a:solidFill>
+                  <a:schemeClr val="accent1"/>
+                </a:solidFill>
+              </a:rPr>
+            </a:br>
+            <a:r>
+              <a:rPr lang="en-US" sz="2200" b="1" dirty="0">
+                <a:solidFill>
+                  <a:schemeClr val="accent1"/>
+                </a:solidFill>
+              </a:rPr>
+              <a:t>and enterprise deployments, not patient-level data</a:t>
             </a:r>
             <a:endParaRPr lang="en-US" sz="2200" dirty="0"/>
           </a:p>
@@ -5967,7 +6110,7 @@
         </p:nvGraphicFramePr>
         <p:xfrm>
           <a:off x="548640" y="2075688"/>
-          <a:ext cx="11091672" cy="2679191"/>
+          <a:ext cx="11091672" cy="2871215"/>
         </p:xfrm>
         <a:graphic>
           <a:graphicData uri="http://schemas.openxmlformats.org/drawingml/2006/table">
@@ -6129,7 +6272,7 @@
                   </a:tcPr>
                 </a:tc>
               </a:tr>
-              <a:tr h="860230">
+              <a:tr h="924238">
                 <a:tc>
                   <a:txBody>
                     <a:bodyPr/>
@@ -6281,7 +6424,7 @@
                             <a:schemeClr val="tx1"/>
                           </a:solidFill>
                         </a:rPr>
-                        <a:t>,” drawing on public databases such as UniProt and ClinVar plus users’ own data.</a:t>
+                        <a:t>,” drawing on public databases such as UniProt and ClinVar plus users’ own data;</a:t>
                       </a:r>
                       <a:endParaRPr lang="en-US" sz="900" dirty="0"/>
                     </a:p>
@@ -6319,7 +6462,7 @@
                             <a:schemeClr val="tx1"/>
                           </a:solidFill>
                         </a:rPr>
-                        <a:t>: trusted access for eligible organizations since September 2026.</a:t>
+                        <a:t>: trusted access for eligible organizations since September 2026;</a:t>
                       </a:r>
                       <a:endParaRPr lang="en-US" sz="900" dirty="0"/>
                     </a:p>
@@ -6349,7 +6492,7 @@
                             <a:schemeClr val="tx1"/>
                           </a:solidFill>
                         </a:rPr>
-                        <a:t>: generally available June 2026, with GSK named.</a:t>
+                        <a:t>: generally available June 2026, with GSK named;</a:t>
                       </a:r>
                       <a:endParaRPr lang="en-US" sz="900" dirty="0"/>
                     </a:p>
@@ -6387,7 +6530,7 @@
                             <a:schemeClr val="tx1"/>
                           </a:solidFill>
                         </a:rPr>
-                        <a:t>: enterprise preview that includes Daiichi Sankyo.</a:t>
+                        <a:t>: enterprise preview that includes Daiichi Sankyo</a:t>
                       </a:r>
                       <a:endParaRPr lang="en-US" sz="900" dirty="0"/>
                     </a:p>
@@ -6427,7 +6570,7 @@
                             <a:schemeClr val="tx1"/>
                           </a:solidFill>
                         </a:rPr>
-                        <a:t>Discovery-stage research on public and customer data; little overlap with RWE, commercial or HEOR.</a:t>
+                        <a:t>Discovery-stage research on public and customer data; little overlap with RWE, commercial or HEOR</a:t>
                       </a:r>
                       <a:endParaRPr lang="en-US" sz="900" dirty="0"/>
                     </a:p>
@@ -6454,7 +6597,7 @@
                   </a:tcPr>
                 </a:tc>
               </a:tr>
-              <a:tr h="735681">
+              <a:tr h="799689">
                 <a:tc>
                   <a:txBody>
                     <a:bodyPr/>
@@ -6619,7 +6762,7 @@
                             <a:schemeClr val="tx1"/>
                           </a:solidFill>
                         </a:rPr>
-                        <a:t>” for HCP engagement.</a:t>
+                        <a:t>” for HCP engagement;</a:t>
                       </a:r>
                       <a:endParaRPr lang="en-US" sz="900" dirty="0"/>
                     </a:p>
@@ -6707,7 +6850,7 @@
                             <a:schemeClr val="tx1"/>
                           </a:solidFill>
                         </a:rPr>
-                        <a:t> (September 2026).</a:t>
+                        <a:t> (September 2026)</a:t>
                       </a:r>
                       <a:endParaRPr lang="en-US" sz="900" dirty="0"/>
                     </a:p>
@@ -6747,7 +6890,7 @@
                             <a:schemeClr val="tx1"/>
                           </a:solidFill>
                         </a:rPr>
-                        <a:t>The closest overlap with Optum LS: pharma companies analyze their own data and systems inside the provider’s assistant, including in commercial functions.</a:t>
+                        <a:t>The closest overlap with Optum LS: pharma companies analyze their own data and systems inside the provider’s assistant, including in commercial functions</a:t>
                       </a:r>
                       <a:endParaRPr lang="en-US" sz="900" dirty="0"/>
                     </a:p>
@@ -6774,7 +6917,7 @@
                   </a:tcPr>
                 </a:tc>
               </a:tr>
-              <a:tr h="680944">
+              <a:tr h="744952">
                 <a:tc>
                   <a:txBody>
                     <a:bodyPr/>
@@ -6939,7 +7082,7 @@
                             <a:schemeClr val="tx1"/>
                           </a:solidFill>
                         </a:rPr>
-                        <a:t>”; North for Pharma is announced.</a:t>
+                        <a:t>”; North for Pharma is announced;</a:t>
                       </a:r>
                       <a:endParaRPr lang="en-US" sz="900" dirty="0"/>
                     </a:p>
@@ -6990,7 +7133,7 @@
                             <a:schemeClr val="tx1"/>
                           </a:solidFill>
                         </a:rPr>
-                        <a:t> building biology-specific models.</a:t>
+                        <a:t> building biology-specific models</a:t>
                       </a:r>
                       <a:endParaRPr lang="en-US" sz="900" dirty="0"/>
                     </a:p>
@@ -7030,7 +7173,7 @@
                             <a:schemeClr val="tx1"/>
                           </a:solidFill>
                         </a:rPr>
-                        <a:t>Research teams, literature-derived data and pharma accounts, not patient-level RWD.</a:t>
+                        <a:t>Research teams, literature-derived data and pharma accounts, not patient-level RWD</a:t>
                       </a:r>
                       <a:endParaRPr lang="en-US" sz="900" dirty="0"/>
                     </a:p>
@@ -7069,8 +7212,8 @@
         </p:nvSpPr>
         <p:spPr>
           <a:xfrm>
-            <a:off x="548640" y="4937760"/>
-            <a:ext cx="11091672" cy="1115568"/>
+            <a:off x="548640" y="5129784"/>
+            <a:ext cx="11091672" cy="923544"/>
           </a:xfrm>
           <a:prstGeom prst="rect">
             <a:avLst/>
@@ -7100,7 +7243,7 @@
         </p:nvSpPr>
         <p:spPr>
           <a:xfrm>
-            <a:off x="749808" y="5010912"/>
+            <a:off x="749808" y="5390388"/>
             <a:ext cx="402336" cy="402336"/>
           </a:xfrm>
           <a:prstGeom prst="ellipse">
@@ -7132,7 +7275,7 @@
         </p:blipFill>
         <p:spPr>
           <a:xfrm>
-            <a:off x="838322" y="5099426"/>
+            <a:off x="838322" y="5478902"/>
             <a:ext cx="225308" cy="225308"/>
           </a:xfrm>
           <a:prstGeom prst="rect">
@@ -7148,8 +7291,8 @@
         </p:nvSpPr>
         <p:spPr>
           <a:xfrm>
-            <a:off x="1280160" y="5010912"/>
-            <a:ext cx="7315200" cy="402336"/>
+            <a:off x="1280160" y="5239512"/>
+            <a:ext cx="7315200" cy="274320"/>
           </a:xfrm>
           <a:prstGeom prst="rect">
             <a:avLst/>
@@ -7184,7 +7327,7 @@
         </p:nvSpPr>
         <p:spPr>
           <a:xfrm>
-            <a:off x="1280160" y="5486400"/>
+            <a:off x="1280160" y="5532120"/>
             <a:ext cx="10131552" cy="411480"/>
           </a:xfrm>
           <a:prstGeom prst="rect">
@@ -7619,7 +7762,7 @@
         </p:nvSpPr>
         <p:spPr>
           <a:xfrm>
-            <a:off x="4108323" y="2549237"/>
+            <a:off x="4108323" y="2581279"/>
             <a:ext cx="843815" cy="127757"/>
           </a:xfrm>
           <a:prstGeom prst="rect">
@@ -7662,7 +7805,7 @@
         </p:nvSpPr>
         <p:spPr>
           <a:xfrm>
-            <a:off x="5943093" y="2549237"/>
+            <a:off x="5943093" y="2581279"/>
             <a:ext cx="1993865" cy="127757"/>
           </a:xfrm>
           <a:prstGeom prst="rect">
@@ -7705,7 +7848,7 @@
         </p:nvSpPr>
         <p:spPr>
           <a:xfrm>
-            <a:off x="3975836" y="2831113"/>
+            <a:off x="3975836" y="2863155"/>
             <a:ext cx="780159" cy="127757"/>
           </a:xfrm>
           <a:prstGeom prst="rect">
@@ -7748,7 +7891,7 @@
         </p:nvSpPr>
         <p:spPr>
           <a:xfrm>
-            <a:off x="3446995" y="2984834"/>
+            <a:off x="3446995" y="3016876"/>
             <a:ext cx="1122868" cy="127757"/>
           </a:xfrm>
           <a:prstGeom prst="rect">
@@ -7791,7 +7934,7 @@
         </p:nvSpPr>
         <p:spPr>
           <a:xfrm>
-            <a:off x="3962158" y="3138555"/>
+            <a:off x="3962158" y="3170597"/>
             <a:ext cx="697711" cy="127757"/>
           </a:xfrm>
           <a:prstGeom prst="rect">
@@ -7834,7 +7977,7 @@
         </p:nvSpPr>
         <p:spPr>
           <a:xfrm>
-            <a:off x="3446995" y="3436636"/>
+            <a:off x="3446995" y="3532763"/>
             <a:ext cx="284795" cy="127757"/>
           </a:xfrm>
           <a:prstGeom prst="rect">
@@ -7877,7 +8020,7 @@
         </p:nvSpPr>
         <p:spPr>
           <a:xfrm>
-            <a:off x="4245682" y="3436636"/>
+            <a:off x="4245682" y="3532763"/>
             <a:ext cx="2800920" cy="127757"/>
           </a:xfrm>
           <a:prstGeom prst="rect">
@@ -7920,7 +8063,7 @@
         </p:nvSpPr>
         <p:spPr>
           <a:xfrm>
-            <a:off x="4545868" y="3564792"/>
+            <a:off x="4545868" y="3660918"/>
             <a:ext cx="2446010" cy="127757"/>
           </a:xfrm>
           <a:prstGeom prst="rect">
@@ -7963,7 +8106,7 @@
         </p:nvSpPr>
         <p:spPr>
           <a:xfrm>
-            <a:off x="5007597" y="3718513"/>
+            <a:off x="5007597" y="3814639"/>
             <a:ext cx="387049" cy="127757"/>
           </a:xfrm>
           <a:prstGeom prst="rect">
@@ -8006,7 +8149,7 @@
         </p:nvSpPr>
         <p:spPr>
           <a:xfrm>
-            <a:off x="6728156" y="3718513"/>
+            <a:off x="6728156" y="3814639"/>
             <a:ext cx="1217753" cy="127757"/>
           </a:xfrm>
           <a:prstGeom prst="rect">
@@ -8049,7 +8192,7 @@
         </p:nvSpPr>
         <p:spPr>
           <a:xfrm>
-            <a:off x="3681717" y="3846681"/>
+            <a:off x="3681717" y="3942795"/>
             <a:ext cx="482523" cy="127757"/>
           </a:xfrm>
           <a:prstGeom prst="rect">
@@ -8092,7 +8235,7 @@
         </p:nvSpPr>
         <p:spPr>
           <a:xfrm>
-            <a:off x="3446995" y="4144763"/>
+            <a:off x="3446995" y="4304961"/>
             <a:ext cx="1047128" cy="127757"/>
           </a:xfrm>
           <a:prstGeom prst="rect">
@@ -8135,7 +8278,7 @@
         </p:nvSpPr>
         <p:spPr>
           <a:xfrm>
-            <a:off x="5445233" y="4144763"/>
+            <a:off x="5445233" y="4304961"/>
             <a:ext cx="1664006" cy="127757"/>
           </a:xfrm>
           <a:prstGeom prst="rect">
@@ -8178,7 +8321,7 @@
         </p:nvSpPr>
         <p:spPr>
           <a:xfrm>
-            <a:off x="3446995" y="4272919"/>
+            <a:off x="3446995" y="4433116"/>
             <a:ext cx="2639585" cy="127757"/>
           </a:xfrm>
           <a:prstGeom prst="rect">
@@ -8221,7 +8364,7 @@
         </p:nvSpPr>
         <p:spPr>
           <a:xfrm>
-            <a:off x="3446995" y="4426639"/>
+            <a:off x="3446995" y="4586837"/>
             <a:ext cx="1475160" cy="127757"/>
           </a:xfrm>
           <a:prstGeom prst="rect">
@@ -8264,7 +8407,7 @@
         </p:nvSpPr>
         <p:spPr>
           <a:xfrm>
-            <a:off x="6115685" y="4426639"/>
+            <a:off x="6115685" y="4586837"/>
             <a:ext cx="691560" cy="127757"/>
           </a:xfrm>
           <a:prstGeom prst="rect">
@@ -8307,7 +8450,7 @@
         </p:nvSpPr>
         <p:spPr>
           <a:xfrm>
-            <a:off x="7429613" y="5499669"/>
+            <a:off x="7429613" y="5545389"/>
             <a:ext cx="2055641" cy="155876"/>
           </a:xfrm>
           <a:prstGeom prst="rect">
@@ -8350,7 +8493,7 @@
         </p:nvSpPr>
         <p:spPr>
           <a:xfrm>
-            <a:off x="1280160" y="5667436"/>
+            <a:off x="1280160" y="5713156"/>
             <a:ext cx="2779527" cy="155876"/>
           </a:xfrm>
           <a:prstGeom prst="rect">
@@ -15534,7 +15677,7 @@
                   <a:schemeClr val="accent1"/>
                 </a:solidFill>
               </a:rPr>
-              <a:t>Conversational AI is most visible in RWE, where competitors</a:t>
+              <a:t>Conversational AI is most visible in RWE, where competitors market</a:t>
             </a:r>
             <a:br>
               <a:rPr lang="en-US" sz="2200" b="1" dirty="0">
@@ -15549,7 +15692,7 @@
                   <a:schemeClr val="accent1"/>
                 </a:solidFill>
               </a:rPr>
-              <a:t>market new access points to tasks Optum LS already serves</a:t>
+              <a:t>new access points to tasks Optum LS already serves</a:t>
             </a:r>
             <a:endParaRPr lang="en-US" sz="2200" dirty="0"/>
           </a:p>
@@ -17524,7 +17667,22 @@
                   <a:schemeClr val="accent1"/>
                 </a:solidFill>
               </a:rPr>
-              <a:t>In RWE, conversational AI now spans the workflow, from pre-sale data previews to analyses traditionally handled by specialists</a:t>
+              <a:t>In RWE, conversational AI now spans the workflow, from pre-sale data</a:t>
+            </a:r>
+            <a:br>
+              <a:rPr lang="en-US" sz="2200" b="1" dirty="0">
+                <a:solidFill>
+                  <a:schemeClr val="accent1"/>
+                </a:solidFill>
+              </a:rPr>
+            </a:br>
+            <a:r>
+              <a:rPr lang="en-US" sz="2200" b="1" dirty="0">
+                <a:solidFill>
+                  <a:schemeClr val="accent1"/>
+                </a:solidFill>
+              </a:rPr>
+              <a:t>previews to analyses traditionally handled by specialists</a:t>
             </a:r>
             <a:endParaRPr lang="en-US" sz="2200" dirty="0"/>
           </a:p>
@@ -19752,7 +19910,22 @@
                   <a:schemeClr val="accent1"/>
                 </a:solidFill>
               </a:rPr>
-              <a:t>In oncology and specialty data, vendors pitch conversational AI as a substitute for some routine analyst work</a:t>
+              <a:t>In oncology and specialty data, vendors pitch conversational AI</a:t>
+            </a:r>
+            <a:br>
+              <a:rPr lang="en-US" sz="2200" b="1" dirty="0">
+                <a:solidFill>
+                  <a:schemeClr val="accent1"/>
+                </a:solidFill>
+              </a:rPr>
+            </a:br>
+            <a:r>
+              <a:rPr lang="en-US" sz="2200" b="1" dirty="0">
+                <a:solidFill>
+                  <a:schemeClr val="accent1"/>
+                </a:solidFill>
+              </a:rPr>
+              <a:t>as a substitute for some routine analyst work</a:t>
             </a:r>
             <a:endParaRPr lang="en-US" sz="2200" dirty="0"/>
           </a:p>
@@ -21712,7 +21885,22 @@
                   <a:schemeClr val="accent1"/>
                 </a:solidFill>
               </a:rPr>
-              <a:t>In commercial intelligence, conversational AI reaches into reps’ daily workflow and simulated market research</a:t>
+              <a:t>In commercial intelligence, conversational AI reaches into reps’ daily workflow</a:t>
+            </a:r>
+            <a:br>
+              <a:rPr lang="en-US" sz="2200" b="1" dirty="0">
+                <a:solidFill>
+                  <a:schemeClr val="accent1"/>
+                </a:solidFill>
+              </a:rPr>
+            </a:br>
+            <a:r>
+              <a:rPr lang="en-US" sz="2200" b="1" dirty="0">
+                <a:solidFill>
+                  <a:schemeClr val="accent1"/>
+                </a:solidFill>
+              </a:rPr>
+              <a:t>and simulated market research</a:t>
             </a:r>
             <a:endParaRPr lang="en-US" sz="2200" dirty="0"/>
           </a:p>

</xml_diff>

<commit_message>
Deck 10.16: new landscape takeaway, BMS cell on LLM slide, cut international appendix
Co-Authored-By: Claude Opus 5.5 <noreply@anthropic.com>
Claude-Session: https://claude.ai/code/session_0198bm9pfzRwgZQBqNvd56W8
</commit_message>
<xml_diff>
--- a/deck/Optum-LS-Conversational-AI-10.16.pptx
+++ b/deck/Optum-LS-Conversational-AI-10.16.pptx
@@ -18,7 +18,6 @@
     <p:sldId id="265" r:id="rId11"/>
     <p:sldId id="269" r:id="rId13"/>
     <p:sldId id="266" r:id="rId12"/>
-    <p:sldId id="259" r:id="rId5"/>
   </p:sldIdLst>
   <p:notesMasterIdLst>
     <p:notesMasterId r:id="rId14"/>
@@ -517,492 +516,6 @@
 </c:chartSpace>
 </file>
 
-<file path=ppt/charts/chart2.xml><?xml version="1.0" encoding="utf-8"?>
-<c:chartSpace xmlns:c="http://schemas.openxmlformats.org/drawingml/2006/chart" xmlns:a="http://schemas.openxmlformats.org/drawingml/2006/main" xmlns:r="http://schemas.openxmlformats.org/officeDocument/2006/relationships">
-  <c:date1904 val="0"/>
-  <c:roundedCorners val="1"/>
-  <c:chart>
-    <c:autoTitleDeleted val="1"/>
-    <c:plotArea>
-      <c:layout>
-        <c:manualLayout>
-          <c:layoutTarget val="inner"/>
-          <c:xMode val="edge"/>
-          <c:yMode val="edge"/>
-          <c:x val="0"/>
-          <c:y val="0"/>
-          <c:w val="1"/>
-          <c:h val="0.9305210918114143"/>
-        </c:manualLayout>
-      </c:layout>
-      <c:barChart>
-        <c:barDir val="bar"/>
-        <c:grouping val="clustered"/>
-        <c:varyColors val="0"/>
-        <c:ser>
-          <c:idx val="0"/>
-          <c:order val="0"/>
-          <c:tx>
-            <c:strRef>
-              <c:f>Sheet1!$B$1</c:f>
-              <c:strCache>
-                <c:ptCount val="1"/>
-                <c:pt idx="0">
-                  <c:v>Screened-company share</c:v>
-                </c:pt>
-              </c:strCache>
-            </c:strRef>
-          </c:tx>
-          <c:spPr>
-            <a:solidFill>
-              <a:srgbClr val="8FA3C4"/>
-            </a:solidFill>
-            <a:effectLst/>
-          </c:spPr>
-          <c:invertIfNegative val="0"/>
-          <c:dLbls>
-            <c:numFmt formatCode="#,##0" sourceLinked="0"/>
-            <c:txPr>
-              <a:bodyPr/>
-              <a:lstStyle/>
-              <a:p>
-                <a:pPr>
-                  <a:defRPr b="0" i="0" strike="noStrike" sz="1200" u="none">
-                    <a:solidFill>
-                      <a:srgbClr val="000000"/>
-                    </a:solidFill>
-                    <a:latin typeface="Arial"/>
-                  </a:defRPr>
-                </a:pPr>
-              </a:p>
-            </c:txPr>
-            <c:showLegendKey val="0"/>
-            <c:showVal val="0"/>
-            <c:showCatName val="0"/>
-            <c:showSerName val="0"/>
-            <c:showPercent val="0"/>
-            <c:showBubbleSize val="0"/>
-            <c:showLeaderLines val="0"/>
-          </c:dLbls>
-          <c:dPt>
-            <c:idx val="0"/>
-            <c:invertIfNegative val="0"/>
-            <c:bubble3D val="0"/>
-            <c:spPr>
-              <a:solidFill>
-                <a:srgbClr val="8FA3C4"/>
-              </a:solidFill>
-              <a:effectLst/>
-            </c:spPr>
-          </c:dPt>
-          <c:dPt>
-            <c:idx val="1"/>
-            <c:invertIfNegative val="0"/>
-            <c:bubble3D val="0"/>
-            <c:spPr>
-              <a:solidFill>
-                <a:srgbClr val="8FA3C4"/>
-              </a:solidFill>
-              <a:effectLst/>
-            </c:spPr>
-          </c:dPt>
-          <c:dPt>
-            <c:idx val="2"/>
-            <c:invertIfNegative val="0"/>
-            <c:bubble3D val="0"/>
-            <c:spPr>
-              <a:solidFill>
-                <a:srgbClr val="8FA3C4"/>
-              </a:solidFill>
-              <a:effectLst/>
-            </c:spPr>
-          </c:dPt>
-          <c:dPt>
-            <c:idx val="3"/>
-            <c:invertIfNegative val="0"/>
-            <c:bubble3D val="0"/>
-            <c:spPr>
-              <a:solidFill>
-                <a:srgbClr val="8FA3C4"/>
-              </a:solidFill>
-              <a:effectLst/>
-            </c:spPr>
-          </c:dPt>
-          <c:dPt>
-            <c:idx val="4"/>
-            <c:invertIfNegative val="0"/>
-            <c:bubble3D val="0"/>
-            <c:spPr>
-              <a:solidFill>
-                <a:srgbClr val="8FA3C4"/>
-              </a:solidFill>
-              <a:effectLst/>
-            </c:spPr>
-          </c:dPt>
-          <c:dPt>
-            <c:idx val="5"/>
-            <c:invertIfNegative val="0"/>
-            <c:bubble3D val="0"/>
-            <c:spPr>
-              <a:solidFill>
-                <a:srgbClr val="8FA3C4"/>
-              </a:solidFill>
-              <a:effectLst/>
-            </c:spPr>
-          </c:dPt>
-          <c:dPt>
-            <c:idx val="6"/>
-            <c:invertIfNegative val="0"/>
-            <c:bubble3D val="0"/>
-            <c:spPr>
-              <a:solidFill>
-                <a:srgbClr val="8FA3C4"/>
-              </a:solidFill>
-              <a:effectLst/>
-            </c:spPr>
-          </c:dPt>
-          <c:dPt>
-            <c:idx val="7"/>
-            <c:invertIfNegative val="0"/>
-            <c:bubble3D val="0"/>
-            <c:spPr>
-              <a:solidFill>
-                <a:srgbClr val="8FA3C4"/>
-              </a:solidFill>
-              <a:effectLst/>
-            </c:spPr>
-          </c:dPt>
-          <c:dPt>
-            <c:idx val="8"/>
-            <c:invertIfNegative val="0"/>
-            <c:bubble3D val="0"/>
-            <c:spPr>
-              <a:solidFill>
-                <a:srgbClr val="8FA3C4"/>
-              </a:solidFill>
-              <a:effectLst/>
-            </c:spPr>
-          </c:dPt>
-          <c:dPt>
-            <c:idx val="9"/>
-            <c:invertIfNegative val="0"/>
-            <c:bubble3D val="0"/>
-            <c:spPr>
-              <a:solidFill>
-                <a:srgbClr val="8FA3C4"/>
-              </a:solidFill>
-              <a:effectLst/>
-            </c:spPr>
-          </c:dPt>
-          <c:dPt>
-            <c:idx val="10"/>
-            <c:invertIfNegative val="0"/>
-            <c:bubble3D val="0"/>
-            <c:spPr>
-              <a:solidFill>
-                <a:srgbClr val="8FA3C4"/>
-              </a:solidFill>
-              <a:effectLst/>
-            </c:spPr>
-          </c:dPt>
-          <c:dPt>
-            <c:idx val="11"/>
-            <c:invertIfNegative val="0"/>
-            <c:bubble3D val="0"/>
-            <c:spPr>
-              <a:solidFill>
-                <a:srgbClr val="8FA3C4"/>
-              </a:solidFill>
-              <a:effectLst/>
-            </c:spPr>
-          </c:dPt>
-          <c:dPt>
-            <c:idx val="12"/>
-            <c:invertIfNegative val="0"/>
-            <c:bubble3D val="0"/>
-            <c:spPr>
-              <a:solidFill>
-                <a:srgbClr val="8FA3C4"/>
-              </a:solidFill>
-              <a:effectLst/>
-            </c:spPr>
-          </c:dPt>
-          <c:dPt>
-            <c:idx val="13"/>
-            <c:invertIfNegative val="0"/>
-            <c:bubble3D val="0"/>
-            <c:spPr>
-              <a:solidFill>
-                <a:srgbClr val="8FA3C4"/>
-              </a:solidFill>
-              <a:effectLst/>
-            </c:spPr>
-          </c:dPt>
-          <c:dPt>
-            <c:idx val="14"/>
-            <c:invertIfNegative val="0"/>
-            <c:bubble3D val="0"/>
-            <c:spPr>
-              <a:solidFill>
-                <a:srgbClr val="002677"/>
-              </a:solidFill>
-              <a:effectLst/>
-            </c:spPr>
-          </c:dPt>
-          <c:cat>
-            <c:strRef>
-              <c:f>Sheet1!$A$2:$A$16</c:f>
-              <c:strCache>
-                <c:ptCount val="15"/>
-                <c:pt idx="0">
-                  <c:v>Japan</c:v>
-                </c:pt>
-                <c:pt idx="1">
-                  <c:v>Germany</c:v>
-                </c:pt>
-                <c:pt idx="2">
-                  <c:v>Canada</c:v>
-                </c:pt>
-                <c:pt idx="3">
-                  <c:v>United Kingdom</c:v>
-                </c:pt>
-                <c:pt idx="4">
-                  <c:v>Belgium</c:v>
-                </c:pt>
-                <c:pt idx="5">
-                  <c:v>South Korea</c:v>
-                </c:pt>
-                <c:pt idx="6">
-                  <c:v>Australia</c:v>
-                </c:pt>
-                <c:pt idx="7">
-                  <c:v>Netherlands</c:v>
-                </c:pt>
-                <c:pt idx="8">
-                  <c:v>India</c:v>
-                </c:pt>
-                <c:pt idx="9">
-                  <c:v>Nordics</c:v>
-                </c:pt>
-                <c:pt idx="10">
-                  <c:v>France</c:v>
-                </c:pt>
-                <c:pt idx="11">
-                  <c:v>Israel</c:v>
-                </c:pt>
-                <c:pt idx="12">
-                  <c:v>Spain</c:v>
-                </c:pt>
-                <c:pt idx="13">
-                  <c:v>China</c:v>
-                </c:pt>
-                <c:pt idx="14">
-                  <c:v>United States</c:v>
-                </c:pt>
-              </c:strCache>
-            </c:strRef>
-          </c:cat>
-          <c:val>
-            <c:numRef>
-              <c:f>Sheet1!$B$2:$B$16</c:f>
-              <c:numCache>
-                <c:formatCode>0%</c:formatCode>
-                <c:ptCount val="15"/>
-                <c:pt idx="0">
-                  <c:v>0.0</c:v>
-                </c:pt>
-                <c:pt idx="1">
-                  <c:v>0.0</c:v>
-                </c:pt>
-                <c:pt idx="2">
-                  <c:v>0.0</c:v>
-                </c:pt>
-                <c:pt idx="3">
-                  <c:v>0.05555555555555555</c:v>
-                </c:pt>
-                <c:pt idx="4">
-                  <c:v>0.05555555555555555</c:v>
-                </c:pt>
-                <c:pt idx="5">
-                  <c:v>0.058823529411764705</c:v>
-                </c:pt>
-                <c:pt idx="6">
-                  <c:v>0.07142857142857142</c:v>
-                </c:pt>
-                <c:pt idx="7">
-                  <c:v>0.09090909090909091</c:v>
-                </c:pt>
-                <c:pt idx="8">
-                  <c:v>0.09375</c:v>
-                </c:pt>
-                <c:pt idx="9">
-                  <c:v>0.11764705882352941</c:v>
-                </c:pt>
-                <c:pt idx="10">
-                  <c:v>0.11764705882352941</c:v>
-                </c:pt>
-                <c:pt idx="11">
-                  <c:v>0.13333333333333333</c:v>
-                </c:pt>
-                <c:pt idx="12">
-                  <c:v>0.17647058823529413</c:v>
-                </c:pt>
-                <c:pt idx="13">
-                  <c:v>0.2</c:v>
-                </c:pt>
-                <c:pt idx="14">
-                  <c:v>0.3488372093023256</c:v>
-                </c:pt>
-              </c:numCache>
-            </c:numRef>
-          </c:val>
-        </c:ser>
-        <c:dLbls>
-          <c:numFmt formatCode="#,##0" sourceLinked="0"/>
-          <c:txPr>
-            <a:bodyPr/>
-            <a:lstStyle/>
-            <a:p>
-              <a:pPr>
-                <a:defRPr b="0" i="0" strike="noStrike" sz="1200" u="none">
-                  <a:solidFill>
-                    <a:srgbClr val="000000"/>
-                  </a:solidFill>
-                  <a:latin typeface="Arial"/>
-                </a:defRPr>
-              </a:pPr>
-            </a:p>
-          </c:txPr>
-          <c:showLegendKey val="0"/>
-          <c:showVal val="0"/>
-          <c:showCatName val="0"/>
-          <c:showSerName val="0"/>
-          <c:showPercent val="0"/>
-          <c:showBubbleSize val="0"/>
-          <c:showLeaderLines val="0"/>
-        </c:dLbls>
-        <c:gapWidth val="55"/>
-        <c:overlap val="0"/>
-        <c:axId val="2094734554"/>
-        <c:axId val="2094734552"/>
-        <c:axId val="2094734556"/>
-      </c:barChart>
-      <c:catAx>
-        <c:axId val="2094734554"/>
-        <c:scaling>
-          <c:orientation val="minMax"/>
-        </c:scaling>
-        <c:delete val="1"/>
-        <c:axPos val="l"/>
-        <c:numFmt formatCode="General" sourceLinked="1"/>
-        <c:majorTickMark val="out"/>
-        <c:minorTickMark val="none"/>
-        <c:tickLblPos val="nextTo"/>
-        <c:spPr>
-          <a:ln w="12700" cap="flat">
-            <a:solidFill>
-              <a:srgbClr val="888888"/>
-            </a:solidFill>
-            <a:prstDash val="solid"/>
-            <a:round/>
-          </a:ln>
-        </c:spPr>
-        <c:txPr>
-          <a:bodyPr/>
-          <a:lstStyle/>
-          <a:p>
-            <a:pPr>
-              <a:defRPr sz="1200" b="0" i="0" u="none" strike="noStrike">
-                <a:solidFill>
-                  <a:srgbClr val="000000"/>
-                </a:solidFill>
-                <a:latin typeface="Arial"/>
-              </a:defRPr>
-            </a:pPr>
-            <a:endParaRPr lang="en-US"/>
-          </a:p>
-        </c:txPr>
-        <c:crossAx val="2094734552"/>
-        <c:crosses val="autoZero"/>
-        <c:auto val="1"/>
-        <c:lblAlgn val="ctr"/>
-        <c:noMultiLvlLbl val="1"/>
-      </c:catAx>
-      <c:valAx>
-        <c:axId val="2094734552"/>
-        <c:scaling>
-          <c:orientation val="minMax"/>
-          <c:max val="0.4"/>
-          <c:min val="0"/>
-        </c:scaling>
-        <c:delete val="0"/>
-        <c:axPos val="b"/>
-        <c:majorGridlines>
-          <c:spPr>
-            <a:ln w="6350" cap="flat">
-              <a:solidFill>
-                <a:srgbClr val="E3DED3"/>
-              </a:solidFill>
-              <a:prstDash val="solid"/>
-              <a:round/>
-            </a:ln>
-          </c:spPr>
-        </c:majorGridlines>
-        <c:numFmt formatCode="0%" sourceLinked="0"/>
-        <c:majorTickMark val="out"/>
-        <c:minorTickMark val="none"/>
-        <c:tickLblPos val="low"/>
-        <c:spPr>
-          <a:ln w="12700" cap="flat">
-            <a:noFill/>
-            <a:prstDash val="solid"/>
-            <a:round/>
-          </a:ln>
-        </c:spPr>
-        <c:txPr>
-          <a:bodyPr/>
-          <a:lstStyle/>
-          <a:p>
-            <a:pPr>
-              <a:defRPr sz="800" b="0" i="0" u="none" strike="noStrike">
-                <a:solidFill>
-                  <a:srgbClr val="7A7C7E"/>
-                </a:solidFill>
-                <a:latin typeface="+mn-lt"/>
-              </a:defRPr>
-            </a:pPr>
-            <a:endParaRPr lang="en-US"/>
-          </a:p>
-        </c:txPr>
-        <c:crossAx val="2094734554"/>
-        <c:crosses val="autoZero"/>
-        <c:crossBetween val="between"/>
-        <c:majorUnit val="0.1"/>
-      </c:valAx>
-      <c:spPr>
-        <a:noFill/>
-        <a:ln>
-          <a:noFill/>
-        </a:ln>
-        <a:effectLst/>
-      </c:spPr>
-    </c:plotArea>
-    <c:plotVisOnly val="1"/>
-    <c:dispBlanksAs val="span"/>
-  </c:chart>
-  <c:spPr>
-    <a:noFill/>
-    <a:ln>
-      <a:noFill/>
-    </a:ln>
-    <a:effectLst/>
-  </c:spPr>
-  <c:externalData r:id="rId1">
-    <c:autoUpdate val="0"/>
-  </c:externalData>
-</c:chartSpace>
-</file>
-
 <file path=ppt/notesMasters/notesMaster1.xml><?xml version="1.0" encoding="utf-8"?>
 <p:notesMaster xmlns:a="http://schemas.openxmlformats.org/drawingml/2006/main" xmlns:r="http://schemas.openxmlformats.org/officeDocument/2006/relationships" xmlns:p="http://schemas.openxmlformats.org/presentationml/2006/main">
   <p:cSld>
@@ -1774,94 +1287,6 @@
             <a:fld id="{F7021451-1387-4CA6-816F-3879F97B5CBC}" type="slidenum">
               <a:rPr lang="en-US"/>
               <a:t>3</a:t>
-            </a:fld>
-            <a:endParaRPr lang="en-US"/>
-          </a:p>
-        </p:txBody>
-      </p:sp>
-    </p:spTree>
-    <p:extLst>
-      <p:ext uri="{BB962C8B-B14F-4D97-AF65-F5344CB8AC3E}">
-        <p14:creationId xmlns:p14="http://schemas.microsoft.com/office/powerpoint/2010/main" val="1024086991"/>
-      </p:ext>
-    </p:extLst>
-  </p:cSld>
-  <p:clrMapOvr>
-    <a:masterClrMapping/>
-  </p:clrMapOvr>
-</p:notes>
-</file>
-
-<file path=ppt/notesSlides/notesSlide4.xml><?xml version="1.0" encoding="utf-8"?>
-<p:notes xmlns:a="http://schemas.openxmlformats.org/drawingml/2006/main" xmlns:r="http://schemas.openxmlformats.org/officeDocument/2006/relationships" xmlns:p="http://schemas.openxmlformats.org/presentationml/2006/main">
-  <p:cSld>
-    <p:spTree>
-      <p:nvGrpSpPr>
-        <p:cNvPr id="1" name=""/>
-        <p:cNvGrpSpPr/>
-        <p:nvPr/>
-      </p:nvGrpSpPr>
-      <p:grpSpPr>
-        <a:xfrm>
-          <a:off x="0" y="0"/>
-          <a:ext cx="0" cy="0"/>
-          <a:chOff x="0" y="0"/>
-          <a:chExt cx="0" cy="0"/>
-        </a:xfrm>
-      </p:grpSpPr>
-      <p:sp>
-        <p:nvSpPr>
-          <p:cNvPr id="2" name="Slide Image Placeholder 1"/>
-          <p:cNvSpPr>
-            <a:spLocks noGrp="1" noRot="1" noChangeAspect="1"/>
-          </p:cNvSpPr>
-          <p:nvPr>
-            <p:ph type="sldImg"/>
-          </p:nvPr>
-        </p:nvSpPr>
-        <p:spPr/>
-      </p:sp>
-      <p:sp>
-        <p:nvSpPr>
-          <p:cNvPr id="3" name="Notes Placeholder 2"/>
-          <p:cNvSpPr>
-            <a:spLocks noGrp="1"/>
-          </p:cNvSpPr>
-          <p:nvPr>
-            <p:ph type="body" idx="1"/>
-          </p:nvPr>
-        </p:nvSpPr>
-        <p:spPr/>
-        <p:txBody>
-          <a:bodyPr/>
-          <a:lstStyle/>
-          <a:p>
-            <a:r>
-              <a:rPr lang="en-US" dirty="0"/>
-              <a:t/>
-            </a:r>
-            <a:endParaRPr lang="en-US" dirty="0"/>
-          </a:p>
-        </p:txBody>
-      </p:sp>
-      <p:sp>
-        <p:nvSpPr>
-          <p:cNvPr id="4" name="Slide Number Placeholder 3"/>
-          <p:cNvSpPr>
-            <a:spLocks noGrp="1"/>
-          </p:cNvSpPr>
-          <p:nvPr>
-            <p:ph type="sldNum" sz="quarter" idx="10"/>
-          </p:nvPr>
-        </p:nvSpPr>
-        <p:spPr/>
-        <p:txBody>
-          <a:bodyPr/>
-          <a:lstStyle/>
-          <a:p>
-            <a:fld id="{F7021451-1387-4CA6-816F-3879F97B5CBC}" type="slidenum">
-              <a:rPr lang="en-US"/>
-              <a:t>4</a:t>
             </a:fld>
             <a:endParaRPr lang="en-US"/>
           </a:p>
@@ -6272,7 +5697,7 @@
                   </a:tcPr>
                 </a:tc>
               </a:tr>
-              <a:tr h="924238">
+              <a:tr h="899761">
                 <a:tc>
                   <a:txBody>
                     <a:bodyPr/>
@@ -6597,7 +6022,7 @@
                   </a:tcPr>
                 </a:tc>
               </a:tr>
-              <a:tr h="799689">
+              <a:tr h="848643">
                 <a:tc>
                   <a:txBody>
                     <a:bodyPr/>
@@ -6741,7 +6166,7 @@
                             <a:schemeClr val="tx1"/>
                           </a:solidFill>
                         </a:rPr>
-                        <a:t>” for more than 30,000 employees, including “</a:t>
+                        <a:t>” across research, clinical, commercial and corporate functions, including “</a:t>
                       </a:r>
                       <a:r>
                         <a:rPr lang="en-US" sz="900" dirty="0" u="sng">
@@ -6917,7 +6342,7 @@
                   </a:tcPr>
                 </a:tc>
               </a:tr>
-              <a:tr h="744952">
+              <a:tr h="720475">
                 <a:tc>
                   <a:txBody>
                     <a:bodyPr/>
@@ -7762,7 +7187,7 @@
         </p:nvSpPr>
         <p:spPr>
           <a:xfrm>
-            <a:off x="4108323" y="2581279"/>
+            <a:off x="4108323" y="2569036"/>
             <a:ext cx="843815" cy="127757"/>
           </a:xfrm>
           <a:prstGeom prst="rect">
@@ -7805,7 +7230,7 @@
         </p:nvSpPr>
         <p:spPr>
           <a:xfrm>
-            <a:off x="5943093" y="2581279"/>
+            <a:off x="5943093" y="2569036"/>
             <a:ext cx="1993865" cy="127757"/>
           </a:xfrm>
           <a:prstGeom prst="rect">
@@ -7848,7 +7273,7 @@
         </p:nvSpPr>
         <p:spPr>
           <a:xfrm>
-            <a:off x="3975836" y="2863155"/>
+            <a:off x="3975836" y="2850912"/>
             <a:ext cx="780159" cy="127757"/>
           </a:xfrm>
           <a:prstGeom prst="rect">
@@ -7891,7 +7316,7 @@
         </p:nvSpPr>
         <p:spPr>
           <a:xfrm>
-            <a:off x="3446995" y="3016876"/>
+            <a:off x="3446995" y="3004633"/>
             <a:ext cx="1122868" cy="127757"/>
           </a:xfrm>
           <a:prstGeom prst="rect">
@@ -7934,7 +7359,7 @@
         </p:nvSpPr>
         <p:spPr>
           <a:xfrm>
-            <a:off x="3962158" y="3170597"/>
+            <a:off x="3962158" y="3158354"/>
             <a:ext cx="697711" cy="127757"/>
           </a:xfrm>
           <a:prstGeom prst="rect">
@@ -7977,7 +7402,7 @@
         </p:nvSpPr>
         <p:spPr>
           <a:xfrm>
-            <a:off x="3446995" y="3532763"/>
+            <a:off x="3446995" y="3468678"/>
             <a:ext cx="284795" cy="127757"/>
           </a:xfrm>
           <a:prstGeom prst="rect">
@@ -8020,7 +7445,7 @@
         </p:nvSpPr>
         <p:spPr>
           <a:xfrm>
-            <a:off x="4245682" y="3532763"/>
+            <a:off x="4245682" y="3468678"/>
             <a:ext cx="2800920" cy="127757"/>
           </a:xfrm>
           <a:prstGeom prst="rect">
@@ -8063,8 +7488,8 @@
         </p:nvSpPr>
         <p:spPr>
           <a:xfrm>
-            <a:off x="4545868" y="3660918"/>
-            <a:ext cx="2446010" cy="127757"/>
+            <a:off x="6210261" y="3596834"/>
+            <a:ext cx="1803832" cy="127757"/>
           </a:xfrm>
           <a:prstGeom prst="rect">
             <a:avLst/>
@@ -8098,16 +7523,16 @@
       </p:sp>
       <p:sp>
         <p:nvSpPr>
-          <p:cNvPr id="9724" name="Invisible source link 11: https://www.biopharminternational.com/view/novo-nordisk-partners-with-openai-for-drug-discovery">
-            <a:hlinkClick r:id="rId15"/>
+          <p:cNvPr id="9725" name="Invisible source link 11: https://news.bms.com/news/details/2026/Bristol-Myers-Squibb-Announces-Strategic-Agreement-with-Anthropic-to-Position-Claude-Enterprise-as-the-Shared-Intelligence-Platform-Across-Its-Global-Operations/default.aspx">
+            <a:hlinkClick r:id="rId14"/>
           </p:cNvPr>
           <p:cNvSpPr/>
           <p:nvPr/>
         </p:nvSpPr>
         <p:spPr>
           <a:xfrm>
-            <a:off x="5007597" y="3814639"/>
-            <a:ext cx="387049" cy="127757"/>
+            <a:off x="3446995" y="3725003"/>
+            <a:ext cx="609798" cy="127757"/>
           </a:xfrm>
           <a:prstGeom prst="rect">
             <a:avLst/>
@@ -8149,8 +7574,8 @@
         </p:nvSpPr>
         <p:spPr>
           <a:xfrm>
-            <a:off x="6728156" y="3814639"/>
-            <a:ext cx="1217753" cy="127757"/>
+            <a:off x="5007597" y="3878723"/>
+            <a:ext cx="387049" cy="127757"/>
           </a:xfrm>
           <a:prstGeom prst="rect">
             <a:avLst/>
@@ -8184,16 +7609,16 @@
       </p:sp>
       <p:sp>
         <p:nvSpPr>
-          <p:cNvPr id="9726" name="Invisible source link 11: https://www.novonordisk.com/news-and-media/news-and-ir-materials/news-details.html?id=916768">
-            <a:hlinkClick r:id="rId16"/>
+          <p:cNvPr id="9726" name="Invisible source link 11: https://www.biopharminternational.com/view/novo-nordisk-partners-with-openai-for-drug-discovery">
+            <a:hlinkClick r:id="rId15"/>
           </p:cNvPr>
           <p:cNvSpPr/>
           <p:nvPr/>
         </p:nvSpPr>
         <p:spPr>
           <a:xfrm>
-            <a:off x="3681717" y="3942795"/>
-            <a:ext cx="482523" cy="127757"/>
+            <a:off x="6728156" y="3878723"/>
+            <a:ext cx="1217753" cy="127757"/>
           </a:xfrm>
           <a:prstGeom prst="rect">
             <a:avLst/>
@@ -8227,16 +7652,16 @@
       </p:sp>
       <p:sp>
         <p:nvSpPr>
-          <p:cNvPr id="9727" name="Invisible source link 11: https://www.hpcwire.com/aiwire/2026/05/19/cohere-acquires-reliant-ai-to-expand-sovereign-enterprise-ai-for-global-biopharma-and-healthcare-sectors/">
-            <a:hlinkClick r:id="rId17"/>
+          <p:cNvPr id="9727" name="Invisible source link 11: https://www.novonordisk.com/news-and-media/news-and-ir-materials/news-details.html?id=916768">
+            <a:hlinkClick r:id="rId16"/>
           </p:cNvPr>
           <p:cNvSpPr/>
           <p:nvPr/>
         </p:nvSpPr>
         <p:spPr>
           <a:xfrm>
-            <a:off x="3446995" y="4304961"/>
-            <a:ext cx="1047128" cy="127757"/>
+            <a:off x="3681717" y="4006879"/>
+            <a:ext cx="482523" cy="127757"/>
           </a:xfrm>
           <a:prstGeom prst="rect">
             <a:avLst/>
@@ -8278,8 +7703,8 @@
         </p:nvSpPr>
         <p:spPr>
           <a:xfrm>
-            <a:off x="5445233" y="4304961"/>
-            <a:ext cx="1664006" cy="127757"/>
+            <a:off x="3446995" y="4317191"/>
+            <a:ext cx="1047128" cy="127757"/>
           </a:xfrm>
           <a:prstGeom prst="rect">
             <a:avLst/>
@@ -8321,8 +7746,8 @@
         </p:nvSpPr>
         <p:spPr>
           <a:xfrm>
-            <a:off x="3446995" y="4433116"/>
-            <a:ext cx="2639585" cy="127757"/>
+            <a:off x="5445233" y="4317191"/>
+            <a:ext cx="1664006" cy="127757"/>
           </a:xfrm>
           <a:prstGeom prst="rect">
             <a:avLst/>
@@ -8356,16 +7781,16 @@
       </p:sp>
       <p:sp>
         <p:nvSpPr>
-          <p:cNvPr id="9730" name="Invisible source link 11: https://www.fiercebiotech.com/biotech/anthropic-acquires-stealth-ai-startup-coefficient-bio-400m-deal">
-            <a:hlinkClick r:id="rId18"/>
+          <p:cNvPr id="9730" name="Invisible source link 11: https://www.hpcwire.com/aiwire/2026/05/19/cohere-acquires-reliant-ai-to-expand-sovereign-enterprise-ai-for-global-biopharma-and-healthcare-sectors/">
+            <a:hlinkClick r:id="rId17"/>
           </p:cNvPr>
           <p:cNvSpPr/>
           <p:nvPr/>
         </p:nvSpPr>
         <p:spPr>
           <a:xfrm>
-            <a:off x="3446995" y="4586837"/>
-            <a:ext cx="1475160" cy="127757"/>
+            <a:off x="3446995" y="4445359"/>
+            <a:ext cx="2639585" cy="127757"/>
           </a:xfrm>
           <a:prstGeom prst="rect">
             <a:avLst/>
@@ -8399,16 +7824,16 @@
       </p:sp>
       <p:sp>
         <p:nvSpPr>
-          <p:cNvPr id="9731" name="Invisible source link 11: https://www.rdworldonline.com/anthropics-400m-acquisition-of-coefficient-bio-signals-a-deeper-push-into-drug-discovery/">
-            <a:hlinkClick r:id="rId19"/>
+          <p:cNvPr id="9731" name="Invisible source link 11: https://www.fiercebiotech.com/biotech/anthropic-acquires-stealth-ai-startup-coefficient-bio-400m-deal">
+            <a:hlinkClick r:id="rId18"/>
           </p:cNvPr>
           <p:cNvSpPr/>
           <p:nvPr/>
         </p:nvSpPr>
         <p:spPr>
           <a:xfrm>
-            <a:off x="6115685" y="4586837"/>
-            <a:ext cx="691560" cy="127757"/>
+            <a:off x="3446995" y="4599080"/>
+            <a:ext cx="1475160" cy="127757"/>
           </a:xfrm>
           <a:prstGeom prst="rect">
             <a:avLst/>
@@ -8442,16 +7867,16 @@
       </p:sp>
       <p:sp>
         <p:nvSpPr>
-          <p:cNvPr id="9732" name="Invisible source link 11: https://news.bms.com/news/details/2026/Bristol-Myers-Squibb-Announces-Strategic-Agreement-with-Anthropic-to-Position-Claude-Enterprise-as-the-Shared-Intelligence-Platform-Across-Its-Global-Operations/default.aspx">
-            <a:hlinkClick r:id="rId14"/>
+          <p:cNvPr id="9732" name="Invisible source link 11: https://www.rdworldonline.com/anthropics-400m-acquisition-of-coefficient-bio-signals-a-deeper-push-into-drug-discovery/">
+            <a:hlinkClick r:id="rId19"/>
           </p:cNvPr>
           <p:cNvSpPr/>
           <p:nvPr/>
         </p:nvSpPr>
         <p:spPr>
           <a:xfrm>
-            <a:off x="7429613" y="5545389"/>
-            <a:ext cx="2055641" cy="155876"/>
+            <a:off x="6115685" y="4599080"/>
+            <a:ext cx="691560" cy="127757"/>
           </a:xfrm>
           <a:prstGeom prst="rect">
             <a:avLst/>
@@ -8485,7 +7910,50 @@
       </p:sp>
       <p:sp>
         <p:nvSpPr>
-          <p:cNvPr id="9733" name="Invisible source link 11: https://www.veeva.com/resources/new-veeva-study-builder-agent-to-configure-clinical-studies-in-as-little-as-one-day/">
+          <p:cNvPr id="9733" name="Invisible source link 11: https://news.bms.com/news/details/2026/Bristol-Myers-Squibb-Announces-Strategic-Agreement-with-Anthropic-to-Position-Claude-Enterprise-as-the-Shared-Intelligence-Platform-Across-Its-Global-Operations/default.aspx">
+            <a:hlinkClick r:id="rId14"/>
+          </p:cNvPr>
+          <p:cNvSpPr/>
+          <p:nvPr/>
+        </p:nvSpPr>
+        <p:spPr>
+          <a:xfrm>
+            <a:off x="7429613" y="5545389"/>
+            <a:ext cx="2055641" cy="155876"/>
+          </a:xfrm>
+          <a:prstGeom prst="rect">
+            <a:avLst/>
+          </a:prstGeom>
+          <a:noFill/>
+          <a:ln>
+            <a:noFill/>
+          </a:ln>
+        </p:spPr>
+        <p:style>
+          <a:lnRef idx="1">
+            <a:schemeClr val="accent1"/>
+          </a:lnRef>
+          <a:fillRef idx="3">
+            <a:schemeClr val="accent1"/>
+          </a:fillRef>
+          <a:effectRef idx="2">
+            <a:schemeClr val="accent1"/>
+          </a:effectRef>
+          <a:fontRef idx="minor">
+            <a:schemeClr val="lt1"/>
+          </a:fontRef>
+        </p:style>
+        <p:txBody>
+          <a:bodyPr rtlCol="0" anchor="ctr"/>
+          <a:lstStyle/>
+          <a:p>
+            <a:pPr algn="ctr"/>
+          </a:p>
+        </p:txBody>
+      </p:sp>
+      <p:sp>
+        <p:nvSpPr>
+          <p:cNvPr id="9734" name="Invisible source link 11: https://www.veeva.com/resources/new-veeva-study-builder-agent-to-configure-clinical-studies-in-as-little-as-one-day/">
             <a:hlinkClick r:id="rId20"/>
           </p:cNvPr>
           <p:cNvSpPr/>
@@ -10034,2221 +9502,6 @@
 </p:sld>
 </file>
 
-<file path=ppt/slides/slide14.xml><?xml version="1.0" encoding="utf-8"?>
-<p:sld xmlns:a="http://schemas.openxmlformats.org/drawingml/2006/main" xmlns:r="http://schemas.openxmlformats.org/officeDocument/2006/relationships" xmlns:p="http://schemas.openxmlformats.org/presentationml/2006/main">
-  <p:cSld name="Slide 4">
-    <p:spTree>
-      <p:nvGrpSpPr>
-        <p:cNvPr id="1" name=""/>
-        <p:cNvGrpSpPr/>
-        <p:nvPr/>
-      </p:nvGrpSpPr>
-      <p:grpSpPr>
-        <a:xfrm>
-          <a:off x="0" y="0"/>
-          <a:ext cx="0" cy="0"/>
-          <a:chOff x="0" y="0"/>
-          <a:chExt cx="0" cy="0"/>
-        </a:xfrm>
-      </p:grpSpPr>
-      <p:sp>
-        <p:nvSpPr>
-          <p:cNvPr id="2" name="Text 2"/>
-          <p:cNvSpPr/>
-          <p:nvPr>
-            <p:ph idx="102" type="body" hasCustomPrompt="1"/>
-          </p:nvPr>
-        </p:nvSpPr>
-        <p:spPr>
-          <a:xfrm>
-            <a:off x="548640" y="384048"/>
-            <a:ext cx="8229600" cy="219456"/>
-          </a:xfrm>
-          <a:prstGeom prst="rect">
-            <a:avLst/>
-          </a:prstGeom>
-          <a:noFill/>
-          <a:ln/>
-        </p:spPr>
-        <p:txBody>
-          <a:bodyPr wrap="square" lIns="0" tIns="0" rIns="0" bIns="0" rtlCol="0" anchor="t"/>
-          <a:lstStyle/>
-          <a:p>
-            <a:pPr indent="0" marL="0">
-              <a:buNone/>
-            </a:pPr>
-            <a:r>
-              <a:rPr lang="en-US" sz="1000" b="1" spc="100" kern="0" dirty="0">
-                <a:solidFill>
-                  <a:schemeClr val="accent2"/>
-                </a:solidFill>
-              </a:rPr>
-              <a:t>APPENDIX: INTERNATIONAL COMPANY SCREENS</a:t>
-            </a:r>
-            <a:endParaRPr lang="en-US" sz="1000" dirty="0"/>
-          </a:p>
-        </p:txBody>
-      </p:sp>
-      <p:sp>
-        <p:nvSpPr>
-          <p:cNvPr id="3" name="Text 2"/>
-          <p:cNvSpPr/>
-          <p:nvPr>
-            <p:ph idx="103" type="title" hasCustomPrompt="1"/>
-          </p:nvPr>
-        </p:nvSpPr>
-        <p:spPr>
-          <a:xfrm>
-            <a:off x="548640" y="640080"/>
-            <a:ext cx="11091672" cy="749808"/>
-          </a:xfrm>
-          <a:prstGeom prst="rect">
-            <a:avLst/>
-          </a:prstGeom>
-          <a:noFill/>
-          <a:ln/>
-        </p:spPr>
-        <p:txBody>
-          <a:bodyPr wrap="square" lIns="0" tIns="0" rIns="0" bIns="0" rtlCol="0" anchor="t"/>
-          <a:lstStyle/>
-          <a:p>
-            <a:pPr algn="l" indent="0" marL="0">
-              <a:buNone/>
-            </a:pPr>
-            <a:r>
-              <a:rPr lang="en-US" sz="2200" b="1" dirty="0">
-                <a:solidFill>
-                  <a:schemeClr val="accent1"/>
-                </a:solidFill>
-              </a:rPr>
-              <a:t>International screens add eight examples; none shows a higher screened share than the U.S.</a:t>
-            </a:r>
-            <a:endParaRPr lang="en-US" sz="2200" dirty="0"/>
-          </a:p>
-        </p:txBody>
-      </p:sp>
-      <p:sp>
-        <p:nvSpPr>
-          <p:cNvPr id="4" name="label"/>
-          <p:cNvSpPr txBox="1"/>
-          <p:nvPr/>
-        </p:nvSpPr>
-        <p:spPr>
-          <a:xfrm>
-            <a:off x="548640" y="1481328"/>
-            <a:ext cx="7680960" cy="201168"/>
-          </a:xfrm>
-          <a:prstGeom prst="rect">
-            <a:avLst/>
-          </a:prstGeom>
-          <a:noFill/>
-          <a:ln/>
-        </p:spPr>
-        <p:txBody>
-          <a:bodyPr wrap="square" lIns="0" tIns="0" rIns="0" bIns="0" rtlCol="0" anchor="t"/>
-          <a:lstStyle/>
-          <a:p>
-            <a:pPr indent="0" marL="0">
-              <a:buNone/>
-            </a:pPr>
-            <a:r>
-              <a:rPr lang="en-US" sz="1000" b="1" spc="100" kern="0" dirty="0">
-                <a:solidFill>
-                  <a:schemeClr val="accent2"/>
-                </a:solidFill>
-              </a:rPr>
-              <a:t>COMPARABLE COMPANIES MARKETING CONVERSATIONAL AI</a:t>
-            </a:r>
-            <a:endParaRPr lang="en-US" sz="1000" dirty="0"/>
-          </a:p>
-        </p:txBody>
-      </p:sp>
-      <p:sp>
-        <p:nvSpPr>
-          <p:cNvPr id="5" name="table header"/>
-          <p:cNvSpPr/>
-          <p:nvPr/>
-        </p:nvSpPr>
-        <p:spPr>
-          <a:xfrm>
-            <a:off x="548640" y="1792224"/>
-            <a:ext cx="7635240" cy="512064"/>
-          </a:xfrm>
-          <a:prstGeom prst="rect">
-            <a:avLst/>
-          </a:prstGeom>
-          <a:solidFill>
-            <a:schemeClr val="accent1"/>
-          </a:solidFill>
-          <a:ln/>
-        </p:spPr>
-        <p:txBody>
-          <a:bodyPr/>
-          <a:p/>
-        </p:txBody>
-      </p:sp>
-      <p:sp>
-        <p:nvSpPr>
-          <p:cNvPr id="6" name="Text 4"/>
-          <p:cNvSpPr txBox="1"/>
-          <p:nvPr/>
-        </p:nvSpPr>
-        <p:spPr>
-          <a:xfrm>
-            <a:off x="548640" y="1792224"/>
-            <a:ext cx="1188720" cy="512064"/>
-          </a:xfrm>
-          <a:prstGeom prst="rect">
-            <a:avLst/>
-          </a:prstGeom>
-          <a:noFill/>
-          <a:ln/>
-        </p:spPr>
-        <p:txBody>
-          <a:bodyPr wrap="square" lIns="0" tIns="0" rIns="0" bIns="0" rtlCol="0" anchor="ctr"/>
-          <a:lstStyle/>
-          <a:p>
-            <a:pPr algn="ctr" indent="0" marL="0">
-              <a:buNone/>
-            </a:pPr>
-            <a:r>
-              <a:rPr lang="en-US" sz="900" b="1" dirty="0">
-                <a:solidFill>
-                  <a:schemeClr val="bg1"/>
-                </a:solidFill>
-              </a:rPr>
-              <a:t>International</a:t>
-            </a:r>
-            <a:endParaRPr lang="en-US" sz="900" dirty="0"/>
-          </a:p>
-          <a:p>
-            <a:pPr algn="ctr" indent="0" marL="0">
-              <a:buNone/>
-            </a:pPr>
-            <a:r>
-              <a:rPr lang="en-US" sz="900" b="1" dirty="0">
-                <a:solidFill>
-                  <a:schemeClr val="bg1"/>
-                </a:solidFill>
-              </a:rPr>
-              <a:t>Screen</a:t>
-            </a:r>
-            <a:endParaRPr lang="en-US" sz="900" dirty="0"/>
-          </a:p>
-        </p:txBody>
-      </p:sp>
-      <p:sp>
-        <p:nvSpPr>
-          <p:cNvPr id="7" name="Text 5"/>
-          <p:cNvSpPr txBox="1"/>
-          <p:nvPr/>
-        </p:nvSpPr>
-        <p:spPr>
-          <a:xfrm>
-            <a:off x="1847088" y="1792224"/>
-            <a:ext cx="4618145" cy="512064"/>
-          </a:xfrm>
-          <a:prstGeom prst="rect">
-            <a:avLst/>
-          </a:prstGeom>
-          <a:noFill/>
-          <a:ln/>
-        </p:spPr>
-        <p:txBody>
-          <a:bodyPr wrap="square" lIns="0" tIns="0" rIns="0" bIns="0" rtlCol="0" anchor="ctr"/>
-          <a:lstStyle/>
-          <a:p>
-            <a:pPr algn="ctr" indent="0" marL="0">
-              <a:buNone/>
-            </a:pPr>
-            <a:r>
-              <a:rPr lang="en-US" sz="900" b="1" dirty="0">
-                <a:solidFill>
-                  <a:schemeClr val="bg1"/>
-                </a:solidFill>
-              </a:rPr>
-              <a:t>Companies marketing conversational AI /</a:t>
-            </a:r>
-            <a:endParaRPr lang="en-US" sz="900" dirty="0"/>
-          </a:p>
-          <a:p>
-            <a:pPr algn="ctr" indent="0" marL="0">
-              <a:buNone/>
-            </a:pPr>
-            <a:r>
-              <a:rPr lang="en-US" sz="900" b="1" dirty="0">
-                <a:solidFill>
-                  <a:schemeClr val="bg1"/>
-                </a:solidFill>
-              </a:rPr>
-              <a:t>Total comparable companies</a:t>
-            </a:r>
-            <a:endParaRPr lang="en-US" sz="900" dirty="0"/>
-          </a:p>
-        </p:txBody>
-      </p:sp>
-      <p:sp>
-        <p:nvSpPr>
-          <p:cNvPr id="8" name="Text 6"/>
-          <p:cNvSpPr txBox="1"/>
-          <p:nvPr/>
-        </p:nvSpPr>
-        <p:spPr>
-          <a:xfrm>
-            <a:off x="6574961" y="1792224"/>
-            <a:ext cx="1608919" cy="512064"/>
-          </a:xfrm>
-          <a:prstGeom prst="rect">
-            <a:avLst/>
-          </a:prstGeom>
-          <a:noFill/>
-          <a:ln/>
-        </p:spPr>
-        <p:txBody>
-          <a:bodyPr wrap="square" lIns="0" tIns="0" rIns="0" bIns="0" rtlCol="0" anchor="ctr"/>
-          <a:lstStyle/>
-          <a:p>
-            <a:pPr algn="ctr" indent="0" marL="0">
-              <a:buNone/>
-            </a:pPr>
-            <a:r>
-              <a:rPr lang="en-US" sz="900" b="1" dirty="0">
-                <a:solidFill>
-                  <a:schemeClr val="bg1"/>
-                </a:solidFill>
-              </a:rPr>
-              <a:t>Screened-</a:t>
-            </a:r>
-            <a:endParaRPr lang="en-US" sz="900" dirty="0"/>
-          </a:p>
-          <a:p>
-            <a:pPr algn="ctr" indent="0" marL="0">
-              <a:buNone/>
-            </a:pPr>
-            <a:r>
-              <a:rPr lang="en-US" sz="900" b="1" dirty="0">
-                <a:solidFill>
-                  <a:schemeClr val="bg1"/>
-                </a:solidFill>
-              </a:rPr>
-              <a:t>company share</a:t>
-            </a:r>
-            <a:endParaRPr lang="en-US" sz="900" dirty="0"/>
-          </a:p>
-        </p:txBody>
-      </p:sp>
-      <p:graphicFrame>
-        <p:nvGraphicFramePr>
-          <p:cNvPr id="9" name="screened-company share chart" descr=""/>
-          <p:cNvGraphicFramePr/>
-          <p:nvPr/>
-        </p:nvGraphicFramePr>
-        <p:xfrm>
-          <a:off x="1847088" y="2432304"/>
-          <a:ext cx="4572000" cy="3685032"/>
-        </p:xfrm>
-        <a:graphic xmlns:a="http://schemas.openxmlformats.org/drawingml/2006/main">
-          <a:graphicData uri="http://schemas.openxmlformats.org/drawingml/2006/chart">
-            <c:chart xmlns:c="http://schemas.openxmlformats.org/drawingml/2006/chart" r:id="rId1"/>
-          </a:graphicData>
-        </a:graphic>
-      </p:graphicFrame>
-      <p:sp>
-        <p:nvSpPr>
-          <p:cNvPr id="10" name="Text 7"/>
-          <p:cNvSpPr txBox="1"/>
-          <p:nvPr/>
-        </p:nvSpPr>
-        <p:spPr>
-          <a:xfrm>
-            <a:off x="548640" y="2432304"/>
-            <a:ext cx="1143000" cy="228600"/>
-          </a:xfrm>
-          <a:prstGeom prst="rect">
-            <a:avLst/>
-          </a:prstGeom>
-          <a:noFill/>
-          <a:ln/>
-        </p:spPr>
-        <p:txBody>
-          <a:bodyPr wrap="square" lIns="0" tIns="0" rIns="0" bIns="0" rtlCol="0" anchor="ctr"/>
-          <a:lstStyle/>
-          <a:p>
-            <a:pPr algn="r" indent="0" marL="0">
-              <a:buNone/>
-            </a:pPr>
-            <a:r>
-              <a:rPr lang="en-US" sz="900" b="1" dirty="0">
-                <a:solidFill>
-                  <a:schemeClr val="accent1"/>
-                </a:solidFill>
-              </a:rPr>
-              <a:t>United States</a:t>
-            </a:r>
-            <a:endParaRPr lang="en-US" sz="900" dirty="0"/>
-          </a:p>
-        </p:txBody>
-      </p:sp>
-      <p:sp>
-        <p:nvSpPr>
-          <p:cNvPr id="11" name="fraction United States"/>
-          <p:cNvSpPr txBox="1"/>
-          <p:nvPr/>
-        </p:nvSpPr>
-        <p:spPr>
-          <a:xfrm>
-            <a:off x="5898305" y="2432304"/>
-            <a:ext cx="640080" cy="228600"/>
-          </a:xfrm>
-          <a:prstGeom prst="rect">
-            <a:avLst/>
-          </a:prstGeom>
-          <a:noFill/>
-          <a:ln/>
-        </p:spPr>
-        <p:txBody>
-          <a:bodyPr wrap="square" lIns="0" tIns="0" rIns="0" bIns="0" rtlCol="0" anchor="ctr"/>
-          <a:lstStyle/>
-          <a:p>
-            <a:pPr indent="0" marL="0">
-              <a:buNone/>
-            </a:pPr>
-            <a:r>
-              <a:rPr lang="en-US" sz="900" b="1" dirty="0">
-                <a:solidFill>
-                  <a:schemeClr val="accent1"/>
-                </a:solidFill>
-              </a:rPr>
-              <a:t>15</a:t>
-            </a:r>
-            <a:r>
-              <a:rPr lang="en-US" sz="900" dirty="0">
-                <a:solidFill>
-                  <a:schemeClr val="tx1"/>
-                </a:solidFill>
-              </a:rPr>
-              <a:t> / 43</a:t>
-            </a:r>
-            <a:endParaRPr lang="en-US" sz="900" dirty="0"/>
-          </a:p>
-        </p:txBody>
-      </p:sp>
-      <p:sp>
-        <p:nvSpPr>
-          <p:cNvPr id="12" name="Text 9"/>
-          <p:cNvSpPr txBox="1"/>
-          <p:nvPr/>
-        </p:nvSpPr>
-        <p:spPr>
-          <a:xfrm>
-            <a:off x="6574961" y="2432304"/>
-            <a:ext cx="1608919" cy="228600"/>
-          </a:xfrm>
-          <a:prstGeom prst="rect">
-            <a:avLst/>
-          </a:prstGeom>
-          <a:noFill/>
-          <a:ln/>
-        </p:spPr>
-        <p:txBody>
-          <a:bodyPr wrap="square" lIns="0" tIns="0" rIns="0" bIns="0" rtlCol="0" anchor="ctr"/>
-          <a:lstStyle/>
-          <a:p>
-            <a:pPr algn="ctr" indent="0" marL="0">
-              <a:buNone/>
-            </a:pPr>
-            <a:r>
-              <a:rPr lang="en-US" sz="900" b="1" dirty="0">
-                <a:solidFill>
-                  <a:schemeClr val="accent1"/>
-                </a:solidFill>
-              </a:rPr>
-              <a:t>34.9%</a:t>
-            </a:r>
-            <a:endParaRPr lang="en-US" sz="900" dirty="0"/>
-          </a:p>
-        </p:txBody>
-      </p:sp>
-      <p:sp>
-        <p:nvSpPr>
-          <p:cNvPr id="13" name="Text 10"/>
-          <p:cNvSpPr txBox="1"/>
-          <p:nvPr/>
-        </p:nvSpPr>
-        <p:spPr>
-          <a:xfrm>
-            <a:off x="548640" y="2660904"/>
-            <a:ext cx="1143000" cy="228600"/>
-          </a:xfrm>
-          <a:prstGeom prst="rect">
-            <a:avLst/>
-          </a:prstGeom>
-          <a:noFill/>
-          <a:ln/>
-        </p:spPr>
-        <p:txBody>
-          <a:bodyPr wrap="square" lIns="0" tIns="0" rIns="0" bIns="0" rtlCol="0" anchor="ctr"/>
-          <a:lstStyle/>
-          <a:p>
-            <a:pPr algn="r" indent="0" marL="0">
-              <a:buNone/>
-            </a:pPr>
-            <a:r>
-              <a:rPr lang="en-US" sz="900" dirty="0">
-                <a:solidFill>
-                  <a:schemeClr val="tx1"/>
-                </a:solidFill>
-              </a:rPr>
-              <a:t>China</a:t>
-            </a:r>
-            <a:endParaRPr lang="en-US" sz="900" dirty="0"/>
-          </a:p>
-        </p:txBody>
-      </p:sp>
-      <p:sp>
-        <p:nvSpPr>
-          <p:cNvPr id="14" name="fraction China"/>
-          <p:cNvSpPr txBox="1"/>
-          <p:nvPr/>
-        </p:nvSpPr>
-        <p:spPr>
-          <a:xfrm>
-            <a:off x="4187952" y="2660904"/>
-            <a:ext cx="640080" cy="228600"/>
-          </a:xfrm>
-          <a:prstGeom prst="rect">
-            <a:avLst/>
-          </a:prstGeom>
-          <a:noFill/>
-          <a:ln/>
-        </p:spPr>
-        <p:txBody>
-          <a:bodyPr wrap="square" lIns="0" tIns="0" rIns="0" bIns="0" rtlCol="0" anchor="ctr"/>
-          <a:lstStyle/>
-          <a:p>
-            <a:pPr indent="0" marL="0">
-              <a:buNone/>
-            </a:pPr>
-            <a:r>
-              <a:rPr lang="en-US" sz="900" b="1" dirty="0">
-                <a:solidFill>
-                  <a:schemeClr val="accent1"/>
-                </a:solidFill>
-              </a:rPr>
-              <a:t>4</a:t>
-            </a:r>
-            <a:r>
-              <a:rPr lang="en-US" sz="900" dirty="0">
-                <a:solidFill>
-                  <a:schemeClr val="tx1"/>
-                </a:solidFill>
-              </a:rPr>
-              <a:t> / 20</a:t>
-            </a:r>
-            <a:endParaRPr lang="en-US" sz="900" dirty="0"/>
-          </a:p>
-        </p:txBody>
-      </p:sp>
-      <p:sp>
-        <p:nvSpPr>
-          <p:cNvPr id="15" name="Text 12"/>
-          <p:cNvSpPr txBox="1"/>
-          <p:nvPr/>
-        </p:nvSpPr>
-        <p:spPr>
-          <a:xfrm>
-            <a:off x="6574961" y="2660904"/>
-            <a:ext cx="1608919" cy="228600"/>
-          </a:xfrm>
-          <a:prstGeom prst="rect">
-            <a:avLst/>
-          </a:prstGeom>
-          <a:noFill/>
-          <a:ln/>
-        </p:spPr>
-        <p:txBody>
-          <a:bodyPr wrap="square" lIns="0" tIns="0" rIns="0" bIns="0" rtlCol="0" anchor="ctr"/>
-          <a:lstStyle/>
-          <a:p>
-            <a:pPr algn="ctr" indent="0" marL="0">
-              <a:buNone/>
-            </a:pPr>
-            <a:r>
-              <a:rPr lang="en-US" sz="900" dirty="0">
-                <a:solidFill>
-                  <a:schemeClr val="accent4"/>
-                </a:solidFill>
-              </a:rPr>
-              <a:t>20.0%</a:t>
-            </a:r>
-            <a:endParaRPr lang="en-US" sz="900" dirty="0"/>
-          </a:p>
-        </p:txBody>
-      </p:sp>
-      <p:sp>
-        <p:nvSpPr>
-          <p:cNvPr id="16" name="Text 13"/>
-          <p:cNvSpPr txBox="1"/>
-          <p:nvPr/>
-        </p:nvSpPr>
-        <p:spPr>
-          <a:xfrm>
-            <a:off x="548640" y="2889504"/>
-            <a:ext cx="1143000" cy="228600"/>
-          </a:xfrm>
-          <a:prstGeom prst="rect">
-            <a:avLst/>
-          </a:prstGeom>
-          <a:noFill/>
-          <a:ln/>
-        </p:spPr>
-        <p:txBody>
-          <a:bodyPr wrap="square" lIns="0" tIns="0" rIns="0" bIns="0" rtlCol="0" anchor="ctr"/>
-          <a:lstStyle/>
-          <a:p>
-            <a:pPr algn="r" indent="0" marL="0">
-              <a:buNone/>
-            </a:pPr>
-            <a:r>
-              <a:rPr lang="en-US" sz="900" dirty="0">
-                <a:solidFill>
-                  <a:schemeClr val="tx1"/>
-                </a:solidFill>
-              </a:rPr>
-              <a:t>Spain</a:t>
-            </a:r>
-            <a:endParaRPr lang="en-US" sz="900" dirty="0"/>
-          </a:p>
-        </p:txBody>
-      </p:sp>
-      <p:sp>
-        <p:nvSpPr>
-          <p:cNvPr id="17" name="fraction Spain"/>
-          <p:cNvSpPr txBox="1"/>
-          <p:nvPr/>
-        </p:nvSpPr>
-        <p:spPr>
-          <a:xfrm>
-            <a:off x="3928155" y="2889504"/>
-            <a:ext cx="640080" cy="228600"/>
-          </a:xfrm>
-          <a:prstGeom prst="rect">
-            <a:avLst/>
-          </a:prstGeom>
-          <a:noFill/>
-          <a:ln/>
-        </p:spPr>
-        <p:txBody>
-          <a:bodyPr wrap="square" lIns="0" tIns="0" rIns="0" bIns="0" rtlCol="0" anchor="ctr"/>
-          <a:lstStyle/>
-          <a:p>
-            <a:pPr indent="0" marL="0">
-              <a:buNone/>
-            </a:pPr>
-            <a:r>
-              <a:rPr lang="en-US" sz="900" b="1" dirty="0">
-                <a:solidFill>
-                  <a:schemeClr val="accent1"/>
-                </a:solidFill>
-              </a:rPr>
-              <a:t>3</a:t>
-            </a:r>
-            <a:r>
-              <a:rPr lang="en-US" sz="900" dirty="0">
-                <a:solidFill>
-                  <a:schemeClr val="tx1"/>
-                </a:solidFill>
-              </a:rPr>
-              <a:t> / 17</a:t>
-            </a:r>
-            <a:endParaRPr lang="en-US" sz="900" dirty="0"/>
-          </a:p>
-        </p:txBody>
-      </p:sp>
-      <p:sp>
-        <p:nvSpPr>
-          <p:cNvPr id="18" name="Text 15"/>
-          <p:cNvSpPr txBox="1"/>
-          <p:nvPr/>
-        </p:nvSpPr>
-        <p:spPr>
-          <a:xfrm>
-            <a:off x="6574961" y="2889504"/>
-            <a:ext cx="1608919" cy="228600"/>
-          </a:xfrm>
-          <a:prstGeom prst="rect">
-            <a:avLst/>
-          </a:prstGeom>
-          <a:noFill/>
-          <a:ln/>
-        </p:spPr>
-        <p:txBody>
-          <a:bodyPr wrap="square" lIns="0" tIns="0" rIns="0" bIns="0" rtlCol="0" anchor="ctr"/>
-          <a:lstStyle/>
-          <a:p>
-            <a:pPr algn="ctr" indent="0" marL="0">
-              <a:buNone/>
-            </a:pPr>
-            <a:r>
-              <a:rPr lang="en-US" sz="900" dirty="0">
-                <a:solidFill>
-                  <a:schemeClr val="accent4"/>
-                </a:solidFill>
-              </a:rPr>
-              <a:t>17.6%</a:t>
-            </a:r>
-            <a:endParaRPr lang="en-US" sz="900" dirty="0"/>
-          </a:p>
-        </p:txBody>
-      </p:sp>
-      <p:sp>
-        <p:nvSpPr>
-          <p:cNvPr id="19" name="Text 16"/>
-          <p:cNvSpPr txBox="1"/>
-          <p:nvPr/>
-        </p:nvSpPr>
-        <p:spPr>
-          <a:xfrm>
-            <a:off x="548640" y="3118104"/>
-            <a:ext cx="1143000" cy="228600"/>
-          </a:xfrm>
-          <a:prstGeom prst="rect">
-            <a:avLst/>
-          </a:prstGeom>
-          <a:noFill/>
-          <a:ln/>
-        </p:spPr>
-        <p:txBody>
-          <a:bodyPr wrap="square" lIns="0" tIns="0" rIns="0" bIns="0" rtlCol="0" anchor="ctr"/>
-          <a:lstStyle/>
-          <a:p>
-            <a:pPr algn="r" indent="0" marL="0">
-              <a:buNone/>
-            </a:pPr>
-            <a:r>
-              <a:rPr lang="en-US" sz="900" dirty="0">
-                <a:solidFill>
-                  <a:schemeClr val="tx1"/>
-                </a:solidFill>
-              </a:rPr>
-              <a:t>Israel</a:t>
-            </a:r>
-            <a:endParaRPr lang="en-US" sz="900" dirty="0"/>
-          </a:p>
-        </p:txBody>
-      </p:sp>
-      <p:sp>
-        <p:nvSpPr>
-          <p:cNvPr id="20" name="fraction Israel"/>
-          <p:cNvSpPr txBox="1"/>
-          <p:nvPr/>
-        </p:nvSpPr>
-        <p:spPr>
-          <a:xfrm>
-            <a:off x="3435096" y="3118104"/>
-            <a:ext cx="640080" cy="228600"/>
-          </a:xfrm>
-          <a:prstGeom prst="rect">
-            <a:avLst/>
-          </a:prstGeom>
-          <a:noFill/>
-          <a:ln/>
-        </p:spPr>
-        <p:txBody>
-          <a:bodyPr wrap="square" lIns="0" tIns="0" rIns="0" bIns="0" rtlCol="0" anchor="ctr"/>
-          <a:lstStyle/>
-          <a:p>
-            <a:pPr indent="0" marL="0">
-              <a:buNone/>
-            </a:pPr>
-            <a:r>
-              <a:rPr lang="en-US" sz="900" b="1" dirty="0">
-                <a:solidFill>
-                  <a:schemeClr val="accent1"/>
-                </a:solidFill>
-              </a:rPr>
-              <a:t>2</a:t>
-            </a:r>
-            <a:r>
-              <a:rPr lang="en-US" sz="900" dirty="0">
-                <a:solidFill>
-                  <a:schemeClr val="tx1"/>
-                </a:solidFill>
-              </a:rPr>
-              <a:t> / 15</a:t>
-            </a:r>
-            <a:endParaRPr lang="en-US" sz="900" dirty="0"/>
-          </a:p>
-        </p:txBody>
-      </p:sp>
-      <p:sp>
-        <p:nvSpPr>
-          <p:cNvPr id="21" name="Text 18"/>
-          <p:cNvSpPr txBox="1"/>
-          <p:nvPr/>
-        </p:nvSpPr>
-        <p:spPr>
-          <a:xfrm>
-            <a:off x="6574961" y="3118104"/>
-            <a:ext cx="1608919" cy="228600"/>
-          </a:xfrm>
-          <a:prstGeom prst="rect">
-            <a:avLst/>
-          </a:prstGeom>
-          <a:noFill/>
-          <a:ln/>
-        </p:spPr>
-        <p:txBody>
-          <a:bodyPr wrap="square" lIns="0" tIns="0" rIns="0" bIns="0" rtlCol="0" anchor="ctr"/>
-          <a:lstStyle/>
-          <a:p>
-            <a:pPr algn="ctr" indent="0" marL="0">
-              <a:buNone/>
-            </a:pPr>
-            <a:r>
-              <a:rPr lang="en-US" sz="900" dirty="0">
-                <a:solidFill>
-                  <a:schemeClr val="accent4"/>
-                </a:solidFill>
-              </a:rPr>
-              <a:t>13.3%</a:t>
-            </a:r>
-            <a:endParaRPr lang="en-US" sz="900" dirty="0"/>
-          </a:p>
-        </p:txBody>
-      </p:sp>
-      <p:sp>
-        <p:nvSpPr>
-          <p:cNvPr id="22" name="Text 19"/>
-          <p:cNvSpPr txBox="1"/>
-          <p:nvPr/>
-        </p:nvSpPr>
-        <p:spPr>
-          <a:xfrm>
-            <a:off x="548640" y="3346704"/>
-            <a:ext cx="1143000" cy="228600"/>
-          </a:xfrm>
-          <a:prstGeom prst="rect">
-            <a:avLst/>
-          </a:prstGeom>
-          <a:noFill/>
-          <a:ln/>
-        </p:spPr>
-        <p:txBody>
-          <a:bodyPr wrap="square" lIns="0" tIns="0" rIns="0" bIns="0" rtlCol="0" anchor="ctr"/>
-          <a:lstStyle/>
-          <a:p>
-            <a:pPr algn="r" indent="0" marL="0">
-              <a:buNone/>
-            </a:pPr>
-            <a:r>
-              <a:rPr lang="en-US" sz="900" dirty="0">
-                <a:solidFill>
-                  <a:schemeClr val="tx1"/>
-                </a:solidFill>
-              </a:rPr>
-              <a:t>France</a:t>
-            </a:r>
-            <a:endParaRPr lang="en-US" sz="900" dirty="0"/>
-          </a:p>
-        </p:txBody>
-      </p:sp>
-      <p:sp>
-        <p:nvSpPr>
-          <p:cNvPr id="23" name="fraction France"/>
-          <p:cNvSpPr txBox="1"/>
-          <p:nvPr/>
-        </p:nvSpPr>
-        <p:spPr>
-          <a:xfrm>
-            <a:off x="3255802" y="3346704"/>
-            <a:ext cx="640080" cy="228600"/>
-          </a:xfrm>
-          <a:prstGeom prst="rect">
-            <a:avLst/>
-          </a:prstGeom>
-          <a:noFill/>
-          <a:ln/>
-        </p:spPr>
-        <p:txBody>
-          <a:bodyPr wrap="square" lIns="0" tIns="0" rIns="0" bIns="0" rtlCol="0" anchor="ctr"/>
-          <a:lstStyle/>
-          <a:p>
-            <a:pPr indent="0" marL="0">
-              <a:buNone/>
-            </a:pPr>
-            <a:r>
-              <a:rPr lang="en-US" sz="900" b="1" dirty="0">
-                <a:solidFill>
-                  <a:schemeClr val="accent1"/>
-                </a:solidFill>
-              </a:rPr>
-              <a:t>2</a:t>
-            </a:r>
-            <a:r>
-              <a:rPr lang="en-US" sz="900" dirty="0">
-                <a:solidFill>
-                  <a:schemeClr val="tx1"/>
-                </a:solidFill>
-              </a:rPr>
-              <a:t> / 17</a:t>
-            </a:r>
-            <a:endParaRPr lang="en-US" sz="900" dirty="0"/>
-          </a:p>
-        </p:txBody>
-      </p:sp>
-      <p:sp>
-        <p:nvSpPr>
-          <p:cNvPr id="24" name="Text 21"/>
-          <p:cNvSpPr txBox="1"/>
-          <p:nvPr/>
-        </p:nvSpPr>
-        <p:spPr>
-          <a:xfrm>
-            <a:off x="6574961" y="3346704"/>
-            <a:ext cx="1608919" cy="228600"/>
-          </a:xfrm>
-          <a:prstGeom prst="rect">
-            <a:avLst/>
-          </a:prstGeom>
-          <a:noFill/>
-          <a:ln/>
-        </p:spPr>
-        <p:txBody>
-          <a:bodyPr wrap="square" lIns="0" tIns="0" rIns="0" bIns="0" rtlCol="0" anchor="ctr"/>
-          <a:lstStyle/>
-          <a:p>
-            <a:pPr algn="ctr" indent="0" marL="0">
-              <a:buNone/>
-            </a:pPr>
-            <a:r>
-              <a:rPr lang="en-US" sz="900" dirty="0">
-                <a:solidFill>
-                  <a:schemeClr val="accent4"/>
-                </a:solidFill>
-              </a:rPr>
-              <a:t>11.8%</a:t>
-            </a:r>
-            <a:endParaRPr lang="en-US" sz="900" dirty="0"/>
-          </a:p>
-        </p:txBody>
-      </p:sp>
-      <p:sp>
-        <p:nvSpPr>
-          <p:cNvPr id="25" name="Text 22"/>
-          <p:cNvSpPr txBox="1"/>
-          <p:nvPr/>
-        </p:nvSpPr>
-        <p:spPr>
-          <a:xfrm>
-            <a:off x="548640" y="3575304"/>
-            <a:ext cx="1143000" cy="228600"/>
-          </a:xfrm>
-          <a:prstGeom prst="rect">
-            <a:avLst/>
-          </a:prstGeom>
-          <a:noFill/>
-          <a:ln/>
-        </p:spPr>
-        <p:txBody>
-          <a:bodyPr wrap="square" lIns="0" tIns="0" rIns="0" bIns="0" rtlCol="0" anchor="ctr"/>
-          <a:lstStyle/>
-          <a:p>
-            <a:pPr algn="r" indent="0" marL="0">
-              <a:buNone/>
-            </a:pPr>
-            <a:r>
-              <a:rPr lang="en-US" sz="900" dirty="0">
-                <a:solidFill>
-                  <a:schemeClr val="tx1"/>
-                </a:solidFill>
-              </a:rPr>
-              <a:t>Nordics</a:t>
-            </a:r>
-            <a:endParaRPr lang="en-US" sz="900" dirty="0"/>
-          </a:p>
-        </p:txBody>
-      </p:sp>
-      <p:sp>
-        <p:nvSpPr>
-          <p:cNvPr id="26" name="fraction Nordics"/>
-          <p:cNvSpPr txBox="1"/>
-          <p:nvPr/>
-        </p:nvSpPr>
-        <p:spPr>
-          <a:xfrm>
-            <a:off x="3255802" y="3575304"/>
-            <a:ext cx="640080" cy="228600"/>
-          </a:xfrm>
-          <a:prstGeom prst="rect">
-            <a:avLst/>
-          </a:prstGeom>
-          <a:noFill/>
-          <a:ln/>
-        </p:spPr>
-        <p:txBody>
-          <a:bodyPr wrap="square" lIns="0" tIns="0" rIns="0" bIns="0" rtlCol="0" anchor="ctr"/>
-          <a:lstStyle/>
-          <a:p>
-            <a:pPr indent="0" marL="0">
-              <a:buNone/>
-            </a:pPr>
-            <a:r>
-              <a:rPr lang="en-US" sz="900" b="1" dirty="0">
-                <a:solidFill>
-                  <a:schemeClr val="accent1"/>
-                </a:solidFill>
-              </a:rPr>
-              <a:t>2</a:t>
-            </a:r>
-            <a:r>
-              <a:rPr lang="en-US" sz="900" dirty="0">
-                <a:solidFill>
-                  <a:schemeClr val="tx1"/>
-                </a:solidFill>
-              </a:rPr>
-              <a:t> / 17</a:t>
-            </a:r>
-            <a:endParaRPr lang="en-US" sz="900" dirty="0"/>
-          </a:p>
-        </p:txBody>
-      </p:sp>
-      <p:sp>
-        <p:nvSpPr>
-          <p:cNvPr id="27" name="Text 24"/>
-          <p:cNvSpPr txBox="1"/>
-          <p:nvPr/>
-        </p:nvSpPr>
-        <p:spPr>
-          <a:xfrm>
-            <a:off x="6574961" y="3575304"/>
-            <a:ext cx="1608919" cy="228600"/>
-          </a:xfrm>
-          <a:prstGeom prst="rect">
-            <a:avLst/>
-          </a:prstGeom>
-          <a:noFill/>
-          <a:ln/>
-        </p:spPr>
-        <p:txBody>
-          <a:bodyPr wrap="square" lIns="0" tIns="0" rIns="0" bIns="0" rtlCol="0" anchor="ctr"/>
-          <a:lstStyle/>
-          <a:p>
-            <a:pPr algn="ctr" indent="0" marL="0">
-              <a:buNone/>
-            </a:pPr>
-            <a:r>
-              <a:rPr lang="en-US" sz="900" dirty="0">
-                <a:solidFill>
-                  <a:schemeClr val="accent4"/>
-                </a:solidFill>
-              </a:rPr>
-              <a:t>11.8%</a:t>
-            </a:r>
-            <a:endParaRPr lang="en-US" sz="900" dirty="0"/>
-          </a:p>
-        </p:txBody>
-      </p:sp>
-      <p:sp>
-        <p:nvSpPr>
-          <p:cNvPr id="28" name="Text 25"/>
-          <p:cNvSpPr txBox="1"/>
-          <p:nvPr/>
-        </p:nvSpPr>
-        <p:spPr>
-          <a:xfrm>
-            <a:off x="548640" y="3803904"/>
-            <a:ext cx="1143000" cy="228600"/>
-          </a:xfrm>
-          <a:prstGeom prst="rect">
-            <a:avLst/>
-          </a:prstGeom>
-          <a:noFill/>
-          <a:ln/>
-        </p:spPr>
-        <p:txBody>
-          <a:bodyPr wrap="square" lIns="0" tIns="0" rIns="0" bIns="0" rtlCol="0" anchor="ctr"/>
-          <a:lstStyle/>
-          <a:p>
-            <a:pPr algn="r" indent="0" marL="0">
-              <a:buNone/>
-            </a:pPr>
-            <a:r>
-              <a:rPr lang="en-US" sz="900" dirty="0">
-                <a:solidFill>
-                  <a:schemeClr val="tx1"/>
-                </a:solidFill>
-              </a:rPr>
-              <a:t>India</a:t>
-            </a:r>
-            <a:endParaRPr lang="en-US" sz="900" dirty="0"/>
-          </a:p>
-        </p:txBody>
-      </p:sp>
-      <p:sp>
-        <p:nvSpPr>
-          <p:cNvPr id="29" name="fraction India"/>
-          <p:cNvSpPr txBox="1"/>
-          <p:nvPr/>
-        </p:nvSpPr>
-        <p:spPr>
-          <a:xfrm>
-            <a:off x="2982659" y="3803904"/>
-            <a:ext cx="640080" cy="228600"/>
-          </a:xfrm>
-          <a:prstGeom prst="rect">
-            <a:avLst/>
-          </a:prstGeom>
-          <a:noFill/>
-          <a:ln/>
-        </p:spPr>
-        <p:txBody>
-          <a:bodyPr wrap="square" lIns="0" tIns="0" rIns="0" bIns="0" rtlCol="0" anchor="ctr"/>
-          <a:lstStyle/>
-          <a:p>
-            <a:pPr indent="0" marL="0">
-              <a:buNone/>
-            </a:pPr>
-            <a:r>
-              <a:rPr lang="en-US" sz="900" b="1" dirty="0">
-                <a:solidFill>
-                  <a:schemeClr val="accent1"/>
-                </a:solidFill>
-              </a:rPr>
-              <a:t>3</a:t>
-            </a:r>
-            <a:r>
-              <a:rPr lang="en-US" sz="900" dirty="0">
-                <a:solidFill>
-                  <a:schemeClr val="tx1"/>
-                </a:solidFill>
-              </a:rPr>
-              <a:t> / 32</a:t>
-            </a:r>
-            <a:endParaRPr lang="en-US" sz="900" dirty="0"/>
-          </a:p>
-        </p:txBody>
-      </p:sp>
-      <p:sp>
-        <p:nvSpPr>
-          <p:cNvPr id="30" name="Text 27"/>
-          <p:cNvSpPr txBox="1"/>
-          <p:nvPr/>
-        </p:nvSpPr>
-        <p:spPr>
-          <a:xfrm>
-            <a:off x="6574961" y="3803904"/>
-            <a:ext cx="1608919" cy="228600"/>
-          </a:xfrm>
-          <a:prstGeom prst="rect">
-            <a:avLst/>
-          </a:prstGeom>
-          <a:noFill/>
-          <a:ln/>
-        </p:spPr>
-        <p:txBody>
-          <a:bodyPr wrap="square" lIns="0" tIns="0" rIns="0" bIns="0" rtlCol="0" anchor="ctr"/>
-          <a:lstStyle/>
-          <a:p>
-            <a:pPr algn="ctr" indent="0" marL="0">
-              <a:buNone/>
-            </a:pPr>
-            <a:r>
-              <a:rPr lang="en-US" sz="900" dirty="0">
-                <a:solidFill>
-                  <a:schemeClr val="accent4"/>
-                </a:solidFill>
-              </a:rPr>
-              <a:t>9.4%</a:t>
-            </a:r>
-            <a:endParaRPr lang="en-US" sz="900" dirty="0"/>
-          </a:p>
-        </p:txBody>
-      </p:sp>
-      <p:sp>
-        <p:nvSpPr>
-          <p:cNvPr id="31" name="Text 28"/>
-          <p:cNvSpPr txBox="1"/>
-          <p:nvPr/>
-        </p:nvSpPr>
-        <p:spPr>
-          <a:xfrm>
-            <a:off x="548640" y="4032504"/>
-            <a:ext cx="1143000" cy="228600"/>
-          </a:xfrm>
-          <a:prstGeom prst="rect">
-            <a:avLst/>
-          </a:prstGeom>
-          <a:noFill/>
-          <a:ln/>
-        </p:spPr>
-        <p:txBody>
-          <a:bodyPr wrap="square" lIns="0" tIns="0" rIns="0" bIns="0" rtlCol="0" anchor="ctr"/>
-          <a:lstStyle/>
-          <a:p>
-            <a:pPr algn="r" indent="0" marL="0">
-              <a:buNone/>
-            </a:pPr>
-            <a:r>
-              <a:rPr lang="en-US" sz="900" dirty="0">
-                <a:solidFill>
-                  <a:schemeClr val="tx1"/>
-                </a:solidFill>
-              </a:rPr>
-              <a:t>Netherlands</a:t>
-            </a:r>
-            <a:endParaRPr lang="en-US" sz="900" dirty="0"/>
-          </a:p>
-        </p:txBody>
-      </p:sp>
-      <p:sp>
-        <p:nvSpPr>
-          <p:cNvPr id="32" name="fraction Netherlands"/>
-          <p:cNvSpPr txBox="1"/>
-          <p:nvPr/>
-        </p:nvSpPr>
-        <p:spPr>
-          <a:xfrm>
-            <a:off x="2950187" y="4032504"/>
-            <a:ext cx="640080" cy="228600"/>
-          </a:xfrm>
-          <a:prstGeom prst="rect">
-            <a:avLst/>
-          </a:prstGeom>
-          <a:noFill/>
-          <a:ln/>
-        </p:spPr>
-        <p:txBody>
-          <a:bodyPr wrap="square" lIns="0" tIns="0" rIns="0" bIns="0" rtlCol="0" anchor="ctr"/>
-          <a:lstStyle/>
-          <a:p>
-            <a:pPr indent="0" marL="0">
-              <a:buNone/>
-            </a:pPr>
-            <a:r>
-              <a:rPr lang="en-US" sz="900" b="1" dirty="0">
-                <a:solidFill>
-                  <a:schemeClr val="accent1"/>
-                </a:solidFill>
-              </a:rPr>
-              <a:t>1</a:t>
-            </a:r>
-            <a:r>
-              <a:rPr lang="en-US" sz="900" dirty="0">
-                <a:solidFill>
-                  <a:schemeClr val="tx1"/>
-                </a:solidFill>
-              </a:rPr>
-              <a:t> / 11</a:t>
-            </a:r>
-            <a:endParaRPr lang="en-US" sz="900" dirty="0"/>
-          </a:p>
-        </p:txBody>
-      </p:sp>
-      <p:sp>
-        <p:nvSpPr>
-          <p:cNvPr id="33" name="Text 30"/>
-          <p:cNvSpPr txBox="1"/>
-          <p:nvPr/>
-        </p:nvSpPr>
-        <p:spPr>
-          <a:xfrm>
-            <a:off x="6574961" y="4032504"/>
-            <a:ext cx="1608919" cy="228600"/>
-          </a:xfrm>
-          <a:prstGeom prst="rect">
-            <a:avLst/>
-          </a:prstGeom>
-          <a:noFill/>
-          <a:ln/>
-        </p:spPr>
-        <p:txBody>
-          <a:bodyPr wrap="square" lIns="0" tIns="0" rIns="0" bIns="0" rtlCol="0" anchor="ctr"/>
-          <a:lstStyle/>
-          <a:p>
-            <a:pPr algn="ctr" indent="0" marL="0">
-              <a:buNone/>
-            </a:pPr>
-            <a:r>
-              <a:rPr lang="en-US" sz="900" dirty="0">
-                <a:solidFill>
-                  <a:schemeClr val="accent4"/>
-                </a:solidFill>
-              </a:rPr>
-              <a:t>9.1%</a:t>
-            </a:r>
-            <a:endParaRPr lang="en-US" sz="900" dirty="0"/>
-          </a:p>
-        </p:txBody>
-      </p:sp>
-      <p:sp>
-        <p:nvSpPr>
-          <p:cNvPr id="34" name="Text 31"/>
-          <p:cNvSpPr txBox="1"/>
-          <p:nvPr/>
-        </p:nvSpPr>
-        <p:spPr>
-          <a:xfrm>
-            <a:off x="548640" y="4261104"/>
-            <a:ext cx="1143000" cy="228600"/>
-          </a:xfrm>
-          <a:prstGeom prst="rect">
-            <a:avLst/>
-          </a:prstGeom>
-          <a:noFill/>
-          <a:ln/>
-        </p:spPr>
-        <p:txBody>
-          <a:bodyPr wrap="square" lIns="0" tIns="0" rIns="0" bIns="0" rtlCol="0" anchor="ctr"/>
-          <a:lstStyle/>
-          <a:p>
-            <a:pPr algn="r" indent="0" marL="0">
-              <a:buNone/>
-            </a:pPr>
-            <a:r>
-              <a:rPr lang="en-US" sz="900" dirty="0">
-                <a:solidFill>
-                  <a:schemeClr val="tx1"/>
-                </a:solidFill>
-              </a:rPr>
-              <a:t>Australia</a:t>
-            </a:r>
-            <a:endParaRPr lang="en-US" sz="900" dirty="0"/>
-          </a:p>
-        </p:txBody>
-      </p:sp>
-      <p:sp>
-        <p:nvSpPr>
-          <p:cNvPr id="35" name="fraction Australia"/>
-          <p:cNvSpPr txBox="1"/>
-          <p:nvPr/>
-        </p:nvSpPr>
-        <p:spPr>
-          <a:xfrm>
-            <a:off x="2727525" y="4261104"/>
-            <a:ext cx="640080" cy="228600"/>
-          </a:xfrm>
-          <a:prstGeom prst="rect">
-            <a:avLst/>
-          </a:prstGeom>
-          <a:noFill/>
-          <a:ln/>
-        </p:spPr>
-        <p:txBody>
-          <a:bodyPr wrap="square" lIns="0" tIns="0" rIns="0" bIns="0" rtlCol="0" anchor="ctr"/>
-          <a:lstStyle/>
-          <a:p>
-            <a:pPr indent="0" marL="0">
-              <a:buNone/>
-            </a:pPr>
-            <a:r>
-              <a:rPr lang="en-US" sz="900" b="1" dirty="0">
-                <a:solidFill>
-                  <a:schemeClr val="accent1"/>
-                </a:solidFill>
-              </a:rPr>
-              <a:t>1</a:t>
-            </a:r>
-            <a:r>
-              <a:rPr lang="en-US" sz="900" dirty="0">
-                <a:solidFill>
-                  <a:schemeClr val="tx1"/>
-                </a:solidFill>
-              </a:rPr>
-              <a:t> / 14</a:t>
-            </a:r>
-            <a:endParaRPr lang="en-US" sz="900" dirty="0"/>
-          </a:p>
-        </p:txBody>
-      </p:sp>
-      <p:sp>
-        <p:nvSpPr>
-          <p:cNvPr id="36" name="Text 33"/>
-          <p:cNvSpPr txBox="1"/>
-          <p:nvPr/>
-        </p:nvSpPr>
-        <p:spPr>
-          <a:xfrm>
-            <a:off x="6574961" y="4261104"/>
-            <a:ext cx="1608919" cy="228600"/>
-          </a:xfrm>
-          <a:prstGeom prst="rect">
-            <a:avLst/>
-          </a:prstGeom>
-          <a:noFill/>
-          <a:ln/>
-        </p:spPr>
-        <p:txBody>
-          <a:bodyPr wrap="square" lIns="0" tIns="0" rIns="0" bIns="0" rtlCol="0" anchor="ctr"/>
-          <a:lstStyle/>
-          <a:p>
-            <a:pPr algn="ctr" indent="0" marL="0">
-              <a:buNone/>
-            </a:pPr>
-            <a:r>
-              <a:rPr lang="en-US" sz="900" dirty="0">
-                <a:solidFill>
-                  <a:schemeClr val="accent4"/>
-                </a:solidFill>
-              </a:rPr>
-              <a:t>7.1%</a:t>
-            </a:r>
-            <a:endParaRPr lang="en-US" sz="900" dirty="0"/>
-          </a:p>
-        </p:txBody>
-      </p:sp>
-      <p:sp>
-        <p:nvSpPr>
-          <p:cNvPr id="37" name="Text 34"/>
-          <p:cNvSpPr txBox="1"/>
-          <p:nvPr/>
-        </p:nvSpPr>
-        <p:spPr>
-          <a:xfrm>
-            <a:off x="548640" y="4489704"/>
-            <a:ext cx="1143000" cy="228600"/>
-          </a:xfrm>
-          <a:prstGeom prst="rect">
-            <a:avLst/>
-          </a:prstGeom>
-          <a:noFill/>
-          <a:ln/>
-        </p:spPr>
-        <p:txBody>
-          <a:bodyPr wrap="square" lIns="0" tIns="0" rIns="0" bIns="0" rtlCol="0" anchor="ctr"/>
-          <a:lstStyle/>
-          <a:p>
-            <a:pPr algn="r" indent="0" marL="0">
-              <a:buNone/>
-            </a:pPr>
-            <a:r>
-              <a:rPr lang="en-US" sz="900" dirty="0">
-                <a:solidFill>
-                  <a:schemeClr val="tx1"/>
-                </a:solidFill>
-              </a:rPr>
-              <a:t>South Korea</a:t>
-            </a:r>
-            <a:endParaRPr lang="en-US" sz="900" dirty="0"/>
-          </a:p>
-        </p:txBody>
-      </p:sp>
-      <p:sp>
-        <p:nvSpPr>
-          <p:cNvPr id="38" name="fraction South Korea"/>
-          <p:cNvSpPr txBox="1"/>
-          <p:nvPr/>
-        </p:nvSpPr>
-        <p:spPr>
-          <a:xfrm>
-            <a:off x="2583449" y="4489704"/>
-            <a:ext cx="640080" cy="228600"/>
-          </a:xfrm>
-          <a:prstGeom prst="rect">
-            <a:avLst/>
-          </a:prstGeom>
-          <a:noFill/>
-          <a:ln/>
-        </p:spPr>
-        <p:txBody>
-          <a:bodyPr wrap="square" lIns="0" tIns="0" rIns="0" bIns="0" rtlCol="0" anchor="ctr"/>
-          <a:lstStyle/>
-          <a:p>
-            <a:pPr indent="0" marL="0">
-              <a:buNone/>
-            </a:pPr>
-            <a:r>
-              <a:rPr lang="en-US" sz="900" b="1" dirty="0">
-                <a:solidFill>
-                  <a:schemeClr val="accent1"/>
-                </a:solidFill>
-              </a:rPr>
-              <a:t>1</a:t>
-            </a:r>
-            <a:r>
-              <a:rPr lang="en-US" sz="900" dirty="0">
-                <a:solidFill>
-                  <a:schemeClr val="tx1"/>
-                </a:solidFill>
-              </a:rPr>
-              <a:t> / 17</a:t>
-            </a:r>
-            <a:endParaRPr lang="en-US" sz="900" dirty="0"/>
-          </a:p>
-        </p:txBody>
-      </p:sp>
-      <p:sp>
-        <p:nvSpPr>
-          <p:cNvPr id="39" name="Text 36"/>
-          <p:cNvSpPr txBox="1"/>
-          <p:nvPr/>
-        </p:nvSpPr>
-        <p:spPr>
-          <a:xfrm>
-            <a:off x="6574961" y="4489704"/>
-            <a:ext cx="1608919" cy="228600"/>
-          </a:xfrm>
-          <a:prstGeom prst="rect">
-            <a:avLst/>
-          </a:prstGeom>
-          <a:noFill/>
-          <a:ln/>
-        </p:spPr>
-        <p:txBody>
-          <a:bodyPr wrap="square" lIns="0" tIns="0" rIns="0" bIns="0" rtlCol="0" anchor="ctr"/>
-          <a:lstStyle/>
-          <a:p>
-            <a:pPr algn="ctr" indent="0" marL="0">
-              <a:buNone/>
-            </a:pPr>
-            <a:r>
-              <a:rPr lang="en-US" sz="900" dirty="0">
-                <a:solidFill>
-                  <a:schemeClr val="accent4"/>
-                </a:solidFill>
-              </a:rPr>
-              <a:t>5.9%</a:t>
-            </a:r>
-            <a:endParaRPr lang="en-US" sz="900" dirty="0"/>
-          </a:p>
-        </p:txBody>
-      </p:sp>
-      <p:sp>
-        <p:nvSpPr>
-          <p:cNvPr id="40" name="Text 37"/>
-          <p:cNvSpPr txBox="1"/>
-          <p:nvPr/>
-        </p:nvSpPr>
-        <p:spPr>
-          <a:xfrm>
-            <a:off x="548640" y="4718304"/>
-            <a:ext cx="1143000" cy="228600"/>
-          </a:xfrm>
-          <a:prstGeom prst="rect">
-            <a:avLst/>
-          </a:prstGeom>
-          <a:noFill/>
-          <a:ln/>
-        </p:spPr>
-        <p:txBody>
-          <a:bodyPr wrap="square" lIns="0" tIns="0" rIns="0" bIns="0" rtlCol="0" anchor="ctr"/>
-          <a:lstStyle/>
-          <a:p>
-            <a:pPr algn="r" indent="0" marL="0">
-              <a:buNone/>
-            </a:pPr>
-            <a:r>
-              <a:rPr lang="en-US" sz="900" dirty="0">
-                <a:solidFill>
-                  <a:schemeClr val="tx1"/>
-                </a:solidFill>
-              </a:rPr>
-              <a:t>Belgium</a:t>
-            </a:r>
-            <a:endParaRPr lang="en-US" sz="900" dirty="0"/>
-          </a:p>
-        </p:txBody>
-      </p:sp>
-      <p:sp>
-        <p:nvSpPr>
-          <p:cNvPr id="41" name="fraction Belgium"/>
-          <p:cNvSpPr txBox="1"/>
-          <p:nvPr/>
-        </p:nvSpPr>
-        <p:spPr>
-          <a:xfrm>
-            <a:off x="2546096" y="4718304"/>
-            <a:ext cx="640080" cy="228600"/>
-          </a:xfrm>
-          <a:prstGeom prst="rect">
-            <a:avLst/>
-          </a:prstGeom>
-          <a:noFill/>
-          <a:ln/>
-        </p:spPr>
-        <p:txBody>
-          <a:bodyPr wrap="square" lIns="0" tIns="0" rIns="0" bIns="0" rtlCol="0" anchor="ctr"/>
-          <a:lstStyle/>
-          <a:p>
-            <a:pPr indent="0" marL="0">
-              <a:buNone/>
-            </a:pPr>
-            <a:r>
-              <a:rPr lang="en-US" sz="900" b="1" dirty="0">
-                <a:solidFill>
-                  <a:schemeClr val="accent1"/>
-                </a:solidFill>
-              </a:rPr>
-              <a:t>1</a:t>
-            </a:r>
-            <a:r>
-              <a:rPr lang="en-US" sz="900" dirty="0">
-                <a:solidFill>
-                  <a:schemeClr val="tx1"/>
-                </a:solidFill>
-              </a:rPr>
-              <a:t> / 18</a:t>
-            </a:r>
-            <a:endParaRPr lang="en-US" sz="900" dirty="0"/>
-          </a:p>
-        </p:txBody>
-      </p:sp>
-      <p:sp>
-        <p:nvSpPr>
-          <p:cNvPr id="42" name="Text 39"/>
-          <p:cNvSpPr txBox="1"/>
-          <p:nvPr/>
-        </p:nvSpPr>
-        <p:spPr>
-          <a:xfrm>
-            <a:off x="6574961" y="4718304"/>
-            <a:ext cx="1608919" cy="228600"/>
-          </a:xfrm>
-          <a:prstGeom prst="rect">
-            <a:avLst/>
-          </a:prstGeom>
-          <a:noFill/>
-          <a:ln/>
-        </p:spPr>
-        <p:txBody>
-          <a:bodyPr wrap="square" lIns="0" tIns="0" rIns="0" bIns="0" rtlCol="0" anchor="ctr"/>
-          <a:lstStyle/>
-          <a:p>
-            <a:pPr algn="ctr" indent="0" marL="0">
-              <a:buNone/>
-            </a:pPr>
-            <a:r>
-              <a:rPr lang="en-US" sz="900" dirty="0">
-                <a:solidFill>
-                  <a:schemeClr val="accent4"/>
-                </a:solidFill>
-              </a:rPr>
-              <a:t>5.6%</a:t>
-            </a:r>
-            <a:endParaRPr lang="en-US" sz="900" dirty="0"/>
-          </a:p>
-        </p:txBody>
-      </p:sp>
-      <p:sp>
-        <p:nvSpPr>
-          <p:cNvPr id="43" name="Text 40"/>
-          <p:cNvSpPr txBox="1"/>
-          <p:nvPr/>
-        </p:nvSpPr>
-        <p:spPr>
-          <a:xfrm>
-            <a:off x="548640" y="4946904"/>
-            <a:ext cx="1143000" cy="228600"/>
-          </a:xfrm>
-          <a:prstGeom prst="rect">
-            <a:avLst/>
-          </a:prstGeom>
-          <a:noFill/>
-          <a:ln/>
-        </p:spPr>
-        <p:txBody>
-          <a:bodyPr wrap="square" lIns="0" tIns="0" rIns="0" bIns="0" rtlCol="0" anchor="ctr"/>
-          <a:lstStyle/>
-          <a:p>
-            <a:pPr algn="r" indent="0" marL="0">
-              <a:buNone/>
-            </a:pPr>
-            <a:r>
-              <a:rPr lang="en-US" sz="900" dirty="0">
-                <a:solidFill>
-                  <a:schemeClr val="tx1"/>
-                </a:solidFill>
-              </a:rPr>
-              <a:t>United Kingdom</a:t>
-            </a:r>
-            <a:endParaRPr lang="en-US" sz="900" dirty="0"/>
-          </a:p>
-        </p:txBody>
-      </p:sp>
-      <p:sp>
-        <p:nvSpPr>
-          <p:cNvPr id="44" name="fraction United Kingdom"/>
-          <p:cNvSpPr txBox="1"/>
-          <p:nvPr/>
-        </p:nvSpPr>
-        <p:spPr>
-          <a:xfrm>
-            <a:off x="2546096" y="4946904"/>
-            <a:ext cx="640080" cy="228600"/>
-          </a:xfrm>
-          <a:prstGeom prst="rect">
-            <a:avLst/>
-          </a:prstGeom>
-          <a:noFill/>
-          <a:ln/>
-        </p:spPr>
-        <p:txBody>
-          <a:bodyPr wrap="square" lIns="0" tIns="0" rIns="0" bIns="0" rtlCol="0" anchor="ctr"/>
-          <a:lstStyle/>
-          <a:p>
-            <a:pPr indent="0" marL="0">
-              <a:buNone/>
-            </a:pPr>
-            <a:r>
-              <a:rPr lang="en-US" sz="900" b="1" dirty="0">
-                <a:solidFill>
-                  <a:schemeClr val="accent1"/>
-                </a:solidFill>
-              </a:rPr>
-              <a:t>1</a:t>
-            </a:r>
-            <a:r>
-              <a:rPr lang="en-US" sz="900" dirty="0">
-                <a:solidFill>
-                  <a:schemeClr val="tx1"/>
-                </a:solidFill>
-              </a:rPr>
-              <a:t> / 18</a:t>
-            </a:r>
-            <a:endParaRPr lang="en-US" sz="900" dirty="0"/>
-          </a:p>
-        </p:txBody>
-      </p:sp>
-      <p:sp>
-        <p:nvSpPr>
-          <p:cNvPr id="45" name="Text 42"/>
-          <p:cNvSpPr txBox="1"/>
-          <p:nvPr/>
-        </p:nvSpPr>
-        <p:spPr>
-          <a:xfrm>
-            <a:off x="6574961" y="4946904"/>
-            <a:ext cx="1608919" cy="228600"/>
-          </a:xfrm>
-          <a:prstGeom prst="rect">
-            <a:avLst/>
-          </a:prstGeom>
-          <a:noFill/>
-          <a:ln/>
-        </p:spPr>
-        <p:txBody>
-          <a:bodyPr wrap="square" lIns="0" tIns="0" rIns="0" bIns="0" rtlCol="0" anchor="ctr"/>
-          <a:lstStyle/>
-          <a:p>
-            <a:pPr algn="ctr" indent="0" marL="0">
-              <a:buNone/>
-            </a:pPr>
-            <a:r>
-              <a:rPr lang="en-US" sz="900" dirty="0">
-                <a:solidFill>
-                  <a:schemeClr val="accent4"/>
-                </a:solidFill>
-              </a:rPr>
-              <a:t>5.6%</a:t>
-            </a:r>
-            <a:endParaRPr lang="en-US" sz="900" dirty="0"/>
-          </a:p>
-        </p:txBody>
-      </p:sp>
-      <p:sp>
-        <p:nvSpPr>
-          <p:cNvPr id="46" name="Text 43"/>
-          <p:cNvSpPr txBox="1"/>
-          <p:nvPr/>
-        </p:nvSpPr>
-        <p:spPr>
-          <a:xfrm>
-            <a:off x="548640" y="5175504"/>
-            <a:ext cx="1143000" cy="228600"/>
-          </a:xfrm>
-          <a:prstGeom prst="rect">
-            <a:avLst/>
-          </a:prstGeom>
-          <a:noFill/>
-          <a:ln/>
-        </p:spPr>
-        <p:txBody>
-          <a:bodyPr wrap="square" lIns="0" tIns="0" rIns="0" bIns="0" rtlCol="0" anchor="ctr"/>
-          <a:lstStyle/>
-          <a:p>
-            <a:pPr algn="r" indent="0" marL="0">
-              <a:buNone/>
-            </a:pPr>
-            <a:r>
-              <a:rPr lang="en-US" sz="900" dirty="0">
-                <a:solidFill>
-                  <a:schemeClr val="tx1"/>
-                </a:solidFill>
-              </a:rPr>
-              <a:t>Canada</a:t>
-            </a:r>
-            <a:endParaRPr lang="en-US" sz="900" dirty="0"/>
-          </a:p>
-        </p:txBody>
-      </p:sp>
-      <p:sp>
-        <p:nvSpPr>
-          <p:cNvPr id="47" name="fraction Canada"/>
-          <p:cNvSpPr txBox="1"/>
-          <p:nvPr/>
-        </p:nvSpPr>
-        <p:spPr>
-          <a:xfrm>
-            <a:off x="1911096" y="5175504"/>
-            <a:ext cx="640080" cy="228600"/>
-          </a:xfrm>
-          <a:prstGeom prst="rect">
-            <a:avLst/>
-          </a:prstGeom>
-          <a:noFill/>
-          <a:ln/>
-        </p:spPr>
-        <p:txBody>
-          <a:bodyPr wrap="square" lIns="0" tIns="0" rIns="0" bIns="0" rtlCol="0" anchor="ctr"/>
-          <a:lstStyle/>
-          <a:p>
-            <a:pPr indent="0" marL="0">
-              <a:buNone/>
-            </a:pPr>
-            <a:r>
-              <a:rPr lang="en-US" sz="900" b="1" dirty="0">
-                <a:solidFill>
-                  <a:schemeClr val="accent1"/>
-                </a:solidFill>
-              </a:rPr>
-              <a:t>0</a:t>
-            </a:r>
-            <a:r>
-              <a:rPr lang="en-US" sz="900" dirty="0">
-                <a:solidFill>
-                  <a:schemeClr val="tx1"/>
-                </a:solidFill>
-              </a:rPr>
-              <a:t> / 11</a:t>
-            </a:r>
-            <a:endParaRPr lang="en-US" sz="900" dirty="0"/>
-          </a:p>
-        </p:txBody>
-      </p:sp>
-      <p:sp>
-        <p:nvSpPr>
-          <p:cNvPr id="48" name="Text 45"/>
-          <p:cNvSpPr txBox="1"/>
-          <p:nvPr/>
-        </p:nvSpPr>
-        <p:spPr>
-          <a:xfrm>
-            <a:off x="6574961" y="5175504"/>
-            <a:ext cx="1608919" cy="228600"/>
-          </a:xfrm>
-          <a:prstGeom prst="rect">
-            <a:avLst/>
-          </a:prstGeom>
-          <a:noFill/>
-          <a:ln/>
-        </p:spPr>
-        <p:txBody>
-          <a:bodyPr wrap="square" lIns="0" tIns="0" rIns="0" bIns="0" rtlCol="0" anchor="ctr"/>
-          <a:lstStyle/>
-          <a:p>
-            <a:pPr algn="ctr" indent="0" marL="0">
-              <a:buNone/>
-            </a:pPr>
-            <a:r>
-              <a:rPr lang="en-US" sz="900" dirty="0">
-                <a:solidFill>
-                  <a:schemeClr val="accent4"/>
-                </a:solidFill>
-              </a:rPr>
-              <a:t>0.0%</a:t>
-            </a:r>
-            <a:endParaRPr lang="en-US" sz="900" dirty="0"/>
-          </a:p>
-        </p:txBody>
-      </p:sp>
-      <p:sp>
-        <p:nvSpPr>
-          <p:cNvPr id="49" name="Text 46"/>
-          <p:cNvSpPr txBox="1"/>
-          <p:nvPr/>
-        </p:nvSpPr>
-        <p:spPr>
-          <a:xfrm>
-            <a:off x="548640" y="5404104"/>
-            <a:ext cx="1143000" cy="228600"/>
-          </a:xfrm>
-          <a:prstGeom prst="rect">
-            <a:avLst/>
-          </a:prstGeom>
-          <a:noFill/>
-          <a:ln/>
-        </p:spPr>
-        <p:txBody>
-          <a:bodyPr wrap="square" lIns="0" tIns="0" rIns="0" bIns="0" rtlCol="0" anchor="ctr"/>
-          <a:lstStyle/>
-          <a:p>
-            <a:pPr algn="r" indent="0" marL="0">
-              <a:buNone/>
-            </a:pPr>
-            <a:r>
-              <a:rPr lang="en-US" sz="900" dirty="0">
-                <a:solidFill>
-                  <a:schemeClr val="tx1"/>
-                </a:solidFill>
-              </a:rPr>
-              <a:t>Germany</a:t>
-            </a:r>
-            <a:endParaRPr lang="en-US" sz="900" dirty="0"/>
-          </a:p>
-        </p:txBody>
-      </p:sp>
-      <p:sp>
-        <p:nvSpPr>
-          <p:cNvPr id="50" name="fraction Germany"/>
-          <p:cNvSpPr txBox="1"/>
-          <p:nvPr/>
-        </p:nvSpPr>
-        <p:spPr>
-          <a:xfrm>
-            <a:off x="1911096" y="5404104"/>
-            <a:ext cx="640080" cy="228600"/>
-          </a:xfrm>
-          <a:prstGeom prst="rect">
-            <a:avLst/>
-          </a:prstGeom>
-          <a:noFill/>
-          <a:ln/>
-        </p:spPr>
-        <p:txBody>
-          <a:bodyPr wrap="square" lIns="0" tIns="0" rIns="0" bIns="0" rtlCol="0" anchor="ctr"/>
-          <a:lstStyle/>
-          <a:p>
-            <a:pPr indent="0" marL="0">
-              <a:buNone/>
-            </a:pPr>
-            <a:r>
-              <a:rPr lang="en-US" sz="900" b="1" dirty="0">
-                <a:solidFill>
-                  <a:schemeClr val="accent1"/>
-                </a:solidFill>
-              </a:rPr>
-              <a:t>0</a:t>
-            </a:r>
-            <a:r>
-              <a:rPr lang="en-US" sz="900" dirty="0">
-                <a:solidFill>
-                  <a:schemeClr val="tx1"/>
-                </a:solidFill>
-              </a:rPr>
-              <a:t> / 13</a:t>
-            </a:r>
-            <a:endParaRPr lang="en-US" sz="900" dirty="0"/>
-          </a:p>
-        </p:txBody>
-      </p:sp>
-      <p:sp>
-        <p:nvSpPr>
-          <p:cNvPr id="51" name="Text 48"/>
-          <p:cNvSpPr txBox="1"/>
-          <p:nvPr/>
-        </p:nvSpPr>
-        <p:spPr>
-          <a:xfrm>
-            <a:off x="6574961" y="5404104"/>
-            <a:ext cx="1608919" cy="228600"/>
-          </a:xfrm>
-          <a:prstGeom prst="rect">
-            <a:avLst/>
-          </a:prstGeom>
-          <a:noFill/>
-          <a:ln/>
-        </p:spPr>
-        <p:txBody>
-          <a:bodyPr wrap="square" lIns="0" tIns="0" rIns="0" bIns="0" rtlCol="0" anchor="ctr"/>
-          <a:lstStyle/>
-          <a:p>
-            <a:pPr algn="ctr" indent="0" marL="0">
-              <a:buNone/>
-            </a:pPr>
-            <a:r>
-              <a:rPr lang="en-US" sz="900" dirty="0">
-                <a:solidFill>
-                  <a:schemeClr val="accent4"/>
-                </a:solidFill>
-              </a:rPr>
-              <a:t>0.0%</a:t>
-            </a:r>
-            <a:endParaRPr lang="en-US" sz="900" dirty="0"/>
-          </a:p>
-        </p:txBody>
-      </p:sp>
-      <p:sp>
-        <p:nvSpPr>
-          <p:cNvPr id="52" name="Text 49"/>
-          <p:cNvSpPr txBox="1"/>
-          <p:nvPr/>
-        </p:nvSpPr>
-        <p:spPr>
-          <a:xfrm>
-            <a:off x="548640" y="5632704"/>
-            <a:ext cx="1143000" cy="228600"/>
-          </a:xfrm>
-          <a:prstGeom prst="rect">
-            <a:avLst/>
-          </a:prstGeom>
-          <a:noFill/>
-          <a:ln/>
-        </p:spPr>
-        <p:txBody>
-          <a:bodyPr wrap="square" lIns="0" tIns="0" rIns="0" bIns="0" rtlCol="0" anchor="ctr"/>
-          <a:lstStyle/>
-          <a:p>
-            <a:pPr algn="r" indent="0" marL="0">
-              <a:buNone/>
-            </a:pPr>
-            <a:r>
-              <a:rPr lang="en-US" sz="900" dirty="0">
-                <a:solidFill>
-                  <a:schemeClr val="tx1"/>
-                </a:solidFill>
-              </a:rPr>
-              <a:t>Japan</a:t>
-            </a:r>
-            <a:endParaRPr lang="en-US" sz="900" dirty="0"/>
-          </a:p>
-        </p:txBody>
-      </p:sp>
-      <p:sp>
-        <p:nvSpPr>
-          <p:cNvPr id="53" name="fraction Japan"/>
-          <p:cNvSpPr txBox="1"/>
-          <p:nvPr/>
-        </p:nvSpPr>
-        <p:spPr>
-          <a:xfrm>
-            <a:off x="1911096" y="5632704"/>
-            <a:ext cx="640080" cy="228600"/>
-          </a:xfrm>
-          <a:prstGeom prst="rect">
-            <a:avLst/>
-          </a:prstGeom>
-          <a:noFill/>
-          <a:ln/>
-        </p:spPr>
-        <p:txBody>
-          <a:bodyPr wrap="square" lIns="0" tIns="0" rIns="0" bIns="0" rtlCol="0" anchor="ctr"/>
-          <a:lstStyle/>
-          <a:p>
-            <a:pPr indent="0" marL="0">
-              <a:buNone/>
-            </a:pPr>
-            <a:r>
-              <a:rPr lang="en-US" sz="900" b="1" dirty="0">
-                <a:solidFill>
-                  <a:schemeClr val="accent1"/>
-                </a:solidFill>
-              </a:rPr>
-              <a:t>0</a:t>
-            </a:r>
-            <a:r>
-              <a:rPr lang="en-US" sz="900" dirty="0">
-                <a:solidFill>
-                  <a:schemeClr val="tx1"/>
-                </a:solidFill>
-              </a:rPr>
-              <a:t> / 15</a:t>
-            </a:r>
-            <a:endParaRPr lang="en-US" sz="900" dirty="0"/>
-          </a:p>
-        </p:txBody>
-      </p:sp>
-      <p:sp>
-        <p:nvSpPr>
-          <p:cNvPr id="54" name="Text 51"/>
-          <p:cNvSpPr txBox="1"/>
-          <p:nvPr/>
-        </p:nvSpPr>
-        <p:spPr>
-          <a:xfrm>
-            <a:off x="6574961" y="5632704"/>
-            <a:ext cx="1608919" cy="228600"/>
-          </a:xfrm>
-          <a:prstGeom prst="rect">
-            <a:avLst/>
-          </a:prstGeom>
-          <a:noFill/>
-          <a:ln/>
-        </p:spPr>
-        <p:txBody>
-          <a:bodyPr wrap="square" lIns="0" tIns="0" rIns="0" bIns="0" rtlCol="0" anchor="ctr"/>
-          <a:lstStyle/>
-          <a:p>
-            <a:pPr algn="ctr" indent="0" marL="0">
-              <a:buNone/>
-            </a:pPr>
-            <a:r>
-              <a:rPr lang="en-US" sz="900" dirty="0">
-                <a:solidFill>
-                  <a:schemeClr val="accent4"/>
-                </a:solidFill>
-              </a:rPr>
-              <a:t>0.0%</a:t>
-            </a:r>
-            <a:endParaRPr lang="en-US" sz="900" dirty="0"/>
-          </a:p>
-        </p:txBody>
-      </p:sp>
-      <p:sp>
-        <p:nvSpPr>
-          <p:cNvPr id="55" name="how to read card"/>
-          <p:cNvSpPr/>
-          <p:nvPr/>
-        </p:nvSpPr>
-        <p:spPr>
-          <a:xfrm>
-            <a:off x="8412480" y="1792224"/>
-            <a:ext cx="3227832" cy="1783080"/>
-          </a:xfrm>
-          <a:prstGeom prst="rect">
-            <a:avLst/>
-          </a:prstGeom>
-          <a:solidFill>
-            <a:schemeClr val="bg1"/>
-          </a:solidFill>
-          <a:ln/>
-          <a:effectLst>
-            <a:outerShdw sx="100000" sy="100000" kx="0" ky="0" algn="bl" rotWithShape="0" blurRad="101600" dist="25400" dir="5400000">
-              <a:srgbClr val="000000">
-                <a:alpha val="10000"/>
-              </a:srgbClr>
-            </a:outerShdw>
-          </a:effectLst>
-        </p:spPr>
-        <p:txBody>
-          <a:bodyPr/>
-          <a:p/>
-        </p:txBody>
-      </p:sp>
-      <p:sp>
-        <p:nvSpPr>
-          <p:cNvPr id="56" name="label"/>
-          <p:cNvSpPr txBox="1"/>
-          <p:nvPr/>
-        </p:nvSpPr>
-        <p:spPr>
-          <a:xfrm>
-            <a:off x="8613648" y="1988820"/>
-            <a:ext cx="2825496" cy="475488"/>
-          </a:xfrm>
-          <a:prstGeom prst="rect">
-            <a:avLst/>
-          </a:prstGeom>
-          <a:noFill/>
-          <a:ln/>
-        </p:spPr>
-        <p:txBody>
-          <a:bodyPr wrap="square" lIns="0" tIns="0" rIns="0" bIns="0" rtlCol="0" anchor="t"/>
-          <a:lstStyle/>
-          <a:p>
-            <a:pPr indent="0" marL="0">
-              <a:buNone/>
-            </a:pPr>
-            <a:r>
-              <a:rPr lang="en-US" sz="1300" b="1" spc="150" kern="0" dirty="0">
-                <a:solidFill>
-                  <a:schemeClr val="accent2"/>
-                </a:solidFill>
-              </a:rPr>
-              <a:t>HOW TO READ THE COMPARISON</a:t>
-            </a:r>
-            <a:endParaRPr lang="en-US" sz="1300" dirty="0"/>
-          </a:p>
-        </p:txBody>
-      </p:sp>
-      <p:sp>
-        <p:nvSpPr>
-          <p:cNvPr id="57" name="Text 54"/>
-          <p:cNvSpPr txBox="1"/>
-          <p:nvPr/>
-        </p:nvSpPr>
-        <p:spPr>
-          <a:xfrm>
-            <a:off x="8613648" y="2555748"/>
-            <a:ext cx="2825496" cy="822960"/>
-          </a:xfrm>
-          <a:prstGeom prst="rect">
-            <a:avLst/>
-          </a:prstGeom>
-          <a:noFill/>
-          <a:ln/>
-        </p:spPr>
-        <p:txBody>
-          <a:bodyPr wrap="square" lIns="0" tIns="0" rIns="0" bIns="0" rtlCol="0" anchor="t"/>
-          <a:lstStyle/>
-          <a:p>
-            <a:pPr indent="0" marL="0">
-              <a:buNone/>
-            </a:pPr>
-            <a:r>
-              <a:rPr lang="en-US" sz="1000" dirty="0">
-                <a:solidFill>
-                  <a:schemeClr val="tx1"/>
-                </a:solidFill>
-              </a:rPr>
-              <a:t>Each bar shows the share of screened comparable companies that market conversational AI. International counts exclude companies already represented in the U.S. inventory.</a:t>
-            </a:r>
-            <a:endParaRPr lang="en-US" sz="1000" dirty="0"/>
-          </a:p>
-        </p:txBody>
-      </p:sp>
-      <p:sp>
-        <p:nvSpPr>
-          <p:cNvPr id="25" name="Slide Number Placeholder 0"/>
-          <p:cNvSpPr>
-            <a:spLocks noGrp="1"/>
-          </p:cNvSpPr>
-          <p:nvPr>
-            <p:ph type="sldNum" sz="quarter" idx="4294967295"/>
-          </p:nvPr>
-        </p:nvSpPr>
-        <p:spPr>
-          <a:xfrm>
-            <a:off x="10725912" y="6309360"/>
-            <a:ext cx="914400" cy="201168"/>
-          </a:xfrm>
-          <a:prstGeom prst="rect">
-            <a:avLst/>
-          </a:prstGeom>
-          <a:extLst>
-            <a:ext uri="{C572A759-6A51-4108-AA02-DFA0A04FC94B}">
-              <ma14:wrappingTextBoxFlag xmlns:ma14="http://schemas.microsoft.com/office/mac/drawingml/2011/main" val="0"/>
-            </a:ext>
-          </a:extLst>
-        </p:spPr>
-        <p:txBody>
-          <a:bodyPr lIns="0" tIns="0" rIns="0" bIns="0"/>
-          <a:lstStyle>
-            <a:lvl1pPr>
-              <a:defRPr sz="900">
-                <a:solidFill>
-                  <a:schemeClr val="accent4"/>
-                </a:solidFill>
-              </a:defRPr>
-            </a:lvl1pPr>
-          </a:lstStyle>
-          <a:p>
-            <a:pPr algn="r"/>
-            <a:fld id="{F7021451-1387-4CA6-816F-3879F97B5CBC}" type="slidenum">
-              <a:rPr b="0" lang="en-US"/>
-              <a:t>14</a:t>
-            </a:fld>
-            <a:endParaRPr lang="en-US"/>
-          </a:p>
-        </p:txBody>
-      </p:sp>
-    </p:spTree>
-  </p:cSld>
-  <p:clrMapOvr>
-    <a:masterClrMapping/>
-  </p:clrMapOvr>
-</p:sld>
-</file>
-
 <file path=ppt/slides/slide2.xml><?xml version="1.0" encoding="utf-8"?>
 <p:sld xmlns:a="http://schemas.openxmlformats.org/drawingml/2006/main" xmlns:r="http://schemas.openxmlformats.org/officeDocument/2006/relationships" xmlns:p="http://schemas.openxmlformats.org/presentationml/2006/main">
   <p:cSld name="Slide 1">
@@ -15850,12 +13103,12 @@
               <a:buNone/>
             </a:pPr>
             <a:r>
-              <a:rPr lang="en-US" sz="1250" b="1" dirty="0">
+              <a:rPr lang="en-US" sz="1000" b="1" dirty="0">
                 <a:solidFill>
                   <a:schemeClr val="tx1"/>
                 </a:solidFill>
               </a:rPr>
-              <a:t>RWE has the highest concentration (9 of 34); market access the lowest (2 of 24).</a:t>
+              <a:t>Every domain now has competitors marketing conversational AI, from 9 in RWE to 2 in market access.</a:t>
             </a:r>
             <a:endParaRPr lang="en-US" sz="1050" dirty="0"/>
           </a:p>
@@ -15867,12 +13120,12 @@
               <a:buNone/>
             </a:pPr>
             <a:r>
-              <a:rPr lang="en-US" sz="1250" b="1" dirty="0">
+              <a:rPr lang="en-US" sz="1000" b="1" dirty="0">
                 <a:solidFill>
                   <a:schemeClr val="tx1"/>
                 </a:solidFill>
               </a:rPr>
-              <a:t>Norstella alone markets Ella-branded assistants in four of five domains.</a:t>
+              <a:t>Norstella alone markets Ella-branded assistants in four of the five.</a:t>
             </a:r>
             <a:endParaRPr lang="en-US" sz="1050" dirty="0"/>
           </a:p>

</xml_diff>

<commit_message>
Deck 10.16: LLM starting point, tile 4 rename, methodology counts note, review date, PDF properties
Co-Authored-By: Claude Opus 5.5 <noreply@anthropic.com>
Claude-Session: https://claude.ai/code/session_0198bm9pfzRwgZQBqNvd56W8
</commit_message>
<xml_diff>
--- a/deck/Optum-LS-Conversational-AI-10.16.pptx
+++ b/deck/Optum-LS-Conversational-AI-10.16.pptx
@@ -2570,7 +2570,7 @@
                 </a:solidFill>
                 <a:latin typeface="Arial"/>
               </a:rPr>
-              <a:t>October 2026  ·  Public sources reviewed as of October 13, 2026</a:t>
+              <a:t>October 2026  ·  Public sources reviewed as of October 16, 2026</a:t>
             </a:r>
           </a:p>
         </p:txBody>
@@ -6947,7 +6947,7 @@
                   <a:srgbClr val="002677"/>
                 </a:solidFill>
               </a:rPr>
-              <a:t>LLM providers already supply the model to </a:t>
+              <a:t>LLM providers already supply the model to competitors such as </a:t>
             </a:r>
             <a:r>
               <a:rPr sz="1050" u="sng">
@@ -6968,7 +6968,7 @@
                   <a:srgbClr val="002677"/>
                 </a:solidFill>
               </a:rPr>
-              <a:t>, </a:t>
+              <a:t> (Anthropic and Amazon) and </a:t>
             </a:r>
             <a:r>
               <a:rPr sz="1050" u="sng">
@@ -6981,7 +6981,7 @@
                   </a:solidFill>
                 </a:uFill>
               </a:rPr>
-              <a:t>Komodo</a:t>
+              <a:t>IQVIA</a:t>
             </a:r>
             <a:r>
               <a:rPr sz="1050">
@@ -6989,28 +6989,7 @@
                   <a:srgbClr val="002677"/>
                 </a:solidFill>
               </a:rPr>
-              <a:t> and </a:t>
-            </a:r>
-            <a:r>
-              <a:rPr sz="1050" u="sng">
-                <a:solidFill>
-                  <a:srgbClr val="002677"/>
-                </a:solidFill>
-                <a:uFill>
-                  <a:solidFill>
-                    <a:srgbClr val="9AA8CC"/>
-                  </a:solidFill>
-                </a:uFill>
-              </a:rPr>
-              <a:t>Datavant</a:t>
-            </a:r>
-            <a:r>
-              <a:rPr sz="1050">
-                <a:solidFill>
-                  <a:srgbClr val="002677"/>
-                </a:solidFill>
-              </a:rPr>
-              <a:t> (previous slide).</a:t>
+              <a:t> (NVIDIA) (previous slide).</a:t>
             </a:r>
           </a:p>
         </p:txBody>
@@ -7058,8 +7037,8 @@
         </p:nvSpPr>
         <p:spPr>
           <a:xfrm>
-            <a:off x="4440605" y="1550941"/>
-            <a:ext cx="404090" cy="148648"/>
+            <a:off x="5656681" y="1550941"/>
+            <a:ext cx="367758" cy="148648"/>
           </a:xfrm>
           <a:prstGeom prst="rect">
             <a:avLst/>
@@ -7093,16 +7072,16 @@
       </p:sp>
       <p:sp>
         <p:nvSpPr>
-          <p:cNvPr id="9714" name="Invisible source link 11: https://www.anthropic.com/news/claude-for-life-sciences">
-            <a:hlinkClick r:id="rId4"/>
+          <p:cNvPr id="9714" name="Invisible source link 11: https://www.iqvia.com/newsroom/2026/03/iqvia-unveils-iqvia-ai-a-unified-agentic-ai-platform">
+            <a:hlinkClick r:id="rId10"/>
           </p:cNvPr>
           <p:cNvSpPr/>
           <p:nvPr/>
         </p:nvSpPr>
         <p:spPr>
           <a:xfrm>
-            <a:off x="4880876" y="1550941"/>
-            <a:ext cx="492431" cy="148648"/>
+            <a:off x="7778165" y="1550941"/>
+            <a:ext cx="353506" cy="148648"/>
           </a:xfrm>
           <a:prstGeom prst="rect">
             <a:avLst/>
@@ -7136,16 +7115,16 @@
       </p:sp>
       <p:sp>
         <p:nvSpPr>
-          <p:cNvPr id="9715" name="Invisible source link 11: https://www.datavant.com/blog/how-ai-is-powering-smarter-privacy-preserving-data-discovery-for-life-sciences">
-            <a:hlinkClick r:id="rId6"/>
+          <p:cNvPr id="9715" name="Invisible source link 11: https://www.anthropic.com/news/claude-science-ai-workbench">
+            <a:hlinkClick r:id="rId11"/>
           </p:cNvPr>
           <p:cNvSpPr/>
           <p:nvPr/>
         </p:nvSpPr>
         <p:spPr>
           <a:xfrm>
-            <a:off x="5668924" y="1550941"/>
-            <a:ext cx="529860" cy="148648"/>
+            <a:off x="4108323" y="2569036"/>
+            <a:ext cx="843815" cy="127757"/>
           </a:xfrm>
           <a:prstGeom prst="rect">
             <a:avLst/>
@@ -7180,15 +7159,15 @@
       <p:sp>
         <p:nvSpPr>
           <p:cNvPr id="9716" name="Invisible source link 11: https://www.anthropic.com/news/claude-science-ai-workbench">
-            <a:hlinkClick r:id="rId10"/>
+            <a:hlinkClick r:id="rId11"/>
           </p:cNvPr>
           <p:cNvSpPr/>
           <p:nvPr/>
         </p:nvSpPr>
         <p:spPr>
           <a:xfrm>
-            <a:off x="4108323" y="2569036"/>
-            <a:ext cx="843815" cy="127757"/>
+            <a:off x="5943093" y="2569036"/>
+            <a:ext cx="1993865" cy="127757"/>
           </a:xfrm>
           <a:prstGeom prst="rect">
             <a:avLst/>
@@ -7222,16 +7201,16 @@
       </p:sp>
       <p:sp>
         <p:nvSpPr>
-          <p:cNvPr id="9717" name="Invisible source link 11: https://www.anthropic.com/news/claude-science-ai-workbench">
-            <a:hlinkClick r:id="rId10"/>
+          <p:cNvPr id="9717" name="Invisible source link 11: https://openai.com/index/introducing-gpt-rosalind">
+            <a:hlinkClick r:id="rId12"/>
           </p:cNvPr>
           <p:cNvSpPr/>
           <p:nvPr/>
         </p:nvSpPr>
         <p:spPr>
           <a:xfrm>
-            <a:off x="5943093" y="2569036"/>
-            <a:ext cx="1993865" cy="127757"/>
+            <a:off x="3975836" y="2850912"/>
+            <a:ext cx="780159" cy="127757"/>
           </a:xfrm>
           <a:prstGeom prst="rect">
             <a:avLst/>
@@ -7265,16 +7244,16 @@
       </p:sp>
       <p:sp>
         <p:nvSpPr>
-          <p:cNvPr id="9718" name="Invisible source link 11: https://openai.com/index/introducing-gpt-rosalind">
-            <a:hlinkClick r:id="rId11"/>
+          <p:cNvPr id="9718" name="Invisible source link 11: https://azure.microsoft.com/en-us/blog/announcing-microsoft-discovery-general-availability-and-microsoft-discovery-app-preview/">
+            <a:hlinkClick r:id="rId13"/>
           </p:cNvPr>
           <p:cNvSpPr/>
           <p:nvPr/>
         </p:nvSpPr>
         <p:spPr>
           <a:xfrm>
-            <a:off x="3975836" y="2850912"/>
-            <a:ext cx="780159" cy="127757"/>
+            <a:off x="3446995" y="3004633"/>
+            <a:ext cx="1122868" cy="127757"/>
           </a:xfrm>
           <a:prstGeom prst="rect">
             <a:avLst/>
@@ -7308,16 +7287,16 @@
       </p:sp>
       <p:sp>
         <p:nvSpPr>
-          <p:cNvPr id="9719" name="Invisible source link 11: https://azure.microsoft.com/en-us/blog/announcing-microsoft-discovery-general-availability-and-microsoft-discovery-app-preview/">
-            <a:hlinkClick r:id="rId12"/>
+          <p:cNvPr id="9719" name="Invisible source link 11: https://deepmind.google/blog/co-scientist-a-multi-agent-ai-partner-to-accelerate-research/">
+            <a:hlinkClick r:id="rId14"/>
           </p:cNvPr>
           <p:cNvSpPr/>
           <p:nvPr/>
         </p:nvSpPr>
         <p:spPr>
           <a:xfrm>
-            <a:off x="3446995" y="3004633"/>
-            <a:ext cx="1122868" cy="127757"/>
+            <a:off x="3962158" y="3158354"/>
+            <a:ext cx="697711" cy="127757"/>
           </a:xfrm>
           <a:prstGeom prst="rect">
             <a:avLst/>
@@ -7351,16 +7330,16 @@
       </p:sp>
       <p:sp>
         <p:nvSpPr>
-          <p:cNvPr id="9720" name="Invisible source link 11: https://deepmind.google/blog/co-scientist-a-multi-agent-ai-partner-to-accelerate-research/">
-            <a:hlinkClick r:id="rId13"/>
+          <p:cNvPr id="9720" name="Invisible source link 11: https://news.bms.com/news/details/2026/Bristol-Myers-Squibb-Announces-Strategic-Agreement-with-Anthropic-to-Position-Claude-Enterprise-as-the-Shared-Intelligence-Platform-Across-Its-Global-Operations/default.aspx">
+            <a:hlinkClick r:id="rId15"/>
           </p:cNvPr>
           <p:cNvSpPr/>
           <p:nvPr/>
         </p:nvSpPr>
         <p:spPr>
           <a:xfrm>
-            <a:off x="3962158" y="3158354"/>
-            <a:ext cx="697711" cy="127757"/>
+            <a:off x="3446995" y="3468678"/>
+            <a:ext cx="284795" cy="127757"/>
           </a:xfrm>
           <a:prstGeom prst="rect">
             <a:avLst/>
@@ -7395,15 +7374,15 @@
       <p:sp>
         <p:nvSpPr>
           <p:cNvPr id="9721" name="Invisible source link 11: https://news.bms.com/news/details/2026/Bristol-Myers-Squibb-Announces-Strategic-Agreement-with-Anthropic-to-Position-Claude-Enterprise-as-the-Shared-Intelligence-Platform-Across-Its-Global-Operations/default.aspx">
-            <a:hlinkClick r:id="rId14"/>
+            <a:hlinkClick r:id="rId15"/>
           </p:cNvPr>
           <p:cNvSpPr/>
           <p:nvPr/>
         </p:nvSpPr>
         <p:spPr>
           <a:xfrm>
-            <a:off x="3446995" y="3468678"/>
-            <a:ext cx="284795" cy="127757"/>
+            <a:off x="4245682" y="3468678"/>
+            <a:ext cx="2800920" cy="127757"/>
           </a:xfrm>
           <a:prstGeom prst="rect">
             <a:avLst/>
@@ -7438,15 +7417,15 @@
       <p:sp>
         <p:nvSpPr>
           <p:cNvPr id="9722" name="Invisible source link 11: https://news.bms.com/news/details/2026/Bristol-Myers-Squibb-Announces-Strategic-Agreement-with-Anthropic-to-Position-Claude-Enterprise-as-the-Shared-Intelligence-Platform-Across-Its-Global-Operations/default.aspx">
-            <a:hlinkClick r:id="rId14"/>
+            <a:hlinkClick r:id="rId15"/>
           </p:cNvPr>
           <p:cNvSpPr/>
           <p:nvPr/>
         </p:nvSpPr>
         <p:spPr>
           <a:xfrm>
-            <a:off x="4245682" y="3468678"/>
-            <a:ext cx="2800920" cy="127757"/>
+            <a:off x="6210261" y="3596834"/>
+            <a:ext cx="1803832" cy="127757"/>
           </a:xfrm>
           <a:prstGeom prst="rect">
             <a:avLst/>
@@ -7480,16 +7459,16 @@
       </p:sp>
       <p:sp>
         <p:nvSpPr>
-          <p:cNvPr id="9723" name="Invisible source link 11: https://news.bms.com/news/details/2026/Bristol-Myers-Squibb-Announces-Strategic-Agreement-with-Anthropic-to-Position-Claude-Enterprise-as-the-Shared-Intelligence-Platform-Across-Its-Global-Operations/default.aspx">
-            <a:hlinkClick r:id="rId14"/>
+          <p:cNvPr id="9724" name="Invisible source link 11: https://news.bms.com/news/details/2026/Bristol-Myers-Squibb-Announces-Strategic-Agreement-with-Anthropic-to-Position-Claude-Enterprise-as-the-Shared-Intelligence-Platform-Across-Its-Global-Operations/default.aspx">
+            <a:hlinkClick r:id="rId15"/>
           </p:cNvPr>
           <p:cNvSpPr/>
           <p:nvPr/>
         </p:nvSpPr>
         <p:spPr>
           <a:xfrm>
-            <a:off x="6210261" y="3596834"/>
-            <a:ext cx="1803832" cy="127757"/>
+            <a:off x="3446995" y="3725003"/>
+            <a:ext cx="609798" cy="127757"/>
           </a:xfrm>
           <a:prstGeom prst="rect">
             <a:avLst/>
@@ -7523,16 +7502,16 @@
       </p:sp>
       <p:sp>
         <p:nvSpPr>
-          <p:cNvPr id="9725" name="Invisible source link 11: https://news.bms.com/news/details/2026/Bristol-Myers-Squibb-Announces-Strategic-Agreement-with-Anthropic-to-Position-Claude-Enterprise-as-the-Shared-Intelligence-Platform-Across-Its-Global-Operations/default.aspx">
-            <a:hlinkClick r:id="rId14"/>
+          <p:cNvPr id="9724" name="Invisible source link 11: https://www.biopharminternational.com/view/novo-nordisk-partners-with-openai-for-drug-discovery">
+            <a:hlinkClick r:id="rId16"/>
           </p:cNvPr>
           <p:cNvSpPr/>
           <p:nvPr/>
         </p:nvSpPr>
         <p:spPr>
           <a:xfrm>
-            <a:off x="3446995" y="3725003"/>
-            <a:ext cx="609798" cy="127757"/>
+            <a:off x="5007597" y="3878723"/>
+            <a:ext cx="387049" cy="127757"/>
           </a:xfrm>
           <a:prstGeom prst="rect">
             <a:avLst/>
@@ -7567,15 +7546,15 @@
       <p:sp>
         <p:nvSpPr>
           <p:cNvPr id="9725" name="Invisible source link 11: https://www.biopharminternational.com/view/novo-nordisk-partners-with-openai-for-drug-discovery">
-            <a:hlinkClick r:id="rId15"/>
+            <a:hlinkClick r:id="rId16"/>
           </p:cNvPr>
           <p:cNvSpPr/>
           <p:nvPr/>
         </p:nvSpPr>
         <p:spPr>
           <a:xfrm>
-            <a:off x="5007597" y="3878723"/>
-            <a:ext cx="387049" cy="127757"/>
+            <a:off x="6728156" y="3878723"/>
+            <a:ext cx="1217753" cy="127757"/>
           </a:xfrm>
           <a:prstGeom prst="rect">
             <a:avLst/>
@@ -7609,16 +7588,16 @@
       </p:sp>
       <p:sp>
         <p:nvSpPr>
-          <p:cNvPr id="9726" name="Invisible source link 11: https://www.biopharminternational.com/view/novo-nordisk-partners-with-openai-for-drug-discovery">
-            <a:hlinkClick r:id="rId15"/>
+          <p:cNvPr id="9726" name="Invisible source link 11: https://www.novonordisk.com/news-and-media/news-and-ir-materials/news-details.html?id=916768">
+            <a:hlinkClick r:id="rId17"/>
           </p:cNvPr>
           <p:cNvSpPr/>
           <p:nvPr/>
         </p:nvSpPr>
         <p:spPr>
           <a:xfrm>
-            <a:off x="6728156" y="3878723"/>
-            <a:ext cx="1217753" cy="127757"/>
+            <a:off x="3681717" y="4006879"/>
+            <a:ext cx="482523" cy="127757"/>
           </a:xfrm>
           <a:prstGeom prst="rect">
             <a:avLst/>
@@ -7652,16 +7631,16 @@
       </p:sp>
       <p:sp>
         <p:nvSpPr>
-          <p:cNvPr id="9727" name="Invisible source link 11: https://www.novonordisk.com/news-and-media/news-and-ir-materials/news-details.html?id=916768">
-            <a:hlinkClick r:id="rId16"/>
+          <p:cNvPr id="9727" name="Invisible source link 11: https://www.hpcwire.com/aiwire/2026/05/19/cohere-acquires-reliant-ai-to-expand-sovereign-enterprise-ai-for-global-biopharma-and-healthcare-sectors/">
+            <a:hlinkClick r:id="rId18"/>
           </p:cNvPr>
           <p:cNvSpPr/>
           <p:nvPr/>
         </p:nvSpPr>
         <p:spPr>
           <a:xfrm>
-            <a:off x="3681717" y="4006879"/>
-            <a:ext cx="482523" cy="127757"/>
+            <a:off x="3446995" y="4317191"/>
+            <a:ext cx="1047128" cy="127757"/>
           </a:xfrm>
           <a:prstGeom prst="rect">
             <a:avLst/>
@@ -7696,15 +7675,15 @@
       <p:sp>
         <p:nvSpPr>
           <p:cNvPr id="9728" name="Invisible source link 11: https://www.hpcwire.com/aiwire/2026/05/19/cohere-acquires-reliant-ai-to-expand-sovereign-enterprise-ai-for-global-biopharma-and-healthcare-sectors/">
-            <a:hlinkClick r:id="rId17"/>
+            <a:hlinkClick r:id="rId18"/>
           </p:cNvPr>
           <p:cNvSpPr/>
           <p:nvPr/>
         </p:nvSpPr>
         <p:spPr>
           <a:xfrm>
-            <a:off x="3446995" y="4317191"/>
-            <a:ext cx="1047128" cy="127757"/>
+            <a:off x="5445233" y="4317191"/>
+            <a:ext cx="1664006" cy="127757"/>
           </a:xfrm>
           <a:prstGeom prst="rect">
             <a:avLst/>
@@ -7739,15 +7718,15 @@
       <p:sp>
         <p:nvSpPr>
           <p:cNvPr id="9729" name="Invisible source link 11: https://www.hpcwire.com/aiwire/2026/05/19/cohere-acquires-reliant-ai-to-expand-sovereign-enterprise-ai-for-global-biopharma-and-healthcare-sectors/">
-            <a:hlinkClick r:id="rId17"/>
+            <a:hlinkClick r:id="rId18"/>
           </p:cNvPr>
           <p:cNvSpPr/>
           <p:nvPr/>
         </p:nvSpPr>
         <p:spPr>
           <a:xfrm>
-            <a:off x="5445233" y="4317191"/>
-            <a:ext cx="1664006" cy="127757"/>
+            <a:off x="3446995" y="4445359"/>
+            <a:ext cx="2639585" cy="127757"/>
           </a:xfrm>
           <a:prstGeom prst="rect">
             <a:avLst/>
@@ -7781,16 +7760,16 @@
       </p:sp>
       <p:sp>
         <p:nvSpPr>
-          <p:cNvPr id="9730" name="Invisible source link 11: https://www.hpcwire.com/aiwire/2026/05/19/cohere-acquires-reliant-ai-to-expand-sovereign-enterprise-ai-for-global-biopharma-and-healthcare-sectors/">
-            <a:hlinkClick r:id="rId17"/>
+          <p:cNvPr id="9730" name="Invisible source link 11: https://www.fiercebiotech.com/biotech/anthropic-acquires-stealth-ai-startup-coefficient-bio-400m-deal">
+            <a:hlinkClick r:id="rId19"/>
           </p:cNvPr>
           <p:cNvSpPr/>
           <p:nvPr/>
         </p:nvSpPr>
         <p:spPr>
           <a:xfrm>
-            <a:off x="3446995" y="4445359"/>
-            <a:ext cx="2639585" cy="127757"/>
+            <a:off x="3446995" y="4599080"/>
+            <a:ext cx="1475160" cy="127757"/>
           </a:xfrm>
           <a:prstGeom prst="rect">
             <a:avLst/>
@@ -7824,16 +7803,16 @@
       </p:sp>
       <p:sp>
         <p:nvSpPr>
-          <p:cNvPr id="9731" name="Invisible source link 11: https://www.fiercebiotech.com/biotech/anthropic-acquires-stealth-ai-startup-coefficient-bio-400m-deal">
-            <a:hlinkClick r:id="rId18"/>
+          <p:cNvPr id="9731" name="Invisible source link 11: https://www.rdworldonline.com/anthropics-400m-acquisition-of-coefficient-bio-signals-a-deeper-push-into-drug-discovery/">
+            <a:hlinkClick r:id="rId20"/>
           </p:cNvPr>
           <p:cNvSpPr/>
           <p:nvPr/>
         </p:nvSpPr>
         <p:spPr>
           <a:xfrm>
-            <a:off x="3446995" y="4599080"/>
-            <a:ext cx="1475160" cy="127757"/>
+            <a:off x="6115685" y="4599080"/>
+            <a:ext cx="691560" cy="127757"/>
           </a:xfrm>
           <a:prstGeom prst="rect">
             <a:avLst/>
@@ -7867,16 +7846,16 @@
       </p:sp>
       <p:sp>
         <p:nvSpPr>
-          <p:cNvPr id="9732" name="Invisible source link 11: https://www.rdworldonline.com/anthropics-400m-acquisition-of-coefficient-bio-signals-a-deeper-push-into-drug-discovery/">
-            <a:hlinkClick r:id="rId19"/>
+          <p:cNvPr id="9732" name="Invisible source link 11: https://news.bms.com/news/details/2026/Bristol-Myers-Squibb-Announces-Strategic-Agreement-with-Anthropic-to-Position-Claude-Enterprise-as-the-Shared-Intelligence-Platform-Across-Its-Global-Operations/default.aspx">
+            <a:hlinkClick r:id="rId15"/>
           </p:cNvPr>
           <p:cNvSpPr/>
           <p:nvPr/>
         </p:nvSpPr>
         <p:spPr>
           <a:xfrm>
-            <a:off x="6115685" y="4599080"/>
-            <a:ext cx="691560" cy="127757"/>
+            <a:off x="7429613" y="5545389"/>
+            <a:ext cx="2055641" cy="155876"/>
           </a:xfrm>
           <a:prstGeom prst="rect">
             <a:avLst/>
@@ -7910,51 +7889,8 @@
       </p:sp>
       <p:sp>
         <p:nvSpPr>
-          <p:cNvPr id="9733" name="Invisible source link 11: https://news.bms.com/news/details/2026/Bristol-Myers-Squibb-Announces-Strategic-Agreement-with-Anthropic-to-Position-Claude-Enterprise-as-the-Shared-Intelligence-Platform-Across-Its-Global-Operations/default.aspx">
-            <a:hlinkClick r:id="rId14"/>
-          </p:cNvPr>
-          <p:cNvSpPr/>
-          <p:nvPr/>
-        </p:nvSpPr>
-        <p:spPr>
-          <a:xfrm>
-            <a:off x="7429613" y="5545389"/>
-            <a:ext cx="2055641" cy="155876"/>
-          </a:xfrm>
-          <a:prstGeom prst="rect">
-            <a:avLst/>
-          </a:prstGeom>
-          <a:noFill/>
-          <a:ln>
-            <a:noFill/>
-          </a:ln>
-        </p:spPr>
-        <p:style>
-          <a:lnRef idx="1">
-            <a:schemeClr val="accent1"/>
-          </a:lnRef>
-          <a:fillRef idx="3">
-            <a:schemeClr val="accent1"/>
-          </a:fillRef>
-          <a:effectRef idx="2">
-            <a:schemeClr val="accent1"/>
-          </a:effectRef>
-          <a:fontRef idx="minor">
-            <a:schemeClr val="lt1"/>
-          </a:fontRef>
-        </p:style>
-        <p:txBody>
-          <a:bodyPr rtlCol="0" anchor="ctr"/>
-          <a:lstStyle/>
-          <a:p>
-            <a:pPr algn="ctr"/>
-          </a:p>
-        </p:txBody>
-      </p:sp>
-      <p:sp>
-        <p:nvSpPr>
-          <p:cNvPr id="9734" name="Invisible source link 11: https://www.veeva.com/resources/new-veeva-study-builder-agent-to-configure-clinical-studies-in-as-little-as-one-day/">
-            <a:hlinkClick r:id="rId20"/>
+          <p:cNvPr id="9733" name="Invisible source link 11: https://www.veeva.com/resources/new-veeva-study-builder-agent-to-configure-clinical-studies-in-as-little-as-one-day/">
+            <a:hlinkClick r:id="rId21"/>
           </p:cNvPr>
           <p:cNvSpPr/>
           <p:nvPr/>
@@ -8905,7 +8841,7 @@
         <p:spPr>
           <a:xfrm>
             <a:off x="548640" y="1481328"/>
-            <a:ext cx="11091672" cy="658368"/>
+            <a:ext cx="11091672" cy="621792"/>
           </a:xfrm>
           <a:prstGeom prst="rect">
             <a:avLst/>
@@ -8935,7 +8871,7 @@
         </p:nvSpPr>
         <p:spPr>
           <a:xfrm>
-            <a:off x="777240" y="1673352"/>
+            <a:off x="777240" y="1655064"/>
             <a:ext cx="2743200" cy="274320"/>
           </a:xfrm>
           <a:prstGeom prst="rect">
@@ -8971,7 +8907,7 @@
         </p:nvSpPr>
         <p:spPr>
           <a:xfrm>
-            <a:off x="3657600" y="1705356"/>
+            <a:off x="3657600" y="1687068"/>
             <a:ext cx="7754112" cy="210312"/>
           </a:xfrm>
           <a:prstGeom prst="rect">
@@ -8993,7 +8929,7 @@
                   <a:schemeClr val="tx1"/>
                 </a:solidFill>
               </a:rPr>
-              <a:t>Official vendor pages and announcements, reviewed through October 13, 2026.</a:t>
+              <a:t>Official vendor pages and announcements, reviewed through October 16, 2026.</a:t>
             </a:r>
             <a:endParaRPr lang="en-US" sz="1000" dirty="0"/>
           </a:p>
@@ -9007,8 +8943,8 @@
         </p:nvSpPr>
         <p:spPr>
           <a:xfrm>
-            <a:off x="548640" y="2276856"/>
-            <a:ext cx="11091672" cy="841248"/>
+            <a:off x="548640" y="2240280"/>
+            <a:ext cx="11091672" cy="804672"/>
           </a:xfrm>
           <a:prstGeom prst="rect">
             <a:avLst/>
@@ -9038,7 +8974,7 @@
         </p:nvSpPr>
         <p:spPr>
           <a:xfrm>
-            <a:off x="777240" y="2560320"/>
+            <a:off x="777240" y="2505456"/>
             <a:ext cx="2743200" cy="274320"/>
           </a:xfrm>
           <a:prstGeom prst="rect">
@@ -9074,7 +9010,7 @@
         </p:nvSpPr>
         <p:spPr>
           <a:xfrm>
-            <a:off x="3657600" y="2500884"/>
+            <a:off x="3657600" y="2446020"/>
             <a:ext cx="7754112" cy="393192"/>
           </a:xfrm>
           <a:prstGeom prst="rect">
@@ -9110,8 +9046,8 @@
         </p:nvSpPr>
         <p:spPr>
           <a:xfrm>
-            <a:off x="548640" y="3255264"/>
-            <a:ext cx="11091672" cy="841248"/>
+            <a:off x="548640" y="3182112"/>
+            <a:ext cx="11091672" cy="804672"/>
           </a:xfrm>
           <a:prstGeom prst="rect">
             <a:avLst/>
@@ -9141,7 +9077,7 @@
         </p:nvSpPr>
         <p:spPr>
           <a:xfrm>
-            <a:off x="777240" y="3538728"/>
+            <a:off x="777240" y="3447288"/>
             <a:ext cx="2743200" cy="274320"/>
           </a:xfrm>
           <a:prstGeom prst="rect">
@@ -9177,7 +9113,7 @@
         </p:nvSpPr>
         <p:spPr>
           <a:xfrm>
-            <a:off x="3657600" y="3479292"/>
+            <a:off x="3657600" y="3387852"/>
             <a:ext cx="7754112" cy="393192"/>
           </a:xfrm>
           <a:prstGeom prst="rect">
@@ -9213,8 +9149,8 @@
         </p:nvSpPr>
         <p:spPr>
           <a:xfrm>
-            <a:off x="548640" y="4233672"/>
-            <a:ext cx="11091672" cy="841248"/>
+            <a:off x="548640" y="4123944"/>
+            <a:ext cx="11091672" cy="987552"/>
           </a:xfrm>
           <a:prstGeom prst="rect">
             <a:avLst/>
@@ -9244,7 +9180,7 @@
         </p:nvSpPr>
         <p:spPr>
           <a:xfrm>
-            <a:off x="777240" y="4517136"/>
+            <a:off x="777240" y="4480560"/>
             <a:ext cx="2743200" cy="274320"/>
           </a:xfrm>
           <a:prstGeom prst="rect">
@@ -9280,8 +9216,8 @@
         </p:nvSpPr>
         <p:spPr>
           <a:xfrm>
-            <a:off x="3657600" y="4457700"/>
-            <a:ext cx="7754112" cy="393192"/>
+            <a:off x="3657600" y="4329684"/>
+            <a:ext cx="7754112" cy="576072"/>
           </a:xfrm>
           <a:prstGeom prst="rect">
             <a:avLst/>
@@ -9302,7 +9238,7 @@
                   <a:schemeClr val="tx1"/>
                 </a:solidFill>
               </a:rPr>
-              <a:t>43 U.S. competitor groups screened; 15 market 23 qualifying offerings. Domain counts overlap. Screens are not exhaustive. Fourteen international screens add eight examples; their percentages aren’t national adoption rates.</a:t>
+              <a:t>43 U.S. competitor groups screened; 15 market 23 qualifying offerings. Domain counts overlap. Screens are not exhaustive. Fourteen country and region screens added eight international examples, shown in the domain tables but not counted with the U.S.</a:t>
             </a:r>
             <a:endParaRPr lang="en-US" sz="1000" dirty="0"/>
           </a:p>
@@ -9316,8 +9252,8 @@
         </p:nvSpPr>
         <p:spPr>
           <a:xfrm>
-            <a:off x="548640" y="5212080"/>
-            <a:ext cx="11091672" cy="841248"/>
+            <a:off x="548640" y="5248656"/>
+            <a:ext cx="11091672" cy="804672"/>
           </a:xfrm>
           <a:prstGeom prst="rect">
             <a:avLst/>
@@ -9347,7 +9283,7 @@
         </p:nvSpPr>
         <p:spPr>
           <a:xfrm>
-            <a:off x="777240" y="5495544"/>
+            <a:off x="777240" y="5513832"/>
             <a:ext cx="2743200" cy="274320"/>
           </a:xfrm>
           <a:prstGeom prst="rect">
@@ -9383,7 +9319,7 @@
         </p:nvSpPr>
         <p:spPr>
           <a:xfrm>
-            <a:off x="3657600" y="5436108"/>
+            <a:off x="3657600" y="5454396"/>
             <a:ext cx="7754112" cy="393192"/>
           </a:xfrm>
           <a:prstGeom prst="rect">
@@ -9784,7 +9720,7 @@
         <p:spPr>
           <a:xfrm>
             <a:off x="694944" y="2176272"/>
-            <a:ext cx="2395728" cy="164592"/>
+            <a:ext cx="2487168" cy="164592"/>
           </a:xfrm>
           <a:prstGeom prst="rect">
             <a:avLst/>
@@ -9803,7 +9739,7 @@
               <a:buNone/>
             </a:pPr>
             <a:r>
-              <a:rPr lang="en-US" sz="900" dirty="0" b="1">
+              <a:rPr lang="en-US" sz="850" dirty="0" b="1">
                 <a:solidFill>
                   <a:srgbClr val="7A7C7E"/>
                 </a:solidFill>
@@ -9811,7 +9747,7 @@
               <a:t>Seen in: </a:t>
             </a:r>
             <a:r>
-              <a:rPr lang="en-US" sz="900" dirty="0">
+              <a:rPr lang="en-US" sz="850" dirty="0">
                 <a:solidFill>
                   <a:srgbClr val="7A7C7E"/>
                 </a:solidFill>
@@ -9930,7 +9866,7 @@
         <p:spPr>
           <a:xfrm>
             <a:off x="3502152" y="2176272"/>
-            <a:ext cx="2395728" cy="164592"/>
+            <a:ext cx="2487168" cy="164592"/>
           </a:xfrm>
           <a:prstGeom prst="rect">
             <a:avLst/>
@@ -9949,7 +9885,7 @@
               <a:buNone/>
             </a:pPr>
             <a:r>
-              <a:rPr lang="en-US" sz="900" dirty="0" b="1">
+              <a:rPr lang="en-US" sz="850" dirty="0" b="1">
                 <a:solidFill>
                   <a:srgbClr val="7A7C7E"/>
                 </a:solidFill>
@@ -9957,7 +9893,7 @@
               <a:t>Seen in: </a:t>
             </a:r>
             <a:r>
-              <a:rPr lang="en-US" sz="900" dirty="0">
+              <a:rPr lang="en-US" sz="850" dirty="0">
                 <a:solidFill>
                   <a:srgbClr val="7A7C7E"/>
                 </a:solidFill>
@@ -10076,7 +10012,7 @@
         <p:spPr>
           <a:xfrm>
             <a:off x="6309360" y="2176272"/>
-            <a:ext cx="2395728" cy="164592"/>
+            <a:ext cx="2487168" cy="164592"/>
           </a:xfrm>
           <a:prstGeom prst="rect">
             <a:avLst/>
@@ -10095,7 +10031,7 @@
               <a:buNone/>
             </a:pPr>
             <a:r>
-              <a:rPr lang="en-US" sz="900" dirty="0" b="1">
+              <a:rPr lang="en-US" sz="850" dirty="0" b="1">
                 <a:solidFill>
                   <a:srgbClr val="7A7C7E"/>
                 </a:solidFill>
@@ -10103,7 +10039,7 @@
               <a:t>Seen in: </a:t>
             </a:r>
             <a:r>
-              <a:rPr lang="en-US" sz="900" dirty="0">
+              <a:rPr lang="en-US" sz="850" dirty="0">
                 <a:solidFill>
                   <a:srgbClr val="7A7C7E"/>
                 </a:solidFill>
@@ -10168,7 +10104,7 @@
                   <a:srgbClr val="002677"/>
                 </a:solidFill>
               </a:rPr>
-              <a:t>4. BUILT OR PARTNERED</a:t>
+              <a:t>4. HOW IT’S ASSEMBLED</a:t>
             </a:r>
             <a:endParaRPr lang="en-US" sz="1300" dirty="0"/>
           </a:p>
@@ -10207,7 +10143,7 @@
                   <a:srgbClr val="4B4D4F"/>
                 </a:solidFill>
               </a:rPr>
-              <a:t>LLM providers supply competitors and sell their own products</a:t>
+              <a:t>Models, engines and interfaces can be built, adapted or sourced separately</a:t>
             </a:r>
             <a:endParaRPr lang="en-US" sz="1100" dirty="0"/>
           </a:p>
@@ -10222,7 +10158,7 @@
         <p:spPr>
           <a:xfrm>
             <a:off x="9116568" y="2176272"/>
-            <a:ext cx="2395728" cy="164592"/>
+            <a:ext cx="2487168" cy="164592"/>
           </a:xfrm>
           <a:prstGeom prst="rect">
             <a:avLst/>
@@ -10241,7 +10177,7 @@
               <a:buNone/>
             </a:pPr>
             <a:r>
-              <a:rPr lang="en-US" sz="900" dirty="0" b="1">
+              <a:rPr lang="en-US" sz="850" dirty="0" b="1">
                 <a:solidFill>
                   <a:srgbClr val="7A7C7E"/>
                 </a:solidFill>
@@ -10249,12 +10185,12 @@
               <a:t>Seen in: </a:t>
             </a:r>
             <a:r>
-              <a:rPr lang="en-US" sz="900" dirty="0">
+              <a:rPr lang="en-US" sz="850" dirty="0">
                 <a:solidFill>
                   <a:srgbClr val="7A7C7E"/>
                 </a:solidFill>
               </a:rPr>
-              <a:t>Anthropic, OpenAI, Cohere</a:t>
+              <a:t>Komodo, HealthVerity, Veeva, Anthropic</a:t>
             </a:r>
             <a:endParaRPr lang="en-US" sz="1100" dirty="0"/>
           </a:p>

</xml_diff>

<commit_message>
Deck 10.16: pages 6, 8, 9, 10 and 13 wording; TriNetX and Citeline links
Co-Authored-By: Claude Opus 5.5 <noreply@anthropic.com>
Claude-Session: https://claude.ai/code/session_0198bm9pfzRwgZQBqNvd56W8
</commit_message>
<xml_diff>
--- a/deck/Optum-LS-Conversational-AI-10.16.pptx
+++ b/deck/Optum-LS-Conversational-AI-10.16.pptx
@@ -3218,7 +3218,7 @@
                             <a:srgbClr val="1A1A1A"/>
                           </a:solidFill>
                         </a:rPr>
-                        <a:t>Often sourced or adapted</a:t>
+                        <a:t>Can be sourced or adapted</a:t>
                       </a:r>
                       <a:endParaRPr lang="en-US" sz="950" dirty="0"/>
                     </a:p>
@@ -3503,7 +3503,7 @@
                             <a:srgbClr val="1A1A1A"/>
                           </a:solidFill>
                         </a:rPr>
-                        <a:t>What launches lead with</a:t>
+                        <a:t>Vendors lead with proprietary data</a:t>
                       </a:r>
                       <a:endParaRPr lang="en-US" sz="950" dirty="0"/>
                     </a:p>
@@ -3809,7 +3809,7 @@
                             <a:srgbClr val="1A1A1A"/>
                           </a:solidFill>
                         </a:rPr>
-                        <a:t>How AI work is constrained and checked</a:t>
+                        <a:t>Constraints and review points</a:t>
                       </a:r>
                       <a:endParaRPr lang="en-US" sz="950" dirty="0"/>
                     </a:p>
@@ -4075,7 +4075,7 @@
                             <a:srgbClr val="1A1A1A"/>
                           </a:solidFill>
                         </a:rPr>
-                        <a:t>Not always the vendor’s</a:t>
+                        <a:t>Can sit in third-party tools</a:t>
                       </a:r>
                       <a:endParaRPr lang="en-US" sz="950" dirty="0"/>
                     </a:p>
@@ -8841,7 +8841,7 @@
         <p:spPr>
           <a:xfrm>
             <a:off x="548640" y="1481328"/>
-            <a:ext cx="11091672" cy="621792"/>
+            <a:ext cx="11091672" cy="585216"/>
           </a:xfrm>
           <a:prstGeom prst="rect">
             <a:avLst/>
@@ -8871,7 +8871,7 @@
         </p:nvSpPr>
         <p:spPr>
           <a:xfrm>
-            <a:off x="777240" y="1655064"/>
+            <a:off x="777240" y="1636776"/>
             <a:ext cx="2743200" cy="274320"/>
           </a:xfrm>
           <a:prstGeom prst="rect">
@@ -8907,7 +8907,7 @@
         </p:nvSpPr>
         <p:spPr>
           <a:xfrm>
-            <a:off x="3657600" y="1687068"/>
+            <a:off x="3657600" y="1668780"/>
             <a:ext cx="7754112" cy="210312"/>
           </a:xfrm>
           <a:prstGeom prst="rect">
@@ -8943,8 +8943,8 @@
         </p:nvSpPr>
         <p:spPr>
           <a:xfrm>
-            <a:off x="548640" y="2240280"/>
-            <a:ext cx="11091672" cy="804672"/>
+            <a:off x="548640" y="2203704"/>
+            <a:ext cx="11091672" cy="768096"/>
           </a:xfrm>
           <a:prstGeom prst="rect">
             <a:avLst/>
@@ -8974,7 +8974,7 @@
         </p:nvSpPr>
         <p:spPr>
           <a:xfrm>
-            <a:off x="777240" y="2505456"/>
+            <a:off x="777240" y="2450592"/>
             <a:ext cx="2743200" cy="274320"/>
           </a:xfrm>
           <a:prstGeom prst="rect">
@@ -9010,7 +9010,7 @@
         </p:nvSpPr>
         <p:spPr>
           <a:xfrm>
-            <a:off x="3657600" y="2446020"/>
+            <a:off x="3657600" y="2391156"/>
             <a:ext cx="7754112" cy="393192"/>
           </a:xfrm>
           <a:prstGeom prst="rect">
@@ -9046,8 +9046,8 @@
         </p:nvSpPr>
         <p:spPr>
           <a:xfrm>
-            <a:off x="548640" y="3182112"/>
-            <a:ext cx="11091672" cy="804672"/>
+            <a:off x="548640" y="3108960"/>
+            <a:ext cx="11091672" cy="768096"/>
           </a:xfrm>
           <a:prstGeom prst="rect">
             <a:avLst/>
@@ -9077,7 +9077,7 @@
         </p:nvSpPr>
         <p:spPr>
           <a:xfrm>
-            <a:off x="777240" y="3447288"/>
+            <a:off x="777240" y="3355848"/>
             <a:ext cx="2743200" cy="274320"/>
           </a:xfrm>
           <a:prstGeom prst="rect">
@@ -9113,7 +9113,7 @@
         </p:nvSpPr>
         <p:spPr>
           <a:xfrm>
-            <a:off x="3657600" y="3387852"/>
+            <a:off x="3657600" y="3296412"/>
             <a:ext cx="7754112" cy="393192"/>
           </a:xfrm>
           <a:prstGeom prst="rect">
@@ -9149,8 +9149,8 @@
         </p:nvSpPr>
         <p:spPr>
           <a:xfrm>
-            <a:off x="548640" y="4123944"/>
-            <a:ext cx="11091672" cy="987552"/>
+            <a:off x="548640" y="4014216"/>
+            <a:ext cx="11091672" cy="950976"/>
           </a:xfrm>
           <a:prstGeom prst="rect">
             <a:avLst/>
@@ -9180,7 +9180,7 @@
         </p:nvSpPr>
         <p:spPr>
           <a:xfrm>
-            <a:off x="777240" y="4480560"/>
+            <a:off x="777240" y="4352544"/>
             <a:ext cx="2743200" cy="274320"/>
           </a:xfrm>
           <a:prstGeom prst="rect">
@@ -9216,7 +9216,7 @@
         </p:nvSpPr>
         <p:spPr>
           <a:xfrm>
-            <a:off x="3657600" y="4329684"/>
+            <a:off x="3657600" y="4201668"/>
             <a:ext cx="7754112" cy="576072"/>
           </a:xfrm>
           <a:prstGeom prst="rect">
@@ -9252,8 +9252,8 @@
         </p:nvSpPr>
         <p:spPr>
           <a:xfrm>
-            <a:off x="548640" y="5248656"/>
-            <a:ext cx="11091672" cy="804672"/>
+            <a:off x="548640" y="5102352"/>
+            <a:ext cx="11091672" cy="950976"/>
           </a:xfrm>
           <a:prstGeom prst="rect">
             <a:avLst/>
@@ -9283,7 +9283,7 @@
         </p:nvSpPr>
         <p:spPr>
           <a:xfrm>
-            <a:off x="777240" y="5513832"/>
+            <a:off x="777240" y="5440680"/>
             <a:ext cx="2743200" cy="274320"/>
           </a:xfrm>
           <a:prstGeom prst="rect">
@@ -9319,8 +9319,8 @@
         </p:nvSpPr>
         <p:spPr>
           <a:xfrm>
-            <a:off x="3657600" y="5454396"/>
-            <a:ext cx="7754112" cy="393192"/>
+            <a:off x="3657600" y="5289804"/>
+            <a:ext cx="7754112" cy="576072"/>
           </a:xfrm>
           <a:prstGeom prst="rect">
             <a:avLst/>
@@ -9341,7 +9341,7 @@
                   <a:schemeClr val="tx1"/>
                 </a:solidFill>
               </a:rPr>
-              <a:t>Offerings were compared by customer task, not assumed to be equivalent. Vendor metrics are reported as claims. LLM-provider developments sit outside the counts. AI tools assisted the research and drafting.</a:t>
+              <a:t>Offerings were compared by customer task, not assumed to be equivalent. Vendor metrics are reported as claims. LLM-provider developments sit outside the counts. AI tools assisted the research and drafting; key quoted claims were checked against cited vendor materials.</a:t>
             </a:r>
             <a:endParaRPr lang="en-US" sz="1000" dirty="0"/>
           </a:p>
@@ -17136,7 +17136,7 @@
         </p:nvGraphicFramePr>
         <p:xfrm>
           <a:off x="548640" y="1481328"/>
-          <a:ext cx="11091672" cy="3008375"/>
+          <a:ext cx="11091672" cy="2848355"/>
         </p:xfrm>
         <a:graphic>
           <a:graphicData uri="http://schemas.openxmlformats.org/drawingml/2006/table">
@@ -17260,7 +17260,7 @@
                   </a:tcPr>
                 </a:tc>
               </a:tr>
-              <a:tr h="847830">
+              <a:tr h="794490">
                 <a:tc>
                   <a:txBody>
                     <a:bodyPr/>
@@ -17507,7 +17507,7 @@
                   </a:tcPr>
                 </a:tc>
               </a:tr>
-              <a:tr h="847818">
+              <a:tr h="794478">
                 <a:tc>
                   <a:txBody>
                     <a:bodyPr/>
@@ -17754,7 +17754,7 @@
                   </a:tcPr>
                 </a:tc>
               </a:tr>
-              <a:tr h="983543">
+              <a:tr h="930203">
                 <a:tc>
                   <a:txBody>
                     <a:bodyPr/>
@@ -17986,8 +17986,8 @@
         </p:nvSpPr>
         <p:spPr>
           <a:xfrm>
-            <a:off x="548640" y="4672584"/>
-            <a:ext cx="5454396" cy="1380744"/>
+            <a:off x="548640" y="4512564"/>
+            <a:ext cx="5454396" cy="1540764"/>
           </a:xfrm>
           <a:prstGeom prst="rect">
             <a:avLst/>
@@ -18017,7 +18017,7 @@
         </p:nvSpPr>
         <p:spPr>
           <a:xfrm>
-            <a:off x="749808" y="4855464"/>
+            <a:off x="749808" y="4695444"/>
             <a:ext cx="5052060" cy="256032"/>
           </a:xfrm>
           <a:prstGeom prst="rect">
@@ -18053,8 +18053,8 @@
         </p:nvSpPr>
         <p:spPr>
           <a:xfrm>
-            <a:off x="749808" y="5202936"/>
-            <a:ext cx="5052060" cy="667512"/>
+            <a:off x="749808" y="5042916"/>
+            <a:ext cx="5052060" cy="827532"/>
           </a:xfrm>
           <a:prstGeom prst="rect">
             <a:avLst/>
@@ -18110,8 +18110,8 @@
         </p:nvSpPr>
         <p:spPr>
           <a:xfrm>
-            <a:off x="6185916" y="4672584"/>
-            <a:ext cx="5454396" cy="1380744"/>
+            <a:off x="6185916" y="4512564"/>
+            <a:ext cx="5454396" cy="1540764"/>
           </a:xfrm>
           <a:prstGeom prst="rect">
             <a:avLst/>
@@ -18141,7 +18141,7 @@
         </p:nvSpPr>
         <p:spPr>
           <a:xfrm>
-            <a:off x="6387084" y="4855464"/>
+            <a:off x="6387084" y="4695444"/>
             <a:ext cx="5052060" cy="256032"/>
           </a:xfrm>
           <a:prstGeom prst="rect">
@@ -18177,8 +18177,8 @@
         </p:nvSpPr>
         <p:spPr>
           <a:xfrm>
-            <a:off x="6387084" y="5202936"/>
-            <a:ext cx="5052060" cy="667512"/>
+            <a:off x="6387084" y="5042916"/>
+            <a:ext cx="5052060" cy="827532"/>
           </a:xfrm>
           <a:prstGeom prst="rect">
             <a:avLst/>
@@ -18199,7 +18199,7 @@
                   <a:schemeClr val="tx1"/>
                 </a:solidFill>
               </a:rPr>
-              <a:t>Specialty-data vendors market conversational AI as a way to supplant routine work by analysts: Flatiron’s Telescope delivers survival analyses on demand, “</a:t>
+              <a:t>Specialty-data vendors market conversational AI as a way to reduce dependence on analyst queues: Flatiron’s Telescope delivers survival analyses on demand, “</a:t>
             </a:r>
             <a:r>
               <a:rPr lang="en-US" sz="1050" b="1" dirty="0" u="sng">
@@ -18335,7 +18335,7 @@
         </p:nvSpPr>
         <p:spPr>
           <a:xfrm>
-            <a:off x="2944075" y="2073898"/>
+            <a:off x="2944075" y="2046898"/>
             <a:ext cx="1513375" cy="134588"/>
           </a:xfrm>
           <a:prstGeom prst="rect">
@@ -18378,7 +18378,7 @@
         </p:nvSpPr>
         <p:spPr>
           <a:xfrm>
-            <a:off x="2944075" y="2260372"/>
+            <a:off x="2944075" y="2233372"/>
             <a:ext cx="853495" cy="134588"/>
           </a:xfrm>
           <a:prstGeom prst="rect">
@@ -18421,7 +18421,7 @@
         </p:nvSpPr>
         <p:spPr>
           <a:xfrm>
-            <a:off x="2944075" y="2921700"/>
+            <a:off x="2944075" y="2841055"/>
             <a:ext cx="1749531" cy="134588"/>
           </a:xfrm>
           <a:prstGeom prst="rect">
@@ -18464,7 +18464,7 @@
         </p:nvSpPr>
         <p:spPr>
           <a:xfrm>
-            <a:off x="2944075" y="3108174"/>
+            <a:off x="2944075" y="3027541"/>
             <a:ext cx="1623166" cy="134588"/>
           </a:xfrm>
           <a:prstGeom prst="rect">
@@ -18507,7 +18507,7 @@
         </p:nvSpPr>
         <p:spPr>
           <a:xfrm>
-            <a:off x="2944075" y="3862731"/>
+            <a:off x="2944075" y="3728454"/>
             <a:ext cx="1507058" cy="134588"/>
           </a:xfrm>
           <a:prstGeom prst="rect">
@@ -18550,7 +18550,7 @@
         </p:nvSpPr>
         <p:spPr>
           <a:xfrm>
-            <a:off x="749515" y="5535058"/>
+            <a:off x="749515" y="5375216"/>
             <a:ext cx="2658874" cy="148648"/>
           </a:xfrm>
           <a:prstGeom prst="rect">
@@ -18593,8 +18593,8 @@
         </p:nvSpPr>
         <p:spPr>
           <a:xfrm>
-            <a:off x="6386753" y="5535058"/>
-            <a:ext cx="3056676" cy="148648"/>
+            <a:off x="7165693" y="5375216"/>
+            <a:ext cx="3058215" cy="148648"/>
           </a:xfrm>
           <a:prstGeom prst="rect">
             <a:avLst/>
@@ -18636,8 +18636,51 @@
         </p:nvSpPr>
         <p:spPr>
           <a:xfrm>
-            <a:off x="7578472" y="5694900"/>
-            <a:ext cx="3823361" cy="148648"/>
+            <a:off x="8395107" y="5535058"/>
+            <a:ext cx="3003068" cy="148648"/>
+          </a:xfrm>
+          <a:prstGeom prst="rect">
+            <a:avLst/>
+          </a:prstGeom>
+          <a:noFill/>
+          <a:ln>
+            <a:noFill/>
+          </a:ln>
+        </p:spPr>
+        <p:style>
+          <a:lnRef idx="1">
+            <a:schemeClr val="accent1"/>
+          </a:lnRef>
+          <a:fillRef idx="3">
+            <a:schemeClr val="accent1"/>
+          </a:fillRef>
+          <a:effectRef idx="2">
+            <a:schemeClr val="accent1"/>
+          </a:effectRef>
+          <a:fontRef idx="minor">
+            <a:schemeClr val="lt1"/>
+          </a:fontRef>
+        </p:style>
+        <p:txBody>
+          <a:bodyPr rtlCol="0" anchor="ctr"/>
+          <a:lstStyle/>
+          <a:p>
+            <a:pPr algn="ctr"/>
+          </a:p>
+        </p:txBody>
+      </p:sp>
+      <p:sp>
+        <p:nvSpPr>
+          <p:cNvPr id="9730" name="Invisible source link 7: https://www.prnewswire.com/news-releases/verana-health-introduces-new-ai-agents-to-expedite-and-streamline-rd-302888122.html">
+            <a:hlinkClick r:id="rId14"/>
+          </p:cNvPr>
+          <p:cNvSpPr/>
+          <p:nvPr/>
+        </p:nvSpPr>
+        <p:spPr>
+          <a:xfrm>
+            <a:off x="6386753" y="5694900"/>
+            <a:ext cx="780036" cy="148648"/>
           </a:xfrm>
           <a:prstGeom prst="rect">
             <a:avLst/>
@@ -22477,7 +22520,7 @@
                   <a:schemeClr val="tx1"/>
                 </a:solidFill>
               </a:rPr>
-              <a:t>IQVIA says its small Med-R1 research agent can “</a:t>
+              <a:t>IQVIA says its 8B-parameter Med-R1 agent can “</a:t>
             </a:r>
             <a:r>
               <a:rPr lang="en-US" sz="1050" b="1" dirty="0" u="sng">
@@ -22498,7 +22541,7 @@
                   <a:schemeClr val="tx1"/>
                 </a:solidFill>
               </a:rPr>
-              <a:t>,” while conceding that multi-step biomedical reasoning remains unsolved. In its December 2025 benchmark, Med-R1 answered 21 of 50 questions—and none of the 10 hardest, where OpenAI’s and Google’s agents managed one between them.</a:t>
+              <a:t>” on some biomedical reasoning tasks, while conceding that multi-step reasoning remains unsolved. In its December 2025 benchmark, Med-R1 answered 21 of 50 questions (versus 25 for OpenAI o3 and 24 for Google Gemini)—and none of the 10 hardest, where OpenAI’s and Google’s agents managed one between them.</a:t>
             </a:r>
             <a:endParaRPr lang="en-US" sz="1050" dirty="0"/>
           </a:p>
@@ -22805,8 +22848,8 @@
         </p:nvSpPr>
         <p:spPr>
           <a:xfrm>
-            <a:off x="9434314" y="5055531"/>
-            <a:ext cx="1571140" cy="148648"/>
+            <a:off x="9360390" y="5055531"/>
+            <a:ext cx="1571989" cy="148648"/>
           </a:xfrm>
           <a:prstGeom prst="rect">
             <a:avLst/>
@@ -22849,7 +22892,7 @@
         <p:spPr>
           <a:xfrm>
             <a:off x="6386753" y="5215373"/>
-            <a:ext cx="1642595" cy="148648"/>
+            <a:ext cx="1605965" cy="148648"/>
           </a:xfrm>
           <a:prstGeom prst="rect">
             <a:avLst/>
@@ -23440,7 +23483,7 @@
                   </a:tcPr>
                 </a:tc>
               </a:tr>
-              <a:tr h="652932">
+              <a:tr h="625579">
                 <a:tc>
                   <a:txBody>
                     <a:bodyPr/>
@@ -23528,7 +23571,28 @@
                             </a:solidFill>
                           </a:uFill>
                         </a:rPr>
-                        <a:t>LIVE Conversational AI + Terrain</a:t>
+                        <a:t>LIVE Query Assistant</a:t>
+                      </a:r>
+                      <a:r>
+                        <a:rPr lang="en-US" sz="950" dirty="0">
+                          <a:solidFill>
+                            <a:schemeClr val="tx1"/>
+                          </a:solidFill>
+                        </a:rPr>
+                        <a:t>; </a:t>
+                      </a:r>
+                      <a:r>
+                        <a:rPr lang="en-US" sz="950" dirty="0" b="1" u="sng">
+                          <a:solidFill>
+                            <a:srgbClr val="002677"/>
+                          </a:solidFill>
+                          <a:uFill>
+                            <a:solidFill>
+                              <a:srgbClr val="9AA8CC"/>
+                            </a:solidFill>
+                          </a:uFill>
+                        </a:rPr>
+                        <a:t>Terrain AI Assistant</a:t>
                       </a:r>
                       <a:r>
                         <a:rPr lang="en-US" sz="950" dirty="0">
@@ -23678,7 +23742,7 @@
                   </a:tcPr>
                 </a:tc>
               </a:tr>
-              <a:tr h="466445">
+              <a:tr h="439092">
                 <a:tc>
                   <a:txBody>
                     <a:bodyPr/>
@@ -23970,7 +24034,7 @@
                   </a:tcPr>
                 </a:tc>
               </a:tr>
-              <a:tr h="737882">
+              <a:tr h="710530">
                 <a:tc>
                   <a:txBody>
                     <a:bodyPr/>
@@ -24189,7 +24253,7 @@
                   </a:tcPr>
                 </a:tc>
               </a:tr>
-              <a:tr h="492747">
+              <a:tr h="574805">
                 <a:tc>
                   <a:txBody>
                     <a:bodyPr/>
@@ -24325,7 +24389,23 @@
                             <a:schemeClr val="tx1"/>
                           </a:solidFill>
                         </a:rPr>
-                        <a:t>No comparable offering established</a:t>
+                        <a:t>No comparable self-service payer/formulary assistant established; </a:t>
+                      </a:r>
+                      <a:r>
+                        <a:rPr lang="en-US" sz="950" dirty="0" b="1">
+                          <a:solidFill>
+                            <a:schemeClr val="tx1"/>
+                          </a:solidFill>
+                        </a:rPr>
+                        <a:t>Evidence Engine</a:t>
+                      </a:r>
+                      <a:r>
+                        <a:rPr lang="en-US" sz="950" dirty="0">
+                          <a:solidFill>
+                            <a:schemeClr val="tx1"/>
+                          </a:solidFill>
+                        </a:rPr>
+                        <a:t> offers stakeholder-feedback and market-access consulting</a:t>
                       </a:r>
                       <a:endParaRPr lang="en-US" sz="950" dirty="0"/>
                     </a:p>
@@ -24705,7 +24785,7 @@
       </p:sp>
       <p:sp>
         <p:nvSpPr>
-          <p:cNvPr id="9721" name="Invisible source link 10: https://trinetx.com/press-releases/trinetx-unveils-conversational-ai-interface-and-enhanced-api-capabilities/">
+          <p:cNvPr id="9721" name="Invisible source link 10: https://trinetx.com/blog/powering-clinical-research-innovation-how-trinetx-uses-databricks-to-accelerate-drug-development">
             <a:hlinkClick r:id="rId10"/>
           </p:cNvPr>
           <p:cNvSpPr/>
@@ -24713,8 +24793,8 @@
         </p:nvSpPr>
         <p:spPr>
           <a:xfrm>
-            <a:off x="2944075" y="1908303"/>
-            <a:ext cx="2410845" cy="134588"/>
+            <a:off x="2944075" y="1894612"/>
+            <a:ext cx="1774004" cy="134588"/>
           </a:xfrm>
           <a:prstGeom prst="rect">
             <a:avLst/>
@@ -24748,16 +24828,16 @@
       </p:sp>
       <p:sp>
         <p:nvSpPr>
-          <p:cNvPr id="9722" name="Invisible source link 10: https://www.navlin.com/products/tender">
-            <a:hlinkClick r:id="rId6"/>
+          <p:cNvPr id="9722" name="Invisible source link 10: https://trinetx.com/solutions/trinetx-live/terrain">
+            <a:hlinkClick r:id="rId11"/>
           </p:cNvPr>
           <p:cNvSpPr/>
           <p:nvPr/>
         </p:nvSpPr>
         <p:spPr>
           <a:xfrm>
-            <a:off x="2944075" y="3491942"/>
-            <a:ext cx="1490324" cy="134588"/>
+            <a:off x="4750193" y="1894612"/>
+            <a:ext cx="1151933" cy="134588"/>
           </a:xfrm>
           <a:prstGeom prst="rect">
             <a:avLst/>
@@ -24791,16 +24871,16 @@
       </p:sp>
       <p:sp>
         <p:nvSpPr>
-          <p:cNvPr id="9723" name="Invisible source link 10: https://citeline.com/plus">
-            <a:hlinkClick r:id="rId11"/>
+          <p:cNvPr id="9723" name="Invisible source link 10: https://www.navlin.com/products/tender">
+            <a:hlinkClick r:id="rId6"/>
           </p:cNvPr>
           <p:cNvSpPr/>
           <p:nvPr/>
         </p:nvSpPr>
         <p:spPr>
           <a:xfrm>
-            <a:off x="2944075" y="2230502"/>
-            <a:ext cx="1307444" cy="134588"/>
+            <a:off x="2944075" y="3423540"/>
+            <a:ext cx="1490324" cy="134588"/>
           </a:xfrm>
           <a:prstGeom prst="rect">
             <a:avLst/>
@@ -24834,7 +24914,7 @@
       </p:sp>
       <p:sp>
         <p:nvSpPr>
-          <p:cNvPr id="9724" name="Invisible source link 10: https://clinicaldata.veevavault.help/en/lr/rn/limited-releases/26r3/new-features">
+          <p:cNvPr id="9724" name="Invisible source link 10: https://www.citeline.com/en/resources/citeline-elevate-spring-2025-brainpower-in-boston">
             <a:hlinkClick r:id="rId12"/>
           </p:cNvPr>
           <p:cNvSpPr/>
@@ -24842,8 +24922,8 @@
         </p:nvSpPr>
         <p:spPr>
           <a:xfrm>
-            <a:off x="2944075" y="2560981"/>
-            <a:ext cx="1127447" cy="134588"/>
+            <a:off x="2944075" y="2216811"/>
+            <a:ext cx="1307444" cy="134588"/>
           </a:xfrm>
           <a:prstGeom prst="rect">
             <a:avLst/>
@@ -24877,7 +24957,7 @@
       </p:sp>
       <p:sp>
         <p:nvSpPr>
-          <p:cNvPr id="9725" name="Invisible source link 10: https://www.mmitnetwork.com/mosaic/">
+          <p:cNvPr id="9725" name="Invisible source link 10: https://clinicaldata.veevavault.help/en/lr/rn/limited-releases/26r3/new-features">
             <a:hlinkClick r:id="rId13"/>
           </p:cNvPr>
           <p:cNvSpPr/>
@@ -24885,8 +24965,8 @@
         </p:nvSpPr>
         <p:spPr>
           <a:xfrm>
-            <a:off x="2944075" y="4107181"/>
-            <a:ext cx="1181092" cy="134588"/>
+            <a:off x="2944075" y="2519935"/>
+            <a:ext cx="1127447" cy="134588"/>
           </a:xfrm>
           <a:prstGeom prst="rect">
             <a:avLst/>
@@ -24920,16 +25000,16 @@
       </p:sp>
       <p:sp>
         <p:nvSpPr>
-          <p:cNvPr id="9726" name="Invisible source link 10: https://clinicaldata.veevavault.help/en/lr/rn/limited-releases/26r3/new-features">
-            <a:hlinkClick r:id="rId12"/>
+          <p:cNvPr id="9726" name="Invisible source link 10: https://www.mmitnetwork.com/mosaic/">
+            <a:hlinkClick r:id="rId14"/>
           </p:cNvPr>
           <p:cNvSpPr/>
           <p:nvPr/>
         </p:nvSpPr>
         <p:spPr>
           <a:xfrm>
-            <a:off x="5037945" y="5375216"/>
-            <a:ext cx="542086" cy="148648"/>
+            <a:off x="2944075" y="4066135"/>
+            <a:ext cx="1181092" cy="134588"/>
           </a:xfrm>
           <a:prstGeom prst="rect">
             <a:avLst/>
@@ -24963,16 +25043,16 @@
       </p:sp>
       <p:sp>
         <p:nvSpPr>
-          <p:cNvPr id="9728" name="Invisible source link 10: https://clinicaldata.veevavault.help/en/lr/rn/limited-releases/26r3/new-features">
-            <a:hlinkClick r:id="rId12"/>
+          <p:cNvPr id="9727" name="Invisible source link 10: https://clinicaldata.veevavault.help/en/lr/rn/limited-releases/26r3/new-features">
+            <a:hlinkClick r:id="rId13"/>
           </p:cNvPr>
           <p:cNvSpPr/>
           <p:nvPr/>
         </p:nvSpPr>
         <p:spPr>
           <a:xfrm>
-            <a:off x="749515" y="5535058"/>
-            <a:ext cx="3384273" cy="148648"/>
+            <a:off x="5037945" y="5375216"/>
+            <a:ext cx="542086" cy="148648"/>
           </a:xfrm>
           <a:prstGeom prst="rect">
             <a:avLst/>
@@ -25006,16 +25086,16 @@
       </p:sp>
       <p:sp>
         <p:nvSpPr>
-          <p:cNvPr id="9728" name="Invisible source link 10: https://www.eversana.com/insights/from-ai-answers-to-decision-grade-market-access/">
-            <a:hlinkClick r:id="rId14"/>
+          <p:cNvPr id="9729" name="Invisible source link 10: https://clinicaldata.veevavault.help/en/lr/rn/limited-releases/26r3/new-features">
+            <a:hlinkClick r:id="rId13"/>
           </p:cNvPr>
           <p:cNvSpPr/>
           <p:nvPr/>
         </p:nvSpPr>
         <p:spPr>
           <a:xfrm>
-            <a:off x="9793548" y="5375216"/>
-            <a:ext cx="1577539" cy="148648"/>
+            <a:off x="749515" y="5535058"/>
+            <a:ext cx="3384273" cy="148648"/>
           </a:xfrm>
           <a:prstGeom prst="rect">
             <a:avLst/>
@@ -25049,16 +25129,16 @@
       </p:sp>
       <p:sp>
         <p:nvSpPr>
-          <p:cNvPr id="9730" name="Invisible source link 10: https://www.eversana.com/insights/from-ai-answers-to-decision-grade-market-access/">
-            <a:hlinkClick r:id="rId14"/>
+          <p:cNvPr id="9729" name="Invisible source link 10: https://www.eversana.com/insights/from-ai-answers-to-decision-grade-market-access/">
+            <a:hlinkClick r:id="rId15"/>
           </p:cNvPr>
           <p:cNvSpPr/>
           <p:nvPr/>
         </p:nvSpPr>
         <p:spPr>
           <a:xfrm>
-            <a:off x="6386753" y="5535058"/>
-            <a:ext cx="2735287" cy="148648"/>
+            <a:off x="9793548" y="5375216"/>
+            <a:ext cx="1577539" cy="148648"/>
           </a:xfrm>
           <a:prstGeom prst="rect">
             <a:avLst/>
@@ -25092,8 +25172,51 @@
       </p:sp>
       <p:sp>
         <p:nvSpPr>
-          <p:cNvPr id="9730" name="Invisible source link 10: https://www.eversana.com/insights/from-ai-answers-to-decision-grade-market-access/">
-            <a:hlinkClick r:id="rId14"/>
+          <p:cNvPr id="9731" name="Invisible source link 10: https://www.eversana.com/insights/from-ai-answers-to-decision-grade-market-access/">
+            <a:hlinkClick r:id="rId15"/>
+          </p:cNvPr>
+          <p:cNvSpPr/>
+          <p:nvPr/>
+        </p:nvSpPr>
+        <p:spPr>
+          <a:xfrm>
+            <a:off x="6386753" y="5535058"/>
+            <a:ext cx="2735287" cy="148648"/>
+          </a:xfrm>
+          <a:prstGeom prst="rect">
+            <a:avLst/>
+          </a:prstGeom>
+          <a:noFill/>
+          <a:ln>
+            <a:noFill/>
+          </a:ln>
+        </p:spPr>
+        <p:style>
+          <a:lnRef idx="1">
+            <a:schemeClr val="accent1"/>
+          </a:lnRef>
+          <a:fillRef idx="3">
+            <a:schemeClr val="accent1"/>
+          </a:fillRef>
+          <a:effectRef idx="2">
+            <a:schemeClr val="accent1"/>
+          </a:effectRef>
+          <a:fontRef idx="minor">
+            <a:schemeClr val="lt1"/>
+          </a:fontRef>
+        </p:style>
+        <p:txBody>
+          <a:bodyPr rtlCol="0" anchor="ctr"/>
+          <a:lstStyle/>
+          <a:p>
+            <a:pPr algn="ctr"/>
+          </a:p>
+        </p:txBody>
+      </p:sp>
+      <p:sp>
+        <p:nvSpPr>
+          <p:cNvPr id="9731" name="Invisible source link 10: https://www.eversana.com/insights/from-ai-answers-to-decision-grade-market-access/">
+            <a:hlinkClick r:id="rId15"/>
           </p:cNvPr>
           <p:cNvSpPr/>
           <p:nvPr/>

</xml_diff>

<commit_message>
Deck 10.16: five-row key assumptions page
Co-Authored-By: Claude Opus 5.5 <noreply@anthropic.com>
Claude-Session: https://claude.ai/code/session_0198bm9pfzRwgZQBqNvd56W8
</commit_message>
<xml_diff>
--- a/deck/Optum-LS-Conversational-AI-10.16.pptx
+++ b/deck/Optum-LS-Conversational-AI-10.16.pptx
@@ -8018,7 +8018,7 @@
                   <a:schemeClr val="accent1"/>
                 </a:solidFill>
               </a:rPr>
-              <a:t>Four assumptions shape this view, and each can be tested with internal evidence</a:t>
+              <a:t>Five assumptions shape this view, and each can be tested</a:t>
             </a:r>
             <a:endParaRPr lang="en-US" sz="2200" dirty="0"/>
           </a:p>
@@ -8040,7 +8040,7 @@
         </p:nvGraphicFramePr>
         <p:xfrm>
           <a:off x="548640" y="1481328"/>
-          <a:ext cx="11091671" cy="4571998"/>
+          <a:ext cx="11091671" cy="4571997"/>
         </p:xfrm>
         <a:graphic>
           <a:graphicData uri="http://schemas.openxmlformats.org/drawingml/2006/table">
@@ -8140,7 +8140,7 @@
                             <a:schemeClr val="bg1"/>
                           </a:solidFill>
                         </a:rPr>
-                        <a:t>HOW TO TEST IT (WHO HOLDS THE EVIDENCE)</a:t>
+                        <a:t>HOW TO TEST IT</a:t>
                       </a:r>
                       <a:endParaRPr lang="en-US" sz="900" dirty="0"/>
                     </a:p>
@@ -8164,7 +8164,7 @@
                   </a:tcPr>
                 </a:tc>
               </a:tr>
-              <a:tr h="1042409">
+              <a:tr h="833927">
                 <a:tc>
                   <a:txBody>
                     <a:bodyPr/>
@@ -8179,7 +8179,7 @@
                             <a:schemeClr val="accent1"/>
                           </a:solidFill>
                         </a:rPr>
-                        <a:t>Optum LS is developing or evaluating conversational AI it doesn’t yet market</a:t>
+                        <a:t>Competitors’ marketing reflects the products customers actually use</a:t>
                       </a:r>
                       <a:endParaRPr lang="en-US" sz="1050" dirty="0"/>
                     </a:p>
@@ -8234,7 +8234,7 @@
                             <a:schemeClr val="tx1"/>
                           </a:solidFill>
                         </a:rPr>
-                        <a:t>If not, the four choices become a decision about whether to build at all, not design choices</a:t>
+                        <a:t>The deck’s evidence is public marketing. If launches are pilots or showcase features, the four choices describe messaging, not the products Optum LS competes against.</a:t>
                       </a:r>
                       <a:endParaRPr lang="en-US" sz="900" dirty="0"/>
                     </a:p>
@@ -8274,7 +8274,7 @@
                             <a:schemeClr val="tx1"/>
                           </a:solidFill>
                         </a:rPr>
-                        <a:t>Product roadmap (product, technology)</a:t>
+                        <a:t>Ask Optum LS sales and account teams which competitor tools come up in deals, and whether clients say they actually use them.</a:t>
                       </a:r>
                       <a:endParaRPr lang="en-US" sz="900" dirty="0"/>
                     </a:p>
@@ -8301,7 +8301,7 @@
                   </a:tcPr>
                 </a:tc>
               </a:tr>
-              <a:tr h="1042422">
+              <a:tr h="678416">
                 <a:tc>
                   <a:txBody>
                     <a:bodyPr/>
@@ -8371,7 +8371,7 @@
                             <a:schemeClr val="tx1"/>
                           </a:solidFill>
                         </a:rPr>
-                        <a:t>It decides whether this is a revenue question or a feature question, and it’s the basis for any dollar estimate</a:t>
+                        <a:t>It decides whether this is a revenue question or a feature question, and it’s the basis for any dollar estimate.</a:t>
                       </a:r>
                       <a:endParaRPr lang="en-US" sz="900" dirty="0"/>
                     </a:p>
@@ -8411,7 +8411,7 @@
                             <a:schemeClr val="tx1"/>
                           </a:solidFill>
                         </a:rPr>
-                        <a:t>Win/loss notes, RFP requirements, pricing (commercial, finance); customer interviews</a:t>
+                        <a:t>Review recent win/loss notes and RFPs for whether conversational access was requested or decided a deal.</a:t>
                       </a:r>
                       <a:endParaRPr lang="en-US" sz="900" dirty="0"/>
                     </a:p>
@@ -8438,7 +8438,7 @@
                   </a:tcPr>
                 </a:tc>
               </a:tr>
-              <a:tr h="1042422">
+              <a:tr h="833927">
                 <a:tc>
                   <a:txBody>
                     <a:bodyPr/>
@@ -8453,15 +8453,7 @@
                             <a:schemeClr val="accent1"/>
                           </a:solidFill>
                         </a:rPr>
-                        <a:t>Vendor claims hold up in practice</a:t>
-                      </a:r>
-                      <a:r>
-                        <a:rPr lang="en-US" sz="1100" dirty="0">
-                          <a:solidFill>
-                            <a:schemeClr val="accent1"/>
-                          </a:solidFill>
-                        </a:rPr>
-                        <a:t> (27% prep time, 6-week studies)</a:t>
+                        <a:t>Pharma buyers want self-service, not just expert-led analysis</a:t>
                       </a:r>
                       <a:endParaRPr lang="en-US" sz="1050" dirty="0"/>
                     </a:p>
@@ -8516,7 +8508,7 @@
                             <a:schemeClr val="tx1"/>
                           </a:solidFill>
                         </a:rPr>
-                        <a:t>These claims set the bar an Optum LS offering would be measured against</a:t>
+                        <a:t>Competitors pitch conversational AI as a way to skip analyst queues. If buyers want that, it pressures expert-led services; if not, expertise is the differentiator.</a:t>
                       </a:r>
                       <a:endParaRPr lang="en-US" sz="900" dirty="0"/>
                     </a:p>
@@ -8556,7 +8548,7 @@
                             <a:schemeClr val="tx1"/>
                           </a:solidFill>
                         </a:rPr>
-                        <a:t>Customer references, independent tests (data and analytics). IQVIA’s own benchmark shows the limits.</a:t>
+                        <a:t>Compare how clients use self-service tools like Prospector with demand for Analytics on Demand, and ask account teams which clients want to run their own analyses.</a:t>
                       </a:r>
                       <a:endParaRPr lang="en-US" sz="900" dirty="0"/>
                     </a:p>
@@ -8583,7 +8575,7 @@
                   </a:tcPr>
                 </a:tc>
               </a:tr>
-              <a:tr h="1042409">
+              <a:tr h="989451">
                 <a:tc>
                   <a:txBody>
                     <a:bodyPr/>
@@ -8598,7 +8590,7 @@
                             <a:schemeClr val="accent1"/>
                           </a:solidFill>
                         </a:rPr>
-                        <a:t>LLM providers remain suppliers more than rivals</a:t>
+                        <a:t>Optum LS’s data licenses permit conversational and third-party AI use</a:t>
                       </a:r>
                       <a:endParaRPr lang="en-US" sz="1050" dirty="0"/>
                     </a:p>
@@ -8653,7 +8645,7 @@
                             <a:schemeClr val="tx1"/>
                           </a:solidFill>
                         </a:rPr>
-                        <a:t>Partnering for the model could create a future competitor</a:t>
+                        <a:t>Pharma companies are moving data work into AI assistants such as Claude. What Optum LS data can be queried, and where, depends on data-use, privacy and de-identification terms.</a:t>
                       </a:r>
                       <a:endParaRPr lang="en-US" sz="900" dirty="0"/>
                     </a:p>
@@ -8693,7 +8685,144 @@
                             <a:schemeClr val="tx1"/>
                           </a:solidFill>
                         </a:rPr>
-                        <a:t>Partnership terms (strategy and enterprise development); see the LLM providers slide</a:t>
+                        <a:t>Ask data licensing and privacy teams whether current terms allow conversational querying and use inside a client’s own AI tools.</a:t>
+                      </a:r>
+                      <a:endParaRPr lang="en-US" sz="900" dirty="0"/>
+                    </a:p>
+                  </a:txBody>
+                  <a:tcPr marL="109728" marR="109728" marT="64008" marB="64008" anchor="ctr">
+                    <a:lnL w="0" cap="flat" cmpd="sng" algn="ctr">
+                      <a:noFill/>
+                    </a:lnL>
+                    <a:lnR w="0" cap="flat" cmpd="sng" algn="ctr">
+                      <a:noFill/>
+                    </a:lnR>
+                    <a:lnT w="0" cap="flat" cmpd="sng" algn="ctr">
+                      <a:noFill/>
+                    </a:lnT>
+                    <a:lnB w="19050" cap="flat" cmpd="sng" algn="ctr">
+                      <a:solidFill>
+                        <a:srgbClr val="002677"/>
+                      </a:solidFill>
+                      <a:prstDash val="solid"/>
+                      <a:round/>
+                      <a:headEnd type="none" w="med" len="med"/>
+                      <a:tailEnd type="none" w="med" len="med"/>
+                    </a:lnB>
+                  </a:tcPr>
+                </a:tc>
+              </a:tr>
+              <a:tr h="833940">
+                <a:tc>
+                  <a:txBody>
+                    <a:bodyPr/>
+                    <a:lstStyle/>
+                    <a:p>
+                      <a:pPr algn="l" indent="0" marL="0">
+                        <a:buNone/>
+                      </a:pPr>
+                      <a:r>
+                        <a:rPr lang="en-US" sz="1100" b="1" dirty="0">
+                          <a:solidFill>
+                            <a:schemeClr val="accent1"/>
+                          </a:solidFill>
+                        </a:rPr>
+                        <a:t>LLM providers remain suppliers more than rivals</a:t>
+                      </a:r>
+                      <a:endParaRPr lang="en-US" sz="1050" dirty="0"/>
+                    </a:p>
+                  </a:txBody>
+                  <a:tcPr marL="109728" marR="109728" marT="64008" marB="64008" anchor="ctr">
+                    <a:lnL w="0" cap="flat" cmpd="sng" algn="ctr">
+                      <a:noFill/>
+                    </a:lnL>
+                    <a:lnR w="25400" cap="flat" cmpd="sng" algn="ctr">
+                      <a:solidFill>
+                        <a:srgbClr val="FFFFFF"/>
+                      </a:solidFill>
+                      <a:prstDash val="solid"/>
+                      <a:round/>
+                      <a:headEnd type="none" w="med" len="med"/>
+                      <a:tailEnd type="none" w="med" len="med"/>
+                    </a:lnR>
+                    <a:lnT w="25400" cap="flat" cmpd="sng" algn="ctr">
+                      <a:solidFill>
+                        <a:srgbClr val="FFFFFF"/>
+                      </a:solidFill>
+                      <a:prstDash val="solid"/>
+                      <a:round/>
+                      <a:headEnd type="none" w="med" len="med"/>
+                      <a:tailEnd type="none" w="med" len="med"/>
+                    </a:lnT>
+                    <a:lnB w="25400" cap="flat" cmpd="sng" algn="ctr">
+                      <a:solidFill>
+                        <a:srgbClr val="FFFFFF"/>
+                      </a:solidFill>
+                      <a:prstDash val="solid"/>
+                      <a:round/>
+                      <a:headEnd type="none" w="med" len="med"/>
+                      <a:tailEnd type="none" w="med" len="med"/>
+                    </a:lnB>
+                    <a:solidFill>
+                      <a:schemeClr val="accent5"/>
+                    </a:solidFill>
+                  </a:tcPr>
+                </a:tc>
+                <a:tc>
+                  <a:txBody>
+                    <a:bodyPr/>
+                    <a:lstStyle/>
+                    <a:p>
+                      <a:pPr indent="0" marL="0">
+                        <a:buNone/>
+                      </a:pPr>
+                      <a:r>
+                        <a:rPr lang="en-US" sz="1100" dirty="0">
+                          <a:solidFill>
+                            <a:schemeClr val="tx1"/>
+                          </a:solidFill>
+                        </a:rPr>
+                        <a:t>Partnering for the model could create a future competitor.</a:t>
+                      </a:r>
+                      <a:endParaRPr lang="en-US" sz="900" dirty="0"/>
+                    </a:p>
+                  </a:txBody>
+                  <a:tcPr marL="109728" marR="109728" marT="64008" marB="64008" anchor="ctr">
+                    <a:lnL w="0" cap="flat" cmpd="sng" algn="ctr">
+                      <a:noFill/>
+                    </a:lnL>
+                    <a:lnR w="0" cap="flat" cmpd="sng" algn="ctr">
+                      <a:noFill/>
+                    </a:lnR>
+                    <a:lnT w="0" cap="flat" cmpd="sng" algn="ctr">
+                      <a:noFill/>
+                    </a:lnT>
+                    <a:lnB w="19050" cap="flat" cmpd="sng" algn="ctr">
+                      <a:solidFill>
+                        <a:srgbClr val="002677"/>
+                      </a:solidFill>
+                      <a:prstDash val="solid"/>
+                      <a:round/>
+                      <a:headEnd type="none" w="med" len="med"/>
+                      <a:tailEnd type="none" w="med" len="med"/>
+                    </a:lnB>
+                  </a:tcPr>
+                </a:tc>
+                <a:tc>
+                  <a:txBody>
+                    <a:bodyPr/>
+                    <a:lstStyle/>
+                    <a:p>
+                      <a:pPr indent="0" marL="0">
+                        <a:buNone/>
+                      </a:pPr>
+                      <a:r>
+                        <a:rPr lang="en-US" sz="1100" dirty="0">
+                          <a:solidFill>
+                            <a:schemeClr val="tx1"/>
+                          </a:solidFill>
+                        </a:rPr>
+                        <a:t>Track whether model partners’ life-sciences products, such as Claude Science or GPT-Rosalind, start reaching RWE and commercial work.</a:t>
                       </a:r>
                       <a:endParaRPr lang="en-US" sz="900" dirty="0"/>
                     </a:p>

</xml_diff>

<commit_message>
Deck 10.16: Evaluate — Ask Ella naming, NAVLIN pricing link, revised LLM assumption
Co-Authored-By: Claude Opus 5.5 <noreply@anthropic.com>
Claude-Session: https://claude.ai/code/session_0198bm9pfzRwgZQBqNvd56W8
</commit_message>
<xml_diff>
--- a/deck/Optum-LS-Conversational-AI-10.16.pptx
+++ b/deck/Optum-LS-Conversational-AI-10.16.pptx
@@ -8164,7 +8164,7 @@
                   </a:tcPr>
                 </a:tc>
               </a:tr>
-              <a:tr h="833927">
+              <a:tr h="802825">
                 <a:tc>
                   <a:txBody>
                     <a:bodyPr/>
@@ -8301,7 +8301,7 @@
                   </a:tcPr>
                 </a:tc>
               </a:tr>
-              <a:tr h="678416">
+              <a:tr h="647313">
                 <a:tc>
                   <a:txBody>
                     <a:bodyPr/>
@@ -8438,7 +8438,7 @@
                   </a:tcPr>
                 </a:tc>
               </a:tr>
-              <a:tr h="833927">
+              <a:tr h="802825">
                 <a:tc>
                   <a:txBody>
                     <a:bodyPr/>
@@ -8575,7 +8575,7 @@
                   </a:tcPr>
                 </a:tc>
               </a:tr>
-              <a:tr h="989451">
+              <a:tr h="958349">
                 <a:tc>
                   <a:txBody>
                     <a:bodyPr/>
@@ -8712,7 +8712,7 @@
                   </a:tcPr>
                 </a:tc>
               </a:tr>
-              <a:tr h="833940">
+              <a:tr h="958349">
                 <a:tc>
                   <a:txBody>
                     <a:bodyPr/>
@@ -8727,7 +8727,7 @@
                             <a:schemeClr val="accent1"/>
                           </a:solidFill>
                         </a:rPr>
-                        <a:t>LLM providers remain suppliers more than rivals</a:t>
+                        <a:t>LLM providers stay out of RWE and commercial analytics</a:t>
                       </a:r>
                       <a:endParaRPr lang="en-US" sz="1050" dirty="0"/>
                     </a:p>
@@ -8782,7 +8782,7 @@
                             <a:schemeClr val="tx1"/>
                           </a:solidFill>
                         </a:rPr>
-                        <a:t>Partnering for the model could create a future competitor.</a:t>
+                        <a:t>Slide 11 finds their overlap with Optum LS is the interface, not the data. If they move into RWE or commercial analytics, they become direct competitors as well as suppliers.</a:t>
                       </a:r>
                       <a:endParaRPr lang="en-US" sz="900" dirty="0"/>
                     </a:p>
@@ -19538,7 +19538,7 @@
                             </a:solidFill>
                           </a:uFill>
                         </a:rPr>
-                        <a:t>Evaluate Ella</a:t>
+                        <a:t>Evaluate — Ask Ella</a:t>
                       </a:r>
                       <a:r>
                         <a:rPr lang="en-US" sz="950" dirty="0">
@@ -20899,7 +20899,7 @@
         <p:spPr>
           <a:xfrm>
             <a:off x="2944075" y="2152740"/>
-            <a:ext cx="1368645" cy="134588"/>
+            <a:ext cx="1772213" cy="134588"/>
           </a:xfrm>
           <a:prstGeom prst="rect">
             <a:avLst/>
@@ -24831,7 +24831,28 @@
                   <a:schemeClr val="tx1"/>
                 </a:solidFill>
               </a:rPr>
-              <a:t>EVERSANA is moving market-access AI past chat answers. While offering Ask NAVLIN over pricing data from 100+ countries, it says “</a:t>
+              <a:t>EVERSANA is moving market-access AI past chat answers. While offering Ask NAVLIN over </a:t>
+            </a:r>
+            <a:r>
+              <a:rPr lang="en-US" sz="1050" b="1" dirty="0" u="sng">
+                <a:solidFill>
+                  <a:srgbClr val="002677"/>
+                </a:solidFill>
+                <a:uFill>
+                  <a:solidFill>
+                    <a:srgbClr val="9AA8CC"/>
+                  </a:solidFill>
+                </a:uFill>
+              </a:rPr>
+              <a:t>pricing data from 100+ countries</a:t>
+            </a:r>
+            <a:r>
+              <a:rPr lang="en-US" sz="1050" b="1" dirty="0">
+                <a:solidFill>
+                  <a:schemeClr val="tx1"/>
+                </a:solidFill>
+              </a:rPr>
+              <a:t>, it says “</a:t>
             </a:r>
             <a:r>
               <a:rPr lang="en-US" sz="1050" b="1" dirty="0" u="sng">
@@ -25258,7 +25279,7 @@
       </p:sp>
       <p:sp>
         <p:nvSpPr>
-          <p:cNvPr id="9729" name="Invisible source link 10: https://www.eversana.com/insights/from-ai-answers-to-decision-grade-market-access/">
+          <p:cNvPr id="9729" name="Invisible source link 10: https://www.navlin.com/products/navlin-price-access-data">
             <a:hlinkClick r:id="rId15"/>
           </p:cNvPr>
           <p:cNvSpPr/>
@@ -25266,8 +25287,8 @@
         </p:nvSpPr>
         <p:spPr>
           <a:xfrm>
-            <a:off x="9793548" y="5375216"/>
-            <a:ext cx="1577539" cy="148648"/>
+            <a:off x="7223404" y="5375216"/>
+            <a:ext cx="2088174" cy="148648"/>
           </a:xfrm>
           <a:prstGeom prst="rect">
             <a:avLst/>
@@ -25301,16 +25322,16 @@
       </p:sp>
       <p:sp>
         <p:nvSpPr>
-          <p:cNvPr id="9731" name="Invisible source link 10: https://www.eversana.com/insights/from-ai-answers-to-decision-grade-market-access/">
-            <a:hlinkClick r:id="rId15"/>
+          <p:cNvPr id="9730" name="Invisible source link 10: https://www.eversana.com/insights/from-ai-answers-to-decision-grade-market-access/">
+            <a:hlinkClick r:id="rId16"/>
           </p:cNvPr>
           <p:cNvSpPr/>
           <p:nvPr/>
         </p:nvSpPr>
         <p:spPr>
           <a:xfrm>
-            <a:off x="6386753" y="5535058"/>
-            <a:ext cx="2735287" cy="148648"/>
+            <a:off x="9796551" y="5375216"/>
+            <a:ext cx="1573101" cy="148648"/>
           </a:xfrm>
           <a:prstGeom prst="rect">
             <a:avLst/>
@@ -25344,8 +25365,51 @@
       </p:sp>
       <p:sp>
         <p:nvSpPr>
-          <p:cNvPr id="9731" name="Invisible source link 10: https://www.eversana.com/insights/from-ai-answers-to-decision-grade-market-access/">
-            <a:hlinkClick r:id="rId15"/>
+          <p:cNvPr id="9732" name="Invisible source link 10: https://www.eversana.com/insights/from-ai-answers-to-decision-grade-market-access/">
+            <a:hlinkClick r:id="rId16"/>
+          </p:cNvPr>
+          <p:cNvSpPr/>
+          <p:nvPr/>
+        </p:nvSpPr>
+        <p:spPr>
+          <a:xfrm>
+            <a:off x="6386753" y="5535058"/>
+            <a:ext cx="2735287" cy="148648"/>
+          </a:xfrm>
+          <a:prstGeom prst="rect">
+            <a:avLst/>
+          </a:prstGeom>
+          <a:noFill/>
+          <a:ln>
+            <a:noFill/>
+          </a:ln>
+        </p:spPr>
+        <p:style>
+          <a:lnRef idx="1">
+            <a:schemeClr val="accent1"/>
+          </a:lnRef>
+          <a:fillRef idx="3">
+            <a:schemeClr val="accent1"/>
+          </a:fillRef>
+          <a:effectRef idx="2">
+            <a:schemeClr val="accent1"/>
+          </a:effectRef>
+          <a:fontRef idx="minor">
+            <a:schemeClr val="lt1"/>
+          </a:fontRef>
+        </p:style>
+        <p:txBody>
+          <a:bodyPr rtlCol="0" anchor="ctr"/>
+          <a:lstStyle/>
+          <a:p>
+            <a:pPr algn="ctr"/>
+          </a:p>
+        </p:txBody>
+      </p:sp>
+      <p:sp>
+        <p:nvSpPr>
+          <p:cNvPr id="9732" name="Invisible source link 10: https://www.eversana.com/insights/from-ai-answers-to-decision-grade-market-access/">
+            <a:hlinkClick r:id="rId16"/>
           </p:cNvPr>
           <p:cNvSpPr/>
           <p:nvPr/>

</xml_diff>

<commit_message>
Deck 10.16: assumptions page alignment, line breaks and LLM row wording
Co-Authored-By: Claude Opus 5.5 <noreply@anthropic.com>
Claude-Session: https://claude.ai/code/session_0198bm9pfzRwgZQBqNvd56W8
</commit_message>
<xml_diff>
--- a/deck/Optum-LS-Conversational-AI-10.16.pptx
+++ b/deck/Optum-LS-Conversational-AI-10.16.pptx
@@ -8057,7 +8057,7 @@
                     <a:bodyPr/>
                     <a:lstStyle/>
                     <a:p>
-                      <a:pPr indent="0" marL="0">
+                      <a:pPr indent="0" marL="0" algn="ctr">
                         <a:buNone/>
                       </a:pPr>
                       <a:r>
@@ -8094,7 +8094,7 @@
                     <a:bodyPr/>
                     <a:lstStyle/>
                     <a:p>
-                      <a:pPr indent="0" marL="0">
+                      <a:pPr indent="0" marL="0" algn="ctr">
                         <a:buNone/>
                       </a:pPr>
                       <a:r>
@@ -8131,7 +8131,7 @@
                     <a:bodyPr/>
                     <a:lstStyle/>
                     <a:p>
-                      <a:pPr indent="0" marL="0">
+                      <a:pPr indent="0" marL="0" algn="ctr">
                         <a:buNone/>
                       </a:pPr>
                       <a:r>
@@ -8164,13 +8164,13 @@
                   </a:tcPr>
                 </a:tc>
               </a:tr>
-              <a:tr h="802825">
+              <a:tr h="833927">
                 <a:tc>
                   <a:txBody>
                     <a:bodyPr/>
                     <a:lstStyle/>
                     <a:p>
-                      <a:pPr algn="l" indent="0" marL="0">
+                      <a:pPr algn="ctr" indent="0" marL="0">
                         <a:buNone/>
                       </a:pPr>
                       <a:r>
@@ -8301,13 +8301,13 @@
                   </a:tcPr>
                 </a:tc>
               </a:tr>
-              <a:tr h="647313">
+              <a:tr h="678416">
                 <a:tc>
                   <a:txBody>
                     <a:bodyPr/>
                     <a:lstStyle/>
                     <a:p>
-                      <a:pPr algn="l" indent="0" marL="0">
+                      <a:pPr algn="ctr" indent="0" marL="0">
                         <a:buNone/>
                       </a:pPr>
                       <a:r>
@@ -8316,7 +8316,22 @@
                             <a:schemeClr val="accent1"/>
                           </a:solidFill>
                         </a:rPr>
-                        <a:t>Conversational AI influences what customers buy</a:t>
+                        <a:t>Conversational AI influences</a:t>
+                      </a:r>
+                      <a:br>
+                        <a:rPr lang="en-US" sz="1100" b="1" dirty="0">
+                          <a:solidFill>
+                            <a:schemeClr val="accent1"/>
+                          </a:solidFill>
+                        </a:rPr>
+                      </a:br>
+                      <a:r>
+                        <a:rPr lang="en-US" sz="1100" b="1" dirty="0">
+                          <a:solidFill>
+                            <a:schemeClr val="accent1"/>
+                          </a:solidFill>
+                        </a:rPr>
+                        <a:t>what customers buy</a:t>
                       </a:r>
                       <a:endParaRPr lang="en-US" sz="1050" dirty="0"/>
                     </a:p>
@@ -8438,13 +8453,13 @@
                   </a:tcPr>
                 </a:tc>
               </a:tr>
-              <a:tr h="802825">
+              <a:tr h="833927">
                 <a:tc>
                   <a:txBody>
                     <a:bodyPr/>
                     <a:lstStyle/>
                     <a:p>
-                      <a:pPr algn="l" indent="0" marL="0">
+                      <a:pPr algn="ctr" indent="0" marL="0">
                         <a:buNone/>
                       </a:pPr>
                       <a:r>
@@ -8453,7 +8468,22 @@
                             <a:schemeClr val="accent1"/>
                           </a:solidFill>
                         </a:rPr>
-                        <a:t>Pharma buyers want self-service, not just expert-led analysis</a:t>
+                        <a:t>Pharma buyers want self-service,</a:t>
+                      </a:r>
+                      <a:br>
+                        <a:rPr lang="en-US" sz="1100" b="1" dirty="0">
+                          <a:solidFill>
+                            <a:schemeClr val="accent1"/>
+                          </a:solidFill>
+                        </a:rPr>
+                      </a:br>
+                      <a:r>
+                        <a:rPr lang="en-US" sz="1100" b="1" dirty="0">
+                          <a:solidFill>
+                            <a:schemeClr val="accent1"/>
+                          </a:solidFill>
+                        </a:rPr>
+                        <a:t>not just expert-led analysis</a:t>
                       </a:r>
                       <a:endParaRPr lang="en-US" sz="1050" dirty="0"/>
                     </a:p>
@@ -8575,13 +8605,13 @@
                   </a:tcPr>
                 </a:tc>
               </a:tr>
-              <a:tr h="958349">
+              <a:tr h="989451">
                 <a:tc>
                   <a:txBody>
                     <a:bodyPr/>
                     <a:lstStyle/>
                     <a:p>
-                      <a:pPr algn="l" indent="0" marL="0">
+                      <a:pPr algn="ctr" indent="0" marL="0">
                         <a:buNone/>
                       </a:pPr>
                       <a:r>
@@ -8645,7 +8675,7 @@
                             <a:schemeClr val="tx1"/>
                           </a:solidFill>
                         </a:rPr>
-                        <a:t>Pharma companies are moving data work into AI assistants such as Claude. What Optum LS data can be queried, and where, depends on data-use, privacy and de-identification terms.</a:t>
+                        <a:t>Pharma companies are moving data work into AI assistants such as Claude. What Optum LS data can be queried, and where, depends on data-use, privacy and de‑identification terms.</a:t>
                       </a:r>
                       <a:endParaRPr lang="en-US" sz="900" dirty="0"/>
                     </a:p>
@@ -8712,13 +8742,13 @@
                   </a:tcPr>
                 </a:tc>
               </a:tr>
-              <a:tr h="958349">
+              <a:tr h="833940">
                 <a:tc>
                   <a:txBody>
                     <a:bodyPr/>
                     <a:lstStyle/>
                     <a:p>
-                      <a:pPr algn="l" indent="0" marL="0">
+                      <a:pPr algn="ctr" indent="0" marL="0">
                         <a:buNone/>
                       </a:pPr>
                       <a:r>
@@ -8727,7 +8757,22 @@
                             <a:schemeClr val="accent1"/>
                           </a:solidFill>
                         </a:rPr>
-                        <a:t>LLM providers stay out of RWE and commercial analytics</a:t>
+                        <a:t>LLM providers stay out of RWE</a:t>
+                      </a:r>
+                      <a:br>
+                        <a:rPr lang="en-US" sz="1100" b="1" dirty="0">
+                          <a:solidFill>
+                            <a:schemeClr val="accent1"/>
+                          </a:solidFill>
+                        </a:rPr>
+                      </a:br>
+                      <a:r>
+                        <a:rPr lang="en-US" sz="1100" b="1" dirty="0">
+                          <a:solidFill>
+                            <a:schemeClr val="accent1"/>
+                          </a:solidFill>
+                        </a:rPr>
+                        <a:t>and commercial analytics</a:t>
                       </a:r>
                       <a:endParaRPr lang="en-US" sz="1050" dirty="0"/>
                     </a:p>
@@ -8782,7 +8827,7 @@
                             <a:schemeClr val="tx1"/>
                           </a:solidFill>
                         </a:rPr>
-                        <a:t>Slide 11 finds their overlap with Optum LS is the interface, not the data. If they move into RWE or commercial analytics, they become direct competitors as well as suppliers.</a:t>
+                        <a:t>Slide 11 finds their overlap with Optum LS is the interface, not the data. If they move into RWE or commercial analytics, they also become direct competitors.</a:t>
                       </a:r>
                       <a:endParaRPr lang="en-US" sz="900" dirty="0"/>
                     </a:p>

</xml_diff>